<commit_message>
Validate 200-trial BFS control and preserve negative pooled agreement result
</commit_message>
<xml_diff>
--- a/presentation/CSLab_Memory_Tiering_Current.pptx
+++ b/presentation/CSLab_Memory_Tiering_Current.pptx
@@ -2,27 +2,27 @@
 <file path=ppt/presentation.xml><?xml version="1.0" encoding="utf-8"?>
 <p:presentation xmlns:p="http://schemas.openxmlformats.org/presentationml/2006/main">
   <p:sldMasterIdLst>
-    <p:sldMasterId xmlns:r="http://schemas.openxmlformats.org/officeDocument/2006/relationships" id="2147483648" r:id="Re6ab124052894470"/>
+    <p:sldMasterId xmlns:r="http://schemas.openxmlformats.org/officeDocument/2006/relationships" id="2147483648" r:id="Rab38a47395e047ca"/>
   </p:sldMasterIdLst>
   <p:notesMasterIdLst>
-    <p:notesMasterId xmlns:r="http://schemas.openxmlformats.org/officeDocument/2006/relationships" r:id="Re100d411bde0457d"/>
+    <p:notesMasterId xmlns:r="http://schemas.openxmlformats.org/officeDocument/2006/relationships" r:id="R02203bdf51474d4d"/>
   </p:notesMasterIdLst>
   <p:sldIdLst>
-    <p:sldId xmlns:r="http://schemas.openxmlformats.org/officeDocument/2006/relationships" id="256" r:id="Rb6a2429fa422421d"/>
-    <p:sldId xmlns:r="http://schemas.openxmlformats.org/officeDocument/2006/relationships" id="257" r:id="R554ed57260ba4b58"/>
-    <p:sldId xmlns:r="http://schemas.openxmlformats.org/officeDocument/2006/relationships" id="258" r:id="Rd53a51ea34974291"/>
-    <p:sldId xmlns:r="http://schemas.openxmlformats.org/officeDocument/2006/relationships" id="259" r:id="Rc9584846d6454007"/>
-    <p:sldId xmlns:r="http://schemas.openxmlformats.org/officeDocument/2006/relationships" id="260" r:id="R38fa596dd0bd4f9e"/>
-    <p:sldId xmlns:r="http://schemas.openxmlformats.org/officeDocument/2006/relationships" id="261" r:id="R7716ea40a44c492e"/>
-    <p:sldId xmlns:r="http://schemas.openxmlformats.org/officeDocument/2006/relationships" id="262" r:id="R5af0fbb864944341"/>
-    <p:sldId xmlns:r="http://schemas.openxmlformats.org/officeDocument/2006/relationships" id="263" r:id="R2bfe5882ce204b09"/>
-    <p:sldId xmlns:r="http://schemas.openxmlformats.org/officeDocument/2006/relationships" id="264" r:id="R54193606f5f04262"/>
-    <p:sldId xmlns:r="http://schemas.openxmlformats.org/officeDocument/2006/relationships" id="265" r:id="R44d7de11cc58439e"/>
-    <p:sldId xmlns:r="http://schemas.openxmlformats.org/officeDocument/2006/relationships" id="266" r:id="Rc8d5000d8de043e6"/>
-    <p:sldId xmlns:r="http://schemas.openxmlformats.org/officeDocument/2006/relationships" id="267" r:id="Rdf06048fc3bf4b44"/>
-    <p:sldId xmlns:r="http://schemas.openxmlformats.org/officeDocument/2006/relationships" id="268" r:id="Rbff3653f53624e46"/>
-    <p:sldId xmlns:r="http://schemas.openxmlformats.org/officeDocument/2006/relationships" id="269" r:id="Ra7e65f5f927a4057"/>
-    <p:sldId xmlns:r="http://schemas.openxmlformats.org/officeDocument/2006/relationships" id="270" r:id="R60c474812889445c"/>
+    <p:sldId xmlns:r="http://schemas.openxmlformats.org/officeDocument/2006/relationships" id="256" r:id="Rcf0602cee57c4b19"/>
+    <p:sldId xmlns:r="http://schemas.openxmlformats.org/officeDocument/2006/relationships" id="257" r:id="R86b21dc2e9724d91"/>
+    <p:sldId xmlns:r="http://schemas.openxmlformats.org/officeDocument/2006/relationships" id="258" r:id="R20106bc1b62c4973"/>
+    <p:sldId xmlns:r="http://schemas.openxmlformats.org/officeDocument/2006/relationships" id="259" r:id="R54c768c0baca4073"/>
+    <p:sldId xmlns:r="http://schemas.openxmlformats.org/officeDocument/2006/relationships" id="260" r:id="Rf3363f4e02e44ec0"/>
+    <p:sldId xmlns:r="http://schemas.openxmlformats.org/officeDocument/2006/relationships" id="261" r:id="Rbda6d09871604669"/>
+    <p:sldId xmlns:r="http://schemas.openxmlformats.org/officeDocument/2006/relationships" id="262" r:id="Rc29e6a918cbe4430"/>
+    <p:sldId xmlns:r="http://schemas.openxmlformats.org/officeDocument/2006/relationships" id="263" r:id="R42a22d6bf19e49e2"/>
+    <p:sldId xmlns:r="http://schemas.openxmlformats.org/officeDocument/2006/relationships" id="264" r:id="R9cb6e4ec22754d29"/>
+    <p:sldId xmlns:r="http://schemas.openxmlformats.org/officeDocument/2006/relationships" id="265" r:id="R1b1b2bb8679b4c95"/>
+    <p:sldId xmlns:r="http://schemas.openxmlformats.org/officeDocument/2006/relationships" id="266" r:id="R9d82e14d61554d4e"/>
+    <p:sldId xmlns:r="http://schemas.openxmlformats.org/officeDocument/2006/relationships" id="267" r:id="R2d7d36dd08fd4f3e"/>
+    <p:sldId xmlns:r="http://schemas.openxmlformats.org/officeDocument/2006/relationships" id="268" r:id="R02124d84dfed4125"/>
+    <p:sldId xmlns:r="http://schemas.openxmlformats.org/officeDocument/2006/relationships" id="269" r:id="R2c917f2c7a2340ec"/>
+    <p:sldId xmlns:r="http://schemas.openxmlformats.org/officeDocument/2006/relationships" id="270" r:id="Rebe609b3d679468d"/>
   </p:sldIdLst>
   <p:sldSz cx="12192000" cy="6858000"/>
   <p:notesSz cx="6858000" cy="9144000"/>
@@ -1633,7 +1633,7 @@
           <p:cNvPr id="3" name="Title">
             <a:extLst xmlns:a="http://schemas.openxmlformats.org/drawingml/2006/main">
               <a:ext uri="{FF2B5EF4-FFF2-40B4-BE49-F238E27FC236}">
-                <a16:creationId xmlns:a16="http://schemas.microsoft.com/office/drawing/2014/main" id="{BAA77CB9-C9D2-4A53-9A27-A2557A8C7340}"/>
+                <a16:creationId xmlns:a16="http://schemas.microsoft.com/office/drawing/2014/main" id="{840CC296-D354-462A-9880-78CC2294AE6F}"/>
               </a:ext>
             </a:extLst>
           </p:cNvPr>
@@ -1862,7 +1862,7 @@
           <p:cNvPr id="2" name="Subtitle">
             <a:extLst xmlns:a="http://schemas.openxmlformats.org/drawingml/2006/main">
               <a:ext uri="{FF2B5EF4-FFF2-40B4-BE49-F238E27FC236}">
-                <a16:creationId xmlns:a16="http://schemas.microsoft.com/office/drawing/2014/main" id="{5FBC1DAC-F339-42C0-9460-C370CFFDDC56}"/>
+                <a16:creationId xmlns:a16="http://schemas.microsoft.com/office/drawing/2014/main" id="{4BD63025-BFD5-4658-80C4-1938EC374998}"/>
               </a:ext>
             </a:extLst>
           </p:cNvPr>
@@ -2108,7 +2108,7 @@
           <p:cNvPr id="2" name="Section title">
             <a:extLst xmlns:a="http://schemas.openxmlformats.org/drawingml/2006/main">
               <a:ext uri="{FF2B5EF4-FFF2-40B4-BE49-F238E27FC236}">
-                <a16:creationId xmlns:a16="http://schemas.microsoft.com/office/drawing/2014/main" id="{A39349A1-13DD-49B4-B6AC-20E4919A913C}"/>
+                <a16:creationId xmlns:a16="http://schemas.microsoft.com/office/drawing/2014/main" id="{9EB92CD0-63C8-4C55-B9F6-22CED8E804AB}"/>
               </a:ext>
             </a:extLst>
           </p:cNvPr>
@@ -2354,7 +2354,7 @@
           <p:cNvPr id="3" name="Title">
             <a:extLst xmlns:a="http://schemas.openxmlformats.org/drawingml/2006/main">
               <a:ext uri="{FF2B5EF4-FFF2-40B4-BE49-F238E27FC236}">
-                <a16:creationId xmlns:a16="http://schemas.microsoft.com/office/drawing/2014/main" id="{8924CBC4-44D9-4377-83D6-A5184E275F29}"/>
+                <a16:creationId xmlns:a16="http://schemas.microsoft.com/office/drawing/2014/main" id="{EABF31AA-8F43-4220-A185-EFF6207C5F3A}"/>
               </a:ext>
             </a:extLst>
           </p:cNvPr>
@@ -2583,7 +2583,7 @@
           <p:cNvPr id="2" name="Body">
             <a:extLst xmlns:a="http://schemas.openxmlformats.org/drawingml/2006/main">
               <a:ext uri="{FF2B5EF4-FFF2-40B4-BE49-F238E27FC236}">
-                <a16:creationId xmlns:a16="http://schemas.microsoft.com/office/drawing/2014/main" id="{27B5D2E1-08C0-458E-8EFE-D5AB5CA28785}"/>
+                <a16:creationId xmlns:a16="http://schemas.microsoft.com/office/drawing/2014/main" id="{7EDB9F99-4C4D-4E18-A0DC-5F1F2BA7C1B1}"/>
               </a:ext>
             </a:extLst>
           </p:cNvPr>
@@ -2829,7 +2829,7 @@
           <p:cNvPr id="4" name="Title">
             <a:extLst xmlns:a="http://schemas.openxmlformats.org/drawingml/2006/main">
               <a:ext uri="{FF2B5EF4-FFF2-40B4-BE49-F238E27FC236}">
-                <a16:creationId xmlns:a16="http://schemas.microsoft.com/office/drawing/2014/main" id="{E7CBDAE1-47EC-4FA6-8474-7C1506618C24}"/>
+                <a16:creationId xmlns:a16="http://schemas.microsoft.com/office/drawing/2014/main" id="{9D71633A-3032-4DB6-A831-8771E6E69DA4}"/>
               </a:ext>
             </a:extLst>
           </p:cNvPr>
@@ -3058,7 +3058,7 @@
           <p:cNvPr id="2" name="Left column">
             <a:extLst xmlns:a="http://schemas.openxmlformats.org/drawingml/2006/main">
               <a:ext uri="{FF2B5EF4-FFF2-40B4-BE49-F238E27FC236}">
-                <a16:creationId xmlns:a16="http://schemas.microsoft.com/office/drawing/2014/main" id="{A5CBF7EE-76B6-4B81-8D4E-C66D368B2420}"/>
+                <a16:creationId xmlns:a16="http://schemas.microsoft.com/office/drawing/2014/main" id="{4F868971-4540-40E2-B3C7-1D50CE0565B8}"/>
               </a:ext>
             </a:extLst>
           </p:cNvPr>
@@ -3287,7 +3287,7 @@
           <p:cNvPr id="3" name="Right column">
             <a:extLst xmlns:a="http://schemas.openxmlformats.org/drawingml/2006/main">
               <a:ext uri="{FF2B5EF4-FFF2-40B4-BE49-F238E27FC236}">
-                <a16:creationId xmlns:a16="http://schemas.microsoft.com/office/drawing/2014/main" id="{B57A60FB-511F-48BA-A068-6EA07DD0E896}"/>
+                <a16:creationId xmlns:a16="http://schemas.microsoft.com/office/drawing/2014/main" id="{F9038620-625D-4628-8899-12506FB8333A}"/>
               </a:ext>
             </a:extLst>
           </p:cNvPr>
@@ -3533,7 +3533,7 @@
           <p:cNvPr id="3" name="Title">
             <a:extLst xmlns:a="http://schemas.openxmlformats.org/drawingml/2006/main">
               <a:ext uri="{FF2B5EF4-FFF2-40B4-BE49-F238E27FC236}">
-                <a16:creationId xmlns:a16="http://schemas.microsoft.com/office/drawing/2014/main" id="{73697FE3-35FC-4CAF-B2F5-CEE40AAC295C}"/>
+                <a16:creationId xmlns:a16="http://schemas.microsoft.com/office/drawing/2014/main" id="{6909D390-CB19-4917-840C-324551B9F3DA}"/>
               </a:ext>
             </a:extLst>
           </p:cNvPr>
@@ -3762,7 +3762,7 @@
           <p:cNvPr id="2" name="Left column">
             <a:extLst xmlns:a="http://schemas.openxmlformats.org/drawingml/2006/main">
               <a:ext uri="{FF2B5EF4-FFF2-40B4-BE49-F238E27FC236}">
-                <a16:creationId xmlns:a16="http://schemas.microsoft.com/office/drawing/2014/main" id="{E5812DC5-FF44-460A-BC4C-34FEDEBD814A}"/>
+                <a16:creationId xmlns:a16="http://schemas.microsoft.com/office/drawing/2014/main" id="{EC1FB732-D59A-41C0-8720-EAD3548450A5}"/>
               </a:ext>
             </a:extLst>
           </p:cNvPr>
@@ -4029,12 +4029,12 @@
   </p:cSld>
   <p:clrMap bg1="lt1" tx1="dk1" bg2="lt2" tx2="dk2" accent1="accent1" accent2="accent2" accent3="accent3" accent4="accent4" accent5="accent5" accent6="accent6" hlink="hlink" folHlink="folHlink"/>
   <p:sldLayoutIdLst>
-    <p:sldLayoutId xmlns:r="http://schemas.openxmlformats.org/officeDocument/2006/relationships" id="2147483649" r:id="R2fe7f990c3374c8f"/>
-    <p:sldLayoutId xmlns:r="http://schemas.openxmlformats.org/officeDocument/2006/relationships" id="2147483650" r:id="Ra5f2ffaa607c4c83"/>
-    <p:sldLayoutId xmlns:r="http://schemas.openxmlformats.org/officeDocument/2006/relationships" id="2147483651" r:id="R35b9cdcd30a54a66"/>
-    <p:sldLayoutId xmlns:r="http://schemas.openxmlformats.org/officeDocument/2006/relationships" id="2147483652" r:id="R87d51c4360774168"/>
-    <p:sldLayoutId xmlns:r="http://schemas.openxmlformats.org/officeDocument/2006/relationships" id="2147483653" r:id="R9d1460a9b65f438f"/>
-    <p:sldLayoutId xmlns:r="http://schemas.openxmlformats.org/officeDocument/2006/relationships" id="2147483654" r:id="R65e9986e39a641a9"/>
+    <p:sldLayoutId xmlns:r="http://schemas.openxmlformats.org/officeDocument/2006/relationships" id="2147483649" r:id="Rfab81d15a5fd43bd"/>
+    <p:sldLayoutId xmlns:r="http://schemas.openxmlformats.org/officeDocument/2006/relationships" id="2147483650" r:id="R602ad623246545d4"/>
+    <p:sldLayoutId xmlns:r="http://schemas.openxmlformats.org/officeDocument/2006/relationships" id="2147483651" r:id="Radfe38f63d14438d"/>
+    <p:sldLayoutId xmlns:r="http://schemas.openxmlformats.org/officeDocument/2006/relationships" id="2147483652" r:id="R3639bcfcd9db401a"/>
+    <p:sldLayoutId xmlns:r="http://schemas.openxmlformats.org/officeDocument/2006/relationships" id="2147483653" r:id="R40111967e6774eb6"/>
+    <p:sldLayoutId xmlns:r="http://schemas.openxmlformats.org/officeDocument/2006/relationships" id="2147483654" r:id="R12b346fcea384e9c"/>
   </p:sldLayoutIdLst>
   <p:txStyles>
     <p:titleStyle>
@@ -4585,7 +4585,7 @@
           <p:cNvPr id="7" name="">
             <a:extLst xmlns:a="http://schemas.openxmlformats.org/drawingml/2006/main">
               <a:ext uri="{FF2B5EF4-FFF2-40B4-BE49-F238E27FC236}">
-                <a16:creationId xmlns:a16="http://schemas.microsoft.com/office/drawing/2014/main" id="{62071054-9A94-412B-A90E-5CD17BD0AE3C}"/>
+                <a16:creationId xmlns:a16="http://schemas.microsoft.com/office/drawing/2014/main" id="{C435C5D5-D1A2-4ED0-BA01-977E20E12C6C}"/>
               </a:ext>
             </a:extLst>
           </p:cNvPr>
@@ -4741,7 +4741,7 @@
           <p:cNvPr id="2" name="">
             <a:extLst xmlns:a="http://schemas.openxmlformats.org/drawingml/2006/main">
               <a:ext uri="{FF2B5EF4-FFF2-40B4-BE49-F238E27FC236}">
-                <a16:creationId xmlns:a16="http://schemas.microsoft.com/office/drawing/2014/main" id="{543B7CAD-F56C-4835-9829-EFD9C365B081}"/>
+                <a16:creationId xmlns:a16="http://schemas.microsoft.com/office/drawing/2014/main" id="{7D41A636-91B7-4A95-982C-0FE6B5CE84A7}"/>
               </a:ext>
             </a:extLst>
           </p:cNvPr>
@@ -4897,7 +4897,7 @@
           <p:cNvPr id="3" name="">
             <a:extLst xmlns:a="http://schemas.openxmlformats.org/drawingml/2006/main">
               <a:ext uri="{FF2B5EF4-FFF2-40B4-BE49-F238E27FC236}">
-                <a16:creationId xmlns:a16="http://schemas.microsoft.com/office/drawing/2014/main" id="{0AC5D4E1-38A2-463D-AC85-EC1ED85570F3}"/>
+                <a16:creationId xmlns:a16="http://schemas.microsoft.com/office/drawing/2014/main" id="{15559B0B-9179-408D-BD95-38E8AC094B3D}"/>
               </a:ext>
             </a:extLst>
           </p:cNvPr>
@@ -5037,7 +5037,7 @@
           <p:cNvPr id="4" name="">
             <a:extLst xmlns:a="http://schemas.openxmlformats.org/drawingml/2006/main">
               <a:ext uri="{FF2B5EF4-FFF2-40B4-BE49-F238E27FC236}">
-                <a16:creationId xmlns:a16="http://schemas.microsoft.com/office/drawing/2014/main" id="{5E7AEE12-CE11-416B-85B3-1FA3F1CF348A}"/>
+                <a16:creationId xmlns:a16="http://schemas.microsoft.com/office/drawing/2014/main" id="{A76476A4-71E3-41D5-B621-2BF879D35EFE}"/>
               </a:ext>
             </a:extLst>
           </p:cNvPr>
@@ -5193,7 +5193,7 @@
           <p:cNvPr id="5" name="">
             <a:extLst xmlns:a="http://schemas.openxmlformats.org/drawingml/2006/main">
               <a:ext uri="{FF2B5EF4-FFF2-40B4-BE49-F238E27FC236}">
-                <a16:creationId xmlns:a16="http://schemas.microsoft.com/office/drawing/2014/main" id="{5BD8E0AE-FD6B-4A16-8385-3957E5439BC7}"/>
+                <a16:creationId xmlns:a16="http://schemas.microsoft.com/office/drawing/2014/main" id="{3DBCE093-DFC4-437B-822D-976C06D27E9D}"/>
               </a:ext>
             </a:extLst>
           </p:cNvPr>
@@ -5349,7 +5349,7 @@
           <p:cNvPr id="6" name="">
             <a:extLst xmlns:a="http://schemas.openxmlformats.org/drawingml/2006/main">
               <a:ext uri="{FF2B5EF4-FFF2-40B4-BE49-F238E27FC236}">
-                <a16:creationId xmlns:a16="http://schemas.microsoft.com/office/drawing/2014/main" id="{729C1F9C-518F-4907-8E25-F124ADFC3938}"/>
+                <a16:creationId xmlns:a16="http://schemas.microsoft.com/office/drawing/2014/main" id="{6BDDB642-0903-4C09-A722-240F0D1CA20E}"/>
               </a:ext>
             </a:extLst>
           </p:cNvPr>
@@ -5554,7 +5554,7 @@
     </p:spTree>
     <p:extLst>
       <p:ext uri="{BB962C8B-B14F-4D97-AF65-F5344CB8AC3E}">
-        <p14:creationId xmlns:p14="http://schemas.microsoft.com/office/powerpoint/2010/main" val="1060147265"/>
+        <p14:creationId xmlns:p14="http://schemas.microsoft.com/office/powerpoint/2010/main" val="1607332118"/>
       </p:ext>
     </p:extLst>
   </p:cSld>
@@ -5585,7 +5585,7 @@
           <p:cNvPr id="7" name="">
             <a:extLst xmlns:a="http://schemas.openxmlformats.org/drawingml/2006/main">
               <a:ext uri="{FF2B5EF4-FFF2-40B4-BE49-F238E27FC236}">
-                <a16:creationId xmlns:a16="http://schemas.microsoft.com/office/drawing/2014/main" id="{994E6990-049D-4096-B6BC-09B914EAF225}"/>
+                <a16:creationId xmlns:a16="http://schemas.microsoft.com/office/drawing/2014/main" id="{144D4312-863C-48BC-B5B3-052B305ED1D3}"/>
               </a:ext>
             </a:extLst>
           </p:cNvPr>
@@ -5741,7 +5741,7 @@
           <p:cNvPr id="2" name="">
             <a:extLst xmlns:a="http://schemas.openxmlformats.org/drawingml/2006/main">
               <a:ext uri="{FF2B5EF4-FFF2-40B4-BE49-F238E27FC236}">
-                <a16:creationId xmlns:a16="http://schemas.microsoft.com/office/drawing/2014/main" id="{D54AD351-9F82-4785-BBC4-3DF244FD6FCD}"/>
+                <a16:creationId xmlns:a16="http://schemas.microsoft.com/office/drawing/2014/main" id="{41BC25B0-D25F-4966-93DB-64680C2137D4}"/>
               </a:ext>
             </a:extLst>
           </p:cNvPr>
@@ -5897,7 +5897,7 @@
           <p:cNvPr id="3" name="">
             <a:extLst xmlns:a="http://schemas.openxmlformats.org/drawingml/2006/main">
               <a:ext uri="{FF2B5EF4-FFF2-40B4-BE49-F238E27FC236}">
-                <a16:creationId xmlns:a16="http://schemas.microsoft.com/office/drawing/2014/main" id="{999DF0B8-18FC-4DD8-8188-7129249D1EC4}"/>
+                <a16:creationId xmlns:a16="http://schemas.microsoft.com/office/drawing/2014/main" id="{C3FF5569-2677-45DF-BA31-721D83C33D62}"/>
               </a:ext>
             </a:extLst>
           </p:cNvPr>
@@ -6037,7 +6037,7 @@
           <p:cNvPr id="4" name="">
             <a:extLst xmlns:a="http://schemas.openxmlformats.org/drawingml/2006/main">
               <a:ext uri="{FF2B5EF4-FFF2-40B4-BE49-F238E27FC236}">
-                <a16:creationId xmlns:a16="http://schemas.microsoft.com/office/drawing/2014/main" id="{675A66C3-1659-4EEC-B4B9-0D4BFCB4405B}"/>
+                <a16:creationId xmlns:a16="http://schemas.microsoft.com/office/drawing/2014/main" id="{8AD675BF-F4BD-4F28-B24B-32948C56F5F7}"/>
               </a:ext>
             </a:extLst>
           </p:cNvPr>
@@ -6193,7 +6193,7 @@
           <p:cNvPr id="5" name="">
             <a:extLst xmlns:a="http://schemas.openxmlformats.org/drawingml/2006/main">
               <a:ext uri="{FF2B5EF4-FFF2-40B4-BE49-F238E27FC236}">
-                <a16:creationId xmlns:a16="http://schemas.microsoft.com/office/drawing/2014/main" id="{B960FBA7-6A7C-4A66-AC3C-3A9A92526065}"/>
+                <a16:creationId xmlns:a16="http://schemas.microsoft.com/office/drawing/2014/main" id="{279C1B24-629C-4BEB-815C-458BC293FAD3}"/>
               </a:ext>
             </a:extLst>
           </p:cNvPr>
@@ -6372,7 +6372,7 @@
           <p:cNvPr id="6" name="">
             <a:extLst xmlns:a="http://schemas.openxmlformats.org/drawingml/2006/main">
               <a:ext uri="{FF2B5EF4-FFF2-40B4-BE49-F238E27FC236}">
-                <a16:creationId xmlns:a16="http://schemas.microsoft.com/office/drawing/2014/main" id="{C8DCEB02-D067-4FE5-99C0-5FB8332CB7AF}"/>
+                <a16:creationId xmlns:a16="http://schemas.microsoft.com/office/drawing/2014/main" id="{CC69BC8F-33F4-408B-9C7A-E45654ECEF59}"/>
               </a:ext>
             </a:extLst>
           </p:cNvPr>
@@ -6554,7 +6554,7 @@
     </p:spTree>
     <p:extLst>
       <p:ext uri="{BB962C8B-B14F-4D97-AF65-F5344CB8AC3E}">
-        <p14:creationId xmlns:p14="http://schemas.microsoft.com/office/powerpoint/2010/main" val="153054216"/>
+        <p14:creationId xmlns:p14="http://schemas.microsoft.com/office/powerpoint/2010/main" val="1662397836"/>
       </p:ext>
     </p:extLst>
   </p:cSld>
@@ -6582,10 +6582,10 @@
       </p:grpSpPr>
       <p:sp>
         <p:nvSpPr>
-          <p:cNvPr id="6" name="">
+          <p:cNvPr id="7" name="">
             <a:extLst xmlns:a="http://schemas.openxmlformats.org/drawingml/2006/main">
               <a:ext uri="{FF2B5EF4-FFF2-40B4-BE49-F238E27FC236}">
-                <a16:creationId xmlns:a16="http://schemas.microsoft.com/office/drawing/2014/main" id="{7EB20057-702F-4F54-9453-1F3B5EF43345}"/>
+                <a16:creationId xmlns:a16="http://schemas.microsoft.com/office/drawing/2014/main" id="{0454CD91-7E01-4E7F-8B27-77B8453608BE}"/>
               </a:ext>
             </a:extLst>
           </p:cNvPr>
@@ -6741,7 +6741,7 @@
           <p:cNvPr id="2" name="">
             <a:extLst xmlns:a="http://schemas.openxmlformats.org/drawingml/2006/main">
               <a:ext uri="{FF2B5EF4-FFF2-40B4-BE49-F238E27FC236}">
-                <a16:creationId xmlns:a16="http://schemas.microsoft.com/office/drawing/2014/main" id="{7AAB217D-BF29-4B75-9016-3D239A842FB9}"/>
+                <a16:creationId xmlns:a16="http://schemas.microsoft.com/office/drawing/2014/main" id="{6DA647AF-2653-4128-AB6A-D0F5F9AC09A9}"/>
               </a:ext>
             </a:extLst>
           </p:cNvPr>
@@ -6897,7 +6897,7 @@
           <p:cNvPr id="3" name="">
             <a:extLst xmlns:a="http://schemas.openxmlformats.org/drawingml/2006/main">
               <a:ext uri="{FF2B5EF4-FFF2-40B4-BE49-F238E27FC236}">
-                <a16:creationId xmlns:a16="http://schemas.microsoft.com/office/drawing/2014/main" id="{B25FEEF7-458B-40BA-BBE1-EADDFD7B7E5F}"/>
+                <a16:creationId xmlns:a16="http://schemas.microsoft.com/office/drawing/2014/main" id="{60F57866-1E7C-4697-A7B3-3ABC937A7A9B}"/>
               </a:ext>
             </a:extLst>
           </p:cNvPr>
@@ -7037,7 +7037,7 @@
           <p:cNvPr id="4" name="">
             <a:extLst xmlns:a="http://schemas.openxmlformats.org/drawingml/2006/main">
               <a:ext uri="{FF2B5EF4-FFF2-40B4-BE49-F238E27FC236}">
-                <a16:creationId xmlns:a16="http://schemas.microsoft.com/office/drawing/2014/main" id="{A865DBF1-7D67-46C3-9E10-C2E925073E0C}"/>
+                <a16:creationId xmlns:a16="http://schemas.microsoft.com/office/drawing/2014/main" id="{6737E84B-7787-4195-A62F-13570B27A1D7}"/>
               </a:ext>
             </a:extLst>
           </p:cNvPr>
@@ -7193,7 +7193,7 @@
           <p:cNvPr id="5" name="">
             <a:extLst xmlns:a="http://schemas.openxmlformats.org/drawingml/2006/main">
               <a:ext uri="{FF2B5EF4-FFF2-40B4-BE49-F238E27FC236}">
-                <a16:creationId xmlns:a16="http://schemas.microsoft.com/office/drawing/2014/main" id="{E510D122-EB04-49F0-AAA1-D261DD6E3461}"/>
+                <a16:creationId xmlns:a16="http://schemas.microsoft.com/office/drawing/2014/main" id="{7B933CC4-41B9-4524-99F7-BB32223BCCF7}"/>
               </a:ext>
             </a:extLst>
           </p:cNvPr>
@@ -7464,10 +7464,166 @@
           </a:p>
         </p:txBody>
       </p:sp>
+      <p:sp>
+        <p:nvSpPr>
+          <p:cNvPr id="6" name="">
+            <a:extLst xmlns:a="http://schemas.openxmlformats.org/drawingml/2006/main">
+              <a:ext uri="{FF2B5EF4-FFF2-40B4-BE49-F238E27FC236}">
+                <a16:creationId xmlns:a16="http://schemas.microsoft.com/office/drawing/2014/main" id="{E6BCAC90-AC26-4496-86FE-DB04BDA31534}"/>
+              </a:ext>
+            </a:extLst>
+          </p:cNvPr>
+          <p:cNvSpPr>
+            <a:spLocks xmlns:a="http://schemas.openxmlformats.org/drawingml/2006/main" noGrp="1"/>
+          </p:cNvSpPr>
+          <p:nvPr/>
+        </p:nvSpPr>
+        <p:spPr>
+          <a:xfrm xmlns:a="http://schemas.openxmlformats.org/drawingml/2006/main">
+            <a:off x="571500" y="6153150"/>
+            <a:ext cx="10858500" cy="304800"/>
+          </a:xfrm>
+          <a:prstGeom xmlns:a="http://schemas.openxmlformats.org/drawingml/2006/main" prst="rect">
+            <a:avLst/>
+          </a:prstGeom>
+          <a:noFill xmlns:a="http://schemas.openxmlformats.org/drawingml/2006/main"/>
+          <a:ln xmlns:a="http://schemas.openxmlformats.org/drawingml/2006/main" w="0">
+            <a:noFill/>
+          </a:ln>
+        </p:spPr>
+        <p:txBody>
+          <a:bodyPr xmlns:a="http://schemas.openxmlformats.org/drawingml/2006/main"/>
+          <a:lstStyle xmlns:a="http://schemas.openxmlformats.org/drawingml/2006/main">
+            <a:defPPr>
+              <a:defRPr sz="1125" b="0">
+                <a:solidFill>
+                  <a:srgbClr val="444444"/>
+                </a:solidFill>
+                <a:latin typeface="Noto Sans"/>
+                <a:ea typeface="Noto Sans"/>
+                <a:cs typeface="Noto Sans"/>
+              </a:defRPr>
+            </a:defPPr>
+            <a:lvl1pPr>
+              <a:defRPr sz="1125" b="0">
+                <a:solidFill>
+                  <a:srgbClr val="444444"/>
+                </a:solidFill>
+                <a:latin typeface="Noto Sans"/>
+                <a:ea typeface="Noto Sans"/>
+                <a:cs typeface="Noto Sans"/>
+              </a:defRPr>
+            </a:lvl1pPr>
+            <a:lvl2pPr>
+              <a:defRPr sz="1125" b="0">
+                <a:solidFill>
+                  <a:srgbClr val="444444"/>
+                </a:solidFill>
+                <a:latin typeface="Noto Sans"/>
+                <a:ea typeface="Noto Sans"/>
+                <a:cs typeface="Noto Sans"/>
+              </a:defRPr>
+            </a:lvl2pPr>
+            <a:lvl3pPr>
+              <a:defRPr sz="1125" b="0">
+                <a:solidFill>
+                  <a:srgbClr val="444444"/>
+                </a:solidFill>
+                <a:latin typeface="Noto Sans"/>
+                <a:ea typeface="Noto Sans"/>
+                <a:cs typeface="Noto Sans"/>
+              </a:defRPr>
+            </a:lvl3pPr>
+            <a:lvl4pPr>
+              <a:defRPr sz="1125" b="0">
+                <a:solidFill>
+                  <a:srgbClr val="444444"/>
+                </a:solidFill>
+                <a:latin typeface="Noto Sans"/>
+                <a:ea typeface="Noto Sans"/>
+                <a:cs typeface="Noto Sans"/>
+              </a:defRPr>
+            </a:lvl4pPr>
+            <a:lvl5pPr>
+              <a:defRPr sz="1125" b="0">
+                <a:solidFill>
+                  <a:srgbClr val="444444"/>
+                </a:solidFill>
+                <a:latin typeface="Noto Sans"/>
+                <a:ea typeface="Noto Sans"/>
+                <a:cs typeface="Noto Sans"/>
+              </a:defRPr>
+            </a:lvl5pPr>
+            <a:lvl6pPr>
+              <a:defRPr sz="1125" b="0">
+                <a:solidFill>
+                  <a:srgbClr val="444444"/>
+                </a:solidFill>
+                <a:latin typeface="Noto Sans"/>
+                <a:ea typeface="Noto Sans"/>
+                <a:cs typeface="Noto Sans"/>
+              </a:defRPr>
+            </a:lvl6pPr>
+            <a:lvl7pPr>
+              <a:defRPr sz="1125" b="0">
+                <a:solidFill>
+                  <a:srgbClr val="444444"/>
+                </a:solidFill>
+                <a:latin typeface="Noto Sans"/>
+                <a:ea typeface="Noto Sans"/>
+                <a:cs typeface="Noto Sans"/>
+              </a:defRPr>
+            </a:lvl7pPr>
+            <a:lvl8pPr>
+              <a:defRPr sz="1125" b="0">
+                <a:solidFill>
+                  <a:srgbClr val="444444"/>
+                </a:solidFill>
+                <a:latin typeface="Noto Sans"/>
+                <a:ea typeface="Noto Sans"/>
+                <a:cs typeface="Noto Sans"/>
+              </a:defRPr>
+            </a:lvl8pPr>
+            <a:lvl9pPr>
+              <a:defRPr sz="1125" b="0">
+                <a:solidFill>
+                  <a:srgbClr val="444444"/>
+                </a:solidFill>
+                <a:latin typeface="Noto Sans"/>
+                <a:ea typeface="Noto Sans"/>
+                <a:cs typeface="Noto Sans"/>
+              </a:defRPr>
+            </a:lvl9pPr>
+          </a:lstStyle>
+          <a:p xmlns:a="http://schemas.openxmlformats.org/drawingml/2006/main">
+            <a:pPr>
+              <a:defRPr sz="1125" b="0">
+                <a:solidFill>
+                  <a:srgbClr val="444444"/>
+                </a:solidFill>
+                <a:latin typeface="Noto Sans"/>
+                <a:ea typeface="Noto Sans"/>
+                <a:cs typeface="Noto Sans"/>
+              </a:defRPr>
+            </a:pPr>
+            <a:r>
+              <a:rPr sz="1125" b="0">
+                <a:solidFill>
+                  <a:srgbClr val="444444"/>
+                </a:solidFill>
+                <a:latin typeface="Noto Sans"/>
+                <a:ea typeface="Noto Sans"/>
+                <a:cs typeface="Noto Sans"/>
+              </a:rPr>
+              <a:t>BFS, 200 trials: pooled σφάλμα 59.6 μ.μ. αντί 59,1. Η επανάληψη μόνη της δεν βελτιώνει τη συμφωνία.</a:t>
+            </a:r>
+          </a:p>
+        </p:txBody>
+      </p:sp>
     </p:spTree>
     <p:extLst>
       <p:ext uri="{BB962C8B-B14F-4D97-AF65-F5344CB8AC3E}">
-        <p14:creationId xmlns:p14="http://schemas.microsoft.com/office/powerpoint/2010/main" val="2032831063"/>
+        <p14:creationId xmlns:p14="http://schemas.microsoft.com/office/powerpoint/2010/main" val="1577976399"/>
       </p:ext>
     </p:extLst>
   </p:cSld>
@@ -7498,7 +7654,7 @@
           <p:cNvPr id="7" name="">
             <a:extLst xmlns:a="http://schemas.openxmlformats.org/drawingml/2006/main">
               <a:ext uri="{FF2B5EF4-FFF2-40B4-BE49-F238E27FC236}">
-                <a16:creationId xmlns:a16="http://schemas.microsoft.com/office/drawing/2014/main" id="{A39E008B-276E-4DAE-B063-5209BE6EB6F1}"/>
+                <a16:creationId xmlns:a16="http://schemas.microsoft.com/office/drawing/2014/main" id="{D155D40F-9E37-4E6A-9DB8-1AB412CF2554}"/>
               </a:ext>
             </a:extLst>
           </p:cNvPr>
@@ -7654,7 +7810,7 @@
           <p:cNvPr id="2" name="">
             <a:extLst xmlns:a="http://schemas.openxmlformats.org/drawingml/2006/main">
               <a:ext uri="{FF2B5EF4-FFF2-40B4-BE49-F238E27FC236}">
-                <a16:creationId xmlns:a16="http://schemas.microsoft.com/office/drawing/2014/main" id="{D49EFE74-BB9B-4102-A1C0-D1E4B8E45B69}"/>
+                <a16:creationId xmlns:a16="http://schemas.microsoft.com/office/drawing/2014/main" id="{33ADFE20-B5C4-4FB1-9255-5ED5422E3EED}"/>
               </a:ext>
             </a:extLst>
           </p:cNvPr>
@@ -7810,7 +7966,7 @@
           <p:cNvPr id="3" name="">
             <a:extLst xmlns:a="http://schemas.openxmlformats.org/drawingml/2006/main">
               <a:ext uri="{FF2B5EF4-FFF2-40B4-BE49-F238E27FC236}">
-                <a16:creationId xmlns:a16="http://schemas.microsoft.com/office/drawing/2014/main" id="{02C6F47E-D54F-4EA1-A56C-57F97D87F486}"/>
+                <a16:creationId xmlns:a16="http://schemas.microsoft.com/office/drawing/2014/main" id="{3E626EEF-495B-4151-861F-79A8CCC9D07C}"/>
               </a:ext>
             </a:extLst>
           </p:cNvPr>
@@ -7950,7 +8106,7 @@
           <p:cNvPr id="4" name="">
             <a:extLst xmlns:a="http://schemas.openxmlformats.org/drawingml/2006/main">
               <a:ext uri="{FF2B5EF4-FFF2-40B4-BE49-F238E27FC236}">
-                <a16:creationId xmlns:a16="http://schemas.microsoft.com/office/drawing/2014/main" id="{63866FA4-222B-4577-BE67-D9FD305CB319}"/>
+                <a16:creationId xmlns:a16="http://schemas.microsoft.com/office/drawing/2014/main" id="{066D2757-FE95-41D1-BB49-43CCF0EAAAB9}"/>
               </a:ext>
             </a:extLst>
           </p:cNvPr>
@@ -8106,7 +8262,7 @@
           <p:cNvPr id="5" name="">
             <a:extLst xmlns:a="http://schemas.openxmlformats.org/drawingml/2006/main">
               <a:ext uri="{FF2B5EF4-FFF2-40B4-BE49-F238E27FC236}">
-                <a16:creationId xmlns:a16="http://schemas.microsoft.com/office/drawing/2014/main" id="{05D5946A-5C4F-48F1-866D-ADA0F4A8E107}"/>
+                <a16:creationId xmlns:a16="http://schemas.microsoft.com/office/drawing/2014/main" id="{368AB821-ECC6-43F4-AFDA-2B1DBF03C383}"/>
               </a:ext>
             </a:extLst>
           </p:cNvPr>
@@ -8116,7 +8272,7 @@
           <p:nvPr/>
         </p:nvPicPr>
         <p:blipFill>
-          <a:blip xmlns:r="http://schemas.openxmlformats.org/officeDocument/2006/relationships" xmlns:a="http://schemas.openxmlformats.org/drawingml/2006/main" r:embed="R94e0ddc303834086"/>
+          <a:blip xmlns:r="http://schemas.openxmlformats.org/officeDocument/2006/relationships" xmlns:a="http://schemas.openxmlformats.org/drawingml/2006/main" r:embed="R0f350274565b4163"/>
           <a:stretch xmlns:a="http://schemas.openxmlformats.org/drawingml/2006/main"/>
         </p:blipFill>
         <p:spPr>
@@ -8134,7 +8290,7 @@
           <p:cNvPr id="6" name="">
             <a:extLst xmlns:a="http://schemas.openxmlformats.org/drawingml/2006/main">
               <a:ext uri="{FF2B5EF4-FFF2-40B4-BE49-F238E27FC236}">
-                <a16:creationId xmlns:a16="http://schemas.microsoft.com/office/drawing/2014/main" id="{A923C036-FBA9-46C0-839C-D74DD7DDCF72}"/>
+                <a16:creationId xmlns:a16="http://schemas.microsoft.com/office/drawing/2014/main" id="{67AFBC86-5A90-4C22-A33A-49FB8614CAF6}"/>
               </a:ext>
             </a:extLst>
           </p:cNvPr>
@@ -8288,7 +8444,7 @@
     </p:spTree>
     <p:extLst>
       <p:ext uri="{BB962C8B-B14F-4D97-AF65-F5344CB8AC3E}">
-        <p14:creationId xmlns:p14="http://schemas.microsoft.com/office/powerpoint/2010/main" val="358444746"/>
+        <p14:creationId xmlns:p14="http://schemas.microsoft.com/office/powerpoint/2010/main" val="1174259185"/>
       </p:ext>
     </p:extLst>
   </p:cSld>
@@ -8319,7 +8475,7 @@
           <p:cNvPr id="7" name="">
             <a:extLst xmlns:a="http://schemas.openxmlformats.org/drawingml/2006/main">
               <a:ext uri="{FF2B5EF4-FFF2-40B4-BE49-F238E27FC236}">
-                <a16:creationId xmlns:a16="http://schemas.microsoft.com/office/drawing/2014/main" id="{FE779BD9-30A2-480B-AB18-2AAF0EBA044B}"/>
+                <a16:creationId xmlns:a16="http://schemas.microsoft.com/office/drawing/2014/main" id="{74C7689C-E771-427C-AB16-CA931AD5E976}"/>
               </a:ext>
             </a:extLst>
           </p:cNvPr>
@@ -8475,7 +8631,7 @@
           <p:cNvPr id="2" name="">
             <a:extLst xmlns:a="http://schemas.openxmlformats.org/drawingml/2006/main">
               <a:ext uri="{FF2B5EF4-FFF2-40B4-BE49-F238E27FC236}">
-                <a16:creationId xmlns:a16="http://schemas.microsoft.com/office/drawing/2014/main" id="{3C032BBE-F431-47F5-93E1-68078EFDE837}"/>
+                <a16:creationId xmlns:a16="http://schemas.microsoft.com/office/drawing/2014/main" id="{AC8F54BB-E4FC-408A-B371-9E56DDB67F76}"/>
               </a:ext>
             </a:extLst>
           </p:cNvPr>
@@ -8631,7 +8787,7 @@
           <p:cNvPr id="3" name="">
             <a:extLst xmlns:a="http://schemas.openxmlformats.org/drawingml/2006/main">
               <a:ext uri="{FF2B5EF4-FFF2-40B4-BE49-F238E27FC236}">
-                <a16:creationId xmlns:a16="http://schemas.microsoft.com/office/drawing/2014/main" id="{824AB7A5-E5D1-4F05-B003-4E96DE026BF7}"/>
+                <a16:creationId xmlns:a16="http://schemas.microsoft.com/office/drawing/2014/main" id="{BC223FD8-AF40-4847-BB10-B949FA6CA073}"/>
               </a:ext>
             </a:extLst>
           </p:cNvPr>
@@ -8771,7 +8927,7 @@
           <p:cNvPr id="4" name="">
             <a:extLst xmlns:a="http://schemas.openxmlformats.org/drawingml/2006/main">
               <a:ext uri="{FF2B5EF4-FFF2-40B4-BE49-F238E27FC236}">
-                <a16:creationId xmlns:a16="http://schemas.microsoft.com/office/drawing/2014/main" id="{ED892D8A-F08E-4B31-8396-DD66B7CF7956}"/>
+                <a16:creationId xmlns:a16="http://schemas.microsoft.com/office/drawing/2014/main" id="{ACC1B457-8AAF-48E9-9D41-E065AA6A3FAA}"/>
               </a:ext>
             </a:extLst>
           </p:cNvPr>
@@ -8927,7 +9083,7 @@
           <p:cNvPr id="5" name="">
             <a:extLst xmlns:a="http://schemas.openxmlformats.org/drawingml/2006/main">
               <a:ext uri="{FF2B5EF4-FFF2-40B4-BE49-F238E27FC236}">
-                <a16:creationId xmlns:a16="http://schemas.microsoft.com/office/drawing/2014/main" id="{E963A6F9-7F3F-40F7-A7D9-E907B4ED9DF2}"/>
+                <a16:creationId xmlns:a16="http://schemas.microsoft.com/office/drawing/2014/main" id="{5EDC418B-F592-49E1-9458-26BBD969F0E9}"/>
               </a:ext>
             </a:extLst>
           </p:cNvPr>
@@ -8937,7 +9093,7 @@
           <p:nvPr/>
         </p:nvPicPr>
         <p:blipFill>
-          <a:blip xmlns:r="http://schemas.openxmlformats.org/officeDocument/2006/relationships" xmlns:a="http://schemas.openxmlformats.org/drawingml/2006/main" r:embed="Rf163c8ed802b46e3"/>
+          <a:blip xmlns:r="http://schemas.openxmlformats.org/officeDocument/2006/relationships" xmlns:a="http://schemas.openxmlformats.org/drawingml/2006/main" r:embed="R00406ce12d894412"/>
           <a:stretch xmlns:a="http://schemas.openxmlformats.org/drawingml/2006/main"/>
         </p:blipFill>
         <p:spPr>
@@ -8955,7 +9111,7 @@
           <p:cNvPr id="6" name="">
             <a:extLst xmlns:a="http://schemas.openxmlformats.org/drawingml/2006/main">
               <a:ext uri="{FF2B5EF4-FFF2-40B4-BE49-F238E27FC236}">
-                <a16:creationId xmlns:a16="http://schemas.microsoft.com/office/drawing/2014/main" id="{62C4892B-E4C2-4F15-901D-80C25C761E82}"/>
+                <a16:creationId xmlns:a16="http://schemas.microsoft.com/office/drawing/2014/main" id="{BEB242CC-69F9-4CE5-A76D-0CFAC6893FD8}"/>
               </a:ext>
             </a:extLst>
           </p:cNvPr>
@@ -9234,7 +9390,7 @@
     </p:spTree>
     <p:extLst>
       <p:ext uri="{BB962C8B-B14F-4D97-AF65-F5344CB8AC3E}">
-        <p14:creationId xmlns:p14="http://schemas.microsoft.com/office/powerpoint/2010/main" val="1289259328"/>
+        <p14:creationId xmlns:p14="http://schemas.microsoft.com/office/powerpoint/2010/main" val="1920510674"/>
       </p:ext>
     </p:extLst>
   </p:cSld>
@@ -9265,7 +9421,7 @@
           <p:cNvPr id="7" name="">
             <a:extLst xmlns:a="http://schemas.openxmlformats.org/drawingml/2006/main">
               <a:ext uri="{FF2B5EF4-FFF2-40B4-BE49-F238E27FC236}">
-                <a16:creationId xmlns:a16="http://schemas.microsoft.com/office/drawing/2014/main" id="{49701FA1-B8C1-4D24-8BBF-A0BBF7E723D7}"/>
+                <a16:creationId xmlns:a16="http://schemas.microsoft.com/office/drawing/2014/main" id="{37958FF6-6B8E-4717-88F8-572F75A707A0}"/>
               </a:ext>
             </a:extLst>
           </p:cNvPr>
@@ -9421,7 +9577,7 @@
           <p:cNvPr id="2" name="">
             <a:extLst xmlns:a="http://schemas.openxmlformats.org/drawingml/2006/main">
               <a:ext uri="{FF2B5EF4-FFF2-40B4-BE49-F238E27FC236}">
-                <a16:creationId xmlns:a16="http://schemas.microsoft.com/office/drawing/2014/main" id="{13F4193B-D201-426B-BBA6-94A63C21B572}"/>
+                <a16:creationId xmlns:a16="http://schemas.microsoft.com/office/drawing/2014/main" id="{38D07E64-5A75-470D-9291-0698D63D8C49}"/>
               </a:ext>
             </a:extLst>
           </p:cNvPr>
@@ -9577,7 +9733,7 @@
           <p:cNvPr id="3" name="">
             <a:extLst xmlns:a="http://schemas.openxmlformats.org/drawingml/2006/main">
               <a:ext uri="{FF2B5EF4-FFF2-40B4-BE49-F238E27FC236}">
-                <a16:creationId xmlns:a16="http://schemas.microsoft.com/office/drawing/2014/main" id="{92E892A2-66D3-4098-8A4B-B213BED147ED}"/>
+                <a16:creationId xmlns:a16="http://schemas.microsoft.com/office/drawing/2014/main" id="{11EF62E6-1287-4D5C-9866-159839AE4AA0}"/>
               </a:ext>
             </a:extLst>
           </p:cNvPr>
@@ -9717,7 +9873,7 @@
           <p:cNvPr id="4" name="">
             <a:extLst xmlns:a="http://schemas.openxmlformats.org/drawingml/2006/main">
               <a:ext uri="{FF2B5EF4-FFF2-40B4-BE49-F238E27FC236}">
-                <a16:creationId xmlns:a16="http://schemas.microsoft.com/office/drawing/2014/main" id="{96A4C51B-EB92-438E-A12D-1CF05E3263CB}"/>
+                <a16:creationId xmlns:a16="http://schemas.microsoft.com/office/drawing/2014/main" id="{DA61AC3B-95D4-4B58-BE8F-FCD2B5FB0C6D}"/>
               </a:ext>
             </a:extLst>
           </p:cNvPr>
@@ -9873,7 +10029,7 @@
           <p:cNvPr id="5" name="">
             <a:extLst xmlns:a="http://schemas.openxmlformats.org/drawingml/2006/main">
               <a:ext uri="{FF2B5EF4-FFF2-40B4-BE49-F238E27FC236}">
-                <a16:creationId xmlns:a16="http://schemas.microsoft.com/office/drawing/2014/main" id="{05C71995-A476-4BC7-9EC0-05A75284DAF6}"/>
+                <a16:creationId xmlns:a16="http://schemas.microsoft.com/office/drawing/2014/main" id="{FD596495-B16A-48F9-8EB3-55FE01CE4FB3}"/>
               </a:ext>
             </a:extLst>
           </p:cNvPr>
@@ -9883,7 +10039,7 @@
           <p:nvPr/>
         </p:nvPicPr>
         <p:blipFill>
-          <a:blip xmlns:r="http://schemas.openxmlformats.org/officeDocument/2006/relationships" xmlns:a="http://schemas.openxmlformats.org/drawingml/2006/main" r:embed="Rd82131e3b4394cc4"/>
+          <a:blip xmlns:r="http://schemas.openxmlformats.org/officeDocument/2006/relationships" xmlns:a="http://schemas.openxmlformats.org/drawingml/2006/main" r:embed="R2632df1f2ce94543"/>
           <a:stretch xmlns:a="http://schemas.openxmlformats.org/drawingml/2006/main"/>
         </p:blipFill>
         <p:spPr>
@@ -9901,7 +10057,7 @@
           <p:cNvPr id="6" name="">
             <a:extLst xmlns:a="http://schemas.openxmlformats.org/drawingml/2006/main">
               <a:ext uri="{FF2B5EF4-FFF2-40B4-BE49-F238E27FC236}">
-                <a16:creationId xmlns:a16="http://schemas.microsoft.com/office/drawing/2014/main" id="{81C22002-0C4D-4EC0-BB3F-FD2D2A752483}"/>
+                <a16:creationId xmlns:a16="http://schemas.microsoft.com/office/drawing/2014/main" id="{202BE011-9BE4-46D2-AA0D-1133DE62BDD8}"/>
               </a:ext>
             </a:extLst>
           </p:cNvPr>
@@ -10162,7 +10318,7 @@
     </p:spTree>
     <p:extLst>
       <p:ext uri="{BB962C8B-B14F-4D97-AF65-F5344CB8AC3E}">
-        <p14:creationId xmlns:p14="http://schemas.microsoft.com/office/powerpoint/2010/main" val="311125909"/>
+        <p14:creationId xmlns:p14="http://schemas.microsoft.com/office/powerpoint/2010/main" val="1836460725"/>
       </p:ext>
     </p:extLst>
   </p:cSld>
@@ -10193,7 +10349,7 @@
           <p:cNvPr id="6" name="">
             <a:extLst xmlns:a="http://schemas.openxmlformats.org/drawingml/2006/main">
               <a:ext uri="{FF2B5EF4-FFF2-40B4-BE49-F238E27FC236}">
-                <a16:creationId xmlns:a16="http://schemas.microsoft.com/office/drawing/2014/main" id="{45D04B8C-F573-4902-9D0C-B1C4B44C91F4}"/>
+                <a16:creationId xmlns:a16="http://schemas.microsoft.com/office/drawing/2014/main" id="{394770E0-E392-4B70-8159-2AEF404DC8B3}"/>
               </a:ext>
             </a:extLst>
           </p:cNvPr>
@@ -10349,7 +10505,7 @@
           <p:cNvPr id="2" name="">
             <a:extLst xmlns:a="http://schemas.openxmlformats.org/drawingml/2006/main">
               <a:ext uri="{FF2B5EF4-FFF2-40B4-BE49-F238E27FC236}">
-                <a16:creationId xmlns:a16="http://schemas.microsoft.com/office/drawing/2014/main" id="{7311E032-4B07-4701-83ED-F93A2AE60BEE}"/>
+                <a16:creationId xmlns:a16="http://schemas.microsoft.com/office/drawing/2014/main" id="{0591F24A-0A55-414C-AC0B-ECA93999A82F}"/>
               </a:ext>
             </a:extLst>
           </p:cNvPr>
@@ -10505,7 +10661,7 @@
           <p:cNvPr id="3" name="">
             <a:extLst xmlns:a="http://schemas.openxmlformats.org/drawingml/2006/main">
               <a:ext uri="{FF2B5EF4-FFF2-40B4-BE49-F238E27FC236}">
-                <a16:creationId xmlns:a16="http://schemas.microsoft.com/office/drawing/2014/main" id="{A3472F9C-5D75-43A1-A2A5-A79D7B9C630F}"/>
+                <a16:creationId xmlns:a16="http://schemas.microsoft.com/office/drawing/2014/main" id="{5B6EE5F0-A804-4034-8E20-D0752BF4B404}"/>
               </a:ext>
             </a:extLst>
           </p:cNvPr>
@@ -10645,7 +10801,7 @@
           <p:cNvPr id="4" name="">
             <a:extLst xmlns:a="http://schemas.openxmlformats.org/drawingml/2006/main">
               <a:ext uri="{FF2B5EF4-FFF2-40B4-BE49-F238E27FC236}">
-                <a16:creationId xmlns:a16="http://schemas.microsoft.com/office/drawing/2014/main" id="{C5464AD3-F13E-4CB4-9B5E-4087A23309EC}"/>
+                <a16:creationId xmlns:a16="http://schemas.microsoft.com/office/drawing/2014/main" id="{164B7057-3B78-42A3-A57E-C420D9F94BC4}"/>
               </a:ext>
             </a:extLst>
           </p:cNvPr>
@@ -10801,7 +10957,7 @@
           <p:cNvPr id="5" name="">
             <a:extLst xmlns:a="http://schemas.openxmlformats.org/drawingml/2006/main">
               <a:ext uri="{FF2B5EF4-FFF2-40B4-BE49-F238E27FC236}">
-                <a16:creationId xmlns:a16="http://schemas.microsoft.com/office/drawing/2014/main" id="{ECD16480-D6E7-4872-A929-00E19D26774B}"/>
+                <a16:creationId xmlns:a16="http://schemas.microsoft.com/office/drawing/2014/main" id="{02071F37-9449-46AD-A4B8-BCAA1D18C5B5}"/>
               </a:ext>
             </a:extLst>
           </p:cNvPr>
@@ -11062,7 +11218,7 @@
     </p:spTree>
     <p:extLst>
       <p:ext uri="{BB962C8B-B14F-4D97-AF65-F5344CB8AC3E}">
-        <p14:creationId xmlns:p14="http://schemas.microsoft.com/office/powerpoint/2010/main" val="179389609"/>
+        <p14:creationId xmlns:p14="http://schemas.microsoft.com/office/powerpoint/2010/main" val="2107189956"/>
       </p:ext>
     </p:extLst>
   </p:cSld>
@@ -11093,7 +11249,7 @@
           <p:cNvPr id="6" name="">
             <a:extLst xmlns:a="http://schemas.openxmlformats.org/drawingml/2006/main">
               <a:ext uri="{FF2B5EF4-FFF2-40B4-BE49-F238E27FC236}">
-                <a16:creationId xmlns:a16="http://schemas.microsoft.com/office/drawing/2014/main" id="{BDCB4011-4990-4831-BA3C-ED829601653B}"/>
+                <a16:creationId xmlns:a16="http://schemas.microsoft.com/office/drawing/2014/main" id="{9AEFBEF6-1BD5-4808-94CC-84F5AD029682}"/>
               </a:ext>
             </a:extLst>
           </p:cNvPr>
@@ -11249,7 +11405,7 @@
           <p:cNvPr id="2" name="">
             <a:extLst xmlns:a="http://schemas.openxmlformats.org/drawingml/2006/main">
               <a:ext uri="{FF2B5EF4-FFF2-40B4-BE49-F238E27FC236}">
-                <a16:creationId xmlns:a16="http://schemas.microsoft.com/office/drawing/2014/main" id="{233898C8-8440-47CD-9A4A-4570449AD302}"/>
+                <a16:creationId xmlns:a16="http://schemas.microsoft.com/office/drawing/2014/main" id="{2CA44939-B7A4-42B3-A248-C5F1F35A5E83}"/>
               </a:ext>
             </a:extLst>
           </p:cNvPr>
@@ -11405,7 +11561,7 @@
           <p:cNvPr id="3" name="">
             <a:extLst xmlns:a="http://schemas.openxmlformats.org/drawingml/2006/main">
               <a:ext uri="{FF2B5EF4-FFF2-40B4-BE49-F238E27FC236}">
-                <a16:creationId xmlns:a16="http://schemas.microsoft.com/office/drawing/2014/main" id="{3DDCD4F3-42A6-4270-B0D7-4D7150DD2ABC}"/>
+                <a16:creationId xmlns:a16="http://schemas.microsoft.com/office/drawing/2014/main" id="{7362BCB4-50D4-4D0F-89F4-7764A26489C4}"/>
               </a:ext>
             </a:extLst>
           </p:cNvPr>
@@ -11545,7 +11701,7 @@
           <p:cNvPr id="4" name="">
             <a:extLst xmlns:a="http://schemas.openxmlformats.org/drawingml/2006/main">
               <a:ext uri="{FF2B5EF4-FFF2-40B4-BE49-F238E27FC236}">
-                <a16:creationId xmlns:a16="http://schemas.microsoft.com/office/drawing/2014/main" id="{9E766FE5-3C81-4E11-89E8-115E2AC11A03}"/>
+                <a16:creationId xmlns:a16="http://schemas.microsoft.com/office/drawing/2014/main" id="{8015DA1D-9A99-4EEA-B75A-7F0F6296C866}"/>
               </a:ext>
             </a:extLst>
           </p:cNvPr>
@@ -11701,7 +11857,7 @@
           <p:cNvPr id="5" name="">
             <a:extLst xmlns:a="http://schemas.openxmlformats.org/drawingml/2006/main">
               <a:ext uri="{FF2B5EF4-FFF2-40B4-BE49-F238E27FC236}">
-                <a16:creationId xmlns:a16="http://schemas.microsoft.com/office/drawing/2014/main" id="{2524FCE9-34DB-497C-8085-1886CB50D788}"/>
+                <a16:creationId xmlns:a16="http://schemas.microsoft.com/office/drawing/2014/main" id="{6750DB1C-4CF3-4507-A2E2-4ECD9A222354}"/>
               </a:ext>
             </a:extLst>
           </p:cNvPr>
@@ -11911,7 +12067,7 @@
     </p:spTree>
     <p:extLst>
       <p:ext uri="{BB962C8B-B14F-4D97-AF65-F5344CB8AC3E}">
-        <p14:creationId xmlns:p14="http://schemas.microsoft.com/office/powerpoint/2010/main" val="1221615907"/>
+        <p14:creationId xmlns:p14="http://schemas.microsoft.com/office/powerpoint/2010/main" val="876039227"/>
       </p:ext>
     </p:extLst>
   </p:cSld>
@@ -11942,7 +12098,7 @@
           <p:cNvPr id="6" name="">
             <a:extLst xmlns:a="http://schemas.openxmlformats.org/drawingml/2006/main">
               <a:ext uri="{FF2B5EF4-FFF2-40B4-BE49-F238E27FC236}">
-                <a16:creationId xmlns:a16="http://schemas.microsoft.com/office/drawing/2014/main" id="{A2AF1636-2DEF-4A95-AB3D-DCC7BD737B48}"/>
+                <a16:creationId xmlns:a16="http://schemas.microsoft.com/office/drawing/2014/main" id="{6B9278A1-6D8B-46C8-B4CA-F7842ED6FAD6}"/>
               </a:ext>
             </a:extLst>
           </p:cNvPr>
@@ -12098,7 +12254,7 @@
           <p:cNvPr id="2" name="">
             <a:extLst xmlns:a="http://schemas.openxmlformats.org/drawingml/2006/main">
               <a:ext uri="{FF2B5EF4-FFF2-40B4-BE49-F238E27FC236}">
-                <a16:creationId xmlns:a16="http://schemas.microsoft.com/office/drawing/2014/main" id="{541C21D3-42DF-4579-B9A5-A412294A497B}"/>
+                <a16:creationId xmlns:a16="http://schemas.microsoft.com/office/drawing/2014/main" id="{7894E0BC-A5D4-48E6-973D-7DEC802FB412}"/>
               </a:ext>
             </a:extLst>
           </p:cNvPr>
@@ -12254,7 +12410,7 @@
           <p:cNvPr id="3" name="">
             <a:extLst xmlns:a="http://schemas.openxmlformats.org/drawingml/2006/main">
               <a:ext uri="{FF2B5EF4-FFF2-40B4-BE49-F238E27FC236}">
-                <a16:creationId xmlns:a16="http://schemas.microsoft.com/office/drawing/2014/main" id="{26AE60CE-98CF-4063-975E-B4726565A167}"/>
+                <a16:creationId xmlns:a16="http://schemas.microsoft.com/office/drawing/2014/main" id="{302E0749-2EE6-461F-9F75-FAC7FFEF7529}"/>
               </a:ext>
             </a:extLst>
           </p:cNvPr>
@@ -12394,7 +12550,7 @@
           <p:cNvPr id="4" name="">
             <a:extLst xmlns:a="http://schemas.openxmlformats.org/drawingml/2006/main">
               <a:ext uri="{FF2B5EF4-FFF2-40B4-BE49-F238E27FC236}">
-                <a16:creationId xmlns:a16="http://schemas.microsoft.com/office/drawing/2014/main" id="{D1478558-3E0A-4BF7-B746-68F485E810B4}"/>
+                <a16:creationId xmlns:a16="http://schemas.microsoft.com/office/drawing/2014/main" id="{73E9F655-4397-4CA9-B853-53604538E5B0}"/>
               </a:ext>
             </a:extLst>
           </p:cNvPr>
@@ -12550,7 +12706,7 @@
           <p:cNvPr id="5" name="">
             <a:extLst xmlns:a="http://schemas.openxmlformats.org/drawingml/2006/main">
               <a:ext uri="{FF2B5EF4-FFF2-40B4-BE49-F238E27FC236}">
-                <a16:creationId xmlns:a16="http://schemas.microsoft.com/office/drawing/2014/main" id="{215CDB1B-82CE-4B06-9456-B8F9818A68F5}"/>
+                <a16:creationId xmlns:a16="http://schemas.microsoft.com/office/drawing/2014/main" id="{09148310-3E7E-4DEE-9BA9-C2312973DB0C}"/>
               </a:ext>
             </a:extLst>
           </p:cNvPr>
@@ -12788,7 +12944,7 @@
     </p:spTree>
     <p:extLst>
       <p:ext uri="{BB962C8B-B14F-4D97-AF65-F5344CB8AC3E}">
-        <p14:creationId xmlns:p14="http://schemas.microsoft.com/office/powerpoint/2010/main" val="1319206001"/>
+        <p14:creationId xmlns:p14="http://schemas.microsoft.com/office/powerpoint/2010/main" val="1161111645"/>
       </p:ext>
     </p:extLst>
   </p:cSld>
@@ -12819,7 +12975,7 @@
           <p:cNvPr id="6" name="">
             <a:extLst xmlns:a="http://schemas.openxmlformats.org/drawingml/2006/main">
               <a:ext uri="{FF2B5EF4-FFF2-40B4-BE49-F238E27FC236}">
-                <a16:creationId xmlns:a16="http://schemas.microsoft.com/office/drawing/2014/main" id="{E7112968-693B-42ED-AADD-01618C4EB5E8}"/>
+                <a16:creationId xmlns:a16="http://schemas.microsoft.com/office/drawing/2014/main" id="{3548A522-EB92-4ABD-84AF-CF219263F2A1}"/>
               </a:ext>
             </a:extLst>
           </p:cNvPr>
@@ -12975,7 +13131,7 @@
           <p:cNvPr id="2" name="">
             <a:extLst xmlns:a="http://schemas.openxmlformats.org/drawingml/2006/main">
               <a:ext uri="{FF2B5EF4-FFF2-40B4-BE49-F238E27FC236}">
-                <a16:creationId xmlns:a16="http://schemas.microsoft.com/office/drawing/2014/main" id="{6A95E635-C903-45AB-9B83-F165377F81A6}"/>
+                <a16:creationId xmlns:a16="http://schemas.microsoft.com/office/drawing/2014/main" id="{04D1ED3D-7766-4C76-A0C1-F294A6F47D66}"/>
               </a:ext>
             </a:extLst>
           </p:cNvPr>
@@ -13131,7 +13287,7 @@
           <p:cNvPr id="3" name="">
             <a:extLst xmlns:a="http://schemas.openxmlformats.org/drawingml/2006/main">
               <a:ext uri="{FF2B5EF4-FFF2-40B4-BE49-F238E27FC236}">
-                <a16:creationId xmlns:a16="http://schemas.microsoft.com/office/drawing/2014/main" id="{9992A598-B3DA-4BAA-B8BA-553A6ACD320D}"/>
+                <a16:creationId xmlns:a16="http://schemas.microsoft.com/office/drawing/2014/main" id="{1792A1FE-8B07-4CF8-92F4-FB9AFBBC4B90}"/>
               </a:ext>
             </a:extLst>
           </p:cNvPr>
@@ -13271,7 +13427,7 @@
           <p:cNvPr id="4" name="">
             <a:extLst xmlns:a="http://schemas.openxmlformats.org/drawingml/2006/main">
               <a:ext uri="{FF2B5EF4-FFF2-40B4-BE49-F238E27FC236}">
-                <a16:creationId xmlns:a16="http://schemas.microsoft.com/office/drawing/2014/main" id="{ABA28CE7-9D3A-47B4-BDC6-1178461E83FF}"/>
+                <a16:creationId xmlns:a16="http://schemas.microsoft.com/office/drawing/2014/main" id="{B77F4EB7-7118-4366-AACA-1A489EE0351C}"/>
               </a:ext>
             </a:extLst>
           </p:cNvPr>
@@ -13427,7 +13583,7 @@
           <p:cNvPr id="5" name="">
             <a:extLst xmlns:a="http://schemas.openxmlformats.org/drawingml/2006/main">
               <a:ext uri="{FF2B5EF4-FFF2-40B4-BE49-F238E27FC236}">
-                <a16:creationId xmlns:a16="http://schemas.microsoft.com/office/drawing/2014/main" id="{2767034F-A94C-469B-9C03-04304B99086F}"/>
+                <a16:creationId xmlns:a16="http://schemas.microsoft.com/office/drawing/2014/main" id="{47FBF774-2021-4492-AC46-6DD9950D2595}"/>
               </a:ext>
             </a:extLst>
           </p:cNvPr>
@@ -13665,7 +13821,7 @@
     </p:spTree>
     <p:extLst>
       <p:ext uri="{BB962C8B-B14F-4D97-AF65-F5344CB8AC3E}">
-        <p14:creationId xmlns:p14="http://schemas.microsoft.com/office/powerpoint/2010/main" val="850850153"/>
+        <p14:creationId xmlns:p14="http://schemas.microsoft.com/office/powerpoint/2010/main" val="1443130701"/>
       </p:ext>
     </p:extLst>
   </p:cSld>
@@ -13696,7 +13852,7 @@
           <p:cNvPr id="6" name="">
             <a:extLst xmlns:a="http://schemas.openxmlformats.org/drawingml/2006/main">
               <a:ext uri="{FF2B5EF4-FFF2-40B4-BE49-F238E27FC236}">
-                <a16:creationId xmlns:a16="http://schemas.microsoft.com/office/drawing/2014/main" id="{CD0361F4-467A-468F-8B11-1F7F9A736243}"/>
+                <a16:creationId xmlns:a16="http://schemas.microsoft.com/office/drawing/2014/main" id="{F8F15FFE-1BF4-45E5-BC13-D255955BB97B}"/>
               </a:ext>
             </a:extLst>
           </p:cNvPr>
@@ -13852,7 +14008,7 @@
           <p:cNvPr id="2" name="">
             <a:extLst xmlns:a="http://schemas.openxmlformats.org/drawingml/2006/main">
               <a:ext uri="{FF2B5EF4-FFF2-40B4-BE49-F238E27FC236}">
-                <a16:creationId xmlns:a16="http://schemas.microsoft.com/office/drawing/2014/main" id="{B879A888-0A12-438D-8C8D-0C7E66104CCB}"/>
+                <a16:creationId xmlns:a16="http://schemas.microsoft.com/office/drawing/2014/main" id="{0FBD71FD-A463-4B3A-86BF-5FA6195C35A9}"/>
               </a:ext>
             </a:extLst>
           </p:cNvPr>
@@ -14008,7 +14164,7 @@
           <p:cNvPr id="3" name="">
             <a:extLst xmlns:a="http://schemas.openxmlformats.org/drawingml/2006/main">
               <a:ext uri="{FF2B5EF4-FFF2-40B4-BE49-F238E27FC236}">
-                <a16:creationId xmlns:a16="http://schemas.microsoft.com/office/drawing/2014/main" id="{ECE51C5E-438A-4D3E-9B40-ABF998600E94}"/>
+                <a16:creationId xmlns:a16="http://schemas.microsoft.com/office/drawing/2014/main" id="{DD8582CA-2573-4581-93F4-FB0247ADD90B}"/>
               </a:ext>
             </a:extLst>
           </p:cNvPr>
@@ -14148,7 +14304,7 @@
           <p:cNvPr id="4" name="">
             <a:extLst xmlns:a="http://schemas.openxmlformats.org/drawingml/2006/main">
               <a:ext uri="{FF2B5EF4-FFF2-40B4-BE49-F238E27FC236}">
-                <a16:creationId xmlns:a16="http://schemas.microsoft.com/office/drawing/2014/main" id="{FDD6BE16-495C-4540-8AF0-E9C55C4E9E30}"/>
+                <a16:creationId xmlns:a16="http://schemas.microsoft.com/office/drawing/2014/main" id="{F162832D-D857-41DB-BE39-1942789B59D1}"/>
               </a:ext>
             </a:extLst>
           </p:cNvPr>
@@ -14304,7 +14460,7 @@
           <p:cNvPr id="5" name="">
             <a:extLst xmlns:a="http://schemas.openxmlformats.org/drawingml/2006/main">
               <a:ext uri="{FF2B5EF4-FFF2-40B4-BE49-F238E27FC236}">
-                <a16:creationId xmlns:a16="http://schemas.microsoft.com/office/drawing/2014/main" id="{EECD4BE8-5E8C-4E8E-A36C-BE6B2109FD3E}"/>
+                <a16:creationId xmlns:a16="http://schemas.microsoft.com/office/drawing/2014/main" id="{EFADEAE3-045C-4B79-BF0A-85E7567EF51A}"/>
               </a:ext>
             </a:extLst>
           </p:cNvPr>
@@ -14560,7 +14716,7 @@
     </p:spTree>
     <p:extLst>
       <p:ext uri="{BB962C8B-B14F-4D97-AF65-F5344CB8AC3E}">
-        <p14:creationId xmlns:p14="http://schemas.microsoft.com/office/powerpoint/2010/main" val="454276045"/>
+        <p14:creationId xmlns:p14="http://schemas.microsoft.com/office/powerpoint/2010/main" val="1114576802"/>
       </p:ext>
     </p:extLst>
   </p:cSld>
@@ -14591,7 +14747,7 @@
           <p:cNvPr id="6" name="">
             <a:extLst xmlns:a="http://schemas.openxmlformats.org/drawingml/2006/main">
               <a:ext uri="{FF2B5EF4-FFF2-40B4-BE49-F238E27FC236}">
-                <a16:creationId xmlns:a16="http://schemas.microsoft.com/office/drawing/2014/main" id="{7CBBD79C-5F11-448C-B37F-3F2957B45262}"/>
+                <a16:creationId xmlns:a16="http://schemas.microsoft.com/office/drawing/2014/main" id="{58DBAF0F-0D8C-4C9D-B2C1-3C113E6CE038}"/>
               </a:ext>
             </a:extLst>
           </p:cNvPr>
@@ -14747,7 +14903,7 @@
           <p:cNvPr id="2" name="">
             <a:extLst xmlns:a="http://schemas.openxmlformats.org/drawingml/2006/main">
               <a:ext uri="{FF2B5EF4-FFF2-40B4-BE49-F238E27FC236}">
-                <a16:creationId xmlns:a16="http://schemas.microsoft.com/office/drawing/2014/main" id="{86688727-46E5-4ECE-BCFF-A1CBBAC1E9FB}"/>
+                <a16:creationId xmlns:a16="http://schemas.microsoft.com/office/drawing/2014/main" id="{B5B82BD9-2E26-4B3D-9937-CE303D8310C4}"/>
               </a:ext>
             </a:extLst>
           </p:cNvPr>
@@ -14903,7 +15059,7 @@
           <p:cNvPr id="3" name="">
             <a:extLst xmlns:a="http://schemas.openxmlformats.org/drawingml/2006/main">
               <a:ext uri="{FF2B5EF4-FFF2-40B4-BE49-F238E27FC236}">
-                <a16:creationId xmlns:a16="http://schemas.microsoft.com/office/drawing/2014/main" id="{D0A5274D-58F7-4E42-9C34-985892B68552}"/>
+                <a16:creationId xmlns:a16="http://schemas.microsoft.com/office/drawing/2014/main" id="{2C93E257-0C71-4C76-9C70-55A574D91A8B}"/>
               </a:ext>
             </a:extLst>
           </p:cNvPr>
@@ -15043,7 +15199,7 @@
           <p:cNvPr id="4" name="">
             <a:extLst xmlns:a="http://schemas.openxmlformats.org/drawingml/2006/main">
               <a:ext uri="{FF2B5EF4-FFF2-40B4-BE49-F238E27FC236}">
-                <a16:creationId xmlns:a16="http://schemas.microsoft.com/office/drawing/2014/main" id="{F17B9F92-926F-43CB-94C2-FDA3546CBA7E}"/>
+                <a16:creationId xmlns:a16="http://schemas.microsoft.com/office/drawing/2014/main" id="{9421B4F3-8105-43DC-AD0E-345C6E2FED9A}"/>
               </a:ext>
             </a:extLst>
           </p:cNvPr>
@@ -15199,7 +15355,7 @@
           <p:cNvPr id="5" name="">
             <a:extLst xmlns:a="http://schemas.openxmlformats.org/drawingml/2006/main">
               <a:ext uri="{FF2B5EF4-FFF2-40B4-BE49-F238E27FC236}">
-                <a16:creationId xmlns:a16="http://schemas.microsoft.com/office/drawing/2014/main" id="{328EA075-9795-4EDA-A6F8-ECF7B94F2C36}"/>
+                <a16:creationId xmlns:a16="http://schemas.microsoft.com/office/drawing/2014/main" id="{2D96B135-BEF8-45D4-9300-62CFBA0E90D3}"/>
               </a:ext>
             </a:extLst>
           </p:cNvPr>
@@ -15437,7 +15593,7 @@
     </p:spTree>
     <p:extLst>
       <p:ext uri="{BB962C8B-B14F-4D97-AF65-F5344CB8AC3E}">
-        <p14:creationId xmlns:p14="http://schemas.microsoft.com/office/powerpoint/2010/main" val="849212214"/>
+        <p14:creationId xmlns:p14="http://schemas.microsoft.com/office/powerpoint/2010/main" val="2059823836"/>
       </p:ext>
     </p:extLst>
   </p:cSld>
@@ -15468,7 +15624,7 @@
           <p:cNvPr id="7" name="">
             <a:extLst xmlns:a="http://schemas.openxmlformats.org/drawingml/2006/main">
               <a:ext uri="{FF2B5EF4-FFF2-40B4-BE49-F238E27FC236}">
-                <a16:creationId xmlns:a16="http://schemas.microsoft.com/office/drawing/2014/main" id="{F877CEA6-E33A-4FA0-99FC-3F8016DD3080}"/>
+                <a16:creationId xmlns:a16="http://schemas.microsoft.com/office/drawing/2014/main" id="{215496EA-F9DA-40DE-B20A-6BA88802D7FA}"/>
               </a:ext>
             </a:extLst>
           </p:cNvPr>
@@ -15624,7 +15780,7 @@
           <p:cNvPr id="2" name="">
             <a:extLst xmlns:a="http://schemas.openxmlformats.org/drawingml/2006/main">
               <a:ext uri="{FF2B5EF4-FFF2-40B4-BE49-F238E27FC236}">
-                <a16:creationId xmlns:a16="http://schemas.microsoft.com/office/drawing/2014/main" id="{36C9E2AE-2CD0-45BF-8098-E0286C9D273A}"/>
+                <a16:creationId xmlns:a16="http://schemas.microsoft.com/office/drawing/2014/main" id="{C8B75421-440B-43FF-913E-A5BFBF6BC3C7}"/>
               </a:ext>
             </a:extLst>
           </p:cNvPr>
@@ -15780,7 +15936,7 @@
           <p:cNvPr id="3" name="">
             <a:extLst xmlns:a="http://schemas.openxmlformats.org/drawingml/2006/main">
               <a:ext uri="{FF2B5EF4-FFF2-40B4-BE49-F238E27FC236}">
-                <a16:creationId xmlns:a16="http://schemas.microsoft.com/office/drawing/2014/main" id="{37FC2F7C-AA55-4B57-8945-7E8E0FBEAC96}"/>
+                <a16:creationId xmlns:a16="http://schemas.microsoft.com/office/drawing/2014/main" id="{793A8C15-1A45-47D3-A674-32372EDD73CA}"/>
               </a:ext>
             </a:extLst>
           </p:cNvPr>
@@ -15920,7 +16076,7 @@
           <p:cNvPr id="4" name="">
             <a:extLst xmlns:a="http://schemas.openxmlformats.org/drawingml/2006/main">
               <a:ext uri="{FF2B5EF4-FFF2-40B4-BE49-F238E27FC236}">
-                <a16:creationId xmlns:a16="http://schemas.microsoft.com/office/drawing/2014/main" id="{BA11AE15-EB9A-4C7E-A818-B8DB83B5886E}"/>
+                <a16:creationId xmlns:a16="http://schemas.microsoft.com/office/drawing/2014/main" id="{31E74449-B425-4622-AD97-D8A89BC5E9FF}"/>
               </a:ext>
             </a:extLst>
           </p:cNvPr>
@@ -16076,7 +16232,7 @@
           <p:cNvPr id="5" name="">
             <a:extLst xmlns:a="http://schemas.openxmlformats.org/drawingml/2006/main">
               <a:ext uri="{FF2B5EF4-FFF2-40B4-BE49-F238E27FC236}">
-                <a16:creationId xmlns:a16="http://schemas.microsoft.com/office/drawing/2014/main" id="{8FBCCA47-C7E9-46F5-86E8-76A5889B6719}"/>
+                <a16:creationId xmlns:a16="http://schemas.microsoft.com/office/drawing/2014/main" id="{21CC96FF-B99E-462A-8213-0C36FE4A1492}"/>
               </a:ext>
             </a:extLst>
           </p:cNvPr>
@@ -16086,7 +16242,7 @@
           <p:nvPr/>
         </p:nvPicPr>
         <p:blipFill>
-          <a:blip xmlns:r="http://schemas.openxmlformats.org/officeDocument/2006/relationships" xmlns:a="http://schemas.openxmlformats.org/drawingml/2006/main" r:embed="R30c0c68e859c406e"/>
+          <a:blip xmlns:r="http://schemas.openxmlformats.org/officeDocument/2006/relationships" xmlns:a="http://schemas.openxmlformats.org/drawingml/2006/main" r:embed="R61ec04f4f9e74b85"/>
           <a:stretch xmlns:a="http://schemas.openxmlformats.org/drawingml/2006/main"/>
         </p:blipFill>
         <p:spPr>
@@ -16104,7 +16260,7 @@
           <p:cNvPr id="6" name="">
             <a:extLst xmlns:a="http://schemas.openxmlformats.org/drawingml/2006/main">
               <a:ext uri="{FF2B5EF4-FFF2-40B4-BE49-F238E27FC236}">
-                <a16:creationId xmlns:a16="http://schemas.microsoft.com/office/drawing/2014/main" id="{858CD84A-32E3-47F5-8E31-F9C7AFFABAD5}"/>
+                <a16:creationId xmlns:a16="http://schemas.microsoft.com/office/drawing/2014/main" id="{8D0A602E-ED5C-4F3A-95F6-2CCAF46BB03F}"/>
               </a:ext>
             </a:extLst>
           </p:cNvPr>
@@ -16258,7 +16414,7 @@
     </p:spTree>
     <p:extLst>
       <p:ext uri="{BB962C8B-B14F-4D97-AF65-F5344CB8AC3E}">
-        <p14:creationId xmlns:p14="http://schemas.microsoft.com/office/powerpoint/2010/main" val="912417599"/>
+        <p14:creationId xmlns:p14="http://schemas.microsoft.com/office/powerpoint/2010/main" val="656375871"/>
       </p:ext>
     </p:extLst>
   </p:cSld>
@@ -16289,7 +16445,7 @@
           <p:cNvPr id="7" name="">
             <a:extLst xmlns:a="http://schemas.openxmlformats.org/drawingml/2006/main">
               <a:ext uri="{FF2B5EF4-FFF2-40B4-BE49-F238E27FC236}">
-                <a16:creationId xmlns:a16="http://schemas.microsoft.com/office/drawing/2014/main" id="{7E6D3F42-0A0D-4A88-B8D3-458880A4CD2B}"/>
+                <a16:creationId xmlns:a16="http://schemas.microsoft.com/office/drawing/2014/main" id="{C8F8BC8B-4BE1-4204-B502-8E4F1AD6AF74}"/>
               </a:ext>
             </a:extLst>
           </p:cNvPr>
@@ -16445,7 +16601,7 @@
           <p:cNvPr id="2" name="">
             <a:extLst xmlns:a="http://schemas.openxmlformats.org/drawingml/2006/main">
               <a:ext uri="{FF2B5EF4-FFF2-40B4-BE49-F238E27FC236}">
-                <a16:creationId xmlns:a16="http://schemas.microsoft.com/office/drawing/2014/main" id="{81E0B42F-B925-4C1C-AC44-DEB193EB5566}"/>
+                <a16:creationId xmlns:a16="http://schemas.microsoft.com/office/drawing/2014/main" id="{53BD99A5-0EFB-48B0-85D1-40C74665B789}"/>
               </a:ext>
             </a:extLst>
           </p:cNvPr>
@@ -16601,7 +16757,7 @@
           <p:cNvPr id="3" name="">
             <a:extLst xmlns:a="http://schemas.openxmlformats.org/drawingml/2006/main">
               <a:ext uri="{FF2B5EF4-FFF2-40B4-BE49-F238E27FC236}">
-                <a16:creationId xmlns:a16="http://schemas.microsoft.com/office/drawing/2014/main" id="{9F13FF86-5040-4258-BC37-0102C9CD68B5}"/>
+                <a16:creationId xmlns:a16="http://schemas.microsoft.com/office/drawing/2014/main" id="{3D1EFFC1-86CC-43E0-A024-CA3132A26575}"/>
               </a:ext>
             </a:extLst>
           </p:cNvPr>
@@ -16741,7 +16897,7 @@
           <p:cNvPr id="4" name="">
             <a:extLst xmlns:a="http://schemas.openxmlformats.org/drawingml/2006/main">
               <a:ext uri="{FF2B5EF4-FFF2-40B4-BE49-F238E27FC236}">
-                <a16:creationId xmlns:a16="http://schemas.microsoft.com/office/drawing/2014/main" id="{6FEE7676-AB4A-4C20-BDAE-FB4C1A0879C6}"/>
+                <a16:creationId xmlns:a16="http://schemas.microsoft.com/office/drawing/2014/main" id="{D7EC4771-554A-4161-889C-6266B0F073D7}"/>
               </a:ext>
             </a:extLst>
           </p:cNvPr>
@@ -16897,7 +17053,7 @@
           <p:cNvPr id="5" name="">
             <a:extLst xmlns:a="http://schemas.openxmlformats.org/drawingml/2006/main">
               <a:ext uri="{FF2B5EF4-FFF2-40B4-BE49-F238E27FC236}">
-                <a16:creationId xmlns:a16="http://schemas.microsoft.com/office/drawing/2014/main" id="{2D90B956-BEAA-4CFF-BC76-4464E9992C2A}"/>
+                <a16:creationId xmlns:a16="http://schemas.microsoft.com/office/drawing/2014/main" id="{235421D8-4CBB-4DA8-95E3-627D5A3887EB}"/>
               </a:ext>
             </a:extLst>
           </p:cNvPr>
@@ -16907,7 +17063,7 @@
           <p:nvPr/>
         </p:nvPicPr>
         <p:blipFill>
-          <a:blip xmlns:r="http://schemas.openxmlformats.org/officeDocument/2006/relationships" xmlns:a="http://schemas.openxmlformats.org/drawingml/2006/main" r:embed="R7124597488e0479b"/>
+          <a:blip xmlns:r="http://schemas.openxmlformats.org/officeDocument/2006/relationships" xmlns:a="http://schemas.openxmlformats.org/drawingml/2006/main" r:embed="R8c445ff73a0a45ad"/>
           <a:stretch xmlns:a="http://schemas.openxmlformats.org/drawingml/2006/main"/>
         </p:blipFill>
         <p:spPr>
@@ -16925,7 +17081,7 @@
           <p:cNvPr id="6" name="">
             <a:extLst xmlns:a="http://schemas.openxmlformats.org/drawingml/2006/main">
               <a:ext uri="{FF2B5EF4-FFF2-40B4-BE49-F238E27FC236}">
-                <a16:creationId xmlns:a16="http://schemas.microsoft.com/office/drawing/2014/main" id="{AE13A944-1286-40F5-90DA-A2BD01EDC915}"/>
+                <a16:creationId xmlns:a16="http://schemas.microsoft.com/office/drawing/2014/main" id="{4FCB57F6-A9AB-4A73-8967-B116B18E3388}"/>
               </a:ext>
             </a:extLst>
           </p:cNvPr>
@@ -17079,7 +17235,7 @@
     </p:spTree>
     <p:extLst>
       <p:ext uri="{BB962C8B-B14F-4D97-AF65-F5344CB8AC3E}">
-        <p14:creationId xmlns:p14="http://schemas.microsoft.com/office/powerpoint/2010/main" val="1362424490"/>
+        <p14:creationId xmlns:p14="http://schemas.microsoft.com/office/powerpoint/2010/main" val="818228953"/>
       </p:ext>
     </p:extLst>
   </p:cSld>
@@ -17110,7 +17266,7 @@
           <p:cNvPr id="7" name="">
             <a:extLst xmlns:a="http://schemas.openxmlformats.org/drawingml/2006/main">
               <a:ext uri="{FF2B5EF4-FFF2-40B4-BE49-F238E27FC236}">
-                <a16:creationId xmlns:a16="http://schemas.microsoft.com/office/drawing/2014/main" id="{082A0861-0D50-426C-9CB6-DFB9ED89FAC3}"/>
+                <a16:creationId xmlns:a16="http://schemas.microsoft.com/office/drawing/2014/main" id="{DECAED2C-A2AB-438E-9D5E-59250F1DAC60}"/>
               </a:ext>
             </a:extLst>
           </p:cNvPr>
@@ -17266,7 +17422,7 @@
           <p:cNvPr id="2" name="">
             <a:extLst xmlns:a="http://schemas.openxmlformats.org/drawingml/2006/main">
               <a:ext uri="{FF2B5EF4-FFF2-40B4-BE49-F238E27FC236}">
-                <a16:creationId xmlns:a16="http://schemas.microsoft.com/office/drawing/2014/main" id="{F4E5A618-A0B5-4A5A-99C6-7AF2E80FAE61}"/>
+                <a16:creationId xmlns:a16="http://schemas.microsoft.com/office/drawing/2014/main" id="{A496658C-13FA-43A7-8BD2-B8D46D2EC7AE}"/>
               </a:ext>
             </a:extLst>
           </p:cNvPr>
@@ -17422,7 +17578,7 @@
           <p:cNvPr id="3" name="">
             <a:extLst xmlns:a="http://schemas.openxmlformats.org/drawingml/2006/main">
               <a:ext uri="{FF2B5EF4-FFF2-40B4-BE49-F238E27FC236}">
-                <a16:creationId xmlns:a16="http://schemas.microsoft.com/office/drawing/2014/main" id="{C53D3E02-5C0C-4C34-970C-5A6ED8631C20}"/>
+                <a16:creationId xmlns:a16="http://schemas.microsoft.com/office/drawing/2014/main" id="{4B3E11DE-CDBC-412B-8C39-0021EA4097E0}"/>
               </a:ext>
             </a:extLst>
           </p:cNvPr>
@@ -17562,7 +17718,7 @@
           <p:cNvPr id="4" name="">
             <a:extLst xmlns:a="http://schemas.openxmlformats.org/drawingml/2006/main">
               <a:ext uri="{FF2B5EF4-FFF2-40B4-BE49-F238E27FC236}">
-                <a16:creationId xmlns:a16="http://schemas.microsoft.com/office/drawing/2014/main" id="{5A87DEEB-E314-4CD1-A488-68FF7AC47991}"/>
+                <a16:creationId xmlns:a16="http://schemas.microsoft.com/office/drawing/2014/main" id="{07724C02-EC92-446C-848D-74FD69D64337}"/>
               </a:ext>
             </a:extLst>
           </p:cNvPr>
@@ -17718,7 +17874,7 @@
           <p:cNvPr id="5" name="">
             <a:extLst xmlns:a="http://schemas.openxmlformats.org/drawingml/2006/main">
               <a:ext uri="{FF2B5EF4-FFF2-40B4-BE49-F238E27FC236}">
-                <a16:creationId xmlns:a16="http://schemas.microsoft.com/office/drawing/2014/main" id="{DEDF702F-EEBA-4526-91B5-725BD6F57075}"/>
+                <a16:creationId xmlns:a16="http://schemas.microsoft.com/office/drawing/2014/main" id="{532A01D9-AADF-4619-AAA1-E772B66B09BE}"/>
               </a:ext>
             </a:extLst>
           </p:cNvPr>
@@ -18577,7 +18733,7 @@
           <p:cNvPr id="6" name="">
             <a:extLst xmlns:a="http://schemas.openxmlformats.org/drawingml/2006/main">
               <a:ext uri="{FF2B5EF4-FFF2-40B4-BE49-F238E27FC236}">
-                <a16:creationId xmlns:a16="http://schemas.microsoft.com/office/drawing/2014/main" id="{F1DAD406-7B28-46EB-9E82-F67F98BE6131}"/>
+                <a16:creationId xmlns:a16="http://schemas.microsoft.com/office/drawing/2014/main" id="{FAAE0E1A-FE5B-43D1-A1FB-0084946147A8}"/>
               </a:ext>
             </a:extLst>
           </p:cNvPr>
@@ -18731,7 +18887,7 @@
     </p:spTree>
     <p:extLst>
       <p:ext uri="{BB962C8B-B14F-4D97-AF65-F5344CB8AC3E}">
-        <p14:creationId xmlns:p14="http://schemas.microsoft.com/office/powerpoint/2010/main" val="1547125110"/>
+        <p14:creationId xmlns:p14="http://schemas.microsoft.com/office/powerpoint/2010/main" val="357157380"/>
       </p:ext>
     </p:extLst>
   </p:cSld>

</xml_diff>

<commit_message>
Publish validated repetition and full-process Pin controls with scope caveats
</commit_message>
<xml_diff>
--- a/presentation/CSLab_Memory_Tiering_Current.pptx
+++ b/presentation/CSLab_Memory_Tiering_Current.pptx
@@ -2,27 +2,27 @@
 <file path=ppt/presentation.xml><?xml version="1.0" encoding="utf-8"?>
 <p:presentation xmlns:p="http://schemas.openxmlformats.org/presentationml/2006/main">
   <p:sldMasterIdLst>
-    <p:sldMasterId xmlns:r="http://schemas.openxmlformats.org/officeDocument/2006/relationships" id="2147483648" r:id="Rab38a47395e047ca"/>
+    <p:sldMasterId xmlns:r="http://schemas.openxmlformats.org/officeDocument/2006/relationships" id="2147483648" r:id="Ra76e879b32004879"/>
   </p:sldMasterIdLst>
   <p:notesMasterIdLst>
-    <p:notesMasterId xmlns:r="http://schemas.openxmlformats.org/officeDocument/2006/relationships" r:id="R02203bdf51474d4d"/>
+    <p:notesMasterId xmlns:r="http://schemas.openxmlformats.org/officeDocument/2006/relationships" r:id="Re07bb77973204bbc"/>
   </p:notesMasterIdLst>
   <p:sldIdLst>
-    <p:sldId xmlns:r="http://schemas.openxmlformats.org/officeDocument/2006/relationships" id="256" r:id="Rcf0602cee57c4b19"/>
-    <p:sldId xmlns:r="http://schemas.openxmlformats.org/officeDocument/2006/relationships" id="257" r:id="R86b21dc2e9724d91"/>
-    <p:sldId xmlns:r="http://schemas.openxmlformats.org/officeDocument/2006/relationships" id="258" r:id="R20106bc1b62c4973"/>
-    <p:sldId xmlns:r="http://schemas.openxmlformats.org/officeDocument/2006/relationships" id="259" r:id="R54c768c0baca4073"/>
-    <p:sldId xmlns:r="http://schemas.openxmlformats.org/officeDocument/2006/relationships" id="260" r:id="Rf3363f4e02e44ec0"/>
-    <p:sldId xmlns:r="http://schemas.openxmlformats.org/officeDocument/2006/relationships" id="261" r:id="Rbda6d09871604669"/>
-    <p:sldId xmlns:r="http://schemas.openxmlformats.org/officeDocument/2006/relationships" id="262" r:id="Rc29e6a918cbe4430"/>
-    <p:sldId xmlns:r="http://schemas.openxmlformats.org/officeDocument/2006/relationships" id="263" r:id="R42a22d6bf19e49e2"/>
-    <p:sldId xmlns:r="http://schemas.openxmlformats.org/officeDocument/2006/relationships" id="264" r:id="R9cb6e4ec22754d29"/>
-    <p:sldId xmlns:r="http://schemas.openxmlformats.org/officeDocument/2006/relationships" id="265" r:id="R1b1b2bb8679b4c95"/>
-    <p:sldId xmlns:r="http://schemas.openxmlformats.org/officeDocument/2006/relationships" id="266" r:id="R9d82e14d61554d4e"/>
-    <p:sldId xmlns:r="http://schemas.openxmlformats.org/officeDocument/2006/relationships" id="267" r:id="R2d7d36dd08fd4f3e"/>
-    <p:sldId xmlns:r="http://schemas.openxmlformats.org/officeDocument/2006/relationships" id="268" r:id="R02124d84dfed4125"/>
-    <p:sldId xmlns:r="http://schemas.openxmlformats.org/officeDocument/2006/relationships" id="269" r:id="R2c917f2c7a2340ec"/>
-    <p:sldId xmlns:r="http://schemas.openxmlformats.org/officeDocument/2006/relationships" id="270" r:id="Rebe609b3d679468d"/>
+    <p:sldId xmlns:r="http://schemas.openxmlformats.org/officeDocument/2006/relationships" id="256" r:id="R294fc1741666473a"/>
+    <p:sldId xmlns:r="http://schemas.openxmlformats.org/officeDocument/2006/relationships" id="257" r:id="R697a6e78d9f34638"/>
+    <p:sldId xmlns:r="http://schemas.openxmlformats.org/officeDocument/2006/relationships" id="258" r:id="Rb9ebf81fcb9544b8"/>
+    <p:sldId xmlns:r="http://schemas.openxmlformats.org/officeDocument/2006/relationships" id="259" r:id="Ra41f609870fc4699"/>
+    <p:sldId xmlns:r="http://schemas.openxmlformats.org/officeDocument/2006/relationships" id="260" r:id="R67a2ce6162c04cbe"/>
+    <p:sldId xmlns:r="http://schemas.openxmlformats.org/officeDocument/2006/relationships" id="261" r:id="R4bd6954a63274a7e"/>
+    <p:sldId xmlns:r="http://schemas.openxmlformats.org/officeDocument/2006/relationships" id="262" r:id="R2830f0f9559d43d4"/>
+    <p:sldId xmlns:r="http://schemas.openxmlformats.org/officeDocument/2006/relationships" id="263" r:id="R2348ff224a974a94"/>
+    <p:sldId xmlns:r="http://schemas.openxmlformats.org/officeDocument/2006/relationships" id="264" r:id="R32a3725bb9ae4039"/>
+    <p:sldId xmlns:r="http://schemas.openxmlformats.org/officeDocument/2006/relationships" id="265" r:id="R5c8b270d6d5e429e"/>
+    <p:sldId xmlns:r="http://schemas.openxmlformats.org/officeDocument/2006/relationships" id="266" r:id="R6ca6f6ff392f49dd"/>
+    <p:sldId xmlns:r="http://schemas.openxmlformats.org/officeDocument/2006/relationships" id="267" r:id="Rbf302d2c1e9d4767"/>
+    <p:sldId xmlns:r="http://schemas.openxmlformats.org/officeDocument/2006/relationships" id="268" r:id="R154dcca4b7ef4951"/>
+    <p:sldId xmlns:r="http://schemas.openxmlformats.org/officeDocument/2006/relationships" id="269" r:id="R0072c14ae3c34aa2"/>
+    <p:sldId xmlns:r="http://schemas.openxmlformats.org/officeDocument/2006/relationships" id="270" r:id="Rd5addd45ca394c2e"/>
   </p:sldIdLst>
   <p:sldSz cx="12192000" cy="6858000"/>
   <p:notesSz cx="6858000" cy="9144000"/>
@@ -1633,7 +1633,7 @@
           <p:cNvPr id="3" name="Title">
             <a:extLst xmlns:a="http://schemas.openxmlformats.org/drawingml/2006/main">
               <a:ext uri="{FF2B5EF4-FFF2-40B4-BE49-F238E27FC236}">
-                <a16:creationId xmlns:a16="http://schemas.microsoft.com/office/drawing/2014/main" id="{840CC296-D354-462A-9880-78CC2294AE6F}"/>
+                <a16:creationId xmlns:a16="http://schemas.microsoft.com/office/drawing/2014/main" id="{4FEF78DB-53E4-4C1B-807E-F237C2DC2374}"/>
               </a:ext>
             </a:extLst>
           </p:cNvPr>
@@ -1862,7 +1862,7 @@
           <p:cNvPr id="2" name="Subtitle">
             <a:extLst xmlns:a="http://schemas.openxmlformats.org/drawingml/2006/main">
               <a:ext uri="{FF2B5EF4-FFF2-40B4-BE49-F238E27FC236}">
-                <a16:creationId xmlns:a16="http://schemas.microsoft.com/office/drawing/2014/main" id="{4BD63025-BFD5-4658-80C4-1938EC374998}"/>
+                <a16:creationId xmlns:a16="http://schemas.microsoft.com/office/drawing/2014/main" id="{2857AB86-CAE2-4EA5-8532-78BEA5966ABA}"/>
               </a:ext>
             </a:extLst>
           </p:cNvPr>
@@ -2108,7 +2108,7 @@
           <p:cNvPr id="2" name="Section title">
             <a:extLst xmlns:a="http://schemas.openxmlformats.org/drawingml/2006/main">
               <a:ext uri="{FF2B5EF4-FFF2-40B4-BE49-F238E27FC236}">
-                <a16:creationId xmlns:a16="http://schemas.microsoft.com/office/drawing/2014/main" id="{9EB92CD0-63C8-4C55-B9F6-22CED8E804AB}"/>
+                <a16:creationId xmlns:a16="http://schemas.microsoft.com/office/drawing/2014/main" id="{556DCA83-6637-4F2F-8E08-3D67F24E54B6}"/>
               </a:ext>
             </a:extLst>
           </p:cNvPr>
@@ -2354,7 +2354,7 @@
           <p:cNvPr id="3" name="Title">
             <a:extLst xmlns:a="http://schemas.openxmlformats.org/drawingml/2006/main">
               <a:ext uri="{FF2B5EF4-FFF2-40B4-BE49-F238E27FC236}">
-                <a16:creationId xmlns:a16="http://schemas.microsoft.com/office/drawing/2014/main" id="{EABF31AA-8F43-4220-A185-EFF6207C5F3A}"/>
+                <a16:creationId xmlns:a16="http://schemas.microsoft.com/office/drawing/2014/main" id="{BB3D3D23-50B4-46C9-895E-DB74D96C46DF}"/>
               </a:ext>
             </a:extLst>
           </p:cNvPr>
@@ -2583,7 +2583,7 @@
           <p:cNvPr id="2" name="Body">
             <a:extLst xmlns:a="http://schemas.openxmlformats.org/drawingml/2006/main">
               <a:ext uri="{FF2B5EF4-FFF2-40B4-BE49-F238E27FC236}">
-                <a16:creationId xmlns:a16="http://schemas.microsoft.com/office/drawing/2014/main" id="{7EDB9F99-4C4D-4E18-A0DC-5F1F2BA7C1B1}"/>
+                <a16:creationId xmlns:a16="http://schemas.microsoft.com/office/drawing/2014/main" id="{A354CCD5-7E52-49E1-9115-C19242EFB49D}"/>
               </a:ext>
             </a:extLst>
           </p:cNvPr>
@@ -2829,7 +2829,7 @@
           <p:cNvPr id="4" name="Title">
             <a:extLst xmlns:a="http://schemas.openxmlformats.org/drawingml/2006/main">
               <a:ext uri="{FF2B5EF4-FFF2-40B4-BE49-F238E27FC236}">
-                <a16:creationId xmlns:a16="http://schemas.microsoft.com/office/drawing/2014/main" id="{9D71633A-3032-4DB6-A831-8771E6E69DA4}"/>
+                <a16:creationId xmlns:a16="http://schemas.microsoft.com/office/drawing/2014/main" id="{76054A32-8DE5-4046-8392-768E16632A6F}"/>
               </a:ext>
             </a:extLst>
           </p:cNvPr>
@@ -3058,7 +3058,7 @@
           <p:cNvPr id="2" name="Left column">
             <a:extLst xmlns:a="http://schemas.openxmlformats.org/drawingml/2006/main">
               <a:ext uri="{FF2B5EF4-FFF2-40B4-BE49-F238E27FC236}">
-                <a16:creationId xmlns:a16="http://schemas.microsoft.com/office/drawing/2014/main" id="{4F868971-4540-40E2-B3C7-1D50CE0565B8}"/>
+                <a16:creationId xmlns:a16="http://schemas.microsoft.com/office/drawing/2014/main" id="{EFB0016B-5A97-4D71-989B-570B33895CBD}"/>
               </a:ext>
             </a:extLst>
           </p:cNvPr>
@@ -3287,7 +3287,7 @@
           <p:cNvPr id="3" name="Right column">
             <a:extLst xmlns:a="http://schemas.openxmlformats.org/drawingml/2006/main">
               <a:ext uri="{FF2B5EF4-FFF2-40B4-BE49-F238E27FC236}">
-                <a16:creationId xmlns:a16="http://schemas.microsoft.com/office/drawing/2014/main" id="{F9038620-625D-4628-8899-12506FB8333A}"/>
+                <a16:creationId xmlns:a16="http://schemas.microsoft.com/office/drawing/2014/main" id="{26FEBF76-2544-47E6-A773-048FA92033DE}"/>
               </a:ext>
             </a:extLst>
           </p:cNvPr>
@@ -3533,7 +3533,7 @@
           <p:cNvPr id="3" name="Title">
             <a:extLst xmlns:a="http://schemas.openxmlformats.org/drawingml/2006/main">
               <a:ext uri="{FF2B5EF4-FFF2-40B4-BE49-F238E27FC236}">
-                <a16:creationId xmlns:a16="http://schemas.microsoft.com/office/drawing/2014/main" id="{6909D390-CB19-4917-840C-324551B9F3DA}"/>
+                <a16:creationId xmlns:a16="http://schemas.microsoft.com/office/drawing/2014/main" id="{893EC604-E01F-4F88-8DAB-2F1FA3B63065}"/>
               </a:ext>
             </a:extLst>
           </p:cNvPr>
@@ -3762,7 +3762,7 @@
           <p:cNvPr id="2" name="Left column">
             <a:extLst xmlns:a="http://schemas.openxmlformats.org/drawingml/2006/main">
               <a:ext uri="{FF2B5EF4-FFF2-40B4-BE49-F238E27FC236}">
-                <a16:creationId xmlns:a16="http://schemas.microsoft.com/office/drawing/2014/main" id="{EC1FB732-D59A-41C0-8720-EAD3548450A5}"/>
+                <a16:creationId xmlns:a16="http://schemas.microsoft.com/office/drawing/2014/main" id="{97E742C4-AC9A-402B-B062-FE7982524B16}"/>
               </a:ext>
             </a:extLst>
           </p:cNvPr>
@@ -4029,12 +4029,12 @@
   </p:cSld>
   <p:clrMap bg1="lt1" tx1="dk1" bg2="lt2" tx2="dk2" accent1="accent1" accent2="accent2" accent3="accent3" accent4="accent4" accent5="accent5" accent6="accent6" hlink="hlink" folHlink="folHlink"/>
   <p:sldLayoutIdLst>
-    <p:sldLayoutId xmlns:r="http://schemas.openxmlformats.org/officeDocument/2006/relationships" id="2147483649" r:id="Rfab81d15a5fd43bd"/>
-    <p:sldLayoutId xmlns:r="http://schemas.openxmlformats.org/officeDocument/2006/relationships" id="2147483650" r:id="R602ad623246545d4"/>
-    <p:sldLayoutId xmlns:r="http://schemas.openxmlformats.org/officeDocument/2006/relationships" id="2147483651" r:id="Radfe38f63d14438d"/>
-    <p:sldLayoutId xmlns:r="http://schemas.openxmlformats.org/officeDocument/2006/relationships" id="2147483652" r:id="R3639bcfcd9db401a"/>
-    <p:sldLayoutId xmlns:r="http://schemas.openxmlformats.org/officeDocument/2006/relationships" id="2147483653" r:id="R40111967e6774eb6"/>
-    <p:sldLayoutId xmlns:r="http://schemas.openxmlformats.org/officeDocument/2006/relationships" id="2147483654" r:id="R12b346fcea384e9c"/>
+    <p:sldLayoutId xmlns:r="http://schemas.openxmlformats.org/officeDocument/2006/relationships" id="2147483649" r:id="R01531a57f6024313"/>
+    <p:sldLayoutId xmlns:r="http://schemas.openxmlformats.org/officeDocument/2006/relationships" id="2147483650" r:id="Rdbf03116bc7845ff"/>
+    <p:sldLayoutId xmlns:r="http://schemas.openxmlformats.org/officeDocument/2006/relationships" id="2147483651" r:id="R26c514ba425b4aff"/>
+    <p:sldLayoutId xmlns:r="http://schemas.openxmlformats.org/officeDocument/2006/relationships" id="2147483652" r:id="R2e81e8ef8f2b4ad7"/>
+    <p:sldLayoutId xmlns:r="http://schemas.openxmlformats.org/officeDocument/2006/relationships" id="2147483653" r:id="R15c676b6d79c44ff"/>
+    <p:sldLayoutId xmlns:r="http://schemas.openxmlformats.org/officeDocument/2006/relationships" id="2147483654" r:id="R47fac33c6bae43c8"/>
   </p:sldLayoutIdLst>
   <p:txStyles>
     <p:titleStyle>
@@ -4585,7 +4585,7 @@
           <p:cNvPr id="7" name="">
             <a:extLst xmlns:a="http://schemas.openxmlformats.org/drawingml/2006/main">
               <a:ext uri="{FF2B5EF4-FFF2-40B4-BE49-F238E27FC236}">
-                <a16:creationId xmlns:a16="http://schemas.microsoft.com/office/drawing/2014/main" id="{C435C5D5-D1A2-4ED0-BA01-977E20E12C6C}"/>
+                <a16:creationId xmlns:a16="http://schemas.microsoft.com/office/drawing/2014/main" id="{8374D728-9BD1-42C9-AA7B-DC084A38A554}"/>
               </a:ext>
             </a:extLst>
           </p:cNvPr>
@@ -4741,7 +4741,7 @@
           <p:cNvPr id="2" name="">
             <a:extLst xmlns:a="http://schemas.openxmlformats.org/drawingml/2006/main">
               <a:ext uri="{FF2B5EF4-FFF2-40B4-BE49-F238E27FC236}">
-                <a16:creationId xmlns:a16="http://schemas.microsoft.com/office/drawing/2014/main" id="{7D41A636-91B7-4A95-982C-0FE6B5CE84A7}"/>
+                <a16:creationId xmlns:a16="http://schemas.microsoft.com/office/drawing/2014/main" id="{E25C06BD-1A5D-4EC3-BBA1-3EAB751337DC}"/>
               </a:ext>
             </a:extLst>
           </p:cNvPr>
@@ -4897,7 +4897,7 @@
           <p:cNvPr id="3" name="">
             <a:extLst xmlns:a="http://schemas.openxmlformats.org/drawingml/2006/main">
               <a:ext uri="{FF2B5EF4-FFF2-40B4-BE49-F238E27FC236}">
-                <a16:creationId xmlns:a16="http://schemas.microsoft.com/office/drawing/2014/main" id="{15559B0B-9179-408D-BD95-38E8AC094B3D}"/>
+                <a16:creationId xmlns:a16="http://schemas.microsoft.com/office/drawing/2014/main" id="{E1F041C5-4348-4C2B-9C71-D586C1764C98}"/>
               </a:ext>
             </a:extLst>
           </p:cNvPr>
@@ -5037,7 +5037,7 @@
           <p:cNvPr id="4" name="">
             <a:extLst xmlns:a="http://schemas.openxmlformats.org/drawingml/2006/main">
               <a:ext uri="{FF2B5EF4-FFF2-40B4-BE49-F238E27FC236}">
-                <a16:creationId xmlns:a16="http://schemas.microsoft.com/office/drawing/2014/main" id="{A76476A4-71E3-41D5-B621-2BF879D35EFE}"/>
+                <a16:creationId xmlns:a16="http://schemas.microsoft.com/office/drawing/2014/main" id="{816B5EE3-58DE-4B5A-BDD3-93701DA7A800}"/>
               </a:ext>
             </a:extLst>
           </p:cNvPr>
@@ -5193,7 +5193,7 @@
           <p:cNvPr id="5" name="">
             <a:extLst xmlns:a="http://schemas.openxmlformats.org/drawingml/2006/main">
               <a:ext uri="{FF2B5EF4-FFF2-40B4-BE49-F238E27FC236}">
-                <a16:creationId xmlns:a16="http://schemas.microsoft.com/office/drawing/2014/main" id="{3DBCE093-DFC4-437B-822D-976C06D27E9D}"/>
+                <a16:creationId xmlns:a16="http://schemas.microsoft.com/office/drawing/2014/main" id="{48397F56-1DCF-48B9-84C5-AB29FD48D5B0}"/>
               </a:ext>
             </a:extLst>
           </p:cNvPr>
@@ -5349,7 +5349,7 @@
           <p:cNvPr id="6" name="">
             <a:extLst xmlns:a="http://schemas.openxmlformats.org/drawingml/2006/main">
               <a:ext uri="{FF2B5EF4-FFF2-40B4-BE49-F238E27FC236}">
-                <a16:creationId xmlns:a16="http://schemas.microsoft.com/office/drawing/2014/main" id="{6BDDB642-0903-4C09-A722-240F0D1CA20E}"/>
+                <a16:creationId xmlns:a16="http://schemas.microsoft.com/office/drawing/2014/main" id="{68852801-E53B-48CD-9F17-563920D2F8D2}"/>
               </a:ext>
             </a:extLst>
           </p:cNvPr>
@@ -5554,7 +5554,7 @@
     </p:spTree>
     <p:extLst>
       <p:ext uri="{BB962C8B-B14F-4D97-AF65-F5344CB8AC3E}">
-        <p14:creationId xmlns:p14="http://schemas.microsoft.com/office/powerpoint/2010/main" val="1607332118"/>
+        <p14:creationId xmlns:p14="http://schemas.microsoft.com/office/powerpoint/2010/main" val="962932628"/>
       </p:ext>
     </p:extLst>
   </p:cSld>
@@ -5585,7 +5585,7 @@
           <p:cNvPr id="7" name="">
             <a:extLst xmlns:a="http://schemas.openxmlformats.org/drawingml/2006/main">
               <a:ext uri="{FF2B5EF4-FFF2-40B4-BE49-F238E27FC236}">
-                <a16:creationId xmlns:a16="http://schemas.microsoft.com/office/drawing/2014/main" id="{144D4312-863C-48BC-B5B3-052B305ED1D3}"/>
+                <a16:creationId xmlns:a16="http://schemas.microsoft.com/office/drawing/2014/main" id="{EECD80C1-DE97-4692-90BF-860FD1C5C36B}"/>
               </a:ext>
             </a:extLst>
           </p:cNvPr>
@@ -5741,7 +5741,7 @@
           <p:cNvPr id="2" name="">
             <a:extLst xmlns:a="http://schemas.openxmlformats.org/drawingml/2006/main">
               <a:ext uri="{FF2B5EF4-FFF2-40B4-BE49-F238E27FC236}">
-                <a16:creationId xmlns:a16="http://schemas.microsoft.com/office/drawing/2014/main" id="{41BC25B0-D25F-4966-93DB-64680C2137D4}"/>
+                <a16:creationId xmlns:a16="http://schemas.microsoft.com/office/drawing/2014/main" id="{94785FE5-3461-4E67-A212-69DBB8A67AC2}"/>
               </a:ext>
             </a:extLst>
           </p:cNvPr>
@@ -5897,7 +5897,7 @@
           <p:cNvPr id="3" name="">
             <a:extLst xmlns:a="http://schemas.openxmlformats.org/drawingml/2006/main">
               <a:ext uri="{FF2B5EF4-FFF2-40B4-BE49-F238E27FC236}">
-                <a16:creationId xmlns:a16="http://schemas.microsoft.com/office/drawing/2014/main" id="{C3FF5569-2677-45DF-BA31-721D83C33D62}"/>
+                <a16:creationId xmlns:a16="http://schemas.microsoft.com/office/drawing/2014/main" id="{23F2E3F5-1BC4-41E1-BF56-FE09B0E4225F}"/>
               </a:ext>
             </a:extLst>
           </p:cNvPr>
@@ -6037,7 +6037,7 @@
           <p:cNvPr id="4" name="">
             <a:extLst xmlns:a="http://schemas.openxmlformats.org/drawingml/2006/main">
               <a:ext uri="{FF2B5EF4-FFF2-40B4-BE49-F238E27FC236}">
-                <a16:creationId xmlns:a16="http://schemas.microsoft.com/office/drawing/2014/main" id="{8AD675BF-F4BD-4F28-B24B-32948C56F5F7}"/>
+                <a16:creationId xmlns:a16="http://schemas.microsoft.com/office/drawing/2014/main" id="{0AD8EFDB-B680-4D10-8D31-BB25D62A251E}"/>
               </a:ext>
             </a:extLst>
           </p:cNvPr>
@@ -6193,7 +6193,7 @@
           <p:cNvPr id="5" name="">
             <a:extLst xmlns:a="http://schemas.openxmlformats.org/drawingml/2006/main">
               <a:ext uri="{FF2B5EF4-FFF2-40B4-BE49-F238E27FC236}">
-                <a16:creationId xmlns:a16="http://schemas.microsoft.com/office/drawing/2014/main" id="{279C1B24-629C-4BEB-815C-458BC293FAD3}"/>
+                <a16:creationId xmlns:a16="http://schemas.microsoft.com/office/drawing/2014/main" id="{9C52AE7C-BFA1-48D2-B461-73765C7BEE9C}"/>
               </a:ext>
             </a:extLst>
           </p:cNvPr>
@@ -6372,7 +6372,7 @@
           <p:cNvPr id="6" name="">
             <a:extLst xmlns:a="http://schemas.openxmlformats.org/drawingml/2006/main">
               <a:ext uri="{FF2B5EF4-FFF2-40B4-BE49-F238E27FC236}">
-                <a16:creationId xmlns:a16="http://schemas.microsoft.com/office/drawing/2014/main" id="{CC69BC8F-33F4-408B-9C7A-E45654ECEF59}"/>
+                <a16:creationId xmlns:a16="http://schemas.microsoft.com/office/drawing/2014/main" id="{40162CB6-23C9-41FF-B2FD-F82D37244791}"/>
               </a:ext>
             </a:extLst>
           </p:cNvPr>
@@ -6554,7 +6554,7 @@
     </p:spTree>
     <p:extLst>
       <p:ext uri="{BB962C8B-B14F-4D97-AF65-F5344CB8AC3E}">
-        <p14:creationId xmlns:p14="http://schemas.microsoft.com/office/powerpoint/2010/main" val="1662397836"/>
+        <p14:creationId xmlns:p14="http://schemas.microsoft.com/office/powerpoint/2010/main" val="964701730"/>
       </p:ext>
     </p:extLst>
   </p:cSld>
@@ -6585,7 +6585,7 @@
           <p:cNvPr id="7" name="">
             <a:extLst xmlns:a="http://schemas.openxmlformats.org/drawingml/2006/main">
               <a:ext uri="{FF2B5EF4-FFF2-40B4-BE49-F238E27FC236}">
-                <a16:creationId xmlns:a16="http://schemas.microsoft.com/office/drawing/2014/main" id="{0454CD91-7E01-4E7F-8B27-77B8453608BE}"/>
+                <a16:creationId xmlns:a16="http://schemas.microsoft.com/office/drawing/2014/main" id="{F07A4AE4-DC72-463D-A757-F3E4F1ED7DDB}"/>
               </a:ext>
             </a:extLst>
           </p:cNvPr>
@@ -6741,7 +6741,7 @@
           <p:cNvPr id="2" name="">
             <a:extLst xmlns:a="http://schemas.openxmlformats.org/drawingml/2006/main">
               <a:ext uri="{FF2B5EF4-FFF2-40B4-BE49-F238E27FC236}">
-                <a16:creationId xmlns:a16="http://schemas.microsoft.com/office/drawing/2014/main" id="{6DA647AF-2653-4128-AB6A-D0F5F9AC09A9}"/>
+                <a16:creationId xmlns:a16="http://schemas.microsoft.com/office/drawing/2014/main" id="{4A759C3C-93C9-4AD9-83CC-51D9DFEF952D}"/>
               </a:ext>
             </a:extLst>
           </p:cNvPr>
@@ -6897,7 +6897,7 @@
           <p:cNvPr id="3" name="">
             <a:extLst xmlns:a="http://schemas.openxmlformats.org/drawingml/2006/main">
               <a:ext uri="{FF2B5EF4-FFF2-40B4-BE49-F238E27FC236}">
-                <a16:creationId xmlns:a16="http://schemas.microsoft.com/office/drawing/2014/main" id="{60F57866-1E7C-4697-A7B3-3ABC937A7A9B}"/>
+                <a16:creationId xmlns:a16="http://schemas.microsoft.com/office/drawing/2014/main" id="{EE97E62C-68E6-4866-ABB1-6E4E8AC861D5}"/>
               </a:ext>
             </a:extLst>
           </p:cNvPr>
@@ -7037,7 +7037,7 @@
           <p:cNvPr id="4" name="">
             <a:extLst xmlns:a="http://schemas.openxmlformats.org/drawingml/2006/main">
               <a:ext uri="{FF2B5EF4-FFF2-40B4-BE49-F238E27FC236}">
-                <a16:creationId xmlns:a16="http://schemas.microsoft.com/office/drawing/2014/main" id="{6737E84B-7787-4195-A62F-13570B27A1D7}"/>
+                <a16:creationId xmlns:a16="http://schemas.microsoft.com/office/drawing/2014/main" id="{FB8FF74F-AA6F-45E6-A913-EAE7A561A1AF}"/>
               </a:ext>
             </a:extLst>
           </p:cNvPr>
@@ -7188,288 +7188,40 @@
           </a:p>
         </p:txBody>
       </p:sp>
-      <p:sp>
-        <p:nvSpPr>
+      <p:pic>
+        <p:nvPicPr>
           <p:cNvPr id="5" name="">
             <a:extLst xmlns:a="http://schemas.openxmlformats.org/drawingml/2006/main">
               <a:ext uri="{FF2B5EF4-FFF2-40B4-BE49-F238E27FC236}">
-                <a16:creationId xmlns:a16="http://schemas.microsoft.com/office/drawing/2014/main" id="{7B933CC4-41B9-4524-99F7-BB32223BCCF7}"/>
+                <a16:creationId xmlns:a16="http://schemas.microsoft.com/office/drawing/2014/main" id="{2ABD26C4-9B29-4C9D-9422-68B8AA3A2F77}"/>
               </a:ext>
             </a:extLst>
           </p:cNvPr>
-          <p:cNvSpPr>
-            <a:spLocks xmlns:a="http://schemas.openxmlformats.org/drawingml/2006/main" noGrp="1"/>
-          </p:cNvSpPr>
+          <p:cNvPicPr>
+            <a:picLocks xmlns:a="http://schemas.openxmlformats.org/drawingml/2006/main" noChangeAspect="1"/>
+          </p:cNvPicPr>
           <p:nvPr/>
-        </p:nvSpPr>
+        </p:nvPicPr>
+        <p:blipFill>
+          <a:blip xmlns:r="http://schemas.openxmlformats.org/officeDocument/2006/relationships" xmlns:a="http://schemas.openxmlformats.org/drawingml/2006/main" r:embed="R5b214cad1c564b5d"/>
+          <a:stretch xmlns:a="http://schemas.openxmlformats.org/drawingml/2006/main"/>
+        </p:blipFill>
         <p:spPr>
           <a:xfrm xmlns:a="http://schemas.openxmlformats.org/drawingml/2006/main">
-            <a:off x="571500" y="1619250"/>
-            <a:ext cx="10858500" cy="4095750"/>
+            <a:off x="2391833" y="1428750"/>
+            <a:ext cx="7408333" cy="4762500"/>
           </a:xfrm>
           <a:prstGeom xmlns:a="http://schemas.openxmlformats.org/drawingml/2006/main" prst="rect">
             <a:avLst/>
           </a:prstGeom>
-          <a:noFill xmlns:a="http://schemas.openxmlformats.org/drawingml/2006/main"/>
-          <a:ln xmlns:a="http://schemas.openxmlformats.org/drawingml/2006/main" w="0">
-            <a:noFill/>
-          </a:ln>
         </p:spPr>
-        <p:txBody>
-          <a:bodyPr xmlns:a="http://schemas.openxmlformats.org/drawingml/2006/main"/>
-          <a:lstStyle xmlns:a="http://schemas.openxmlformats.org/drawingml/2006/main">
-            <a:defPPr>
-              <a:defRPr sz="2100" b="0">
-                <a:solidFill>
-                  <a:srgbClr val="111111"/>
-                </a:solidFill>
-                <a:latin typeface="Noto Sans"/>
-                <a:ea typeface="Noto Sans"/>
-                <a:cs typeface="Noto Sans"/>
-              </a:defRPr>
-            </a:defPPr>
-            <a:lvl1pPr>
-              <a:defRPr sz="2100" b="0">
-                <a:solidFill>
-                  <a:srgbClr val="111111"/>
-                </a:solidFill>
-                <a:latin typeface="Noto Sans"/>
-                <a:ea typeface="Noto Sans"/>
-                <a:cs typeface="Noto Sans"/>
-              </a:defRPr>
-            </a:lvl1pPr>
-            <a:lvl2pPr>
-              <a:defRPr sz="2100" b="0">
-                <a:solidFill>
-                  <a:srgbClr val="111111"/>
-                </a:solidFill>
-                <a:latin typeface="Noto Sans"/>
-                <a:ea typeface="Noto Sans"/>
-                <a:cs typeface="Noto Sans"/>
-              </a:defRPr>
-            </a:lvl2pPr>
-            <a:lvl3pPr>
-              <a:defRPr sz="2100" b="0">
-                <a:solidFill>
-                  <a:srgbClr val="111111"/>
-                </a:solidFill>
-                <a:latin typeface="Noto Sans"/>
-                <a:ea typeface="Noto Sans"/>
-                <a:cs typeface="Noto Sans"/>
-              </a:defRPr>
-            </a:lvl3pPr>
-            <a:lvl4pPr>
-              <a:defRPr sz="2100" b="0">
-                <a:solidFill>
-                  <a:srgbClr val="111111"/>
-                </a:solidFill>
-                <a:latin typeface="Noto Sans"/>
-                <a:ea typeface="Noto Sans"/>
-                <a:cs typeface="Noto Sans"/>
-              </a:defRPr>
-            </a:lvl4pPr>
-            <a:lvl5pPr>
-              <a:defRPr sz="2100" b="0">
-                <a:solidFill>
-                  <a:srgbClr val="111111"/>
-                </a:solidFill>
-                <a:latin typeface="Noto Sans"/>
-                <a:ea typeface="Noto Sans"/>
-                <a:cs typeface="Noto Sans"/>
-              </a:defRPr>
-            </a:lvl5pPr>
-            <a:lvl6pPr>
-              <a:defRPr sz="2100" b="0">
-                <a:solidFill>
-                  <a:srgbClr val="111111"/>
-                </a:solidFill>
-                <a:latin typeface="Noto Sans"/>
-                <a:ea typeface="Noto Sans"/>
-                <a:cs typeface="Noto Sans"/>
-              </a:defRPr>
-            </a:lvl6pPr>
-            <a:lvl7pPr>
-              <a:defRPr sz="2100" b="0">
-                <a:solidFill>
-                  <a:srgbClr val="111111"/>
-                </a:solidFill>
-                <a:latin typeface="Noto Sans"/>
-                <a:ea typeface="Noto Sans"/>
-                <a:cs typeface="Noto Sans"/>
-              </a:defRPr>
-            </a:lvl7pPr>
-            <a:lvl8pPr>
-              <a:defRPr sz="2100" b="0">
-                <a:solidFill>
-                  <a:srgbClr val="111111"/>
-                </a:solidFill>
-                <a:latin typeface="Noto Sans"/>
-                <a:ea typeface="Noto Sans"/>
-                <a:cs typeface="Noto Sans"/>
-              </a:defRPr>
-            </a:lvl8pPr>
-            <a:lvl9pPr>
-              <a:defRPr sz="2100" b="0">
-                <a:solidFill>
-                  <a:srgbClr val="111111"/>
-                </a:solidFill>
-                <a:latin typeface="Noto Sans"/>
-                <a:ea typeface="Noto Sans"/>
-                <a:cs typeface="Noto Sans"/>
-              </a:defRPr>
-            </a:lvl9pPr>
-          </a:lstStyle>
-          <a:p xmlns:a="http://schemas.openxmlformats.org/drawingml/2006/main">
-            <a:pPr>
-              <a:defRPr sz="2100" b="0">
-                <a:solidFill>
-                  <a:srgbClr val="111111"/>
-                </a:solidFill>
-                <a:latin typeface="Noto Sans"/>
-                <a:ea typeface="Noto Sans"/>
-                <a:cs typeface="Noto Sans"/>
-              </a:defRPr>
-            </a:pPr>
-            <a:r>
-              <a:rPr sz="2100" b="0">
-                <a:solidFill>
-                  <a:srgbClr val="111111"/>
-                </a:solidFill>
-                <a:latin typeface="Noto Sans"/>
-                <a:ea typeface="Noto Sans"/>
-                <a:cs typeface="Noto Sans"/>
-              </a:rPr>
-              <a:t>Full process έναντι timed-kernel ROI.</a:t>
-            </a:r>
-          </a:p>
-          <a:p xmlns:a="http://schemas.openxmlformats.org/drawingml/2006/main">
-            <a:pPr>
-              <a:defRPr sz="2100" b="0">
-                <a:solidFill>
-                  <a:srgbClr val="111111"/>
-                </a:solidFill>
-                <a:latin typeface="Noto Sans"/>
-                <a:ea typeface="Noto Sans"/>
-                <a:cs typeface="Noto Sans"/>
-              </a:defRPr>
-            </a:pPr>
-            <a:r>
-              <a:rPr sz="2100" b="0">
-                <a:solidFill>
-                  <a:srgbClr val="111111"/>
-                </a:solidFill>
-                <a:latin typeface="Noto Sans"/>
-                <a:ea typeface="Noto Sans"/>
-                <a:cs typeface="Noto Sans"/>
-              </a:rPr>
-              <a:t>Real inputs μαζί με 20 software threads.</a:t>
-            </a:r>
-          </a:p>
-          <a:p xmlns:a="http://schemas.openxmlformats.org/drawingml/2006/main">
-            <a:pPr>
-              <a:defRPr sz="2100" b="0">
-                <a:solidFill>
-                  <a:srgbClr val="111111"/>
-                </a:solidFill>
-                <a:latin typeface="Noto Sans"/>
-                <a:ea typeface="Noto Sans"/>
-                <a:cs typeface="Noto Sans"/>
-              </a:defRPr>
-            </a:pPr>
-            <a:r>
-              <a:rPr sz="2100" b="0">
-                <a:solidFill>
-                  <a:srgbClr val="111111"/>
-                </a:solidFill>
-                <a:latin typeface="Noto Sans"/>
-                <a:ea typeface="Noto Sans"/>
-                <a:cs typeface="Noto Sans"/>
-              </a:rPr>
-              <a:t>9 LLC ways αντί για 10.</a:t>
-            </a:r>
-          </a:p>
-          <a:p xmlns:a="http://schemas.openxmlformats.org/drawingml/2006/main">
-            <a:pPr>
-              <a:defRPr sz="2100" b="0">
-                <a:solidFill>
-                  <a:srgbClr val="111111"/>
-                </a:solidFill>
-                <a:latin typeface="Noto Sans"/>
-                <a:ea typeface="Noto Sans"/>
-                <a:cs typeface="Noto Sans"/>
-              </a:defRPr>
-            </a:pPr>
-            <a:r>
-              <a:rPr sz="2100" b="0">
-                <a:solidFill>
-                  <a:srgbClr val="111111"/>
-                </a:solidFill>
-                <a:latin typeface="Noto Sans"/>
-                <a:ea typeface="Noto Sans"/>
-                <a:cs typeface="Noto Sans"/>
-              </a:rPr>
-              <a:t>TC footprint: επιλογή μόνο με native RSS.</a:t>
-            </a:r>
-          </a:p>
-          <a:p xmlns:a="http://schemas.openxmlformats.org/drawingml/2006/main">
-            <a:r>
-              <a:t/>
-            </a:r>
-          </a:p>
-          <a:p xmlns:a="http://schemas.openxmlformats.org/drawingml/2006/main">
-            <a:pPr>
-              <a:defRPr sz="2100" b="0">
-                <a:solidFill>
-                  <a:srgbClr val="111111"/>
-                </a:solidFill>
-                <a:latin typeface="Noto Sans"/>
-                <a:ea typeface="Noto Sans"/>
-                <a:cs typeface="Noto Sans"/>
-              </a:defRPr>
-            </a:pPr>
-            <a:r>
-              <a:rPr sz="2100" b="0">
-                <a:solidFill>
-                  <a:srgbClr val="111111"/>
-                </a:solidFill>
-                <a:latin typeface="Noto Sans"/>
-                <a:ea typeface="Noto Sans"/>
-                <a:cs typeface="Noto Sans"/>
-              </a:rPr>
-              <a:t>Ολοκληρωμένοι έλεγχοι: 0 / 21</a:t>
-            </a:r>
-          </a:p>
-          <a:p xmlns:a="http://schemas.openxmlformats.org/drawingml/2006/main">
-            <a:pPr>
-              <a:defRPr sz="2100" b="0">
-                <a:solidFill>
-                  <a:srgbClr val="111111"/>
-                </a:solidFill>
-                <a:latin typeface="Noto Sans"/>
-                <a:ea typeface="Noto Sans"/>
-                <a:cs typeface="Noto Sans"/>
-              </a:defRPr>
-            </a:pPr>
-            <a:r>
-              <a:rPr sz="2100" b="0">
-                <a:solidFill>
-                  <a:srgbClr val="111111"/>
-                </a:solidFill>
-                <a:latin typeface="Noto Sans"/>
-                <a:ea typeface="Noto Sans"/>
-                <a:cs typeface="Noto Sans"/>
-              </a:rPr>
-              <a:t>Κατάσταση: αναμονή ολοκλήρωσης των repetition controls</a:t>
-            </a:r>
-          </a:p>
-        </p:txBody>
-      </p:sp>
+      </p:pic>
       <p:sp>
         <p:nvSpPr>
           <p:cNvPr id="6" name="">
             <a:extLst xmlns:a="http://schemas.openxmlformats.org/drawingml/2006/main">
               <a:ext uri="{FF2B5EF4-FFF2-40B4-BE49-F238E27FC236}">
-                <a16:creationId xmlns:a16="http://schemas.microsoft.com/office/drawing/2014/main" id="{E6BCAC90-AC26-4496-86FE-DB04BDA31534}"/>
+                <a16:creationId xmlns:a16="http://schemas.microsoft.com/office/drawing/2014/main" id="{7DADFBFC-216B-4240-900D-F8E856167FF8}"/>
               </a:ext>
             </a:extLst>
           </p:cNvPr>
@@ -7615,7 +7367,7 @@
                 <a:ea typeface="Noto Sans"/>
                 <a:cs typeface="Noto Sans"/>
               </a:rPr>
-              <a:t>BFS, 200 trials: pooled σφάλμα 59.6 μ.μ. αντί 59,1. Η επανάληψη μόνη της δεν βελτιώνει τη συμφωνία.</a:t>
+              <a:t>Exploratory closest cases: επιλογή με βάση το reference, όχι ανεξάρτητη replication. Όλες οι δοκιμές διατηρούνται.</a:t>
             </a:r>
           </a:p>
         </p:txBody>
@@ -7623,7 +7375,7 @@
     </p:spTree>
     <p:extLst>
       <p:ext uri="{BB962C8B-B14F-4D97-AF65-F5344CB8AC3E}">
-        <p14:creationId xmlns:p14="http://schemas.microsoft.com/office/powerpoint/2010/main" val="1577976399"/>
+        <p14:creationId xmlns:p14="http://schemas.microsoft.com/office/powerpoint/2010/main" val="2022201113"/>
       </p:ext>
     </p:extLst>
   </p:cSld>
@@ -7654,7 +7406,7 @@
           <p:cNvPr id="7" name="">
             <a:extLst xmlns:a="http://schemas.openxmlformats.org/drawingml/2006/main">
               <a:ext uri="{FF2B5EF4-FFF2-40B4-BE49-F238E27FC236}">
-                <a16:creationId xmlns:a16="http://schemas.microsoft.com/office/drawing/2014/main" id="{D155D40F-9E37-4E6A-9DB8-1AB412CF2554}"/>
+                <a16:creationId xmlns:a16="http://schemas.microsoft.com/office/drawing/2014/main" id="{0F7C887F-8470-4DBD-8E7C-27DA81C7C9C8}"/>
               </a:ext>
             </a:extLst>
           </p:cNvPr>
@@ -7810,7 +7562,7 @@
           <p:cNvPr id="2" name="">
             <a:extLst xmlns:a="http://schemas.openxmlformats.org/drawingml/2006/main">
               <a:ext uri="{FF2B5EF4-FFF2-40B4-BE49-F238E27FC236}">
-                <a16:creationId xmlns:a16="http://schemas.microsoft.com/office/drawing/2014/main" id="{33ADFE20-B5C4-4FB1-9255-5ED5422E3EED}"/>
+                <a16:creationId xmlns:a16="http://schemas.microsoft.com/office/drawing/2014/main" id="{0E33F6EF-68F1-4DBA-9874-273BDA945DFB}"/>
               </a:ext>
             </a:extLst>
           </p:cNvPr>
@@ -7966,7 +7718,7 @@
           <p:cNvPr id="3" name="">
             <a:extLst xmlns:a="http://schemas.openxmlformats.org/drawingml/2006/main">
               <a:ext uri="{FF2B5EF4-FFF2-40B4-BE49-F238E27FC236}">
-                <a16:creationId xmlns:a16="http://schemas.microsoft.com/office/drawing/2014/main" id="{3E626EEF-495B-4151-861F-79A8CCC9D07C}"/>
+                <a16:creationId xmlns:a16="http://schemas.microsoft.com/office/drawing/2014/main" id="{BFDBCC86-C79F-4F68-AE5F-75B1221DCBEC}"/>
               </a:ext>
             </a:extLst>
           </p:cNvPr>
@@ -8106,7 +7858,7 @@
           <p:cNvPr id="4" name="">
             <a:extLst xmlns:a="http://schemas.openxmlformats.org/drawingml/2006/main">
               <a:ext uri="{FF2B5EF4-FFF2-40B4-BE49-F238E27FC236}">
-                <a16:creationId xmlns:a16="http://schemas.microsoft.com/office/drawing/2014/main" id="{066D2757-FE95-41D1-BB49-43CCF0EAAAB9}"/>
+                <a16:creationId xmlns:a16="http://schemas.microsoft.com/office/drawing/2014/main" id="{A704F3F7-9C64-4585-BC00-648A98E34F27}"/>
               </a:ext>
             </a:extLst>
           </p:cNvPr>
@@ -8262,7 +8014,7 @@
           <p:cNvPr id="5" name="">
             <a:extLst xmlns:a="http://schemas.openxmlformats.org/drawingml/2006/main">
               <a:ext uri="{FF2B5EF4-FFF2-40B4-BE49-F238E27FC236}">
-                <a16:creationId xmlns:a16="http://schemas.microsoft.com/office/drawing/2014/main" id="{368AB821-ECC6-43F4-AFDA-2B1DBF03C383}"/>
+                <a16:creationId xmlns:a16="http://schemas.microsoft.com/office/drawing/2014/main" id="{1EA736E6-B8C5-4074-A803-E11FB6A8F9AC}"/>
               </a:ext>
             </a:extLst>
           </p:cNvPr>
@@ -8272,7 +8024,7 @@
           <p:nvPr/>
         </p:nvPicPr>
         <p:blipFill>
-          <a:blip xmlns:r="http://schemas.openxmlformats.org/officeDocument/2006/relationships" xmlns:a="http://schemas.openxmlformats.org/drawingml/2006/main" r:embed="R0f350274565b4163"/>
+          <a:blip xmlns:r="http://schemas.openxmlformats.org/officeDocument/2006/relationships" xmlns:a="http://schemas.openxmlformats.org/drawingml/2006/main" r:embed="Rf08fa6cd3051402e"/>
           <a:stretch xmlns:a="http://schemas.openxmlformats.org/drawingml/2006/main"/>
         </p:blipFill>
         <p:spPr>
@@ -8290,7 +8042,7 @@
           <p:cNvPr id="6" name="">
             <a:extLst xmlns:a="http://schemas.openxmlformats.org/drawingml/2006/main">
               <a:ext uri="{FF2B5EF4-FFF2-40B4-BE49-F238E27FC236}">
-                <a16:creationId xmlns:a16="http://schemas.microsoft.com/office/drawing/2014/main" id="{67AFBC86-5A90-4C22-A33A-49FB8614CAF6}"/>
+                <a16:creationId xmlns:a16="http://schemas.microsoft.com/office/drawing/2014/main" id="{35111749-FB58-4862-B989-36FB4C6A7AA0}"/>
               </a:ext>
             </a:extLst>
           </p:cNvPr>
@@ -8444,7 +8196,7 @@
     </p:spTree>
     <p:extLst>
       <p:ext uri="{BB962C8B-B14F-4D97-AF65-F5344CB8AC3E}">
-        <p14:creationId xmlns:p14="http://schemas.microsoft.com/office/powerpoint/2010/main" val="1174259185"/>
+        <p14:creationId xmlns:p14="http://schemas.microsoft.com/office/powerpoint/2010/main" val="866879716"/>
       </p:ext>
     </p:extLst>
   </p:cSld>
@@ -8475,7 +8227,7 @@
           <p:cNvPr id="7" name="">
             <a:extLst xmlns:a="http://schemas.openxmlformats.org/drawingml/2006/main">
               <a:ext uri="{FF2B5EF4-FFF2-40B4-BE49-F238E27FC236}">
-                <a16:creationId xmlns:a16="http://schemas.microsoft.com/office/drawing/2014/main" id="{74C7689C-E771-427C-AB16-CA931AD5E976}"/>
+                <a16:creationId xmlns:a16="http://schemas.microsoft.com/office/drawing/2014/main" id="{3F28C925-CB73-47AB-A8D3-5A8DD9952FE0}"/>
               </a:ext>
             </a:extLst>
           </p:cNvPr>
@@ -8631,7 +8383,7 @@
           <p:cNvPr id="2" name="">
             <a:extLst xmlns:a="http://schemas.openxmlformats.org/drawingml/2006/main">
               <a:ext uri="{FF2B5EF4-FFF2-40B4-BE49-F238E27FC236}">
-                <a16:creationId xmlns:a16="http://schemas.microsoft.com/office/drawing/2014/main" id="{AC8F54BB-E4FC-408A-B371-9E56DDB67F76}"/>
+                <a16:creationId xmlns:a16="http://schemas.microsoft.com/office/drawing/2014/main" id="{4B191676-F8EB-42B7-BF69-1D89AA11AA7F}"/>
               </a:ext>
             </a:extLst>
           </p:cNvPr>
@@ -8787,7 +8539,7 @@
           <p:cNvPr id="3" name="">
             <a:extLst xmlns:a="http://schemas.openxmlformats.org/drawingml/2006/main">
               <a:ext uri="{FF2B5EF4-FFF2-40B4-BE49-F238E27FC236}">
-                <a16:creationId xmlns:a16="http://schemas.microsoft.com/office/drawing/2014/main" id="{BC223FD8-AF40-4847-BB10-B949FA6CA073}"/>
+                <a16:creationId xmlns:a16="http://schemas.microsoft.com/office/drawing/2014/main" id="{7316D889-4818-43A5-ABD7-8580144CE31C}"/>
               </a:ext>
             </a:extLst>
           </p:cNvPr>
@@ -8927,7 +8679,7 @@
           <p:cNvPr id="4" name="">
             <a:extLst xmlns:a="http://schemas.openxmlformats.org/drawingml/2006/main">
               <a:ext uri="{FF2B5EF4-FFF2-40B4-BE49-F238E27FC236}">
-                <a16:creationId xmlns:a16="http://schemas.microsoft.com/office/drawing/2014/main" id="{ACC1B457-8AAF-48E9-9D41-E065AA6A3FAA}"/>
+                <a16:creationId xmlns:a16="http://schemas.microsoft.com/office/drawing/2014/main" id="{9287C9B1-1E94-4CA1-8F9C-49EEE67DAC67}"/>
               </a:ext>
             </a:extLst>
           </p:cNvPr>
@@ -9083,7 +8835,7 @@
           <p:cNvPr id="5" name="">
             <a:extLst xmlns:a="http://schemas.openxmlformats.org/drawingml/2006/main">
               <a:ext uri="{FF2B5EF4-FFF2-40B4-BE49-F238E27FC236}">
-                <a16:creationId xmlns:a16="http://schemas.microsoft.com/office/drawing/2014/main" id="{5EDC418B-F592-49E1-9458-26BBD969F0E9}"/>
+                <a16:creationId xmlns:a16="http://schemas.microsoft.com/office/drawing/2014/main" id="{95D0B10E-5646-43D6-83B2-647EDCB85026}"/>
               </a:ext>
             </a:extLst>
           </p:cNvPr>
@@ -9093,7 +8845,7 @@
           <p:nvPr/>
         </p:nvPicPr>
         <p:blipFill>
-          <a:blip xmlns:r="http://schemas.openxmlformats.org/officeDocument/2006/relationships" xmlns:a="http://schemas.openxmlformats.org/drawingml/2006/main" r:embed="R00406ce12d894412"/>
+          <a:blip xmlns:r="http://schemas.openxmlformats.org/officeDocument/2006/relationships" xmlns:a="http://schemas.openxmlformats.org/drawingml/2006/main" r:embed="R47ac4eff43ac4357"/>
           <a:stretch xmlns:a="http://schemas.openxmlformats.org/drawingml/2006/main"/>
         </p:blipFill>
         <p:spPr>
@@ -9111,7 +8863,7 @@
           <p:cNvPr id="6" name="">
             <a:extLst xmlns:a="http://schemas.openxmlformats.org/drawingml/2006/main">
               <a:ext uri="{FF2B5EF4-FFF2-40B4-BE49-F238E27FC236}">
-                <a16:creationId xmlns:a16="http://schemas.microsoft.com/office/drawing/2014/main" id="{BEB242CC-69F9-4CE5-A76D-0CFAC6893FD8}"/>
+                <a16:creationId xmlns:a16="http://schemas.microsoft.com/office/drawing/2014/main" id="{BF83F30C-7C05-44BB-969C-876D11A81FCD}"/>
               </a:ext>
             </a:extLst>
           </p:cNvPr>
@@ -9390,7 +9142,7 @@
     </p:spTree>
     <p:extLst>
       <p:ext uri="{BB962C8B-B14F-4D97-AF65-F5344CB8AC3E}">
-        <p14:creationId xmlns:p14="http://schemas.microsoft.com/office/powerpoint/2010/main" val="1920510674"/>
+        <p14:creationId xmlns:p14="http://schemas.microsoft.com/office/powerpoint/2010/main" val="260887433"/>
       </p:ext>
     </p:extLst>
   </p:cSld>
@@ -9421,7 +9173,7 @@
           <p:cNvPr id="7" name="">
             <a:extLst xmlns:a="http://schemas.openxmlformats.org/drawingml/2006/main">
               <a:ext uri="{FF2B5EF4-FFF2-40B4-BE49-F238E27FC236}">
-                <a16:creationId xmlns:a16="http://schemas.microsoft.com/office/drawing/2014/main" id="{37958FF6-6B8E-4717-88F8-572F75A707A0}"/>
+                <a16:creationId xmlns:a16="http://schemas.microsoft.com/office/drawing/2014/main" id="{F206E82B-7795-4C3D-B8B0-32E0F554F45D}"/>
               </a:ext>
             </a:extLst>
           </p:cNvPr>
@@ -9577,7 +9329,7 @@
           <p:cNvPr id="2" name="">
             <a:extLst xmlns:a="http://schemas.openxmlformats.org/drawingml/2006/main">
               <a:ext uri="{FF2B5EF4-FFF2-40B4-BE49-F238E27FC236}">
-                <a16:creationId xmlns:a16="http://schemas.microsoft.com/office/drawing/2014/main" id="{38D07E64-5A75-470D-9291-0698D63D8C49}"/>
+                <a16:creationId xmlns:a16="http://schemas.microsoft.com/office/drawing/2014/main" id="{76BBE00C-3994-49E4-B44B-AAC893A1092B}"/>
               </a:ext>
             </a:extLst>
           </p:cNvPr>
@@ -9733,7 +9485,7 @@
           <p:cNvPr id="3" name="">
             <a:extLst xmlns:a="http://schemas.openxmlformats.org/drawingml/2006/main">
               <a:ext uri="{FF2B5EF4-FFF2-40B4-BE49-F238E27FC236}">
-                <a16:creationId xmlns:a16="http://schemas.microsoft.com/office/drawing/2014/main" id="{11EF62E6-1287-4D5C-9866-159839AE4AA0}"/>
+                <a16:creationId xmlns:a16="http://schemas.microsoft.com/office/drawing/2014/main" id="{09183AB5-2101-4A68-BA32-FC3036A482A7}"/>
               </a:ext>
             </a:extLst>
           </p:cNvPr>
@@ -9873,7 +9625,7 @@
           <p:cNvPr id="4" name="">
             <a:extLst xmlns:a="http://schemas.openxmlformats.org/drawingml/2006/main">
               <a:ext uri="{FF2B5EF4-FFF2-40B4-BE49-F238E27FC236}">
-                <a16:creationId xmlns:a16="http://schemas.microsoft.com/office/drawing/2014/main" id="{DA61AC3B-95D4-4B58-BE8F-FCD2B5FB0C6D}"/>
+                <a16:creationId xmlns:a16="http://schemas.microsoft.com/office/drawing/2014/main" id="{FEA0C875-7099-47D5-B143-E82DC3EC08EF}"/>
               </a:ext>
             </a:extLst>
           </p:cNvPr>
@@ -10029,7 +9781,7 @@
           <p:cNvPr id="5" name="">
             <a:extLst xmlns:a="http://schemas.openxmlformats.org/drawingml/2006/main">
               <a:ext uri="{FF2B5EF4-FFF2-40B4-BE49-F238E27FC236}">
-                <a16:creationId xmlns:a16="http://schemas.microsoft.com/office/drawing/2014/main" id="{FD596495-B16A-48F9-8EB3-55FE01CE4FB3}"/>
+                <a16:creationId xmlns:a16="http://schemas.microsoft.com/office/drawing/2014/main" id="{B49880C5-CB45-42CD-A86E-AC268F324688}"/>
               </a:ext>
             </a:extLst>
           </p:cNvPr>
@@ -10039,7 +9791,7 @@
           <p:nvPr/>
         </p:nvPicPr>
         <p:blipFill>
-          <a:blip xmlns:r="http://schemas.openxmlformats.org/officeDocument/2006/relationships" xmlns:a="http://schemas.openxmlformats.org/drawingml/2006/main" r:embed="R2632df1f2ce94543"/>
+          <a:blip xmlns:r="http://schemas.openxmlformats.org/officeDocument/2006/relationships" xmlns:a="http://schemas.openxmlformats.org/drawingml/2006/main" r:embed="Rf96cae15b7574f0c"/>
           <a:stretch xmlns:a="http://schemas.openxmlformats.org/drawingml/2006/main"/>
         </p:blipFill>
         <p:spPr>
@@ -10057,7 +9809,7 @@
           <p:cNvPr id="6" name="">
             <a:extLst xmlns:a="http://schemas.openxmlformats.org/drawingml/2006/main">
               <a:ext uri="{FF2B5EF4-FFF2-40B4-BE49-F238E27FC236}">
-                <a16:creationId xmlns:a16="http://schemas.microsoft.com/office/drawing/2014/main" id="{202BE011-9BE4-46D2-AA0D-1133DE62BDD8}"/>
+                <a16:creationId xmlns:a16="http://schemas.microsoft.com/office/drawing/2014/main" id="{42172F7C-9283-4A98-ACC6-214063C9FCEE}"/>
               </a:ext>
             </a:extLst>
           </p:cNvPr>
@@ -10318,7 +10070,7 @@
     </p:spTree>
     <p:extLst>
       <p:ext uri="{BB962C8B-B14F-4D97-AF65-F5344CB8AC3E}">
-        <p14:creationId xmlns:p14="http://schemas.microsoft.com/office/powerpoint/2010/main" val="1836460725"/>
+        <p14:creationId xmlns:p14="http://schemas.microsoft.com/office/powerpoint/2010/main" val="1740724406"/>
       </p:ext>
     </p:extLst>
   </p:cSld>
@@ -10349,7 +10101,7 @@
           <p:cNvPr id="6" name="">
             <a:extLst xmlns:a="http://schemas.openxmlformats.org/drawingml/2006/main">
               <a:ext uri="{FF2B5EF4-FFF2-40B4-BE49-F238E27FC236}">
-                <a16:creationId xmlns:a16="http://schemas.microsoft.com/office/drawing/2014/main" id="{394770E0-E392-4B70-8159-2AEF404DC8B3}"/>
+                <a16:creationId xmlns:a16="http://schemas.microsoft.com/office/drawing/2014/main" id="{D54E77C0-3AC5-4595-BEAE-A5347ADD595C}"/>
               </a:ext>
             </a:extLst>
           </p:cNvPr>
@@ -10505,7 +10257,7 @@
           <p:cNvPr id="2" name="">
             <a:extLst xmlns:a="http://schemas.openxmlformats.org/drawingml/2006/main">
               <a:ext uri="{FF2B5EF4-FFF2-40B4-BE49-F238E27FC236}">
-                <a16:creationId xmlns:a16="http://schemas.microsoft.com/office/drawing/2014/main" id="{0591F24A-0A55-414C-AC0B-ECA93999A82F}"/>
+                <a16:creationId xmlns:a16="http://schemas.microsoft.com/office/drawing/2014/main" id="{F68BEA8E-2178-4325-ACD6-8D6E776CDA57}"/>
               </a:ext>
             </a:extLst>
           </p:cNvPr>
@@ -10661,7 +10413,7 @@
           <p:cNvPr id="3" name="">
             <a:extLst xmlns:a="http://schemas.openxmlformats.org/drawingml/2006/main">
               <a:ext uri="{FF2B5EF4-FFF2-40B4-BE49-F238E27FC236}">
-                <a16:creationId xmlns:a16="http://schemas.microsoft.com/office/drawing/2014/main" id="{5B6EE5F0-A804-4034-8E20-D0752BF4B404}"/>
+                <a16:creationId xmlns:a16="http://schemas.microsoft.com/office/drawing/2014/main" id="{AA30E169-6268-4DBF-A6DB-8D7881B0EFAB}"/>
               </a:ext>
             </a:extLst>
           </p:cNvPr>
@@ -10801,7 +10553,7 @@
           <p:cNvPr id="4" name="">
             <a:extLst xmlns:a="http://schemas.openxmlformats.org/drawingml/2006/main">
               <a:ext uri="{FF2B5EF4-FFF2-40B4-BE49-F238E27FC236}">
-                <a16:creationId xmlns:a16="http://schemas.microsoft.com/office/drawing/2014/main" id="{164B7057-3B78-42A3-A57E-C420D9F94BC4}"/>
+                <a16:creationId xmlns:a16="http://schemas.microsoft.com/office/drawing/2014/main" id="{281625D9-B00A-4E69-B78E-E1D0930437F2}"/>
               </a:ext>
             </a:extLst>
           </p:cNvPr>
@@ -10957,7 +10709,7 @@
           <p:cNvPr id="5" name="">
             <a:extLst xmlns:a="http://schemas.openxmlformats.org/drawingml/2006/main">
               <a:ext uri="{FF2B5EF4-FFF2-40B4-BE49-F238E27FC236}">
-                <a16:creationId xmlns:a16="http://schemas.microsoft.com/office/drawing/2014/main" id="{02071F37-9449-46AD-A4B8-BCAA1D18C5B5}"/>
+                <a16:creationId xmlns:a16="http://schemas.microsoft.com/office/drawing/2014/main" id="{6F4E29BE-BB2B-4F81-A91E-D27F7EAC6528}"/>
               </a:ext>
             </a:extLst>
           </p:cNvPr>
@@ -11218,7 +10970,7 @@
     </p:spTree>
     <p:extLst>
       <p:ext uri="{BB962C8B-B14F-4D97-AF65-F5344CB8AC3E}">
-        <p14:creationId xmlns:p14="http://schemas.microsoft.com/office/powerpoint/2010/main" val="2107189956"/>
+        <p14:creationId xmlns:p14="http://schemas.microsoft.com/office/powerpoint/2010/main" val="1142521944"/>
       </p:ext>
     </p:extLst>
   </p:cSld>
@@ -11249,7 +11001,7 @@
           <p:cNvPr id="6" name="">
             <a:extLst xmlns:a="http://schemas.openxmlformats.org/drawingml/2006/main">
               <a:ext uri="{FF2B5EF4-FFF2-40B4-BE49-F238E27FC236}">
-                <a16:creationId xmlns:a16="http://schemas.microsoft.com/office/drawing/2014/main" id="{9AEFBEF6-1BD5-4808-94CC-84F5AD029682}"/>
+                <a16:creationId xmlns:a16="http://schemas.microsoft.com/office/drawing/2014/main" id="{EACE5044-8C6D-4835-8071-84FE976BFCFD}"/>
               </a:ext>
             </a:extLst>
           </p:cNvPr>
@@ -11405,7 +11157,7 @@
           <p:cNvPr id="2" name="">
             <a:extLst xmlns:a="http://schemas.openxmlformats.org/drawingml/2006/main">
               <a:ext uri="{FF2B5EF4-FFF2-40B4-BE49-F238E27FC236}">
-                <a16:creationId xmlns:a16="http://schemas.microsoft.com/office/drawing/2014/main" id="{2CA44939-B7A4-42B3-A248-C5F1F35A5E83}"/>
+                <a16:creationId xmlns:a16="http://schemas.microsoft.com/office/drawing/2014/main" id="{5D538CB0-35C9-4996-B890-2A58B732CC3A}"/>
               </a:ext>
             </a:extLst>
           </p:cNvPr>
@@ -11561,7 +11313,7 @@
           <p:cNvPr id="3" name="">
             <a:extLst xmlns:a="http://schemas.openxmlformats.org/drawingml/2006/main">
               <a:ext uri="{FF2B5EF4-FFF2-40B4-BE49-F238E27FC236}">
-                <a16:creationId xmlns:a16="http://schemas.microsoft.com/office/drawing/2014/main" id="{7362BCB4-50D4-4D0F-89F4-7764A26489C4}"/>
+                <a16:creationId xmlns:a16="http://schemas.microsoft.com/office/drawing/2014/main" id="{98CAC82B-FEC7-4B6D-905C-A638370DEE72}"/>
               </a:ext>
             </a:extLst>
           </p:cNvPr>
@@ -11701,7 +11453,7 @@
           <p:cNvPr id="4" name="">
             <a:extLst xmlns:a="http://schemas.openxmlformats.org/drawingml/2006/main">
               <a:ext uri="{FF2B5EF4-FFF2-40B4-BE49-F238E27FC236}">
-                <a16:creationId xmlns:a16="http://schemas.microsoft.com/office/drawing/2014/main" id="{8015DA1D-9A99-4EEA-B75A-7F0F6296C866}"/>
+                <a16:creationId xmlns:a16="http://schemas.microsoft.com/office/drawing/2014/main" id="{D2D4F01E-4AFB-4A59-991E-87A8EB0DB96E}"/>
               </a:ext>
             </a:extLst>
           </p:cNvPr>
@@ -11857,7 +11609,7 @@
           <p:cNvPr id="5" name="">
             <a:extLst xmlns:a="http://schemas.openxmlformats.org/drawingml/2006/main">
               <a:ext uri="{FF2B5EF4-FFF2-40B4-BE49-F238E27FC236}">
-                <a16:creationId xmlns:a16="http://schemas.microsoft.com/office/drawing/2014/main" id="{6750DB1C-4CF3-4507-A2E2-4ECD9A222354}"/>
+                <a16:creationId xmlns:a16="http://schemas.microsoft.com/office/drawing/2014/main" id="{474A050F-F1AF-4A97-88AF-1004313AA1B2}"/>
               </a:ext>
             </a:extLst>
           </p:cNvPr>
@@ -12067,7 +11819,7 @@
     </p:spTree>
     <p:extLst>
       <p:ext uri="{BB962C8B-B14F-4D97-AF65-F5344CB8AC3E}">
-        <p14:creationId xmlns:p14="http://schemas.microsoft.com/office/powerpoint/2010/main" val="876039227"/>
+        <p14:creationId xmlns:p14="http://schemas.microsoft.com/office/powerpoint/2010/main" val="779362980"/>
       </p:ext>
     </p:extLst>
   </p:cSld>
@@ -12098,7 +11850,7 @@
           <p:cNvPr id="6" name="">
             <a:extLst xmlns:a="http://schemas.openxmlformats.org/drawingml/2006/main">
               <a:ext uri="{FF2B5EF4-FFF2-40B4-BE49-F238E27FC236}">
-                <a16:creationId xmlns:a16="http://schemas.microsoft.com/office/drawing/2014/main" id="{6B9278A1-6D8B-46C8-B4CA-F7842ED6FAD6}"/>
+                <a16:creationId xmlns:a16="http://schemas.microsoft.com/office/drawing/2014/main" id="{02838C1C-ABE5-44A9-9252-51D835268B32}"/>
               </a:ext>
             </a:extLst>
           </p:cNvPr>
@@ -12254,7 +12006,7 @@
           <p:cNvPr id="2" name="">
             <a:extLst xmlns:a="http://schemas.openxmlformats.org/drawingml/2006/main">
               <a:ext uri="{FF2B5EF4-FFF2-40B4-BE49-F238E27FC236}">
-                <a16:creationId xmlns:a16="http://schemas.microsoft.com/office/drawing/2014/main" id="{7894E0BC-A5D4-48E6-973D-7DEC802FB412}"/>
+                <a16:creationId xmlns:a16="http://schemas.microsoft.com/office/drawing/2014/main" id="{CC66C021-1D59-4A80-BDAC-5162541405EA}"/>
               </a:ext>
             </a:extLst>
           </p:cNvPr>
@@ -12410,7 +12162,7 @@
           <p:cNvPr id="3" name="">
             <a:extLst xmlns:a="http://schemas.openxmlformats.org/drawingml/2006/main">
               <a:ext uri="{FF2B5EF4-FFF2-40B4-BE49-F238E27FC236}">
-                <a16:creationId xmlns:a16="http://schemas.microsoft.com/office/drawing/2014/main" id="{302E0749-2EE6-461F-9F75-FAC7FFEF7529}"/>
+                <a16:creationId xmlns:a16="http://schemas.microsoft.com/office/drawing/2014/main" id="{4B95A6BD-D813-4472-90AC-0EAF9EAF9747}"/>
               </a:ext>
             </a:extLst>
           </p:cNvPr>
@@ -12550,7 +12302,7 @@
           <p:cNvPr id="4" name="">
             <a:extLst xmlns:a="http://schemas.openxmlformats.org/drawingml/2006/main">
               <a:ext uri="{FF2B5EF4-FFF2-40B4-BE49-F238E27FC236}">
-                <a16:creationId xmlns:a16="http://schemas.microsoft.com/office/drawing/2014/main" id="{73E9F655-4397-4CA9-B853-53604538E5B0}"/>
+                <a16:creationId xmlns:a16="http://schemas.microsoft.com/office/drawing/2014/main" id="{347DCBE4-1DF7-4765-AC5C-97DB33872256}"/>
               </a:ext>
             </a:extLst>
           </p:cNvPr>
@@ -12706,7 +12458,7 @@
           <p:cNvPr id="5" name="">
             <a:extLst xmlns:a="http://schemas.openxmlformats.org/drawingml/2006/main">
               <a:ext uri="{FF2B5EF4-FFF2-40B4-BE49-F238E27FC236}">
-                <a16:creationId xmlns:a16="http://schemas.microsoft.com/office/drawing/2014/main" id="{09148310-3E7E-4DEE-9BA9-C2312973DB0C}"/>
+                <a16:creationId xmlns:a16="http://schemas.microsoft.com/office/drawing/2014/main" id="{6426441B-670B-4564-8B02-7E2D4F4F45F4}"/>
               </a:ext>
             </a:extLst>
           </p:cNvPr>
@@ -12944,7 +12696,7 @@
     </p:spTree>
     <p:extLst>
       <p:ext uri="{BB962C8B-B14F-4D97-AF65-F5344CB8AC3E}">
-        <p14:creationId xmlns:p14="http://schemas.microsoft.com/office/powerpoint/2010/main" val="1161111645"/>
+        <p14:creationId xmlns:p14="http://schemas.microsoft.com/office/powerpoint/2010/main" val="1824481270"/>
       </p:ext>
     </p:extLst>
   </p:cSld>
@@ -12975,7 +12727,7 @@
           <p:cNvPr id="6" name="">
             <a:extLst xmlns:a="http://schemas.openxmlformats.org/drawingml/2006/main">
               <a:ext uri="{FF2B5EF4-FFF2-40B4-BE49-F238E27FC236}">
-                <a16:creationId xmlns:a16="http://schemas.microsoft.com/office/drawing/2014/main" id="{3548A522-EB92-4ABD-84AF-CF219263F2A1}"/>
+                <a16:creationId xmlns:a16="http://schemas.microsoft.com/office/drawing/2014/main" id="{750A2B88-A5B8-444B-A65D-4C902E8C20C7}"/>
               </a:ext>
             </a:extLst>
           </p:cNvPr>
@@ -13131,7 +12883,7 @@
           <p:cNvPr id="2" name="">
             <a:extLst xmlns:a="http://schemas.openxmlformats.org/drawingml/2006/main">
               <a:ext uri="{FF2B5EF4-FFF2-40B4-BE49-F238E27FC236}">
-                <a16:creationId xmlns:a16="http://schemas.microsoft.com/office/drawing/2014/main" id="{04D1ED3D-7766-4C76-A0C1-F294A6F47D66}"/>
+                <a16:creationId xmlns:a16="http://schemas.microsoft.com/office/drawing/2014/main" id="{8139A9F5-32FF-4866-B0A5-835D08350B30}"/>
               </a:ext>
             </a:extLst>
           </p:cNvPr>
@@ -13287,7 +13039,7 @@
           <p:cNvPr id="3" name="">
             <a:extLst xmlns:a="http://schemas.openxmlformats.org/drawingml/2006/main">
               <a:ext uri="{FF2B5EF4-FFF2-40B4-BE49-F238E27FC236}">
-                <a16:creationId xmlns:a16="http://schemas.microsoft.com/office/drawing/2014/main" id="{1792A1FE-8B07-4CF8-92F4-FB9AFBBC4B90}"/>
+                <a16:creationId xmlns:a16="http://schemas.microsoft.com/office/drawing/2014/main" id="{834F2207-B451-4799-960C-C8DAF527FB02}"/>
               </a:ext>
             </a:extLst>
           </p:cNvPr>
@@ -13427,7 +13179,7 @@
           <p:cNvPr id="4" name="">
             <a:extLst xmlns:a="http://schemas.openxmlformats.org/drawingml/2006/main">
               <a:ext uri="{FF2B5EF4-FFF2-40B4-BE49-F238E27FC236}">
-                <a16:creationId xmlns:a16="http://schemas.microsoft.com/office/drawing/2014/main" id="{B77F4EB7-7118-4366-AACA-1A489EE0351C}"/>
+                <a16:creationId xmlns:a16="http://schemas.microsoft.com/office/drawing/2014/main" id="{5452A70E-B51B-4B81-A171-19BC4DD62B44}"/>
               </a:ext>
             </a:extLst>
           </p:cNvPr>
@@ -13583,7 +13335,7 @@
           <p:cNvPr id="5" name="">
             <a:extLst xmlns:a="http://schemas.openxmlformats.org/drawingml/2006/main">
               <a:ext uri="{FF2B5EF4-FFF2-40B4-BE49-F238E27FC236}">
-                <a16:creationId xmlns:a16="http://schemas.microsoft.com/office/drawing/2014/main" id="{47FBF774-2021-4492-AC46-6DD9950D2595}"/>
+                <a16:creationId xmlns:a16="http://schemas.microsoft.com/office/drawing/2014/main" id="{5F66A2AC-AF83-469E-B785-58E1670EA87B}"/>
               </a:ext>
             </a:extLst>
           </p:cNvPr>
@@ -13821,7 +13573,7 @@
     </p:spTree>
     <p:extLst>
       <p:ext uri="{BB962C8B-B14F-4D97-AF65-F5344CB8AC3E}">
-        <p14:creationId xmlns:p14="http://schemas.microsoft.com/office/powerpoint/2010/main" val="1443130701"/>
+        <p14:creationId xmlns:p14="http://schemas.microsoft.com/office/powerpoint/2010/main" val="1879098980"/>
       </p:ext>
     </p:extLst>
   </p:cSld>
@@ -13852,7 +13604,7 @@
           <p:cNvPr id="6" name="">
             <a:extLst xmlns:a="http://schemas.openxmlformats.org/drawingml/2006/main">
               <a:ext uri="{FF2B5EF4-FFF2-40B4-BE49-F238E27FC236}">
-                <a16:creationId xmlns:a16="http://schemas.microsoft.com/office/drawing/2014/main" id="{F8F15FFE-1BF4-45E5-BC13-D255955BB97B}"/>
+                <a16:creationId xmlns:a16="http://schemas.microsoft.com/office/drawing/2014/main" id="{A110A8C7-D6B3-469D-990A-6C791C496D22}"/>
               </a:ext>
             </a:extLst>
           </p:cNvPr>
@@ -14008,7 +13760,7 @@
           <p:cNvPr id="2" name="">
             <a:extLst xmlns:a="http://schemas.openxmlformats.org/drawingml/2006/main">
               <a:ext uri="{FF2B5EF4-FFF2-40B4-BE49-F238E27FC236}">
-                <a16:creationId xmlns:a16="http://schemas.microsoft.com/office/drawing/2014/main" id="{0FBD71FD-A463-4B3A-86BF-5FA6195C35A9}"/>
+                <a16:creationId xmlns:a16="http://schemas.microsoft.com/office/drawing/2014/main" id="{B402366F-05FB-4235-AE37-68D7298C50D7}"/>
               </a:ext>
             </a:extLst>
           </p:cNvPr>
@@ -14164,7 +13916,7 @@
           <p:cNvPr id="3" name="">
             <a:extLst xmlns:a="http://schemas.openxmlformats.org/drawingml/2006/main">
               <a:ext uri="{FF2B5EF4-FFF2-40B4-BE49-F238E27FC236}">
-                <a16:creationId xmlns:a16="http://schemas.microsoft.com/office/drawing/2014/main" id="{DD8582CA-2573-4581-93F4-FB0247ADD90B}"/>
+                <a16:creationId xmlns:a16="http://schemas.microsoft.com/office/drawing/2014/main" id="{ECE8447E-780A-4312-A4F2-FBB0A8DEDDE3}"/>
               </a:ext>
             </a:extLst>
           </p:cNvPr>
@@ -14304,7 +14056,7 @@
           <p:cNvPr id="4" name="">
             <a:extLst xmlns:a="http://schemas.openxmlformats.org/drawingml/2006/main">
               <a:ext uri="{FF2B5EF4-FFF2-40B4-BE49-F238E27FC236}">
-                <a16:creationId xmlns:a16="http://schemas.microsoft.com/office/drawing/2014/main" id="{F162832D-D857-41DB-BE39-1942789B59D1}"/>
+                <a16:creationId xmlns:a16="http://schemas.microsoft.com/office/drawing/2014/main" id="{5C0ABE74-88D3-499D-8FE3-BA2B3B8B7FB5}"/>
               </a:ext>
             </a:extLst>
           </p:cNvPr>
@@ -14460,7 +14212,7 @@
           <p:cNvPr id="5" name="">
             <a:extLst xmlns:a="http://schemas.openxmlformats.org/drawingml/2006/main">
               <a:ext uri="{FF2B5EF4-FFF2-40B4-BE49-F238E27FC236}">
-                <a16:creationId xmlns:a16="http://schemas.microsoft.com/office/drawing/2014/main" id="{EFADEAE3-045C-4B79-BF0A-85E7567EF51A}"/>
+                <a16:creationId xmlns:a16="http://schemas.microsoft.com/office/drawing/2014/main" id="{C50DB0D1-C1CB-460A-B085-6A1E34948EBB}"/>
               </a:ext>
             </a:extLst>
           </p:cNvPr>
@@ -14716,7 +14468,7 @@
     </p:spTree>
     <p:extLst>
       <p:ext uri="{BB962C8B-B14F-4D97-AF65-F5344CB8AC3E}">
-        <p14:creationId xmlns:p14="http://schemas.microsoft.com/office/powerpoint/2010/main" val="1114576802"/>
+        <p14:creationId xmlns:p14="http://schemas.microsoft.com/office/powerpoint/2010/main" val="885495888"/>
       </p:ext>
     </p:extLst>
   </p:cSld>
@@ -14747,7 +14499,7 @@
           <p:cNvPr id="6" name="">
             <a:extLst xmlns:a="http://schemas.openxmlformats.org/drawingml/2006/main">
               <a:ext uri="{FF2B5EF4-FFF2-40B4-BE49-F238E27FC236}">
-                <a16:creationId xmlns:a16="http://schemas.microsoft.com/office/drawing/2014/main" id="{58DBAF0F-0D8C-4C9D-B2C1-3C113E6CE038}"/>
+                <a16:creationId xmlns:a16="http://schemas.microsoft.com/office/drawing/2014/main" id="{6686D590-6CE4-4B78-8B7F-826D15003DCB}"/>
               </a:ext>
             </a:extLst>
           </p:cNvPr>
@@ -14903,7 +14655,7 @@
           <p:cNvPr id="2" name="">
             <a:extLst xmlns:a="http://schemas.openxmlformats.org/drawingml/2006/main">
               <a:ext uri="{FF2B5EF4-FFF2-40B4-BE49-F238E27FC236}">
-                <a16:creationId xmlns:a16="http://schemas.microsoft.com/office/drawing/2014/main" id="{B5B82BD9-2E26-4B3D-9937-CE303D8310C4}"/>
+                <a16:creationId xmlns:a16="http://schemas.microsoft.com/office/drawing/2014/main" id="{2E39405B-2D8F-4FDB-A986-E5631BE37467}"/>
               </a:ext>
             </a:extLst>
           </p:cNvPr>
@@ -15059,7 +14811,7 @@
           <p:cNvPr id="3" name="">
             <a:extLst xmlns:a="http://schemas.openxmlformats.org/drawingml/2006/main">
               <a:ext uri="{FF2B5EF4-FFF2-40B4-BE49-F238E27FC236}">
-                <a16:creationId xmlns:a16="http://schemas.microsoft.com/office/drawing/2014/main" id="{2C93E257-0C71-4C76-9C70-55A574D91A8B}"/>
+                <a16:creationId xmlns:a16="http://schemas.microsoft.com/office/drawing/2014/main" id="{DFD6AC47-F1BA-4E71-BA65-C51D0A566106}"/>
               </a:ext>
             </a:extLst>
           </p:cNvPr>
@@ -15199,7 +14951,7 @@
           <p:cNvPr id="4" name="">
             <a:extLst xmlns:a="http://schemas.openxmlformats.org/drawingml/2006/main">
               <a:ext uri="{FF2B5EF4-FFF2-40B4-BE49-F238E27FC236}">
-                <a16:creationId xmlns:a16="http://schemas.microsoft.com/office/drawing/2014/main" id="{9421B4F3-8105-43DC-AD0E-345C6E2FED9A}"/>
+                <a16:creationId xmlns:a16="http://schemas.microsoft.com/office/drawing/2014/main" id="{9841D918-4D47-4A94-8CD3-F3817306689B}"/>
               </a:ext>
             </a:extLst>
           </p:cNvPr>
@@ -15355,7 +15107,7 @@
           <p:cNvPr id="5" name="">
             <a:extLst xmlns:a="http://schemas.openxmlformats.org/drawingml/2006/main">
               <a:ext uri="{FF2B5EF4-FFF2-40B4-BE49-F238E27FC236}">
-                <a16:creationId xmlns:a16="http://schemas.microsoft.com/office/drawing/2014/main" id="{2D96B135-BEF8-45D4-9300-62CFBA0E90D3}"/>
+                <a16:creationId xmlns:a16="http://schemas.microsoft.com/office/drawing/2014/main" id="{358A95E3-1954-4B02-A1BF-B4DCA5423DB3}"/>
               </a:ext>
             </a:extLst>
           </p:cNvPr>
@@ -15593,7 +15345,7 @@
     </p:spTree>
     <p:extLst>
       <p:ext uri="{BB962C8B-B14F-4D97-AF65-F5344CB8AC3E}">
-        <p14:creationId xmlns:p14="http://schemas.microsoft.com/office/powerpoint/2010/main" val="2059823836"/>
+        <p14:creationId xmlns:p14="http://schemas.microsoft.com/office/powerpoint/2010/main" val="1968442466"/>
       </p:ext>
     </p:extLst>
   </p:cSld>
@@ -15624,7 +15376,7 @@
           <p:cNvPr id="7" name="">
             <a:extLst xmlns:a="http://schemas.openxmlformats.org/drawingml/2006/main">
               <a:ext uri="{FF2B5EF4-FFF2-40B4-BE49-F238E27FC236}">
-                <a16:creationId xmlns:a16="http://schemas.microsoft.com/office/drawing/2014/main" id="{215496EA-F9DA-40DE-B20A-6BA88802D7FA}"/>
+                <a16:creationId xmlns:a16="http://schemas.microsoft.com/office/drawing/2014/main" id="{B586437F-0477-4F8C-B3F6-C80964A5CD71}"/>
               </a:ext>
             </a:extLst>
           </p:cNvPr>
@@ -15780,7 +15532,7 @@
           <p:cNvPr id="2" name="">
             <a:extLst xmlns:a="http://schemas.openxmlformats.org/drawingml/2006/main">
               <a:ext uri="{FF2B5EF4-FFF2-40B4-BE49-F238E27FC236}">
-                <a16:creationId xmlns:a16="http://schemas.microsoft.com/office/drawing/2014/main" id="{C8B75421-440B-43FF-913E-A5BFBF6BC3C7}"/>
+                <a16:creationId xmlns:a16="http://schemas.microsoft.com/office/drawing/2014/main" id="{639BD782-B0D0-46BC-9A09-D82933F5D6C0}"/>
               </a:ext>
             </a:extLst>
           </p:cNvPr>
@@ -15936,7 +15688,7 @@
           <p:cNvPr id="3" name="">
             <a:extLst xmlns:a="http://schemas.openxmlformats.org/drawingml/2006/main">
               <a:ext uri="{FF2B5EF4-FFF2-40B4-BE49-F238E27FC236}">
-                <a16:creationId xmlns:a16="http://schemas.microsoft.com/office/drawing/2014/main" id="{793A8C15-1A45-47D3-A674-32372EDD73CA}"/>
+                <a16:creationId xmlns:a16="http://schemas.microsoft.com/office/drawing/2014/main" id="{870EF667-41B0-4984-9389-ED57BDD2E3A3}"/>
               </a:ext>
             </a:extLst>
           </p:cNvPr>
@@ -16076,7 +15828,7 @@
           <p:cNvPr id="4" name="">
             <a:extLst xmlns:a="http://schemas.openxmlformats.org/drawingml/2006/main">
               <a:ext uri="{FF2B5EF4-FFF2-40B4-BE49-F238E27FC236}">
-                <a16:creationId xmlns:a16="http://schemas.microsoft.com/office/drawing/2014/main" id="{31E74449-B425-4622-AD97-D8A89BC5E9FF}"/>
+                <a16:creationId xmlns:a16="http://schemas.microsoft.com/office/drawing/2014/main" id="{839D0CFC-6629-487D-B460-998AE7C0F758}"/>
               </a:ext>
             </a:extLst>
           </p:cNvPr>
@@ -16232,7 +15984,7 @@
           <p:cNvPr id="5" name="">
             <a:extLst xmlns:a="http://schemas.openxmlformats.org/drawingml/2006/main">
               <a:ext uri="{FF2B5EF4-FFF2-40B4-BE49-F238E27FC236}">
-                <a16:creationId xmlns:a16="http://schemas.microsoft.com/office/drawing/2014/main" id="{21CC96FF-B99E-462A-8213-0C36FE4A1492}"/>
+                <a16:creationId xmlns:a16="http://schemas.microsoft.com/office/drawing/2014/main" id="{22345A8E-0DD4-4420-B90A-DB3F362170D3}"/>
               </a:ext>
             </a:extLst>
           </p:cNvPr>
@@ -16242,7 +15994,7 @@
           <p:nvPr/>
         </p:nvPicPr>
         <p:blipFill>
-          <a:blip xmlns:r="http://schemas.openxmlformats.org/officeDocument/2006/relationships" xmlns:a="http://schemas.openxmlformats.org/drawingml/2006/main" r:embed="R61ec04f4f9e74b85"/>
+          <a:blip xmlns:r="http://schemas.openxmlformats.org/officeDocument/2006/relationships" xmlns:a="http://schemas.openxmlformats.org/drawingml/2006/main" r:embed="Rd7ef54f791b3407a"/>
           <a:stretch xmlns:a="http://schemas.openxmlformats.org/drawingml/2006/main"/>
         </p:blipFill>
         <p:spPr>
@@ -16260,7 +16012,7 @@
           <p:cNvPr id="6" name="">
             <a:extLst xmlns:a="http://schemas.openxmlformats.org/drawingml/2006/main">
               <a:ext uri="{FF2B5EF4-FFF2-40B4-BE49-F238E27FC236}">
-                <a16:creationId xmlns:a16="http://schemas.microsoft.com/office/drawing/2014/main" id="{8D0A602E-ED5C-4F3A-95F6-2CCAF46BB03F}"/>
+                <a16:creationId xmlns:a16="http://schemas.microsoft.com/office/drawing/2014/main" id="{8D71E540-F004-48F0-9FA9-CC2F932B8D14}"/>
               </a:ext>
             </a:extLst>
           </p:cNvPr>
@@ -16414,7 +16166,7 @@
     </p:spTree>
     <p:extLst>
       <p:ext uri="{BB962C8B-B14F-4D97-AF65-F5344CB8AC3E}">
-        <p14:creationId xmlns:p14="http://schemas.microsoft.com/office/powerpoint/2010/main" val="656375871"/>
+        <p14:creationId xmlns:p14="http://schemas.microsoft.com/office/powerpoint/2010/main" val="1134809859"/>
       </p:ext>
     </p:extLst>
   </p:cSld>
@@ -16445,7 +16197,7 @@
           <p:cNvPr id="7" name="">
             <a:extLst xmlns:a="http://schemas.openxmlformats.org/drawingml/2006/main">
               <a:ext uri="{FF2B5EF4-FFF2-40B4-BE49-F238E27FC236}">
-                <a16:creationId xmlns:a16="http://schemas.microsoft.com/office/drawing/2014/main" id="{C8F8BC8B-4BE1-4204-B502-8E4F1AD6AF74}"/>
+                <a16:creationId xmlns:a16="http://schemas.microsoft.com/office/drawing/2014/main" id="{4AC9506A-9422-4D5E-9173-E91131A4F185}"/>
               </a:ext>
             </a:extLst>
           </p:cNvPr>
@@ -16601,7 +16353,7 @@
           <p:cNvPr id="2" name="">
             <a:extLst xmlns:a="http://schemas.openxmlformats.org/drawingml/2006/main">
               <a:ext uri="{FF2B5EF4-FFF2-40B4-BE49-F238E27FC236}">
-                <a16:creationId xmlns:a16="http://schemas.microsoft.com/office/drawing/2014/main" id="{53BD99A5-0EFB-48B0-85D1-40C74665B789}"/>
+                <a16:creationId xmlns:a16="http://schemas.microsoft.com/office/drawing/2014/main" id="{238BD408-9A0B-4638-BBF2-885797B54980}"/>
               </a:ext>
             </a:extLst>
           </p:cNvPr>
@@ -16757,7 +16509,7 @@
           <p:cNvPr id="3" name="">
             <a:extLst xmlns:a="http://schemas.openxmlformats.org/drawingml/2006/main">
               <a:ext uri="{FF2B5EF4-FFF2-40B4-BE49-F238E27FC236}">
-                <a16:creationId xmlns:a16="http://schemas.microsoft.com/office/drawing/2014/main" id="{3D1EFFC1-86CC-43E0-A024-CA3132A26575}"/>
+                <a16:creationId xmlns:a16="http://schemas.microsoft.com/office/drawing/2014/main" id="{0D89CAC9-8399-4AB7-B037-2DD8A9E4ED2A}"/>
               </a:ext>
             </a:extLst>
           </p:cNvPr>
@@ -16897,7 +16649,7 @@
           <p:cNvPr id="4" name="">
             <a:extLst xmlns:a="http://schemas.openxmlformats.org/drawingml/2006/main">
               <a:ext uri="{FF2B5EF4-FFF2-40B4-BE49-F238E27FC236}">
-                <a16:creationId xmlns:a16="http://schemas.microsoft.com/office/drawing/2014/main" id="{D7EC4771-554A-4161-889C-6266B0F073D7}"/>
+                <a16:creationId xmlns:a16="http://schemas.microsoft.com/office/drawing/2014/main" id="{03371071-F918-4753-954C-24CEEBB3131C}"/>
               </a:ext>
             </a:extLst>
           </p:cNvPr>
@@ -17053,7 +16805,7 @@
           <p:cNvPr id="5" name="">
             <a:extLst xmlns:a="http://schemas.openxmlformats.org/drawingml/2006/main">
               <a:ext uri="{FF2B5EF4-FFF2-40B4-BE49-F238E27FC236}">
-                <a16:creationId xmlns:a16="http://schemas.microsoft.com/office/drawing/2014/main" id="{235421D8-4CBB-4DA8-95E3-627D5A3887EB}"/>
+                <a16:creationId xmlns:a16="http://schemas.microsoft.com/office/drawing/2014/main" id="{B3407DA8-D5B6-484A-B9A2-E94E682A1CDB}"/>
               </a:ext>
             </a:extLst>
           </p:cNvPr>
@@ -17063,7 +16815,7 @@
           <p:nvPr/>
         </p:nvPicPr>
         <p:blipFill>
-          <a:blip xmlns:r="http://schemas.openxmlformats.org/officeDocument/2006/relationships" xmlns:a="http://schemas.openxmlformats.org/drawingml/2006/main" r:embed="R8c445ff73a0a45ad"/>
+          <a:blip xmlns:r="http://schemas.openxmlformats.org/officeDocument/2006/relationships" xmlns:a="http://schemas.openxmlformats.org/drawingml/2006/main" r:embed="R06cd59647b1346d9"/>
           <a:stretch xmlns:a="http://schemas.openxmlformats.org/drawingml/2006/main"/>
         </p:blipFill>
         <p:spPr>
@@ -17081,7 +16833,7 @@
           <p:cNvPr id="6" name="">
             <a:extLst xmlns:a="http://schemas.openxmlformats.org/drawingml/2006/main">
               <a:ext uri="{FF2B5EF4-FFF2-40B4-BE49-F238E27FC236}">
-                <a16:creationId xmlns:a16="http://schemas.microsoft.com/office/drawing/2014/main" id="{4FCB57F6-A9AB-4A73-8967-B116B18E3388}"/>
+                <a16:creationId xmlns:a16="http://schemas.microsoft.com/office/drawing/2014/main" id="{CB9AABFC-5558-41E8-87AF-6EBD342B0647}"/>
               </a:ext>
             </a:extLst>
           </p:cNvPr>
@@ -17235,7 +16987,7 @@
     </p:spTree>
     <p:extLst>
       <p:ext uri="{BB962C8B-B14F-4D97-AF65-F5344CB8AC3E}">
-        <p14:creationId xmlns:p14="http://schemas.microsoft.com/office/powerpoint/2010/main" val="818228953"/>
+        <p14:creationId xmlns:p14="http://schemas.microsoft.com/office/powerpoint/2010/main" val="1693952675"/>
       </p:ext>
     </p:extLst>
   </p:cSld>
@@ -17266,7 +17018,7 @@
           <p:cNvPr id="7" name="">
             <a:extLst xmlns:a="http://schemas.openxmlformats.org/drawingml/2006/main">
               <a:ext uri="{FF2B5EF4-FFF2-40B4-BE49-F238E27FC236}">
-                <a16:creationId xmlns:a16="http://schemas.microsoft.com/office/drawing/2014/main" id="{DECAED2C-A2AB-438E-9D5E-59250F1DAC60}"/>
+                <a16:creationId xmlns:a16="http://schemas.microsoft.com/office/drawing/2014/main" id="{E106A436-4172-4641-9FAC-88274050C69F}"/>
               </a:ext>
             </a:extLst>
           </p:cNvPr>
@@ -17422,7 +17174,7 @@
           <p:cNvPr id="2" name="">
             <a:extLst xmlns:a="http://schemas.openxmlformats.org/drawingml/2006/main">
               <a:ext uri="{FF2B5EF4-FFF2-40B4-BE49-F238E27FC236}">
-                <a16:creationId xmlns:a16="http://schemas.microsoft.com/office/drawing/2014/main" id="{A496658C-13FA-43A7-8BD2-B8D46D2EC7AE}"/>
+                <a16:creationId xmlns:a16="http://schemas.microsoft.com/office/drawing/2014/main" id="{E4FCBBAB-F4ED-4200-A84D-FCF9C68DDCAF}"/>
               </a:ext>
             </a:extLst>
           </p:cNvPr>
@@ -17578,7 +17330,7 @@
           <p:cNvPr id="3" name="">
             <a:extLst xmlns:a="http://schemas.openxmlformats.org/drawingml/2006/main">
               <a:ext uri="{FF2B5EF4-FFF2-40B4-BE49-F238E27FC236}">
-                <a16:creationId xmlns:a16="http://schemas.microsoft.com/office/drawing/2014/main" id="{4B3E11DE-CDBC-412B-8C39-0021EA4097E0}"/>
+                <a16:creationId xmlns:a16="http://schemas.microsoft.com/office/drawing/2014/main" id="{6326F258-60AA-46C2-9687-79B2221E5607}"/>
               </a:ext>
             </a:extLst>
           </p:cNvPr>
@@ -17718,7 +17470,7 @@
           <p:cNvPr id="4" name="">
             <a:extLst xmlns:a="http://schemas.openxmlformats.org/drawingml/2006/main">
               <a:ext uri="{FF2B5EF4-FFF2-40B4-BE49-F238E27FC236}">
-                <a16:creationId xmlns:a16="http://schemas.microsoft.com/office/drawing/2014/main" id="{07724C02-EC92-446C-848D-74FD69D64337}"/>
+                <a16:creationId xmlns:a16="http://schemas.microsoft.com/office/drawing/2014/main" id="{DBD40E7E-5747-4744-AE97-3DBF0CDF1472}"/>
               </a:ext>
             </a:extLst>
           </p:cNvPr>
@@ -17874,7 +17626,7 @@
           <p:cNvPr id="5" name="">
             <a:extLst xmlns:a="http://schemas.openxmlformats.org/drawingml/2006/main">
               <a:ext uri="{FF2B5EF4-FFF2-40B4-BE49-F238E27FC236}">
-                <a16:creationId xmlns:a16="http://schemas.microsoft.com/office/drawing/2014/main" id="{532A01D9-AADF-4619-AAA1-E772B66B09BE}"/>
+                <a16:creationId xmlns:a16="http://schemas.microsoft.com/office/drawing/2014/main" id="{424A19C3-83C9-4FF6-9D56-AC514BA9FE43}"/>
               </a:ext>
             </a:extLst>
           </p:cNvPr>
@@ -18733,7 +18485,7 @@
           <p:cNvPr id="6" name="">
             <a:extLst xmlns:a="http://schemas.openxmlformats.org/drawingml/2006/main">
               <a:ext uri="{FF2B5EF4-FFF2-40B4-BE49-F238E27FC236}">
-                <a16:creationId xmlns:a16="http://schemas.microsoft.com/office/drawing/2014/main" id="{FAAE0E1A-FE5B-43D1-A1FB-0084946147A8}"/>
+                <a16:creationId xmlns:a16="http://schemas.microsoft.com/office/drawing/2014/main" id="{0B276F1B-9234-44D6-A1FA-28CB153B1C9D}"/>
               </a:ext>
             </a:extLst>
           </p:cNvPr>
@@ -18887,7 +18639,7 @@
     </p:spTree>
     <p:extLst>
       <p:ext uri="{BB962C8B-B14F-4D97-AF65-F5344CB8AC3E}">
-        <p14:creationId xmlns:p14="http://schemas.microsoft.com/office/powerpoint/2010/main" val="357157380"/>
+        <p14:creationId xmlns:p14="http://schemas.microsoft.com/office/powerpoint/2010/main" val="1275368150"/>
       </p:ext>
     </p:extLst>
   </p:cSld>

</xml_diff>

<commit_message>
Complete four-workload LLC controls and document TC memory wait
</commit_message>
<xml_diff>
--- a/presentation/CSLab_Memory_Tiering_Current.pptx
+++ b/presentation/CSLab_Memory_Tiering_Current.pptx
@@ -2,27 +2,27 @@
 <file path=ppt/presentation.xml><?xml version="1.0" encoding="utf-8"?>
 <p:presentation xmlns:p="http://schemas.openxmlformats.org/presentationml/2006/main">
   <p:sldMasterIdLst>
-    <p:sldMasterId xmlns:r="http://schemas.openxmlformats.org/officeDocument/2006/relationships" id="2147483648" r:id="Ra76e879b32004879"/>
+    <p:sldMasterId xmlns:r="http://schemas.openxmlformats.org/officeDocument/2006/relationships" id="2147483648" r:id="Rfa31b1364f8a4554"/>
   </p:sldMasterIdLst>
   <p:notesMasterIdLst>
-    <p:notesMasterId xmlns:r="http://schemas.openxmlformats.org/officeDocument/2006/relationships" r:id="Re07bb77973204bbc"/>
+    <p:notesMasterId xmlns:r="http://schemas.openxmlformats.org/officeDocument/2006/relationships" r:id="R1305bb37e6844e52"/>
   </p:notesMasterIdLst>
   <p:sldIdLst>
-    <p:sldId xmlns:r="http://schemas.openxmlformats.org/officeDocument/2006/relationships" id="256" r:id="R294fc1741666473a"/>
-    <p:sldId xmlns:r="http://schemas.openxmlformats.org/officeDocument/2006/relationships" id="257" r:id="R697a6e78d9f34638"/>
-    <p:sldId xmlns:r="http://schemas.openxmlformats.org/officeDocument/2006/relationships" id="258" r:id="Rb9ebf81fcb9544b8"/>
-    <p:sldId xmlns:r="http://schemas.openxmlformats.org/officeDocument/2006/relationships" id="259" r:id="Ra41f609870fc4699"/>
-    <p:sldId xmlns:r="http://schemas.openxmlformats.org/officeDocument/2006/relationships" id="260" r:id="R67a2ce6162c04cbe"/>
-    <p:sldId xmlns:r="http://schemas.openxmlformats.org/officeDocument/2006/relationships" id="261" r:id="R4bd6954a63274a7e"/>
-    <p:sldId xmlns:r="http://schemas.openxmlformats.org/officeDocument/2006/relationships" id="262" r:id="R2830f0f9559d43d4"/>
-    <p:sldId xmlns:r="http://schemas.openxmlformats.org/officeDocument/2006/relationships" id="263" r:id="R2348ff224a974a94"/>
-    <p:sldId xmlns:r="http://schemas.openxmlformats.org/officeDocument/2006/relationships" id="264" r:id="R32a3725bb9ae4039"/>
-    <p:sldId xmlns:r="http://schemas.openxmlformats.org/officeDocument/2006/relationships" id="265" r:id="R5c8b270d6d5e429e"/>
-    <p:sldId xmlns:r="http://schemas.openxmlformats.org/officeDocument/2006/relationships" id="266" r:id="R6ca6f6ff392f49dd"/>
-    <p:sldId xmlns:r="http://schemas.openxmlformats.org/officeDocument/2006/relationships" id="267" r:id="Rbf302d2c1e9d4767"/>
-    <p:sldId xmlns:r="http://schemas.openxmlformats.org/officeDocument/2006/relationships" id="268" r:id="R154dcca4b7ef4951"/>
-    <p:sldId xmlns:r="http://schemas.openxmlformats.org/officeDocument/2006/relationships" id="269" r:id="R0072c14ae3c34aa2"/>
-    <p:sldId xmlns:r="http://schemas.openxmlformats.org/officeDocument/2006/relationships" id="270" r:id="Rd5addd45ca394c2e"/>
+    <p:sldId xmlns:r="http://schemas.openxmlformats.org/officeDocument/2006/relationships" id="256" r:id="Racef20f68ed14a1b"/>
+    <p:sldId xmlns:r="http://schemas.openxmlformats.org/officeDocument/2006/relationships" id="257" r:id="Rbc62f27f2d42456f"/>
+    <p:sldId xmlns:r="http://schemas.openxmlformats.org/officeDocument/2006/relationships" id="258" r:id="R808c1f20a02c4c79"/>
+    <p:sldId xmlns:r="http://schemas.openxmlformats.org/officeDocument/2006/relationships" id="259" r:id="Rd039691dfde343d2"/>
+    <p:sldId xmlns:r="http://schemas.openxmlformats.org/officeDocument/2006/relationships" id="260" r:id="Rdcdbc295b78d4950"/>
+    <p:sldId xmlns:r="http://schemas.openxmlformats.org/officeDocument/2006/relationships" id="261" r:id="R14a63060e30a43b7"/>
+    <p:sldId xmlns:r="http://schemas.openxmlformats.org/officeDocument/2006/relationships" id="262" r:id="R0898579cc7674802"/>
+    <p:sldId xmlns:r="http://schemas.openxmlformats.org/officeDocument/2006/relationships" id="263" r:id="R5dd893a95d7e4001"/>
+    <p:sldId xmlns:r="http://schemas.openxmlformats.org/officeDocument/2006/relationships" id="264" r:id="R6f3748e1ce274c75"/>
+    <p:sldId xmlns:r="http://schemas.openxmlformats.org/officeDocument/2006/relationships" id="265" r:id="R37e72d1e96c54fea"/>
+    <p:sldId xmlns:r="http://schemas.openxmlformats.org/officeDocument/2006/relationships" id="266" r:id="R490df86c39b34bd1"/>
+    <p:sldId xmlns:r="http://schemas.openxmlformats.org/officeDocument/2006/relationships" id="267" r:id="Ree9523e4511b47dc"/>
+    <p:sldId xmlns:r="http://schemas.openxmlformats.org/officeDocument/2006/relationships" id="268" r:id="R1ddf6802886d4a70"/>
+    <p:sldId xmlns:r="http://schemas.openxmlformats.org/officeDocument/2006/relationships" id="269" r:id="R342caf2b2c07463d"/>
+    <p:sldId xmlns:r="http://schemas.openxmlformats.org/officeDocument/2006/relationships" id="270" r:id="R2efff1a077ff410d"/>
   </p:sldIdLst>
   <p:sldSz cx="12192000" cy="6858000"/>
   <p:notesSz cx="6858000" cy="9144000"/>
@@ -1633,7 +1633,7 @@
           <p:cNvPr id="3" name="Title">
             <a:extLst xmlns:a="http://schemas.openxmlformats.org/drawingml/2006/main">
               <a:ext uri="{FF2B5EF4-FFF2-40B4-BE49-F238E27FC236}">
-                <a16:creationId xmlns:a16="http://schemas.microsoft.com/office/drawing/2014/main" id="{4FEF78DB-53E4-4C1B-807E-F237C2DC2374}"/>
+                <a16:creationId xmlns:a16="http://schemas.microsoft.com/office/drawing/2014/main" id="{785BD520-0C16-4183-804C-9FA5EEC24E85}"/>
               </a:ext>
             </a:extLst>
           </p:cNvPr>
@@ -1862,7 +1862,7 @@
           <p:cNvPr id="2" name="Subtitle">
             <a:extLst xmlns:a="http://schemas.openxmlformats.org/drawingml/2006/main">
               <a:ext uri="{FF2B5EF4-FFF2-40B4-BE49-F238E27FC236}">
-                <a16:creationId xmlns:a16="http://schemas.microsoft.com/office/drawing/2014/main" id="{2857AB86-CAE2-4EA5-8532-78BEA5966ABA}"/>
+                <a16:creationId xmlns:a16="http://schemas.microsoft.com/office/drawing/2014/main" id="{49F0A8E9-315F-4797-9F72-C6C6DDACA656}"/>
               </a:ext>
             </a:extLst>
           </p:cNvPr>
@@ -2108,7 +2108,7 @@
           <p:cNvPr id="2" name="Section title">
             <a:extLst xmlns:a="http://schemas.openxmlformats.org/drawingml/2006/main">
               <a:ext uri="{FF2B5EF4-FFF2-40B4-BE49-F238E27FC236}">
-                <a16:creationId xmlns:a16="http://schemas.microsoft.com/office/drawing/2014/main" id="{556DCA83-6637-4F2F-8E08-3D67F24E54B6}"/>
+                <a16:creationId xmlns:a16="http://schemas.microsoft.com/office/drawing/2014/main" id="{00FA708B-DCF6-45BF-AC07-979A2543C4E3}"/>
               </a:ext>
             </a:extLst>
           </p:cNvPr>
@@ -2354,7 +2354,7 @@
           <p:cNvPr id="3" name="Title">
             <a:extLst xmlns:a="http://schemas.openxmlformats.org/drawingml/2006/main">
               <a:ext uri="{FF2B5EF4-FFF2-40B4-BE49-F238E27FC236}">
-                <a16:creationId xmlns:a16="http://schemas.microsoft.com/office/drawing/2014/main" id="{BB3D3D23-50B4-46C9-895E-DB74D96C46DF}"/>
+                <a16:creationId xmlns:a16="http://schemas.microsoft.com/office/drawing/2014/main" id="{564EB2F3-DF4E-40F5-AF2F-78F0F1C35120}"/>
               </a:ext>
             </a:extLst>
           </p:cNvPr>
@@ -2583,7 +2583,7 @@
           <p:cNvPr id="2" name="Body">
             <a:extLst xmlns:a="http://schemas.openxmlformats.org/drawingml/2006/main">
               <a:ext uri="{FF2B5EF4-FFF2-40B4-BE49-F238E27FC236}">
-                <a16:creationId xmlns:a16="http://schemas.microsoft.com/office/drawing/2014/main" id="{A354CCD5-7E52-49E1-9115-C19242EFB49D}"/>
+                <a16:creationId xmlns:a16="http://schemas.microsoft.com/office/drawing/2014/main" id="{ACC1BFCD-4997-4978-B04D-CB858B4755D6}"/>
               </a:ext>
             </a:extLst>
           </p:cNvPr>
@@ -2829,7 +2829,7 @@
           <p:cNvPr id="4" name="Title">
             <a:extLst xmlns:a="http://schemas.openxmlformats.org/drawingml/2006/main">
               <a:ext uri="{FF2B5EF4-FFF2-40B4-BE49-F238E27FC236}">
-                <a16:creationId xmlns:a16="http://schemas.microsoft.com/office/drawing/2014/main" id="{76054A32-8DE5-4046-8392-768E16632A6F}"/>
+                <a16:creationId xmlns:a16="http://schemas.microsoft.com/office/drawing/2014/main" id="{AE4CD80E-A6D2-4221-9188-061952977AE7}"/>
               </a:ext>
             </a:extLst>
           </p:cNvPr>
@@ -3058,7 +3058,7 @@
           <p:cNvPr id="2" name="Left column">
             <a:extLst xmlns:a="http://schemas.openxmlformats.org/drawingml/2006/main">
               <a:ext uri="{FF2B5EF4-FFF2-40B4-BE49-F238E27FC236}">
-                <a16:creationId xmlns:a16="http://schemas.microsoft.com/office/drawing/2014/main" id="{EFB0016B-5A97-4D71-989B-570B33895CBD}"/>
+                <a16:creationId xmlns:a16="http://schemas.microsoft.com/office/drawing/2014/main" id="{64BF7D3A-5D2C-4C6D-92EF-E157BDEDE1A2}"/>
               </a:ext>
             </a:extLst>
           </p:cNvPr>
@@ -3287,7 +3287,7 @@
           <p:cNvPr id="3" name="Right column">
             <a:extLst xmlns:a="http://schemas.openxmlformats.org/drawingml/2006/main">
               <a:ext uri="{FF2B5EF4-FFF2-40B4-BE49-F238E27FC236}">
-                <a16:creationId xmlns:a16="http://schemas.microsoft.com/office/drawing/2014/main" id="{26FEBF76-2544-47E6-A773-048FA92033DE}"/>
+                <a16:creationId xmlns:a16="http://schemas.microsoft.com/office/drawing/2014/main" id="{488BC072-65CD-411D-B312-D69E69BF484D}"/>
               </a:ext>
             </a:extLst>
           </p:cNvPr>
@@ -3533,7 +3533,7 @@
           <p:cNvPr id="3" name="Title">
             <a:extLst xmlns:a="http://schemas.openxmlformats.org/drawingml/2006/main">
               <a:ext uri="{FF2B5EF4-FFF2-40B4-BE49-F238E27FC236}">
-                <a16:creationId xmlns:a16="http://schemas.microsoft.com/office/drawing/2014/main" id="{893EC604-E01F-4F88-8DAB-2F1FA3B63065}"/>
+                <a16:creationId xmlns:a16="http://schemas.microsoft.com/office/drawing/2014/main" id="{98014FCC-DD33-4CF6-9A3D-B9FED1FB08EC}"/>
               </a:ext>
             </a:extLst>
           </p:cNvPr>
@@ -3762,7 +3762,7 @@
           <p:cNvPr id="2" name="Left column">
             <a:extLst xmlns:a="http://schemas.openxmlformats.org/drawingml/2006/main">
               <a:ext uri="{FF2B5EF4-FFF2-40B4-BE49-F238E27FC236}">
-                <a16:creationId xmlns:a16="http://schemas.microsoft.com/office/drawing/2014/main" id="{97E742C4-AC9A-402B-B062-FE7982524B16}"/>
+                <a16:creationId xmlns:a16="http://schemas.microsoft.com/office/drawing/2014/main" id="{205A3EE3-CD0A-4561-AC26-9ABB64D4E23E}"/>
               </a:ext>
             </a:extLst>
           </p:cNvPr>
@@ -4029,12 +4029,12 @@
   </p:cSld>
   <p:clrMap bg1="lt1" tx1="dk1" bg2="lt2" tx2="dk2" accent1="accent1" accent2="accent2" accent3="accent3" accent4="accent4" accent5="accent5" accent6="accent6" hlink="hlink" folHlink="folHlink"/>
   <p:sldLayoutIdLst>
-    <p:sldLayoutId xmlns:r="http://schemas.openxmlformats.org/officeDocument/2006/relationships" id="2147483649" r:id="R01531a57f6024313"/>
-    <p:sldLayoutId xmlns:r="http://schemas.openxmlformats.org/officeDocument/2006/relationships" id="2147483650" r:id="Rdbf03116bc7845ff"/>
-    <p:sldLayoutId xmlns:r="http://schemas.openxmlformats.org/officeDocument/2006/relationships" id="2147483651" r:id="R26c514ba425b4aff"/>
-    <p:sldLayoutId xmlns:r="http://schemas.openxmlformats.org/officeDocument/2006/relationships" id="2147483652" r:id="R2e81e8ef8f2b4ad7"/>
-    <p:sldLayoutId xmlns:r="http://schemas.openxmlformats.org/officeDocument/2006/relationships" id="2147483653" r:id="R15c676b6d79c44ff"/>
-    <p:sldLayoutId xmlns:r="http://schemas.openxmlformats.org/officeDocument/2006/relationships" id="2147483654" r:id="R47fac33c6bae43c8"/>
+    <p:sldLayoutId xmlns:r="http://schemas.openxmlformats.org/officeDocument/2006/relationships" id="2147483649" r:id="Rf71d6ef056b041eb"/>
+    <p:sldLayoutId xmlns:r="http://schemas.openxmlformats.org/officeDocument/2006/relationships" id="2147483650" r:id="R4ae1178e55944506"/>
+    <p:sldLayoutId xmlns:r="http://schemas.openxmlformats.org/officeDocument/2006/relationships" id="2147483651" r:id="R4e45a419fea8485b"/>
+    <p:sldLayoutId xmlns:r="http://schemas.openxmlformats.org/officeDocument/2006/relationships" id="2147483652" r:id="R7beaf89ef4714473"/>
+    <p:sldLayoutId xmlns:r="http://schemas.openxmlformats.org/officeDocument/2006/relationships" id="2147483653" r:id="R417c33ab428f4a60"/>
+    <p:sldLayoutId xmlns:r="http://schemas.openxmlformats.org/officeDocument/2006/relationships" id="2147483654" r:id="R32db2bccec6a400b"/>
   </p:sldLayoutIdLst>
   <p:txStyles>
     <p:titleStyle>
@@ -4585,7 +4585,7 @@
           <p:cNvPr id="7" name="">
             <a:extLst xmlns:a="http://schemas.openxmlformats.org/drawingml/2006/main">
               <a:ext uri="{FF2B5EF4-FFF2-40B4-BE49-F238E27FC236}">
-                <a16:creationId xmlns:a16="http://schemas.microsoft.com/office/drawing/2014/main" id="{8374D728-9BD1-42C9-AA7B-DC084A38A554}"/>
+                <a16:creationId xmlns:a16="http://schemas.microsoft.com/office/drawing/2014/main" id="{3FA64B5D-576F-441F-A772-613AAD0A9AF0}"/>
               </a:ext>
             </a:extLst>
           </p:cNvPr>
@@ -4741,7 +4741,7 @@
           <p:cNvPr id="2" name="">
             <a:extLst xmlns:a="http://schemas.openxmlformats.org/drawingml/2006/main">
               <a:ext uri="{FF2B5EF4-FFF2-40B4-BE49-F238E27FC236}">
-                <a16:creationId xmlns:a16="http://schemas.microsoft.com/office/drawing/2014/main" id="{E25C06BD-1A5D-4EC3-BBA1-3EAB751337DC}"/>
+                <a16:creationId xmlns:a16="http://schemas.microsoft.com/office/drawing/2014/main" id="{01B5FE0C-D7B9-4990-A8BF-9C17BFF491C9}"/>
               </a:ext>
             </a:extLst>
           </p:cNvPr>
@@ -4897,7 +4897,7 @@
           <p:cNvPr id="3" name="">
             <a:extLst xmlns:a="http://schemas.openxmlformats.org/drawingml/2006/main">
               <a:ext uri="{FF2B5EF4-FFF2-40B4-BE49-F238E27FC236}">
-                <a16:creationId xmlns:a16="http://schemas.microsoft.com/office/drawing/2014/main" id="{E1F041C5-4348-4C2B-9C71-D586C1764C98}"/>
+                <a16:creationId xmlns:a16="http://schemas.microsoft.com/office/drawing/2014/main" id="{F0569AB1-8342-43D8-A6E6-C855AAFB91E9}"/>
               </a:ext>
             </a:extLst>
           </p:cNvPr>
@@ -5037,7 +5037,7 @@
           <p:cNvPr id="4" name="">
             <a:extLst xmlns:a="http://schemas.openxmlformats.org/drawingml/2006/main">
               <a:ext uri="{FF2B5EF4-FFF2-40B4-BE49-F238E27FC236}">
-                <a16:creationId xmlns:a16="http://schemas.microsoft.com/office/drawing/2014/main" id="{816B5EE3-58DE-4B5A-BDD3-93701DA7A800}"/>
+                <a16:creationId xmlns:a16="http://schemas.microsoft.com/office/drawing/2014/main" id="{D5794958-4D48-44F0-BA56-1DAD23C5DFD5}"/>
               </a:ext>
             </a:extLst>
           </p:cNvPr>
@@ -5193,7 +5193,7 @@
           <p:cNvPr id="5" name="">
             <a:extLst xmlns:a="http://schemas.openxmlformats.org/drawingml/2006/main">
               <a:ext uri="{FF2B5EF4-FFF2-40B4-BE49-F238E27FC236}">
-                <a16:creationId xmlns:a16="http://schemas.microsoft.com/office/drawing/2014/main" id="{48397F56-1DCF-48B9-84C5-AB29FD48D5B0}"/>
+                <a16:creationId xmlns:a16="http://schemas.microsoft.com/office/drawing/2014/main" id="{D712155A-BFE0-4C78-9242-251E31C857A8}"/>
               </a:ext>
             </a:extLst>
           </p:cNvPr>
@@ -5349,7 +5349,7 @@
           <p:cNvPr id="6" name="">
             <a:extLst xmlns:a="http://schemas.openxmlformats.org/drawingml/2006/main">
               <a:ext uri="{FF2B5EF4-FFF2-40B4-BE49-F238E27FC236}">
-                <a16:creationId xmlns:a16="http://schemas.microsoft.com/office/drawing/2014/main" id="{68852801-E53B-48CD-9F17-563920D2F8D2}"/>
+                <a16:creationId xmlns:a16="http://schemas.microsoft.com/office/drawing/2014/main" id="{06159314-1407-4BC9-A48E-BD214DA2F7FB}"/>
               </a:ext>
             </a:extLst>
           </p:cNvPr>
@@ -5554,7 +5554,7 @@
     </p:spTree>
     <p:extLst>
       <p:ext uri="{BB962C8B-B14F-4D97-AF65-F5344CB8AC3E}">
-        <p14:creationId xmlns:p14="http://schemas.microsoft.com/office/powerpoint/2010/main" val="962932628"/>
+        <p14:creationId xmlns:p14="http://schemas.microsoft.com/office/powerpoint/2010/main" val="1869164389"/>
       </p:ext>
     </p:extLst>
   </p:cSld>
@@ -5585,7 +5585,7 @@
           <p:cNvPr id="7" name="">
             <a:extLst xmlns:a="http://schemas.openxmlformats.org/drawingml/2006/main">
               <a:ext uri="{FF2B5EF4-FFF2-40B4-BE49-F238E27FC236}">
-                <a16:creationId xmlns:a16="http://schemas.microsoft.com/office/drawing/2014/main" id="{EECD80C1-DE97-4692-90BF-860FD1C5C36B}"/>
+                <a16:creationId xmlns:a16="http://schemas.microsoft.com/office/drawing/2014/main" id="{7D85AD17-F23E-4A9A-A053-8645863EDD51}"/>
               </a:ext>
             </a:extLst>
           </p:cNvPr>
@@ -5741,7 +5741,7 @@
           <p:cNvPr id="2" name="">
             <a:extLst xmlns:a="http://schemas.openxmlformats.org/drawingml/2006/main">
               <a:ext uri="{FF2B5EF4-FFF2-40B4-BE49-F238E27FC236}">
-                <a16:creationId xmlns:a16="http://schemas.microsoft.com/office/drawing/2014/main" id="{94785FE5-3461-4E67-A212-69DBB8A67AC2}"/>
+                <a16:creationId xmlns:a16="http://schemas.microsoft.com/office/drawing/2014/main" id="{EE137B99-DF61-47A0-92BA-7DBDDC0F8062}"/>
               </a:ext>
             </a:extLst>
           </p:cNvPr>
@@ -5897,7 +5897,7 @@
           <p:cNvPr id="3" name="">
             <a:extLst xmlns:a="http://schemas.openxmlformats.org/drawingml/2006/main">
               <a:ext uri="{FF2B5EF4-FFF2-40B4-BE49-F238E27FC236}">
-                <a16:creationId xmlns:a16="http://schemas.microsoft.com/office/drawing/2014/main" id="{23F2E3F5-1BC4-41E1-BF56-FE09B0E4225F}"/>
+                <a16:creationId xmlns:a16="http://schemas.microsoft.com/office/drawing/2014/main" id="{2C94EFD9-9DAB-4118-807E-28FFF4C1EC2D}"/>
               </a:ext>
             </a:extLst>
           </p:cNvPr>
@@ -6037,7 +6037,7 @@
           <p:cNvPr id="4" name="">
             <a:extLst xmlns:a="http://schemas.openxmlformats.org/drawingml/2006/main">
               <a:ext uri="{FF2B5EF4-FFF2-40B4-BE49-F238E27FC236}">
-                <a16:creationId xmlns:a16="http://schemas.microsoft.com/office/drawing/2014/main" id="{0AD8EFDB-B680-4D10-8D31-BB25D62A251E}"/>
+                <a16:creationId xmlns:a16="http://schemas.microsoft.com/office/drawing/2014/main" id="{397C5464-6C0E-46F3-BFB5-C76FD313135C}"/>
               </a:ext>
             </a:extLst>
           </p:cNvPr>
@@ -6193,7 +6193,7 @@
           <p:cNvPr id="5" name="">
             <a:extLst xmlns:a="http://schemas.openxmlformats.org/drawingml/2006/main">
               <a:ext uri="{FF2B5EF4-FFF2-40B4-BE49-F238E27FC236}">
-                <a16:creationId xmlns:a16="http://schemas.microsoft.com/office/drawing/2014/main" id="{9C52AE7C-BFA1-48D2-B461-73765C7BEE9C}"/>
+                <a16:creationId xmlns:a16="http://schemas.microsoft.com/office/drawing/2014/main" id="{A758C09A-D650-4E95-B558-499E22888983}"/>
               </a:ext>
             </a:extLst>
           </p:cNvPr>
@@ -6372,7 +6372,7 @@
           <p:cNvPr id="6" name="">
             <a:extLst xmlns:a="http://schemas.openxmlformats.org/drawingml/2006/main">
               <a:ext uri="{FF2B5EF4-FFF2-40B4-BE49-F238E27FC236}">
-                <a16:creationId xmlns:a16="http://schemas.microsoft.com/office/drawing/2014/main" id="{40162CB6-23C9-41FF-B2FD-F82D37244791}"/>
+                <a16:creationId xmlns:a16="http://schemas.microsoft.com/office/drawing/2014/main" id="{711763C1-4322-4D6B-AD16-0C61A3CC034F}"/>
               </a:ext>
             </a:extLst>
           </p:cNvPr>
@@ -6554,7 +6554,7 @@
     </p:spTree>
     <p:extLst>
       <p:ext uri="{BB962C8B-B14F-4D97-AF65-F5344CB8AC3E}">
-        <p14:creationId xmlns:p14="http://schemas.microsoft.com/office/powerpoint/2010/main" val="964701730"/>
+        <p14:creationId xmlns:p14="http://schemas.microsoft.com/office/powerpoint/2010/main" val="291745989"/>
       </p:ext>
     </p:extLst>
   </p:cSld>
@@ -6585,7 +6585,7 @@
           <p:cNvPr id="7" name="">
             <a:extLst xmlns:a="http://schemas.openxmlformats.org/drawingml/2006/main">
               <a:ext uri="{FF2B5EF4-FFF2-40B4-BE49-F238E27FC236}">
-                <a16:creationId xmlns:a16="http://schemas.microsoft.com/office/drawing/2014/main" id="{F07A4AE4-DC72-463D-A757-F3E4F1ED7DDB}"/>
+                <a16:creationId xmlns:a16="http://schemas.microsoft.com/office/drawing/2014/main" id="{E6B90B6C-EB35-4E5E-914C-90A49F2769F2}"/>
               </a:ext>
             </a:extLst>
           </p:cNvPr>
@@ -6741,7 +6741,7 @@
           <p:cNvPr id="2" name="">
             <a:extLst xmlns:a="http://schemas.openxmlformats.org/drawingml/2006/main">
               <a:ext uri="{FF2B5EF4-FFF2-40B4-BE49-F238E27FC236}">
-                <a16:creationId xmlns:a16="http://schemas.microsoft.com/office/drawing/2014/main" id="{4A759C3C-93C9-4AD9-83CC-51D9DFEF952D}"/>
+                <a16:creationId xmlns:a16="http://schemas.microsoft.com/office/drawing/2014/main" id="{B7131635-B4F2-4FD2-AEA4-D7A721F1BCB0}"/>
               </a:ext>
             </a:extLst>
           </p:cNvPr>
@@ -6897,7 +6897,7 @@
           <p:cNvPr id="3" name="">
             <a:extLst xmlns:a="http://schemas.openxmlformats.org/drawingml/2006/main">
               <a:ext uri="{FF2B5EF4-FFF2-40B4-BE49-F238E27FC236}">
-                <a16:creationId xmlns:a16="http://schemas.microsoft.com/office/drawing/2014/main" id="{EE97E62C-68E6-4866-ABB1-6E4E8AC861D5}"/>
+                <a16:creationId xmlns:a16="http://schemas.microsoft.com/office/drawing/2014/main" id="{5E6B6551-73FA-4953-A876-1A3DAED4C25B}"/>
               </a:ext>
             </a:extLst>
           </p:cNvPr>
@@ -7037,7 +7037,7 @@
           <p:cNvPr id="4" name="">
             <a:extLst xmlns:a="http://schemas.openxmlformats.org/drawingml/2006/main">
               <a:ext uri="{FF2B5EF4-FFF2-40B4-BE49-F238E27FC236}">
-                <a16:creationId xmlns:a16="http://schemas.microsoft.com/office/drawing/2014/main" id="{FB8FF74F-AA6F-45E6-A913-EAE7A561A1AF}"/>
+                <a16:creationId xmlns:a16="http://schemas.microsoft.com/office/drawing/2014/main" id="{C180610B-F87A-4A0B-BEE6-F8A3D9859199}"/>
               </a:ext>
             </a:extLst>
           </p:cNvPr>
@@ -7193,7 +7193,7 @@
           <p:cNvPr id="5" name="">
             <a:extLst xmlns:a="http://schemas.openxmlformats.org/drawingml/2006/main">
               <a:ext uri="{FF2B5EF4-FFF2-40B4-BE49-F238E27FC236}">
-                <a16:creationId xmlns:a16="http://schemas.microsoft.com/office/drawing/2014/main" id="{2ABD26C4-9B29-4C9D-9422-68B8AA3A2F77}"/>
+                <a16:creationId xmlns:a16="http://schemas.microsoft.com/office/drawing/2014/main" id="{EE39114F-336D-4071-93DB-F30FDA1F1A7E}"/>
               </a:ext>
             </a:extLst>
           </p:cNvPr>
@@ -7203,7 +7203,7 @@
           <p:nvPr/>
         </p:nvPicPr>
         <p:blipFill>
-          <a:blip xmlns:r="http://schemas.openxmlformats.org/officeDocument/2006/relationships" xmlns:a="http://schemas.openxmlformats.org/drawingml/2006/main" r:embed="R5b214cad1c564b5d"/>
+          <a:blip xmlns:r="http://schemas.openxmlformats.org/officeDocument/2006/relationships" xmlns:a="http://schemas.openxmlformats.org/drawingml/2006/main" r:embed="R1b707b49c2af4064"/>
           <a:stretch xmlns:a="http://schemas.openxmlformats.org/drawingml/2006/main"/>
         </p:blipFill>
         <p:spPr>
@@ -7221,7 +7221,7 @@
           <p:cNvPr id="6" name="">
             <a:extLst xmlns:a="http://schemas.openxmlformats.org/drawingml/2006/main">
               <a:ext uri="{FF2B5EF4-FFF2-40B4-BE49-F238E27FC236}">
-                <a16:creationId xmlns:a16="http://schemas.microsoft.com/office/drawing/2014/main" id="{7DADFBFC-216B-4240-900D-F8E856167FF8}"/>
+                <a16:creationId xmlns:a16="http://schemas.microsoft.com/office/drawing/2014/main" id="{F32DA1F7-0C44-4655-AA9F-EDE9E7D42033}"/>
               </a:ext>
             </a:extLst>
           </p:cNvPr>
@@ -7367,7 +7367,7 @@
                 <a:ea typeface="Noto Sans"/>
                 <a:cs typeface="Noto Sans"/>
               </a:rPr>
-              <a:t>Exploratory closest cases: επιλογή με βάση το reference, όχι ανεξάρτητη replication. Όλες οι δοκιμές διατηρούνται.</a:t>
+              <a:t>Reference-selected, όχι ανεξάρτητη replication. Έλεγχοι: 12 / 21. Όλες οι δοκιμές διατηρούνται.</a:t>
             </a:r>
           </a:p>
         </p:txBody>
@@ -7375,7 +7375,7 @@
     </p:spTree>
     <p:extLst>
       <p:ext uri="{BB962C8B-B14F-4D97-AF65-F5344CB8AC3E}">
-        <p14:creationId xmlns:p14="http://schemas.microsoft.com/office/powerpoint/2010/main" val="2022201113"/>
+        <p14:creationId xmlns:p14="http://schemas.microsoft.com/office/powerpoint/2010/main" val="1261908021"/>
       </p:ext>
     </p:extLst>
   </p:cSld>
@@ -7406,7 +7406,7 @@
           <p:cNvPr id="7" name="">
             <a:extLst xmlns:a="http://schemas.openxmlformats.org/drawingml/2006/main">
               <a:ext uri="{FF2B5EF4-FFF2-40B4-BE49-F238E27FC236}">
-                <a16:creationId xmlns:a16="http://schemas.microsoft.com/office/drawing/2014/main" id="{0F7C887F-8470-4DBD-8E7C-27DA81C7C9C8}"/>
+                <a16:creationId xmlns:a16="http://schemas.microsoft.com/office/drawing/2014/main" id="{FC34B32D-EDC1-4863-A289-F36721E7E438}"/>
               </a:ext>
             </a:extLst>
           </p:cNvPr>
@@ -7562,7 +7562,7 @@
           <p:cNvPr id="2" name="">
             <a:extLst xmlns:a="http://schemas.openxmlformats.org/drawingml/2006/main">
               <a:ext uri="{FF2B5EF4-FFF2-40B4-BE49-F238E27FC236}">
-                <a16:creationId xmlns:a16="http://schemas.microsoft.com/office/drawing/2014/main" id="{0E33F6EF-68F1-4DBA-9874-273BDA945DFB}"/>
+                <a16:creationId xmlns:a16="http://schemas.microsoft.com/office/drawing/2014/main" id="{1FC0B396-A1AD-4517-B484-7815E7A9F8CA}"/>
               </a:ext>
             </a:extLst>
           </p:cNvPr>
@@ -7718,7 +7718,7 @@
           <p:cNvPr id="3" name="">
             <a:extLst xmlns:a="http://schemas.openxmlformats.org/drawingml/2006/main">
               <a:ext uri="{FF2B5EF4-FFF2-40B4-BE49-F238E27FC236}">
-                <a16:creationId xmlns:a16="http://schemas.microsoft.com/office/drawing/2014/main" id="{BFDBCC86-C79F-4F68-AE5F-75B1221DCBEC}"/>
+                <a16:creationId xmlns:a16="http://schemas.microsoft.com/office/drawing/2014/main" id="{3FF14D1B-1A9E-4035-A64B-C3EEF55B0217}"/>
               </a:ext>
             </a:extLst>
           </p:cNvPr>
@@ -7858,7 +7858,7 @@
           <p:cNvPr id="4" name="">
             <a:extLst xmlns:a="http://schemas.openxmlformats.org/drawingml/2006/main">
               <a:ext uri="{FF2B5EF4-FFF2-40B4-BE49-F238E27FC236}">
-                <a16:creationId xmlns:a16="http://schemas.microsoft.com/office/drawing/2014/main" id="{A704F3F7-9C64-4585-BC00-648A98E34F27}"/>
+                <a16:creationId xmlns:a16="http://schemas.microsoft.com/office/drawing/2014/main" id="{A5F7169E-BCD6-4157-833C-73B017261C31}"/>
               </a:ext>
             </a:extLst>
           </p:cNvPr>
@@ -8014,7 +8014,7 @@
           <p:cNvPr id="5" name="">
             <a:extLst xmlns:a="http://schemas.openxmlformats.org/drawingml/2006/main">
               <a:ext uri="{FF2B5EF4-FFF2-40B4-BE49-F238E27FC236}">
-                <a16:creationId xmlns:a16="http://schemas.microsoft.com/office/drawing/2014/main" id="{1EA736E6-B8C5-4074-A803-E11FB6A8F9AC}"/>
+                <a16:creationId xmlns:a16="http://schemas.microsoft.com/office/drawing/2014/main" id="{8CF30CB9-1DE2-40F6-B510-A7F0724EE592}"/>
               </a:ext>
             </a:extLst>
           </p:cNvPr>
@@ -8024,7 +8024,7 @@
           <p:nvPr/>
         </p:nvPicPr>
         <p:blipFill>
-          <a:blip xmlns:r="http://schemas.openxmlformats.org/officeDocument/2006/relationships" xmlns:a="http://schemas.openxmlformats.org/drawingml/2006/main" r:embed="Rf08fa6cd3051402e"/>
+          <a:blip xmlns:r="http://schemas.openxmlformats.org/officeDocument/2006/relationships" xmlns:a="http://schemas.openxmlformats.org/drawingml/2006/main" r:embed="Rf95c2940481845e8"/>
           <a:stretch xmlns:a="http://schemas.openxmlformats.org/drawingml/2006/main"/>
         </p:blipFill>
         <p:spPr>
@@ -8042,7 +8042,7 @@
           <p:cNvPr id="6" name="">
             <a:extLst xmlns:a="http://schemas.openxmlformats.org/drawingml/2006/main">
               <a:ext uri="{FF2B5EF4-FFF2-40B4-BE49-F238E27FC236}">
-                <a16:creationId xmlns:a16="http://schemas.microsoft.com/office/drawing/2014/main" id="{35111749-FB58-4862-B989-36FB4C6A7AA0}"/>
+                <a16:creationId xmlns:a16="http://schemas.microsoft.com/office/drawing/2014/main" id="{75B5B5CF-EE65-4710-A7DD-06B1A19C3305}"/>
               </a:ext>
             </a:extLst>
           </p:cNvPr>
@@ -8196,7 +8196,7 @@
     </p:spTree>
     <p:extLst>
       <p:ext uri="{BB962C8B-B14F-4D97-AF65-F5344CB8AC3E}">
-        <p14:creationId xmlns:p14="http://schemas.microsoft.com/office/powerpoint/2010/main" val="866879716"/>
+        <p14:creationId xmlns:p14="http://schemas.microsoft.com/office/powerpoint/2010/main" val="1752638563"/>
       </p:ext>
     </p:extLst>
   </p:cSld>
@@ -8227,7 +8227,7 @@
           <p:cNvPr id="7" name="">
             <a:extLst xmlns:a="http://schemas.openxmlformats.org/drawingml/2006/main">
               <a:ext uri="{FF2B5EF4-FFF2-40B4-BE49-F238E27FC236}">
-                <a16:creationId xmlns:a16="http://schemas.microsoft.com/office/drawing/2014/main" id="{3F28C925-CB73-47AB-A8D3-5A8DD9952FE0}"/>
+                <a16:creationId xmlns:a16="http://schemas.microsoft.com/office/drawing/2014/main" id="{2739B3A4-A824-4B48-A66E-90A360A73280}"/>
               </a:ext>
             </a:extLst>
           </p:cNvPr>
@@ -8383,7 +8383,7 @@
           <p:cNvPr id="2" name="">
             <a:extLst xmlns:a="http://schemas.openxmlformats.org/drawingml/2006/main">
               <a:ext uri="{FF2B5EF4-FFF2-40B4-BE49-F238E27FC236}">
-                <a16:creationId xmlns:a16="http://schemas.microsoft.com/office/drawing/2014/main" id="{4B191676-F8EB-42B7-BF69-1D89AA11AA7F}"/>
+                <a16:creationId xmlns:a16="http://schemas.microsoft.com/office/drawing/2014/main" id="{01B31750-2C17-4CAF-AC0C-65E9A9C5EFBA}"/>
               </a:ext>
             </a:extLst>
           </p:cNvPr>
@@ -8539,7 +8539,7 @@
           <p:cNvPr id="3" name="">
             <a:extLst xmlns:a="http://schemas.openxmlformats.org/drawingml/2006/main">
               <a:ext uri="{FF2B5EF4-FFF2-40B4-BE49-F238E27FC236}">
-                <a16:creationId xmlns:a16="http://schemas.microsoft.com/office/drawing/2014/main" id="{7316D889-4818-43A5-ABD7-8580144CE31C}"/>
+                <a16:creationId xmlns:a16="http://schemas.microsoft.com/office/drawing/2014/main" id="{E25F1B4D-DDC1-4C84-93C7-B6CC5D298598}"/>
               </a:ext>
             </a:extLst>
           </p:cNvPr>
@@ -8679,7 +8679,7 @@
           <p:cNvPr id="4" name="">
             <a:extLst xmlns:a="http://schemas.openxmlformats.org/drawingml/2006/main">
               <a:ext uri="{FF2B5EF4-FFF2-40B4-BE49-F238E27FC236}">
-                <a16:creationId xmlns:a16="http://schemas.microsoft.com/office/drawing/2014/main" id="{9287C9B1-1E94-4CA1-8F9C-49EEE67DAC67}"/>
+                <a16:creationId xmlns:a16="http://schemas.microsoft.com/office/drawing/2014/main" id="{776A7B55-E781-48CF-83BB-4CA25FE565B8}"/>
               </a:ext>
             </a:extLst>
           </p:cNvPr>
@@ -8835,7 +8835,7 @@
           <p:cNvPr id="5" name="">
             <a:extLst xmlns:a="http://schemas.openxmlformats.org/drawingml/2006/main">
               <a:ext uri="{FF2B5EF4-FFF2-40B4-BE49-F238E27FC236}">
-                <a16:creationId xmlns:a16="http://schemas.microsoft.com/office/drawing/2014/main" id="{95D0B10E-5646-43D6-83B2-647EDCB85026}"/>
+                <a16:creationId xmlns:a16="http://schemas.microsoft.com/office/drawing/2014/main" id="{F1B0D0F0-6767-408E-A18C-E0B711758559}"/>
               </a:ext>
             </a:extLst>
           </p:cNvPr>
@@ -8845,7 +8845,7 @@
           <p:nvPr/>
         </p:nvPicPr>
         <p:blipFill>
-          <a:blip xmlns:r="http://schemas.openxmlformats.org/officeDocument/2006/relationships" xmlns:a="http://schemas.openxmlformats.org/drawingml/2006/main" r:embed="R47ac4eff43ac4357"/>
+          <a:blip xmlns:r="http://schemas.openxmlformats.org/officeDocument/2006/relationships" xmlns:a="http://schemas.openxmlformats.org/drawingml/2006/main" r:embed="R0389e4b821b74c08"/>
           <a:stretch xmlns:a="http://schemas.openxmlformats.org/drawingml/2006/main"/>
         </p:blipFill>
         <p:spPr>
@@ -8863,7 +8863,7 @@
           <p:cNvPr id="6" name="">
             <a:extLst xmlns:a="http://schemas.openxmlformats.org/drawingml/2006/main">
               <a:ext uri="{FF2B5EF4-FFF2-40B4-BE49-F238E27FC236}">
-                <a16:creationId xmlns:a16="http://schemas.microsoft.com/office/drawing/2014/main" id="{BF83F30C-7C05-44BB-969C-876D11A81FCD}"/>
+                <a16:creationId xmlns:a16="http://schemas.microsoft.com/office/drawing/2014/main" id="{12FAFD86-CD61-4889-94C0-852D67E99ABC}"/>
               </a:ext>
             </a:extLst>
           </p:cNvPr>
@@ -9142,7 +9142,7 @@
     </p:spTree>
     <p:extLst>
       <p:ext uri="{BB962C8B-B14F-4D97-AF65-F5344CB8AC3E}">
-        <p14:creationId xmlns:p14="http://schemas.microsoft.com/office/powerpoint/2010/main" val="260887433"/>
+        <p14:creationId xmlns:p14="http://schemas.microsoft.com/office/powerpoint/2010/main" val="2117805753"/>
       </p:ext>
     </p:extLst>
   </p:cSld>
@@ -9173,7 +9173,7 @@
           <p:cNvPr id="7" name="">
             <a:extLst xmlns:a="http://schemas.openxmlformats.org/drawingml/2006/main">
               <a:ext uri="{FF2B5EF4-FFF2-40B4-BE49-F238E27FC236}">
-                <a16:creationId xmlns:a16="http://schemas.microsoft.com/office/drawing/2014/main" id="{F206E82B-7795-4C3D-B8B0-32E0F554F45D}"/>
+                <a16:creationId xmlns:a16="http://schemas.microsoft.com/office/drawing/2014/main" id="{FAB41BE6-5ACD-4D19-8499-1F719A9313F7}"/>
               </a:ext>
             </a:extLst>
           </p:cNvPr>
@@ -9329,7 +9329,7 @@
           <p:cNvPr id="2" name="">
             <a:extLst xmlns:a="http://schemas.openxmlformats.org/drawingml/2006/main">
               <a:ext uri="{FF2B5EF4-FFF2-40B4-BE49-F238E27FC236}">
-                <a16:creationId xmlns:a16="http://schemas.microsoft.com/office/drawing/2014/main" id="{76BBE00C-3994-49E4-B44B-AAC893A1092B}"/>
+                <a16:creationId xmlns:a16="http://schemas.microsoft.com/office/drawing/2014/main" id="{CC028520-61C0-4B59-917D-DF49048A4F20}"/>
               </a:ext>
             </a:extLst>
           </p:cNvPr>
@@ -9485,7 +9485,7 @@
           <p:cNvPr id="3" name="">
             <a:extLst xmlns:a="http://schemas.openxmlformats.org/drawingml/2006/main">
               <a:ext uri="{FF2B5EF4-FFF2-40B4-BE49-F238E27FC236}">
-                <a16:creationId xmlns:a16="http://schemas.microsoft.com/office/drawing/2014/main" id="{09183AB5-2101-4A68-BA32-FC3036A482A7}"/>
+                <a16:creationId xmlns:a16="http://schemas.microsoft.com/office/drawing/2014/main" id="{A9B2EA25-8AF0-4E9F-BD9D-8C6F59A39C8E}"/>
               </a:ext>
             </a:extLst>
           </p:cNvPr>
@@ -9625,7 +9625,7 @@
           <p:cNvPr id="4" name="">
             <a:extLst xmlns:a="http://schemas.openxmlformats.org/drawingml/2006/main">
               <a:ext uri="{FF2B5EF4-FFF2-40B4-BE49-F238E27FC236}">
-                <a16:creationId xmlns:a16="http://schemas.microsoft.com/office/drawing/2014/main" id="{FEA0C875-7099-47D5-B143-E82DC3EC08EF}"/>
+                <a16:creationId xmlns:a16="http://schemas.microsoft.com/office/drawing/2014/main" id="{23AA5B71-CAE6-4DB0-92E4-3394A32B8FE1}"/>
               </a:ext>
             </a:extLst>
           </p:cNvPr>
@@ -9781,7 +9781,7 @@
           <p:cNvPr id="5" name="">
             <a:extLst xmlns:a="http://schemas.openxmlformats.org/drawingml/2006/main">
               <a:ext uri="{FF2B5EF4-FFF2-40B4-BE49-F238E27FC236}">
-                <a16:creationId xmlns:a16="http://schemas.microsoft.com/office/drawing/2014/main" id="{B49880C5-CB45-42CD-A86E-AC268F324688}"/>
+                <a16:creationId xmlns:a16="http://schemas.microsoft.com/office/drawing/2014/main" id="{F622B527-D568-46EE-978B-0A8BC47D4871}"/>
               </a:ext>
             </a:extLst>
           </p:cNvPr>
@@ -9791,7 +9791,7 @@
           <p:nvPr/>
         </p:nvPicPr>
         <p:blipFill>
-          <a:blip xmlns:r="http://schemas.openxmlformats.org/officeDocument/2006/relationships" xmlns:a="http://schemas.openxmlformats.org/drawingml/2006/main" r:embed="Rf96cae15b7574f0c"/>
+          <a:blip xmlns:r="http://schemas.openxmlformats.org/officeDocument/2006/relationships" xmlns:a="http://schemas.openxmlformats.org/drawingml/2006/main" r:embed="R8d139abfdb854b66"/>
           <a:stretch xmlns:a="http://schemas.openxmlformats.org/drawingml/2006/main"/>
         </p:blipFill>
         <p:spPr>
@@ -9809,7 +9809,7 @@
           <p:cNvPr id="6" name="">
             <a:extLst xmlns:a="http://schemas.openxmlformats.org/drawingml/2006/main">
               <a:ext uri="{FF2B5EF4-FFF2-40B4-BE49-F238E27FC236}">
-                <a16:creationId xmlns:a16="http://schemas.microsoft.com/office/drawing/2014/main" id="{42172F7C-9283-4A98-ACC6-214063C9FCEE}"/>
+                <a16:creationId xmlns:a16="http://schemas.microsoft.com/office/drawing/2014/main" id="{8C8A1385-2F9C-4B2D-A3C6-FEC8EC8060FD}"/>
               </a:ext>
             </a:extLst>
           </p:cNvPr>
@@ -10070,7 +10070,7 @@
     </p:spTree>
     <p:extLst>
       <p:ext uri="{BB962C8B-B14F-4D97-AF65-F5344CB8AC3E}">
-        <p14:creationId xmlns:p14="http://schemas.microsoft.com/office/powerpoint/2010/main" val="1740724406"/>
+        <p14:creationId xmlns:p14="http://schemas.microsoft.com/office/powerpoint/2010/main" val="394731011"/>
       </p:ext>
     </p:extLst>
   </p:cSld>
@@ -10101,7 +10101,7 @@
           <p:cNvPr id="6" name="">
             <a:extLst xmlns:a="http://schemas.openxmlformats.org/drawingml/2006/main">
               <a:ext uri="{FF2B5EF4-FFF2-40B4-BE49-F238E27FC236}">
-                <a16:creationId xmlns:a16="http://schemas.microsoft.com/office/drawing/2014/main" id="{D54E77C0-3AC5-4595-BEAE-A5347ADD595C}"/>
+                <a16:creationId xmlns:a16="http://schemas.microsoft.com/office/drawing/2014/main" id="{76323E50-062C-40B4-85C1-D86AA11BDDC2}"/>
               </a:ext>
             </a:extLst>
           </p:cNvPr>
@@ -10257,7 +10257,7 @@
           <p:cNvPr id="2" name="">
             <a:extLst xmlns:a="http://schemas.openxmlformats.org/drawingml/2006/main">
               <a:ext uri="{FF2B5EF4-FFF2-40B4-BE49-F238E27FC236}">
-                <a16:creationId xmlns:a16="http://schemas.microsoft.com/office/drawing/2014/main" id="{F68BEA8E-2178-4325-ACD6-8D6E776CDA57}"/>
+                <a16:creationId xmlns:a16="http://schemas.microsoft.com/office/drawing/2014/main" id="{5F6B8176-9BAA-40EE-872A-4333BFB6ADEA}"/>
               </a:ext>
             </a:extLst>
           </p:cNvPr>
@@ -10413,7 +10413,7 @@
           <p:cNvPr id="3" name="">
             <a:extLst xmlns:a="http://schemas.openxmlformats.org/drawingml/2006/main">
               <a:ext uri="{FF2B5EF4-FFF2-40B4-BE49-F238E27FC236}">
-                <a16:creationId xmlns:a16="http://schemas.microsoft.com/office/drawing/2014/main" id="{AA30E169-6268-4DBF-A6DB-8D7881B0EFAB}"/>
+                <a16:creationId xmlns:a16="http://schemas.microsoft.com/office/drawing/2014/main" id="{B443DF7A-01E6-481A-89D2-A445882A90D1}"/>
               </a:ext>
             </a:extLst>
           </p:cNvPr>
@@ -10553,7 +10553,7 @@
           <p:cNvPr id="4" name="">
             <a:extLst xmlns:a="http://schemas.openxmlformats.org/drawingml/2006/main">
               <a:ext uri="{FF2B5EF4-FFF2-40B4-BE49-F238E27FC236}">
-                <a16:creationId xmlns:a16="http://schemas.microsoft.com/office/drawing/2014/main" id="{281625D9-B00A-4E69-B78E-E1D0930437F2}"/>
+                <a16:creationId xmlns:a16="http://schemas.microsoft.com/office/drawing/2014/main" id="{8615FB91-AE29-44C0-A228-C7E8C914D1ED}"/>
               </a:ext>
             </a:extLst>
           </p:cNvPr>
@@ -10709,7 +10709,7 @@
           <p:cNvPr id="5" name="">
             <a:extLst xmlns:a="http://schemas.openxmlformats.org/drawingml/2006/main">
               <a:ext uri="{FF2B5EF4-FFF2-40B4-BE49-F238E27FC236}">
-                <a16:creationId xmlns:a16="http://schemas.microsoft.com/office/drawing/2014/main" id="{6F4E29BE-BB2B-4F81-A91E-D27F7EAC6528}"/>
+                <a16:creationId xmlns:a16="http://schemas.microsoft.com/office/drawing/2014/main" id="{261851E1-2B95-4CE2-ABED-EE80EDF8C082}"/>
               </a:ext>
             </a:extLst>
           </p:cNvPr>
@@ -10970,7 +10970,7 @@
     </p:spTree>
     <p:extLst>
       <p:ext uri="{BB962C8B-B14F-4D97-AF65-F5344CB8AC3E}">
-        <p14:creationId xmlns:p14="http://schemas.microsoft.com/office/powerpoint/2010/main" val="1142521944"/>
+        <p14:creationId xmlns:p14="http://schemas.microsoft.com/office/powerpoint/2010/main" val="856548276"/>
       </p:ext>
     </p:extLst>
   </p:cSld>
@@ -11001,7 +11001,7 @@
           <p:cNvPr id="6" name="">
             <a:extLst xmlns:a="http://schemas.openxmlformats.org/drawingml/2006/main">
               <a:ext uri="{FF2B5EF4-FFF2-40B4-BE49-F238E27FC236}">
-                <a16:creationId xmlns:a16="http://schemas.microsoft.com/office/drawing/2014/main" id="{EACE5044-8C6D-4835-8071-84FE976BFCFD}"/>
+                <a16:creationId xmlns:a16="http://schemas.microsoft.com/office/drawing/2014/main" id="{7427BF54-A668-4B14-89AC-2234F6DE18CC}"/>
               </a:ext>
             </a:extLst>
           </p:cNvPr>
@@ -11157,7 +11157,7 @@
           <p:cNvPr id="2" name="">
             <a:extLst xmlns:a="http://schemas.openxmlformats.org/drawingml/2006/main">
               <a:ext uri="{FF2B5EF4-FFF2-40B4-BE49-F238E27FC236}">
-                <a16:creationId xmlns:a16="http://schemas.microsoft.com/office/drawing/2014/main" id="{5D538CB0-35C9-4996-B890-2A58B732CC3A}"/>
+                <a16:creationId xmlns:a16="http://schemas.microsoft.com/office/drawing/2014/main" id="{D908F103-2360-455C-995D-F44297D4BC18}"/>
               </a:ext>
             </a:extLst>
           </p:cNvPr>
@@ -11313,7 +11313,7 @@
           <p:cNvPr id="3" name="">
             <a:extLst xmlns:a="http://schemas.openxmlformats.org/drawingml/2006/main">
               <a:ext uri="{FF2B5EF4-FFF2-40B4-BE49-F238E27FC236}">
-                <a16:creationId xmlns:a16="http://schemas.microsoft.com/office/drawing/2014/main" id="{98CAC82B-FEC7-4B6D-905C-A638370DEE72}"/>
+                <a16:creationId xmlns:a16="http://schemas.microsoft.com/office/drawing/2014/main" id="{25F8FF10-7E91-485C-B90F-AE8F336305F2}"/>
               </a:ext>
             </a:extLst>
           </p:cNvPr>
@@ -11453,7 +11453,7 @@
           <p:cNvPr id="4" name="">
             <a:extLst xmlns:a="http://schemas.openxmlformats.org/drawingml/2006/main">
               <a:ext uri="{FF2B5EF4-FFF2-40B4-BE49-F238E27FC236}">
-                <a16:creationId xmlns:a16="http://schemas.microsoft.com/office/drawing/2014/main" id="{D2D4F01E-4AFB-4A59-991E-87A8EB0DB96E}"/>
+                <a16:creationId xmlns:a16="http://schemas.microsoft.com/office/drawing/2014/main" id="{D3D7A319-BDDB-46AF-AD8D-C516AD7A3611}"/>
               </a:ext>
             </a:extLst>
           </p:cNvPr>
@@ -11609,7 +11609,7 @@
           <p:cNvPr id="5" name="">
             <a:extLst xmlns:a="http://schemas.openxmlformats.org/drawingml/2006/main">
               <a:ext uri="{FF2B5EF4-FFF2-40B4-BE49-F238E27FC236}">
-                <a16:creationId xmlns:a16="http://schemas.microsoft.com/office/drawing/2014/main" id="{474A050F-F1AF-4A97-88AF-1004313AA1B2}"/>
+                <a16:creationId xmlns:a16="http://schemas.microsoft.com/office/drawing/2014/main" id="{D2C4977A-82B7-45C2-9EBF-31F95B08B07B}"/>
               </a:ext>
             </a:extLst>
           </p:cNvPr>
@@ -11819,7 +11819,7 @@
     </p:spTree>
     <p:extLst>
       <p:ext uri="{BB962C8B-B14F-4D97-AF65-F5344CB8AC3E}">
-        <p14:creationId xmlns:p14="http://schemas.microsoft.com/office/powerpoint/2010/main" val="779362980"/>
+        <p14:creationId xmlns:p14="http://schemas.microsoft.com/office/powerpoint/2010/main" val="1251648765"/>
       </p:ext>
     </p:extLst>
   </p:cSld>
@@ -11850,7 +11850,7 @@
           <p:cNvPr id="6" name="">
             <a:extLst xmlns:a="http://schemas.openxmlformats.org/drawingml/2006/main">
               <a:ext uri="{FF2B5EF4-FFF2-40B4-BE49-F238E27FC236}">
-                <a16:creationId xmlns:a16="http://schemas.microsoft.com/office/drawing/2014/main" id="{02838C1C-ABE5-44A9-9252-51D835268B32}"/>
+                <a16:creationId xmlns:a16="http://schemas.microsoft.com/office/drawing/2014/main" id="{E3418A02-F628-4D2C-A64B-DE35462FC864}"/>
               </a:ext>
             </a:extLst>
           </p:cNvPr>
@@ -12006,7 +12006,7 @@
           <p:cNvPr id="2" name="">
             <a:extLst xmlns:a="http://schemas.openxmlformats.org/drawingml/2006/main">
               <a:ext uri="{FF2B5EF4-FFF2-40B4-BE49-F238E27FC236}">
-                <a16:creationId xmlns:a16="http://schemas.microsoft.com/office/drawing/2014/main" id="{CC66C021-1D59-4A80-BDAC-5162541405EA}"/>
+                <a16:creationId xmlns:a16="http://schemas.microsoft.com/office/drawing/2014/main" id="{5631E9B6-3CE4-4823-B939-7F5A22E190DA}"/>
               </a:ext>
             </a:extLst>
           </p:cNvPr>
@@ -12162,7 +12162,7 @@
           <p:cNvPr id="3" name="">
             <a:extLst xmlns:a="http://schemas.openxmlformats.org/drawingml/2006/main">
               <a:ext uri="{FF2B5EF4-FFF2-40B4-BE49-F238E27FC236}">
-                <a16:creationId xmlns:a16="http://schemas.microsoft.com/office/drawing/2014/main" id="{4B95A6BD-D813-4472-90AC-0EAF9EAF9747}"/>
+                <a16:creationId xmlns:a16="http://schemas.microsoft.com/office/drawing/2014/main" id="{25F755E3-7F1F-4813-9ED7-672650764B11}"/>
               </a:ext>
             </a:extLst>
           </p:cNvPr>
@@ -12302,7 +12302,7 @@
           <p:cNvPr id="4" name="">
             <a:extLst xmlns:a="http://schemas.openxmlformats.org/drawingml/2006/main">
               <a:ext uri="{FF2B5EF4-FFF2-40B4-BE49-F238E27FC236}">
-                <a16:creationId xmlns:a16="http://schemas.microsoft.com/office/drawing/2014/main" id="{347DCBE4-1DF7-4765-AC5C-97DB33872256}"/>
+                <a16:creationId xmlns:a16="http://schemas.microsoft.com/office/drawing/2014/main" id="{F80A025B-C943-49B1-900E-E319AD372CD3}"/>
               </a:ext>
             </a:extLst>
           </p:cNvPr>
@@ -12458,7 +12458,7 @@
           <p:cNvPr id="5" name="">
             <a:extLst xmlns:a="http://schemas.openxmlformats.org/drawingml/2006/main">
               <a:ext uri="{FF2B5EF4-FFF2-40B4-BE49-F238E27FC236}">
-                <a16:creationId xmlns:a16="http://schemas.microsoft.com/office/drawing/2014/main" id="{6426441B-670B-4564-8B02-7E2D4F4F45F4}"/>
+                <a16:creationId xmlns:a16="http://schemas.microsoft.com/office/drawing/2014/main" id="{3A95727C-C883-42A1-A4AB-EB79EF5941DD}"/>
               </a:ext>
             </a:extLst>
           </p:cNvPr>
@@ -12696,7 +12696,7 @@
     </p:spTree>
     <p:extLst>
       <p:ext uri="{BB962C8B-B14F-4D97-AF65-F5344CB8AC3E}">
-        <p14:creationId xmlns:p14="http://schemas.microsoft.com/office/powerpoint/2010/main" val="1824481270"/>
+        <p14:creationId xmlns:p14="http://schemas.microsoft.com/office/powerpoint/2010/main" val="665191684"/>
       </p:ext>
     </p:extLst>
   </p:cSld>
@@ -12727,7 +12727,7 @@
           <p:cNvPr id="6" name="">
             <a:extLst xmlns:a="http://schemas.openxmlformats.org/drawingml/2006/main">
               <a:ext uri="{FF2B5EF4-FFF2-40B4-BE49-F238E27FC236}">
-                <a16:creationId xmlns:a16="http://schemas.microsoft.com/office/drawing/2014/main" id="{750A2B88-A5B8-444B-A65D-4C902E8C20C7}"/>
+                <a16:creationId xmlns:a16="http://schemas.microsoft.com/office/drawing/2014/main" id="{AB5C7AF9-4B76-48CF-A623-CC2F8150E1D9}"/>
               </a:ext>
             </a:extLst>
           </p:cNvPr>
@@ -12883,7 +12883,7 @@
           <p:cNvPr id="2" name="">
             <a:extLst xmlns:a="http://schemas.openxmlformats.org/drawingml/2006/main">
               <a:ext uri="{FF2B5EF4-FFF2-40B4-BE49-F238E27FC236}">
-                <a16:creationId xmlns:a16="http://schemas.microsoft.com/office/drawing/2014/main" id="{8139A9F5-32FF-4866-B0A5-835D08350B30}"/>
+                <a16:creationId xmlns:a16="http://schemas.microsoft.com/office/drawing/2014/main" id="{DB003921-080E-4D04-8F6F-16193485AC35}"/>
               </a:ext>
             </a:extLst>
           </p:cNvPr>
@@ -13039,7 +13039,7 @@
           <p:cNvPr id="3" name="">
             <a:extLst xmlns:a="http://schemas.openxmlformats.org/drawingml/2006/main">
               <a:ext uri="{FF2B5EF4-FFF2-40B4-BE49-F238E27FC236}">
-                <a16:creationId xmlns:a16="http://schemas.microsoft.com/office/drawing/2014/main" id="{834F2207-B451-4799-960C-C8DAF527FB02}"/>
+                <a16:creationId xmlns:a16="http://schemas.microsoft.com/office/drawing/2014/main" id="{CA38C291-C92B-426D-B083-0A8B4B57CE0A}"/>
               </a:ext>
             </a:extLst>
           </p:cNvPr>
@@ -13179,7 +13179,7 @@
           <p:cNvPr id="4" name="">
             <a:extLst xmlns:a="http://schemas.openxmlformats.org/drawingml/2006/main">
               <a:ext uri="{FF2B5EF4-FFF2-40B4-BE49-F238E27FC236}">
-                <a16:creationId xmlns:a16="http://schemas.microsoft.com/office/drawing/2014/main" id="{5452A70E-B51B-4B81-A171-19BC4DD62B44}"/>
+                <a16:creationId xmlns:a16="http://schemas.microsoft.com/office/drawing/2014/main" id="{5547503E-5A67-4E77-A803-CD0B84AE914B}"/>
               </a:ext>
             </a:extLst>
           </p:cNvPr>
@@ -13335,7 +13335,7 @@
           <p:cNvPr id="5" name="">
             <a:extLst xmlns:a="http://schemas.openxmlformats.org/drawingml/2006/main">
               <a:ext uri="{FF2B5EF4-FFF2-40B4-BE49-F238E27FC236}">
-                <a16:creationId xmlns:a16="http://schemas.microsoft.com/office/drawing/2014/main" id="{5F66A2AC-AF83-469E-B785-58E1670EA87B}"/>
+                <a16:creationId xmlns:a16="http://schemas.microsoft.com/office/drawing/2014/main" id="{2408D7CD-F174-4398-852F-A8CDAF29665C}"/>
               </a:ext>
             </a:extLst>
           </p:cNvPr>
@@ -13573,7 +13573,7 @@
     </p:spTree>
     <p:extLst>
       <p:ext uri="{BB962C8B-B14F-4D97-AF65-F5344CB8AC3E}">
-        <p14:creationId xmlns:p14="http://schemas.microsoft.com/office/powerpoint/2010/main" val="1879098980"/>
+        <p14:creationId xmlns:p14="http://schemas.microsoft.com/office/powerpoint/2010/main" val="34873054"/>
       </p:ext>
     </p:extLst>
   </p:cSld>
@@ -13604,7 +13604,7 @@
           <p:cNvPr id="6" name="">
             <a:extLst xmlns:a="http://schemas.openxmlformats.org/drawingml/2006/main">
               <a:ext uri="{FF2B5EF4-FFF2-40B4-BE49-F238E27FC236}">
-                <a16:creationId xmlns:a16="http://schemas.microsoft.com/office/drawing/2014/main" id="{A110A8C7-D6B3-469D-990A-6C791C496D22}"/>
+                <a16:creationId xmlns:a16="http://schemas.microsoft.com/office/drawing/2014/main" id="{06B7A963-6AA3-43EA-9258-CDC02974FB01}"/>
               </a:ext>
             </a:extLst>
           </p:cNvPr>
@@ -13760,7 +13760,7 @@
           <p:cNvPr id="2" name="">
             <a:extLst xmlns:a="http://schemas.openxmlformats.org/drawingml/2006/main">
               <a:ext uri="{FF2B5EF4-FFF2-40B4-BE49-F238E27FC236}">
-                <a16:creationId xmlns:a16="http://schemas.microsoft.com/office/drawing/2014/main" id="{B402366F-05FB-4235-AE37-68D7298C50D7}"/>
+                <a16:creationId xmlns:a16="http://schemas.microsoft.com/office/drawing/2014/main" id="{2DA549AF-88BB-473C-AFB8-E9C6FABAA166}"/>
               </a:ext>
             </a:extLst>
           </p:cNvPr>
@@ -13916,7 +13916,7 @@
           <p:cNvPr id="3" name="">
             <a:extLst xmlns:a="http://schemas.openxmlformats.org/drawingml/2006/main">
               <a:ext uri="{FF2B5EF4-FFF2-40B4-BE49-F238E27FC236}">
-                <a16:creationId xmlns:a16="http://schemas.microsoft.com/office/drawing/2014/main" id="{ECE8447E-780A-4312-A4F2-FBB0A8DEDDE3}"/>
+                <a16:creationId xmlns:a16="http://schemas.microsoft.com/office/drawing/2014/main" id="{323B3BA8-A29B-4BA5-809C-1F3F16238A1A}"/>
               </a:ext>
             </a:extLst>
           </p:cNvPr>
@@ -14056,7 +14056,7 @@
           <p:cNvPr id="4" name="">
             <a:extLst xmlns:a="http://schemas.openxmlformats.org/drawingml/2006/main">
               <a:ext uri="{FF2B5EF4-FFF2-40B4-BE49-F238E27FC236}">
-                <a16:creationId xmlns:a16="http://schemas.microsoft.com/office/drawing/2014/main" id="{5C0ABE74-88D3-499D-8FE3-BA2B3B8B7FB5}"/>
+                <a16:creationId xmlns:a16="http://schemas.microsoft.com/office/drawing/2014/main" id="{73EEC915-C77C-48ED-B92C-26BDFF53D661}"/>
               </a:ext>
             </a:extLst>
           </p:cNvPr>
@@ -14212,7 +14212,7 @@
           <p:cNvPr id="5" name="">
             <a:extLst xmlns:a="http://schemas.openxmlformats.org/drawingml/2006/main">
               <a:ext uri="{FF2B5EF4-FFF2-40B4-BE49-F238E27FC236}">
-                <a16:creationId xmlns:a16="http://schemas.microsoft.com/office/drawing/2014/main" id="{C50DB0D1-C1CB-460A-B085-6A1E34948EBB}"/>
+                <a16:creationId xmlns:a16="http://schemas.microsoft.com/office/drawing/2014/main" id="{9E1B415B-E69E-435A-9123-B8F9E04F1587}"/>
               </a:ext>
             </a:extLst>
           </p:cNvPr>
@@ -14468,7 +14468,7 @@
     </p:spTree>
     <p:extLst>
       <p:ext uri="{BB962C8B-B14F-4D97-AF65-F5344CB8AC3E}">
-        <p14:creationId xmlns:p14="http://schemas.microsoft.com/office/powerpoint/2010/main" val="885495888"/>
+        <p14:creationId xmlns:p14="http://schemas.microsoft.com/office/powerpoint/2010/main" val="1149796289"/>
       </p:ext>
     </p:extLst>
   </p:cSld>
@@ -14499,7 +14499,7 @@
           <p:cNvPr id="6" name="">
             <a:extLst xmlns:a="http://schemas.openxmlformats.org/drawingml/2006/main">
               <a:ext uri="{FF2B5EF4-FFF2-40B4-BE49-F238E27FC236}">
-                <a16:creationId xmlns:a16="http://schemas.microsoft.com/office/drawing/2014/main" id="{6686D590-6CE4-4B78-8B7F-826D15003DCB}"/>
+                <a16:creationId xmlns:a16="http://schemas.microsoft.com/office/drawing/2014/main" id="{6E46C00A-19C9-4938-B2D5-861E88A6C3EA}"/>
               </a:ext>
             </a:extLst>
           </p:cNvPr>
@@ -14655,7 +14655,7 @@
           <p:cNvPr id="2" name="">
             <a:extLst xmlns:a="http://schemas.openxmlformats.org/drawingml/2006/main">
               <a:ext uri="{FF2B5EF4-FFF2-40B4-BE49-F238E27FC236}">
-                <a16:creationId xmlns:a16="http://schemas.microsoft.com/office/drawing/2014/main" id="{2E39405B-2D8F-4FDB-A986-E5631BE37467}"/>
+                <a16:creationId xmlns:a16="http://schemas.microsoft.com/office/drawing/2014/main" id="{8011829F-238F-4468-87FF-F2BDD471D5D3}"/>
               </a:ext>
             </a:extLst>
           </p:cNvPr>
@@ -14811,7 +14811,7 @@
           <p:cNvPr id="3" name="">
             <a:extLst xmlns:a="http://schemas.openxmlformats.org/drawingml/2006/main">
               <a:ext uri="{FF2B5EF4-FFF2-40B4-BE49-F238E27FC236}">
-                <a16:creationId xmlns:a16="http://schemas.microsoft.com/office/drawing/2014/main" id="{DFD6AC47-F1BA-4E71-BA65-C51D0A566106}"/>
+                <a16:creationId xmlns:a16="http://schemas.microsoft.com/office/drawing/2014/main" id="{35D09CE5-E350-4D5F-9047-82D9FC645918}"/>
               </a:ext>
             </a:extLst>
           </p:cNvPr>
@@ -14951,7 +14951,7 @@
           <p:cNvPr id="4" name="">
             <a:extLst xmlns:a="http://schemas.openxmlformats.org/drawingml/2006/main">
               <a:ext uri="{FF2B5EF4-FFF2-40B4-BE49-F238E27FC236}">
-                <a16:creationId xmlns:a16="http://schemas.microsoft.com/office/drawing/2014/main" id="{9841D918-4D47-4A94-8CD3-F3817306689B}"/>
+                <a16:creationId xmlns:a16="http://schemas.microsoft.com/office/drawing/2014/main" id="{ACE9972D-9EE3-4811-9C9A-F41B3642F541}"/>
               </a:ext>
             </a:extLst>
           </p:cNvPr>
@@ -15107,7 +15107,7 @@
           <p:cNvPr id="5" name="">
             <a:extLst xmlns:a="http://schemas.openxmlformats.org/drawingml/2006/main">
               <a:ext uri="{FF2B5EF4-FFF2-40B4-BE49-F238E27FC236}">
-                <a16:creationId xmlns:a16="http://schemas.microsoft.com/office/drawing/2014/main" id="{358A95E3-1954-4B02-A1BF-B4DCA5423DB3}"/>
+                <a16:creationId xmlns:a16="http://schemas.microsoft.com/office/drawing/2014/main" id="{0493243D-1BED-4083-BA70-7D1E0717378D}"/>
               </a:ext>
             </a:extLst>
           </p:cNvPr>
@@ -15345,7 +15345,7 @@
     </p:spTree>
     <p:extLst>
       <p:ext uri="{BB962C8B-B14F-4D97-AF65-F5344CB8AC3E}">
-        <p14:creationId xmlns:p14="http://schemas.microsoft.com/office/powerpoint/2010/main" val="1968442466"/>
+        <p14:creationId xmlns:p14="http://schemas.microsoft.com/office/powerpoint/2010/main" val="1194099202"/>
       </p:ext>
     </p:extLst>
   </p:cSld>
@@ -15376,7 +15376,7 @@
           <p:cNvPr id="7" name="">
             <a:extLst xmlns:a="http://schemas.openxmlformats.org/drawingml/2006/main">
               <a:ext uri="{FF2B5EF4-FFF2-40B4-BE49-F238E27FC236}">
-                <a16:creationId xmlns:a16="http://schemas.microsoft.com/office/drawing/2014/main" id="{B586437F-0477-4F8C-B3F6-C80964A5CD71}"/>
+                <a16:creationId xmlns:a16="http://schemas.microsoft.com/office/drawing/2014/main" id="{B3D5C326-3F8D-45A2-8497-8F890F1C8E06}"/>
               </a:ext>
             </a:extLst>
           </p:cNvPr>
@@ -15532,7 +15532,7 @@
           <p:cNvPr id="2" name="">
             <a:extLst xmlns:a="http://schemas.openxmlformats.org/drawingml/2006/main">
               <a:ext uri="{FF2B5EF4-FFF2-40B4-BE49-F238E27FC236}">
-                <a16:creationId xmlns:a16="http://schemas.microsoft.com/office/drawing/2014/main" id="{639BD782-B0D0-46BC-9A09-D82933F5D6C0}"/>
+                <a16:creationId xmlns:a16="http://schemas.microsoft.com/office/drawing/2014/main" id="{828D7A0D-D593-40BC-B0C1-9CF80F32F97E}"/>
               </a:ext>
             </a:extLst>
           </p:cNvPr>
@@ -15688,7 +15688,7 @@
           <p:cNvPr id="3" name="">
             <a:extLst xmlns:a="http://schemas.openxmlformats.org/drawingml/2006/main">
               <a:ext uri="{FF2B5EF4-FFF2-40B4-BE49-F238E27FC236}">
-                <a16:creationId xmlns:a16="http://schemas.microsoft.com/office/drawing/2014/main" id="{870EF667-41B0-4984-9389-ED57BDD2E3A3}"/>
+                <a16:creationId xmlns:a16="http://schemas.microsoft.com/office/drawing/2014/main" id="{E2CEF18F-28F4-4696-B995-A5F88D48F172}"/>
               </a:ext>
             </a:extLst>
           </p:cNvPr>
@@ -15828,7 +15828,7 @@
           <p:cNvPr id="4" name="">
             <a:extLst xmlns:a="http://schemas.openxmlformats.org/drawingml/2006/main">
               <a:ext uri="{FF2B5EF4-FFF2-40B4-BE49-F238E27FC236}">
-                <a16:creationId xmlns:a16="http://schemas.microsoft.com/office/drawing/2014/main" id="{839D0CFC-6629-487D-B460-998AE7C0F758}"/>
+                <a16:creationId xmlns:a16="http://schemas.microsoft.com/office/drawing/2014/main" id="{F0C70473-759B-40ED-9CC2-2B5E3784A896}"/>
               </a:ext>
             </a:extLst>
           </p:cNvPr>
@@ -15984,7 +15984,7 @@
           <p:cNvPr id="5" name="">
             <a:extLst xmlns:a="http://schemas.openxmlformats.org/drawingml/2006/main">
               <a:ext uri="{FF2B5EF4-FFF2-40B4-BE49-F238E27FC236}">
-                <a16:creationId xmlns:a16="http://schemas.microsoft.com/office/drawing/2014/main" id="{22345A8E-0DD4-4420-B90A-DB3F362170D3}"/>
+                <a16:creationId xmlns:a16="http://schemas.microsoft.com/office/drawing/2014/main" id="{54A7BA4C-DFEC-4D5D-ACA7-95BAD69DB754}"/>
               </a:ext>
             </a:extLst>
           </p:cNvPr>
@@ -15994,7 +15994,7 @@
           <p:nvPr/>
         </p:nvPicPr>
         <p:blipFill>
-          <a:blip xmlns:r="http://schemas.openxmlformats.org/officeDocument/2006/relationships" xmlns:a="http://schemas.openxmlformats.org/drawingml/2006/main" r:embed="Rd7ef54f791b3407a"/>
+          <a:blip xmlns:r="http://schemas.openxmlformats.org/officeDocument/2006/relationships" xmlns:a="http://schemas.openxmlformats.org/drawingml/2006/main" r:embed="R84726f66787e4145"/>
           <a:stretch xmlns:a="http://schemas.openxmlformats.org/drawingml/2006/main"/>
         </p:blipFill>
         <p:spPr>
@@ -16012,7 +16012,7 @@
           <p:cNvPr id="6" name="">
             <a:extLst xmlns:a="http://schemas.openxmlformats.org/drawingml/2006/main">
               <a:ext uri="{FF2B5EF4-FFF2-40B4-BE49-F238E27FC236}">
-                <a16:creationId xmlns:a16="http://schemas.microsoft.com/office/drawing/2014/main" id="{8D71E540-F004-48F0-9FA9-CC2F932B8D14}"/>
+                <a16:creationId xmlns:a16="http://schemas.microsoft.com/office/drawing/2014/main" id="{EFC71EEA-34C6-406F-8282-A545154A9A93}"/>
               </a:ext>
             </a:extLst>
           </p:cNvPr>
@@ -16166,7 +16166,7 @@
     </p:spTree>
     <p:extLst>
       <p:ext uri="{BB962C8B-B14F-4D97-AF65-F5344CB8AC3E}">
-        <p14:creationId xmlns:p14="http://schemas.microsoft.com/office/powerpoint/2010/main" val="1134809859"/>
+        <p14:creationId xmlns:p14="http://schemas.microsoft.com/office/powerpoint/2010/main" val="913267307"/>
       </p:ext>
     </p:extLst>
   </p:cSld>
@@ -16197,7 +16197,7 @@
           <p:cNvPr id="7" name="">
             <a:extLst xmlns:a="http://schemas.openxmlformats.org/drawingml/2006/main">
               <a:ext uri="{FF2B5EF4-FFF2-40B4-BE49-F238E27FC236}">
-                <a16:creationId xmlns:a16="http://schemas.microsoft.com/office/drawing/2014/main" id="{4AC9506A-9422-4D5E-9173-E91131A4F185}"/>
+                <a16:creationId xmlns:a16="http://schemas.microsoft.com/office/drawing/2014/main" id="{B310B770-E9AB-48C8-8A56-0279704E9FE3}"/>
               </a:ext>
             </a:extLst>
           </p:cNvPr>
@@ -16353,7 +16353,7 @@
           <p:cNvPr id="2" name="">
             <a:extLst xmlns:a="http://schemas.openxmlformats.org/drawingml/2006/main">
               <a:ext uri="{FF2B5EF4-FFF2-40B4-BE49-F238E27FC236}">
-                <a16:creationId xmlns:a16="http://schemas.microsoft.com/office/drawing/2014/main" id="{238BD408-9A0B-4638-BBF2-885797B54980}"/>
+                <a16:creationId xmlns:a16="http://schemas.microsoft.com/office/drawing/2014/main" id="{B99E9212-F077-4B2D-9616-3DF502BB1634}"/>
               </a:ext>
             </a:extLst>
           </p:cNvPr>
@@ -16509,7 +16509,7 @@
           <p:cNvPr id="3" name="">
             <a:extLst xmlns:a="http://schemas.openxmlformats.org/drawingml/2006/main">
               <a:ext uri="{FF2B5EF4-FFF2-40B4-BE49-F238E27FC236}">
-                <a16:creationId xmlns:a16="http://schemas.microsoft.com/office/drawing/2014/main" id="{0D89CAC9-8399-4AB7-B037-2DD8A9E4ED2A}"/>
+                <a16:creationId xmlns:a16="http://schemas.microsoft.com/office/drawing/2014/main" id="{EE9F8380-6938-4E30-BEBC-B5937F3CAD7E}"/>
               </a:ext>
             </a:extLst>
           </p:cNvPr>
@@ -16649,7 +16649,7 @@
           <p:cNvPr id="4" name="">
             <a:extLst xmlns:a="http://schemas.openxmlformats.org/drawingml/2006/main">
               <a:ext uri="{FF2B5EF4-FFF2-40B4-BE49-F238E27FC236}">
-                <a16:creationId xmlns:a16="http://schemas.microsoft.com/office/drawing/2014/main" id="{03371071-F918-4753-954C-24CEEBB3131C}"/>
+                <a16:creationId xmlns:a16="http://schemas.microsoft.com/office/drawing/2014/main" id="{65620F2A-DADA-4AF0-9DB4-E1159ADC4F11}"/>
               </a:ext>
             </a:extLst>
           </p:cNvPr>
@@ -16805,7 +16805,7 @@
           <p:cNvPr id="5" name="">
             <a:extLst xmlns:a="http://schemas.openxmlformats.org/drawingml/2006/main">
               <a:ext uri="{FF2B5EF4-FFF2-40B4-BE49-F238E27FC236}">
-                <a16:creationId xmlns:a16="http://schemas.microsoft.com/office/drawing/2014/main" id="{B3407DA8-D5B6-484A-B9A2-E94E682A1CDB}"/>
+                <a16:creationId xmlns:a16="http://schemas.microsoft.com/office/drawing/2014/main" id="{6EA825B6-2FDA-49FC-B420-54946F19AC9D}"/>
               </a:ext>
             </a:extLst>
           </p:cNvPr>
@@ -16815,7 +16815,7 @@
           <p:nvPr/>
         </p:nvPicPr>
         <p:blipFill>
-          <a:blip xmlns:r="http://schemas.openxmlformats.org/officeDocument/2006/relationships" xmlns:a="http://schemas.openxmlformats.org/drawingml/2006/main" r:embed="R06cd59647b1346d9"/>
+          <a:blip xmlns:r="http://schemas.openxmlformats.org/officeDocument/2006/relationships" xmlns:a="http://schemas.openxmlformats.org/drawingml/2006/main" r:embed="R7759df24b20e474f"/>
           <a:stretch xmlns:a="http://schemas.openxmlformats.org/drawingml/2006/main"/>
         </p:blipFill>
         <p:spPr>
@@ -16833,7 +16833,7 @@
           <p:cNvPr id="6" name="">
             <a:extLst xmlns:a="http://schemas.openxmlformats.org/drawingml/2006/main">
               <a:ext uri="{FF2B5EF4-FFF2-40B4-BE49-F238E27FC236}">
-                <a16:creationId xmlns:a16="http://schemas.microsoft.com/office/drawing/2014/main" id="{CB9AABFC-5558-41E8-87AF-6EBD342B0647}"/>
+                <a16:creationId xmlns:a16="http://schemas.microsoft.com/office/drawing/2014/main" id="{A03CDDEA-A8AE-4FB9-86AA-3BF883C2D956}"/>
               </a:ext>
             </a:extLst>
           </p:cNvPr>
@@ -16987,7 +16987,7 @@
     </p:spTree>
     <p:extLst>
       <p:ext uri="{BB962C8B-B14F-4D97-AF65-F5344CB8AC3E}">
-        <p14:creationId xmlns:p14="http://schemas.microsoft.com/office/powerpoint/2010/main" val="1693952675"/>
+        <p14:creationId xmlns:p14="http://schemas.microsoft.com/office/powerpoint/2010/main" val="849550471"/>
       </p:ext>
     </p:extLst>
   </p:cSld>
@@ -17018,7 +17018,7 @@
           <p:cNvPr id="7" name="">
             <a:extLst xmlns:a="http://schemas.openxmlformats.org/drawingml/2006/main">
               <a:ext uri="{FF2B5EF4-FFF2-40B4-BE49-F238E27FC236}">
-                <a16:creationId xmlns:a16="http://schemas.microsoft.com/office/drawing/2014/main" id="{E106A436-4172-4641-9FAC-88274050C69F}"/>
+                <a16:creationId xmlns:a16="http://schemas.microsoft.com/office/drawing/2014/main" id="{39F6D3F8-F1D0-4AFD-86D7-81F94493FF77}"/>
               </a:ext>
             </a:extLst>
           </p:cNvPr>
@@ -17174,7 +17174,7 @@
           <p:cNvPr id="2" name="">
             <a:extLst xmlns:a="http://schemas.openxmlformats.org/drawingml/2006/main">
               <a:ext uri="{FF2B5EF4-FFF2-40B4-BE49-F238E27FC236}">
-                <a16:creationId xmlns:a16="http://schemas.microsoft.com/office/drawing/2014/main" id="{E4FCBBAB-F4ED-4200-A84D-FCF9C68DDCAF}"/>
+                <a16:creationId xmlns:a16="http://schemas.microsoft.com/office/drawing/2014/main" id="{EC258688-EC61-4486-8EB8-B15714297F31}"/>
               </a:ext>
             </a:extLst>
           </p:cNvPr>
@@ -17330,7 +17330,7 @@
           <p:cNvPr id="3" name="">
             <a:extLst xmlns:a="http://schemas.openxmlformats.org/drawingml/2006/main">
               <a:ext uri="{FF2B5EF4-FFF2-40B4-BE49-F238E27FC236}">
-                <a16:creationId xmlns:a16="http://schemas.microsoft.com/office/drawing/2014/main" id="{6326F258-60AA-46C2-9687-79B2221E5607}"/>
+                <a16:creationId xmlns:a16="http://schemas.microsoft.com/office/drawing/2014/main" id="{1286492C-C582-4F6F-A119-28538FD0EE26}"/>
               </a:ext>
             </a:extLst>
           </p:cNvPr>
@@ -17470,7 +17470,7 @@
           <p:cNvPr id="4" name="">
             <a:extLst xmlns:a="http://schemas.openxmlformats.org/drawingml/2006/main">
               <a:ext uri="{FF2B5EF4-FFF2-40B4-BE49-F238E27FC236}">
-                <a16:creationId xmlns:a16="http://schemas.microsoft.com/office/drawing/2014/main" id="{DBD40E7E-5747-4744-AE97-3DBF0CDF1472}"/>
+                <a16:creationId xmlns:a16="http://schemas.microsoft.com/office/drawing/2014/main" id="{9D34C7E2-A0DE-4F73-8B90-128EB2015419}"/>
               </a:ext>
             </a:extLst>
           </p:cNvPr>
@@ -17626,7 +17626,7 @@
           <p:cNvPr id="5" name="">
             <a:extLst xmlns:a="http://schemas.openxmlformats.org/drawingml/2006/main">
               <a:ext uri="{FF2B5EF4-FFF2-40B4-BE49-F238E27FC236}">
-                <a16:creationId xmlns:a16="http://schemas.microsoft.com/office/drawing/2014/main" id="{424A19C3-83C9-4FF6-9D56-AC514BA9FE43}"/>
+                <a16:creationId xmlns:a16="http://schemas.microsoft.com/office/drawing/2014/main" id="{1E09E438-51EB-4802-9B4E-BF33E2D38A80}"/>
               </a:ext>
             </a:extLst>
           </p:cNvPr>
@@ -18485,7 +18485,7 @@
           <p:cNvPr id="6" name="">
             <a:extLst xmlns:a="http://schemas.openxmlformats.org/drawingml/2006/main">
               <a:ext uri="{FF2B5EF4-FFF2-40B4-BE49-F238E27FC236}">
-                <a16:creationId xmlns:a16="http://schemas.microsoft.com/office/drawing/2014/main" id="{0B276F1B-9234-44D6-A1FA-28CB153B1C9D}"/>
+                <a16:creationId xmlns:a16="http://schemas.microsoft.com/office/drawing/2014/main" id="{F32D2FBB-9426-456C-B1AB-1B52F8FBD2E9}"/>
               </a:ext>
             </a:extLst>
           </p:cNvPr>
@@ -18639,7 +18639,7 @@
     </p:spTree>
     <p:extLst>
       <p:ext uri="{BB962C8B-B14F-4D97-AF65-F5344CB8AC3E}">
-        <p14:creationId xmlns:p14="http://schemas.microsoft.com/office/powerpoint/2010/main" val="1275368150"/>
+        <p14:creationId xmlns:p14="http://schemas.microsoft.com/office/powerpoint/2010/main" val="1097702538"/>
       </p:ext>
     </p:extLst>
   </p:cSld>

</xml_diff>

<commit_message>
Validate simulator PageRank and add its M5 comparison to the Greek presentation
</commit_message>
<xml_diff>
--- a/presentation/CSLab_Memory_Tiering_Current.pptx
+++ b/presentation/CSLab_Memory_Tiering_Current.pptx
@@ -2,27 +2,27 @@
 <file path=ppt/presentation.xml><?xml version="1.0" encoding="utf-8"?>
 <p:presentation xmlns:p="http://schemas.openxmlformats.org/presentationml/2006/main">
   <p:sldMasterIdLst>
-    <p:sldMasterId xmlns:r="http://schemas.openxmlformats.org/officeDocument/2006/relationships" id="2147483648" r:id="Rfa31b1364f8a4554"/>
+    <p:sldMasterId xmlns:r="http://schemas.openxmlformats.org/officeDocument/2006/relationships" id="2147483648" r:id="R4f1ad751d2b04494"/>
   </p:sldMasterIdLst>
   <p:notesMasterIdLst>
-    <p:notesMasterId xmlns:r="http://schemas.openxmlformats.org/officeDocument/2006/relationships" r:id="R1305bb37e6844e52"/>
+    <p:notesMasterId xmlns:r="http://schemas.openxmlformats.org/officeDocument/2006/relationships" r:id="Rdac69977fb5748f5"/>
   </p:notesMasterIdLst>
   <p:sldIdLst>
-    <p:sldId xmlns:r="http://schemas.openxmlformats.org/officeDocument/2006/relationships" id="256" r:id="Racef20f68ed14a1b"/>
-    <p:sldId xmlns:r="http://schemas.openxmlformats.org/officeDocument/2006/relationships" id="257" r:id="Rbc62f27f2d42456f"/>
-    <p:sldId xmlns:r="http://schemas.openxmlformats.org/officeDocument/2006/relationships" id="258" r:id="R808c1f20a02c4c79"/>
-    <p:sldId xmlns:r="http://schemas.openxmlformats.org/officeDocument/2006/relationships" id="259" r:id="Rd039691dfde343d2"/>
-    <p:sldId xmlns:r="http://schemas.openxmlformats.org/officeDocument/2006/relationships" id="260" r:id="Rdcdbc295b78d4950"/>
-    <p:sldId xmlns:r="http://schemas.openxmlformats.org/officeDocument/2006/relationships" id="261" r:id="R14a63060e30a43b7"/>
-    <p:sldId xmlns:r="http://schemas.openxmlformats.org/officeDocument/2006/relationships" id="262" r:id="R0898579cc7674802"/>
-    <p:sldId xmlns:r="http://schemas.openxmlformats.org/officeDocument/2006/relationships" id="263" r:id="R5dd893a95d7e4001"/>
-    <p:sldId xmlns:r="http://schemas.openxmlformats.org/officeDocument/2006/relationships" id="264" r:id="R6f3748e1ce274c75"/>
-    <p:sldId xmlns:r="http://schemas.openxmlformats.org/officeDocument/2006/relationships" id="265" r:id="R37e72d1e96c54fea"/>
-    <p:sldId xmlns:r="http://schemas.openxmlformats.org/officeDocument/2006/relationships" id="266" r:id="R490df86c39b34bd1"/>
-    <p:sldId xmlns:r="http://schemas.openxmlformats.org/officeDocument/2006/relationships" id="267" r:id="Ree9523e4511b47dc"/>
-    <p:sldId xmlns:r="http://schemas.openxmlformats.org/officeDocument/2006/relationships" id="268" r:id="R1ddf6802886d4a70"/>
-    <p:sldId xmlns:r="http://schemas.openxmlformats.org/officeDocument/2006/relationships" id="269" r:id="R342caf2b2c07463d"/>
-    <p:sldId xmlns:r="http://schemas.openxmlformats.org/officeDocument/2006/relationships" id="270" r:id="R2efff1a077ff410d"/>
+    <p:sldId xmlns:r="http://schemas.openxmlformats.org/officeDocument/2006/relationships" id="256" r:id="R6db70253e1424e41"/>
+    <p:sldId xmlns:r="http://schemas.openxmlformats.org/officeDocument/2006/relationships" id="257" r:id="R5ac0d56ca19c4d93"/>
+    <p:sldId xmlns:r="http://schemas.openxmlformats.org/officeDocument/2006/relationships" id="258" r:id="R4a9ff6096b2e46c7"/>
+    <p:sldId xmlns:r="http://schemas.openxmlformats.org/officeDocument/2006/relationships" id="259" r:id="R984e69386650498e"/>
+    <p:sldId xmlns:r="http://schemas.openxmlformats.org/officeDocument/2006/relationships" id="260" r:id="Rd6f1012dbd5f4417"/>
+    <p:sldId xmlns:r="http://schemas.openxmlformats.org/officeDocument/2006/relationships" id="261" r:id="R7531b3899b004718"/>
+    <p:sldId xmlns:r="http://schemas.openxmlformats.org/officeDocument/2006/relationships" id="262" r:id="R11280f12a85c453a"/>
+    <p:sldId xmlns:r="http://schemas.openxmlformats.org/officeDocument/2006/relationships" id="263" r:id="R289510d96b814b2d"/>
+    <p:sldId xmlns:r="http://schemas.openxmlformats.org/officeDocument/2006/relationships" id="264" r:id="R7a554075a7ad4df8"/>
+    <p:sldId xmlns:r="http://schemas.openxmlformats.org/officeDocument/2006/relationships" id="265" r:id="Radf64c86c4b04d5d"/>
+    <p:sldId xmlns:r="http://schemas.openxmlformats.org/officeDocument/2006/relationships" id="266" r:id="R8ceaa216f1244f6d"/>
+    <p:sldId xmlns:r="http://schemas.openxmlformats.org/officeDocument/2006/relationships" id="267" r:id="Rb66ed1a87887450b"/>
+    <p:sldId xmlns:r="http://schemas.openxmlformats.org/officeDocument/2006/relationships" id="268" r:id="R7b2573e031564a3b"/>
+    <p:sldId xmlns:r="http://schemas.openxmlformats.org/officeDocument/2006/relationships" id="269" r:id="R908bba270eb94cd6"/>
+    <p:sldId xmlns:r="http://schemas.openxmlformats.org/officeDocument/2006/relationships" id="270" r:id="R836e6f97427a482e"/>
   </p:sldIdLst>
   <p:sldSz cx="12192000" cy="6858000"/>
   <p:notesSz cx="6858000" cy="9144000"/>
@@ -1633,7 +1633,7 @@
           <p:cNvPr id="3" name="Title">
             <a:extLst xmlns:a="http://schemas.openxmlformats.org/drawingml/2006/main">
               <a:ext uri="{FF2B5EF4-FFF2-40B4-BE49-F238E27FC236}">
-                <a16:creationId xmlns:a16="http://schemas.microsoft.com/office/drawing/2014/main" id="{785BD520-0C16-4183-804C-9FA5EEC24E85}"/>
+                <a16:creationId xmlns:a16="http://schemas.microsoft.com/office/drawing/2014/main" id="{3ED9AFBA-3032-4C3B-9B9A-77437D9C9F12}"/>
               </a:ext>
             </a:extLst>
           </p:cNvPr>
@@ -1862,7 +1862,7 @@
           <p:cNvPr id="2" name="Subtitle">
             <a:extLst xmlns:a="http://schemas.openxmlformats.org/drawingml/2006/main">
               <a:ext uri="{FF2B5EF4-FFF2-40B4-BE49-F238E27FC236}">
-                <a16:creationId xmlns:a16="http://schemas.microsoft.com/office/drawing/2014/main" id="{49F0A8E9-315F-4797-9F72-C6C6DDACA656}"/>
+                <a16:creationId xmlns:a16="http://schemas.microsoft.com/office/drawing/2014/main" id="{AFDE049C-2D21-4477-8F90-881596062967}"/>
               </a:ext>
             </a:extLst>
           </p:cNvPr>
@@ -2108,7 +2108,7 @@
           <p:cNvPr id="2" name="Section title">
             <a:extLst xmlns:a="http://schemas.openxmlformats.org/drawingml/2006/main">
               <a:ext uri="{FF2B5EF4-FFF2-40B4-BE49-F238E27FC236}">
-                <a16:creationId xmlns:a16="http://schemas.microsoft.com/office/drawing/2014/main" id="{00FA708B-DCF6-45BF-AC07-979A2543C4E3}"/>
+                <a16:creationId xmlns:a16="http://schemas.microsoft.com/office/drawing/2014/main" id="{55269F5C-14F4-48F0-9755-A7C458771E12}"/>
               </a:ext>
             </a:extLst>
           </p:cNvPr>
@@ -2354,7 +2354,7 @@
           <p:cNvPr id="3" name="Title">
             <a:extLst xmlns:a="http://schemas.openxmlformats.org/drawingml/2006/main">
               <a:ext uri="{FF2B5EF4-FFF2-40B4-BE49-F238E27FC236}">
-                <a16:creationId xmlns:a16="http://schemas.microsoft.com/office/drawing/2014/main" id="{564EB2F3-DF4E-40F5-AF2F-78F0F1C35120}"/>
+                <a16:creationId xmlns:a16="http://schemas.microsoft.com/office/drawing/2014/main" id="{8230BAC6-C2CB-4ABE-8D1F-C70727A2F078}"/>
               </a:ext>
             </a:extLst>
           </p:cNvPr>
@@ -2583,7 +2583,7 @@
           <p:cNvPr id="2" name="Body">
             <a:extLst xmlns:a="http://schemas.openxmlformats.org/drawingml/2006/main">
               <a:ext uri="{FF2B5EF4-FFF2-40B4-BE49-F238E27FC236}">
-                <a16:creationId xmlns:a16="http://schemas.microsoft.com/office/drawing/2014/main" id="{ACC1BFCD-4997-4978-B04D-CB858B4755D6}"/>
+                <a16:creationId xmlns:a16="http://schemas.microsoft.com/office/drawing/2014/main" id="{7187C114-08F5-42EB-8849-5D18026251E8}"/>
               </a:ext>
             </a:extLst>
           </p:cNvPr>
@@ -2829,7 +2829,7 @@
           <p:cNvPr id="4" name="Title">
             <a:extLst xmlns:a="http://schemas.openxmlformats.org/drawingml/2006/main">
               <a:ext uri="{FF2B5EF4-FFF2-40B4-BE49-F238E27FC236}">
-                <a16:creationId xmlns:a16="http://schemas.microsoft.com/office/drawing/2014/main" id="{AE4CD80E-A6D2-4221-9188-061952977AE7}"/>
+                <a16:creationId xmlns:a16="http://schemas.microsoft.com/office/drawing/2014/main" id="{F33E2D3E-CB9E-4040-ACE2-ED23A1B3175D}"/>
               </a:ext>
             </a:extLst>
           </p:cNvPr>
@@ -3058,7 +3058,7 @@
           <p:cNvPr id="2" name="Left column">
             <a:extLst xmlns:a="http://schemas.openxmlformats.org/drawingml/2006/main">
               <a:ext uri="{FF2B5EF4-FFF2-40B4-BE49-F238E27FC236}">
-                <a16:creationId xmlns:a16="http://schemas.microsoft.com/office/drawing/2014/main" id="{64BF7D3A-5D2C-4C6D-92EF-E157BDEDE1A2}"/>
+                <a16:creationId xmlns:a16="http://schemas.microsoft.com/office/drawing/2014/main" id="{D27A3C77-2013-4C0B-ADA6-EBBB037252C3}"/>
               </a:ext>
             </a:extLst>
           </p:cNvPr>
@@ -3287,7 +3287,7 @@
           <p:cNvPr id="3" name="Right column">
             <a:extLst xmlns:a="http://schemas.openxmlformats.org/drawingml/2006/main">
               <a:ext uri="{FF2B5EF4-FFF2-40B4-BE49-F238E27FC236}">
-                <a16:creationId xmlns:a16="http://schemas.microsoft.com/office/drawing/2014/main" id="{488BC072-65CD-411D-B312-D69E69BF484D}"/>
+                <a16:creationId xmlns:a16="http://schemas.microsoft.com/office/drawing/2014/main" id="{85178862-C97D-435B-BCA6-96A00FA6339C}"/>
               </a:ext>
             </a:extLst>
           </p:cNvPr>
@@ -3533,7 +3533,7 @@
           <p:cNvPr id="3" name="Title">
             <a:extLst xmlns:a="http://schemas.openxmlformats.org/drawingml/2006/main">
               <a:ext uri="{FF2B5EF4-FFF2-40B4-BE49-F238E27FC236}">
-                <a16:creationId xmlns:a16="http://schemas.microsoft.com/office/drawing/2014/main" id="{98014FCC-DD33-4CF6-9A3D-B9FED1FB08EC}"/>
+                <a16:creationId xmlns:a16="http://schemas.microsoft.com/office/drawing/2014/main" id="{458C921F-E065-4767-B1DC-2B4ECDADF0A3}"/>
               </a:ext>
             </a:extLst>
           </p:cNvPr>
@@ -3762,7 +3762,7 @@
           <p:cNvPr id="2" name="Left column">
             <a:extLst xmlns:a="http://schemas.openxmlformats.org/drawingml/2006/main">
               <a:ext uri="{FF2B5EF4-FFF2-40B4-BE49-F238E27FC236}">
-                <a16:creationId xmlns:a16="http://schemas.microsoft.com/office/drawing/2014/main" id="{205A3EE3-CD0A-4561-AC26-9ABB64D4E23E}"/>
+                <a16:creationId xmlns:a16="http://schemas.microsoft.com/office/drawing/2014/main" id="{4E71476E-A351-46CD-A829-52A9FE07D00C}"/>
               </a:ext>
             </a:extLst>
           </p:cNvPr>
@@ -4029,12 +4029,12 @@
   </p:cSld>
   <p:clrMap bg1="lt1" tx1="dk1" bg2="lt2" tx2="dk2" accent1="accent1" accent2="accent2" accent3="accent3" accent4="accent4" accent5="accent5" accent6="accent6" hlink="hlink" folHlink="folHlink"/>
   <p:sldLayoutIdLst>
-    <p:sldLayoutId xmlns:r="http://schemas.openxmlformats.org/officeDocument/2006/relationships" id="2147483649" r:id="Rf71d6ef056b041eb"/>
-    <p:sldLayoutId xmlns:r="http://schemas.openxmlformats.org/officeDocument/2006/relationships" id="2147483650" r:id="R4ae1178e55944506"/>
-    <p:sldLayoutId xmlns:r="http://schemas.openxmlformats.org/officeDocument/2006/relationships" id="2147483651" r:id="R4e45a419fea8485b"/>
-    <p:sldLayoutId xmlns:r="http://schemas.openxmlformats.org/officeDocument/2006/relationships" id="2147483652" r:id="R7beaf89ef4714473"/>
-    <p:sldLayoutId xmlns:r="http://schemas.openxmlformats.org/officeDocument/2006/relationships" id="2147483653" r:id="R417c33ab428f4a60"/>
-    <p:sldLayoutId xmlns:r="http://schemas.openxmlformats.org/officeDocument/2006/relationships" id="2147483654" r:id="R32db2bccec6a400b"/>
+    <p:sldLayoutId xmlns:r="http://schemas.openxmlformats.org/officeDocument/2006/relationships" id="2147483649" r:id="Ra011dcee3e0544b7"/>
+    <p:sldLayoutId xmlns:r="http://schemas.openxmlformats.org/officeDocument/2006/relationships" id="2147483650" r:id="Ra780604ead9f415c"/>
+    <p:sldLayoutId xmlns:r="http://schemas.openxmlformats.org/officeDocument/2006/relationships" id="2147483651" r:id="R7563659d246e4f6e"/>
+    <p:sldLayoutId xmlns:r="http://schemas.openxmlformats.org/officeDocument/2006/relationships" id="2147483652" r:id="Rcd0c2036cb004e54"/>
+    <p:sldLayoutId xmlns:r="http://schemas.openxmlformats.org/officeDocument/2006/relationships" id="2147483653" r:id="R9f518913c849444a"/>
+    <p:sldLayoutId xmlns:r="http://schemas.openxmlformats.org/officeDocument/2006/relationships" id="2147483654" r:id="R69448717db5b4859"/>
   </p:sldLayoutIdLst>
   <p:txStyles>
     <p:titleStyle>
@@ -4585,7 +4585,7 @@
           <p:cNvPr id="7" name="">
             <a:extLst xmlns:a="http://schemas.openxmlformats.org/drawingml/2006/main">
               <a:ext uri="{FF2B5EF4-FFF2-40B4-BE49-F238E27FC236}">
-                <a16:creationId xmlns:a16="http://schemas.microsoft.com/office/drawing/2014/main" id="{3FA64B5D-576F-441F-A772-613AAD0A9AF0}"/>
+                <a16:creationId xmlns:a16="http://schemas.microsoft.com/office/drawing/2014/main" id="{43F459D3-AEEB-4F7C-B5BC-4A613BCA38B4}"/>
               </a:ext>
             </a:extLst>
           </p:cNvPr>
@@ -4741,7 +4741,7 @@
           <p:cNvPr id="2" name="">
             <a:extLst xmlns:a="http://schemas.openxmlformats.org/drawingml/2006/main">
               <a:ext uri="{FF2B5EF4-FFF2-40B4-BE49-F238E27FC236}">
-                <a16:creationId xmlns:a16="http://schemas.microsoft.com/office/drawing/2014/main" id="{01B5FE0C-D7B9-4990-A8BF-9C17BFF491C9}"/>
+                <a16:creationId xmlns:a16="http://schemas.microsoft.com/office/drawing/2014/main" id="{13903F9D-B1B9-49B9-AD30-C1E3A39DE5C3}"/>
               </a:ext>
             </a:extLst>
           </p:cNvPr>
@@ -4897,7 +4897,7 @@
           <p:cNvPr id="3" name="">
             <a:extLst xmlns:a="http://schemas.openxmlformats.org/drawingml/2006/main">
               <a:ext uri="{FF2B5EF4-FFF2-40B4-BE49-F238E27FC236}">
-                <a16:creationId xmlns:a16="http://schemas.microsoft.com/office/drawing/2014/main" id="{F0569AB1-8342-43D8-A6E6-C855AAFB91E9}"/>
+                <a16:creationId xmlns:a16="http://schemas.microsoft.com/office/drawing/2014/main" id="{44EB9DA4-488D-42E2-B3BE-892C18C01D01}"/>
               </a:ext>
             </a:extLst>
           </p:cNvPr>
@@ -5037,7 +5037,7 @@
           <p:cNvPr id="4" name="">
             <a:extLst xmlns:a="http://schemas.openxmlformats.org/drawingml/2006/main">
               <a:ext uri="{FF2B5EF4-FFF2-40B4-BE49-F238E27FC236}">
-                <a16:creationId xmlns:a16="http://schemas.microsoft.com/office/drawing/2014/main" id="{D5794958-4D48-44F0-BA56-1DAD23C5DFD5}"/>
+                <a16:creationId xmlns:a16="http://schemas.microsoft.com/office/drawing/2014/main" id="{87855A04-1088-43E2-8F5E-82406DEB5377}"/>
               </a:ext>
             </a:extLst>
           </p:cNvPr>
@@ -5193,7 +5193,7 @@
           <p:cNvPr id="5" name="">
             <a:extLst xmlns:a="http://schemas.openxmlformats.org/drawingml/2006/main">
               <a:ext uri="{FF2B5EF4-FFF2-40B4-BE49-F238E27FC236}">
-                <a16:creationId xmlns:a16="http://schemas.microsoft.com/office/drawing/2014/main" id="{D712155A-BFE0-4C78-9242-251E31C857A8}"/>
+                <a16:creationId xmlns:a16="http://schemas.microsoft.com/office/drawing/2014/main" id="{9C4CF11A-6D79-442D-B7D6-628AE62A1488}"/>
               </a:ext>
             </a:extLst>
           </p:cNvPr>
@@ -5349,7 +5349,7 @@
           <p:cNvPr id="6" name="">
             <a:extLst xmlns:a="http://schemas.openxmlformats.org/drawingml/2006/main">
               <a:ext uri="{FF2B5EF4-FFF2-40B4-BE49-F238E27FC236}">
-                <a16:creationId xmlns:a16="http://schemas.microsoft.com/office/drawing/2014/main" id="{06159314-1407-4BC9-A48E-BD214DA2F7FB}"/>
+                <a16:creationId xmlns:a16="http://schemas.microsoft.com/office/drawing/2014/main" id="{64518918-FECC-40BA-8D3F-47B5C64B037E}"/>
               </a:ext>
             </a:extLst>
           </p:cNvPr>
@@ -5554,7 +5554,7 @@
     </p:spTree>
     <p:extLst>
       <p:ext uri="{BB962C8B-B14F-4D97-AF65-F5344CB8AC3E}">
-        <p14:creationId xmlns:p14="http://schemas.microsoft.com/office/powerpoint/2010/main" val="1869164389"/>
+        <p14:creationId xmlns:p14="http://schemas.microsoft.com/office/powerpoint/2010/main" val="1931644613"/>
       </p:ext>
     </p:extLst>
   </p:cSld>
@@ -5585,7 +5585,7 @@
           <p:cNvPr id="7" name="">
             <a:extLst xmlns:a="http://schemas.openxmlformats.org/drawingml/2006/main">
               <a:ext uri="{FF2B5EF4-FFF2-40B4-BE49-F238E27FC236}">
-                <a16:creationId xmlns:a16="http://schemas.microsoft.com/office/drawing/2014/main" id="{7D85AD17-F23E-4A9A-A053-8645863EDD51}"/>
+                <a16:creationId xmlns:a16="http://schemas.microsoft.com/office/drawing/2014/main" id="{D28FC8AC-5BE9-48A3-8747-4767BFB9903B}"/>
               </a:ext>
             </a:extLst>
           </p:cNvPr>
@@ -5741,7 +5741,7 @@
           <p:cNvPr id="2" name="">
             <a:extLst xmlns:a="http://schemas.openxmlformats.org/drawingml/2006/main">
               <a:ext uri="{FF2B5EF4-FFF2-40B4-BE49-F238E27FC236}">
-                <a16:creationId xmlns:a16="http://schemas.microsoft.com/office/drawing/2014/main" id="{EE137B99-DF61-47A0-92BA-7DBDDC0F8062}"/>
+                <a16:creationId xmlns:a16="http://schemas.microsoft.com/office/drawing/2014/main" id="{033B8758-E562-434D-9CE8-EC43AD2680A2}"/>
               </a:ext>
             </a:extLst>
           </p:cNvPr>
@@ -5897,7 +5897,7 @@
           <p:cNvPr id="3" name="">
             <a:extLst xmlns:a="http://schemas.openxmlformats.org/drawingml/2006/main">
               <a:ext uri="{FF2B5EF4-FFF2-40B4-BE49-F238E27FC236}">
-                <a16:creationId xmlns:a16="http://schemas.microsoft.com/office/drawing/2014/main" id="{2C94EFD9-9DAB-4118-807E-28FFF4C1EC2D}"/>
+                <a16:creationId xmlns:a16="http://schemas.microsoft.com/office/drawing/2014/main" id="{2A172307-BD0C-441E-8F0D-F495835613B2}"/>
               </a:ext>
             </a:extLst>
           </p:cNvPr>
@@ -6037,7 +6037,7 @@
           <p:cNvPr id="4" name="">
             <a:extLst xmlns:a="http://schemas.openxmlformats.org/drawingml/2006/main">
               <a:ext uri="{FF2B5EF4-FFF2-40B4-BE49-F238E27FC236}">
-                <a16:creationId xmlns:a16="http://schemas.microsoft.com/office/drawing/2014/main" id="{397C5464-6C0E-46F3-BFB5-C76FD313135C}"/>
+                <a16:creationId xmlns:a16="http://schemas.microsoft.com/office/drawing/2014/main" id="{78896F23-3D1F-45E0-9890-ED45EAD4EEE2}"/>
               </a:ext>
             </a:extLst>
           </p:cNvPr>
@@ -6193,7 +6193,7 @@
           <p:cNvPr id="5" name="">
             <a:extLst xmlns:a="http://schemas.openxmlformats.org/drawingml/2006/main">
               <a:ext uri="{FF2B5EF4-FFF2-40B4-BE49-F238E27FC236}">
-                <a16:creationId xmlns:a16="http://schemas.microsoft.com/office/drawing/2014/main" id="{A758C09A-D650-4E95-B558-499E22888983}"/>
+                <a16:creationId xmlns:a16="http://schemas.microsoft.com/office/drawing/2014/main" id="{C049AEC3-CD6A-496B-BAC7-BC62382DE23B}"/>
               </a:ext>
             </a:extLst>
           </p:cNvPr>
@@ -6372,7 +6372,7 @@
           <p:cNvPr id="6" name="">
             <a:extLst xmlns:a="http://schemas.openxmlformats.org/drawingml/2006/main">
               <a:ext uri="{FF2B5EF4-FFF2-40B4-BE49-F238E27FC236}">
-                <a16:creationId xmlns:a16="http://schemas.microsoft.com/office/drawing/2014/main" id="{711763C1-4322-4D6B-AD16-0C61A3CC034F}"/>
+                <a16:creationId xmlns:a16="http://schemas.microsoft.com/office/drawing/2014/main" id="{1BEE0AE4-C48F-4EA9-B789-736E40227853}"/>
               </a:ext>
             </a:extLst>
           </p:cNvPr>
@@ -6554,7 +6554,7 @@
     </p:spTree>
     <p:extLst>
       <p:ext uri="{BB962C8B-B14F-4D97-AF65-F5344CB8AC3E}">
-        <p14:creationId xmlns:p14="http://schemas.microsoft.com/office/powerpoint/2010/main" val="291745989"/>
+        <p14:creationId xmlns:p14="http://schemas.microsoft.com/office/powerpoint/2010/main" val="1539211053"/>
       </p:ext>
     </p:extLst>
   </p:cSld>
@@ -6585,7 +6585,7 @@
           <p:cNvPr id="7" name="">
             <a:extLst xmlns:a="http://schemas.openxmlformats.org/drawingml/2006/main">
               <a:ext uri="{FF2B5EF4-FFF2-40B4-BE49-F238E27FC236}">
-                <a16:creationId xmlns:a16="http://schemas.microsoft.com/office/drawing/2014/main" id="{E6B90B6C-EB35-4E5E-914C-90A49F2769F2}"/>
+                <a16:creationId xmlns:a16="http://schemas.microsoft.com/office/drawing/2014/main" id="{FAA318BE-D117-4A08-98C9-236924CC5B58}"/>
               </a:ext>
             </a:extLst>
           </p:cNvPr>
@@ -6741,7 +6741,7 @@
           <p:cNvPr id="2" name="">
             <a:extLst xmlns:a="http://schemas.openxmlformats.org/drawingml/2006/main">
               <a:ext uri="{FF2B5EF4-FFF2-40B4-BE49-F238E27FC236}">
-                <a16:creationId xmlns:a16="http://schemas.microsoft.com/office/drawing/2014/main" id="{B7131635-B4F2-4FD2-AEA4-D7A721F1BCB0}"/>
+                <a16:creationId xmlns:a16="http://schemas.microsoft.com/office/drawing/2014/main" id="{308FB4AD-73A3-4117-81BD-ADD32C30F0A9}"/>
               </a:ext>
             </a:extLst>
           </p:cNvPr>
@@ -6897,7 +6897,7 @@
           <p:cNvPr id="3" name="">
             <a:extLst xmlns:a="http://schemas.openxmlformats.org/drawingml/2006/main">
               <a:ext uri="{FF2B5EF4-FFF2-40B4-BE49-F238E27FC236}">
-                <a16:creationId xmlns:a16="http://schemas.microsoft.com/office/drawing/2014/main" id="{5E6B6551-73FA-4953-A876-1A3DAED4C25B}"/>
+                <a16:creationId xmlns:a16="http://schemas.microsoft.com/office/drawing/2014/main" id="{CA4A3FC9-C822-4DF9-894D-944A4E1545E5}"/>
               </a:ext>
             </a:extLst>
           </p:cNvPr>
@@ -7037,7 +7037,7 @@
           <p:cNvPr id="4" name="">
             <a:extLst xmlns:a="http://schemas.openxmlformats.org/drawingml/2006/main">
               <a:ext uri="{FF2B5EF4-FFF2-40B4-BE49-F238E27FC236}">
-                <a16:creationId xmlns:a16="http://schemas.microsoft.com/office/drawing/2014/main" id="{C180610B-F87A-4A0B-BEE6-F8A3D9859199}"/>
+                <a16:creationId xmlns:a16="http://schemas.microsoft.com/office/drawing/2014/main" id="{17A45C2C-A56B-4DAD-BDC1-20EC34C16F61}"/>
               </a:ext>
             </a:extLst>
           </p:cNvPr>
@@ -7193,7 +7193,7 @@
           <p:cNvPr id="5" name="">
             <a:extLst xmlns:a="http://schemas.openxmlformats.org/drawingml/2006/main">
               <a:ext uri="{FF2B5EF4-FFF2-40B4-BE49-F238E27FC236}">
-                <a16:creationId xmlns:a16="http://schemas.microsoft.com/office/drawing/2014/main" id="{EE39114F-336D-4071-93DB-F30FDA1F1A7E}"/>
+                <a16:creationId xmlns:a16="http://schemas.microsoft.com/office/drawing/2014/main" id="{9C9A08B0-1FBB-465C-B748-9A7EBFAC4C48}"/>
               </a:ext>
             </a:extLst>
           </p:cNvPr>
@@ -7203,7 +7203,7 @@
           <p:nvPr/>
         </p:nvPicPr>
         <p:blipFill>
-          <a:blip xmlns:r="http://schemas.openxmlformats.org/officeDocument/2006/relationships" xmlns:a="http://schemas.openxmlformats.org/drawingml/2006/main" r:embed="R1b707b49c2af4064"/>
+          <a:blip xmlns:r="http://schemas.openxmlformats.org/officeDocument/2006/relationships" xmlns:a="http://schemas.openxmlformats.org/drawingml/2006/main" r:embed="R3de2c380ccf2439b"/>
           <a:stretch xmlns:a="http://schemas.openxmlformats.org/drawingml/2006/main"/>
         </p:blipFill>
         <p:spPr>
@@ -7221,7 +7221,7 @@
           <p:cNvPr id="6" name="">
             <a:extLst xmlns:a="http://schemas.openxmlformats.org/drawingml/2006/main">
               <a:ext uri="{FF2B5EF4-FFF2-40B4-BE49-F238E27FC236}">
-                <a16:creationId xmlns:a16="http://schemas.microsoft.com/office/drawing/2014/main" id="{F32DA1F7-0C44-4655-AA9F-EDE9E7D42033}"/>
+                <a16:creationId xmlns:a16="http://schemas.microsoft.com/office/drawing/2014/main" id="{7722310F-213A-4845-BDA7-994CEFDD2458}"/>
               </a:ext>
             </a:extLst>
           </p:cNvPr>
@@ -7375,7 +7375,7 @@
     </p:spTree>
     <p:extLst>
       <p:ext uri="{BB962C8B-B14F-4D97-AF65-F5344CB8AC3E}">
-        <p14:creationId xmlns:p14="http://schemas.microsoft.com/office/powerpoint/2010/main" val="1261908021"/>
+        <p14:creationId xmlns:p14="http://schemas.microsoft.com/office/powerpoint/2010/main" val="1304764051"/>
       </p:ext>
     </p:extLst>
   </p:cSld>
@@ -7406,7 +7406,7 @@
           <p:cNvPr id="7" name="">
             <a:extLst xmlns:a="http://schemas.openxmlformats.org/drawingml/2006/main">
               <a:ext uri="{FF2B5EF4-FFF2-40B4-BE49-F238E27FC236}">
-                <a16:creationId xmlns:a16="http://schemas.microsoft.com/office/drawing/2014/main" id="{FC34B32D-EDC1-4863-A289-F36721E7E438}"/>
+                <a16:creationId xmlns:a16="http://schemas.microsoft.com/office/drawing/2014/main" id="{2BAD2977-C84B-4067-84DC-11451592B214}"/>
               </a:ext>
             </a:extLst>
           </p:cNvPr>
@@ -7562,7 +7562,7 @@
           <p:cNvPr id="2" name="">
             <a:extLst xmlns:a="http://schemas.openxmlformats.org/drawingml/2006/main">
               <a:ext uri="{FF2B5EF4-FFF2-40B4-BE49-F238E27FC236}">
-                <a16:creationId xmlns:a16="http://schemas.microsoft.com/office/drawing/2014/main" id="{1FC0B396-A1AD-4517-B484-7815E7A9F8CA}"/>
+                <a16:creationId xmlns:a16="http://schemas.microsoft.com/office/drawing/2014/main" id="{03402246-C3AE-42AA-AE87-F6C8AFB28F06}"/>
               </a:ext>
             </a:extLst>
           </p:cNvPr>
@@ -7718,7 +7718,7 @@
           <p:cNvPr id="3" name="">
             <a:extLst xmlns:a="http://schemas.openxmlformats.org/drawingml/2006/main">
               <a:ext uri="{FF2B5EF4-FFF2-40B4-BE49-F238E27FC236}">
-                <a16:creationId xmlns:a16="http://schemas.microsoft.com/office/drawing/2014/main" id="{3FF14D1B-1A9E-4035-A64B-C3EEF55B0217}"/>
+                <a16:creationId xmlns:a16="http://schemas.microsoft.com/office/drawing/2014/main" id="{4BE06859-0479-4F52-A308-48E99CDEEEE3}"/>
               </a:ext>
             </a:extLst>
           </p:cNvPr>
@@ -7858,7 +7858,7 @@
           <p:cNvPr id="4" name="">
             <a:extLst xmlns:a="http://schemas.openxmlformats.org/drawingml/2006/main">
               <a:ext uri="{FF2B5EF4-FFF2-40B4-BE49-F238E27FC236}">
-                <a16:creationId xmlns:a16="http://schemas.microsoft.com/office/drawing/2014/main" id="{A5F7169E-BCD6-4157-833C-73B017261C31}"/>
+                <a16:creationId xmlns:a16="http://schemas.microsoft.com/office/drawing/2014/main" id="{512FA0D5-1529-468F-BA72-846D52F20F90}"/>
               </a:ext>
             </a:extLst>
           </p:cNvPr>
@@ -8014,7 +8014,7 @@
           <p:cNvPr id="5" name="">
             <a:extLst xmlns:a="http://schemas.openxmlformats.org/drawingml/2006/main">
               <a:ext uri="{FF2B5EF4-FFF2-40B4-BE49-F238E27FC236}">
-                <a16:creationId xmlns:a16="http://schemas.microsoft.com/office/drawing/2014/main" id="{8CF30CB9-1DE2-40F6-B510-A7F0724EE592}"/>
+                <a16:creationId xmlns:a16="http://schemas.microsoft.com/office/drawing/2014/main" id="{88284DF1-9636-4CF8-BEC3-92329F7AE49E}"/>
               </a:ext>
             </a:extLst>
           </p:cNvPr>
@@ -8024,7 +8024,7 @@
           <p:nvPr/>
         </p:nvPicPr>
         <p:blipFill>
-          <a:blip xmlns:r="http://schemas.openxmlformats.org/officeDocument/2006/relationships" xmlns:a="http://schemas.openxmlformats.org/drawingml/2006/main" r:embed="Rf95c2940481845e8"/>
+          <a:blip xmlns:r="http://schemas.openxmlformats.org/officeDocument/2006/relationships" xmlns:a="http://schemas.openxmlformats.org/drawingml/2006/main" r:embed="R3486443dc846437a"/>
           <a:stretch xmlns:a="http://schemas.openxmlformats.org/drawingml/2006/main"/>
         </p:blipFill>
         <p:spPr>
@@ -8042,7 +8042,7 @@
           <p:cNvPr id="6" name="">
             <a:extLst xmlns:a="http://schemas.openxmlformats.org/drawingml/2006/main">
               <a:ext uri="{FF2B5EF4-FFF2-40B4-BE49-F238E27FC236}">
-                <a16:creationId xmlns:a16="http://schemas.microsoft.com/office/drawing/2014/main" id="{75B5B5CF-EE65-4710-A7DD-06B1A19C3305}"/>
+                <a16:creationId xmlns:a16="http://schemas.microsoft.com/office/drawing/2014/main" id="{9EFF4861-9FE3-4DAF-9B3C-65B739DB3C8C}"/>
               </a:ext>
             </a:extLst>
           </p:cNvPr>
@@ -8188,7 +8188,7 @@
                 <a:ea typeface="Noto Sans"/>
                 <a:cs typeface="Noto Sans"/>
               </a:rPr>
-              <a:t>PR: running · TC: queued · Snapshot resume: bounded validation passed, reboot untested.</a:t>
+              <a:t>PR: complete · TC: running · Snapshot resume: bounded validation passed, reboot untested.</a:t>
             </a:r>
           </a:p>
         </p:txBody>
@@ -8196,7 +8196,7 @@
     </p:spTree>
     <p:extLst>
       <p:ext uri="{BB962C8B-B14F-4D97-AF65-F5344CB8AC3E}">
-        <p14:creationId xmlns:p14="http://schemas.microsoft.com/office/powerpoint/2010/main" val="1752638563"/>
+        <p14:creationId xmlns:p14="http://schemas.microsoft.com/office/powerpoint/2010/main" val="308193032"/>
       </p:ext>
     </p:extLst>
   </p:cSld>
@@ -8227,7 +8227,7 @@
           <p:cNvPr id="7" name="">
             <a:extLst xmlns:a="http://schemas.openxmlformats.org/drawingml/2006/main">
               <a:ext uri="{FF2B5EF4-FFF2-40B4-BE49-F238E27FC236}">
-                <a16:creationId xmlns:a16="http://schemas.microsoft.com/office/drawing/2014/main" id="{2739B3A4-A824-4B48-A66E-90A360A73280}"/>
+                <a16:creationId xmlns:a16="http://schemas.microsoft.com/office/drawing/2014/main" id="{D9F0B41C-FFCD-4453-8D53-5E3A974CAC0E}"/>
               </a:ext>
             </a:extLst>
           </p:cNvPr>
@@ -8383,7 +8383,7 @@
           <p:cNvPr id="2" name="">
             <a:extLst xmlns:a="http://schemas.openxmlformats.org/drawingml/2006/main">
               <a:ext uri="{FF2B5EF4-FFF2-40B4-BE49-F238E27FC236}">
-                <a16:creationId xmlns:a16="http://schemas.microsoft.com/office/drawing/2014/main" id="{01B31750-2C17-4CAF-AC0C-65E9A9C5EFBA}"/>
+                <a16:creationId xmlns:a16="http://schemas.microsoft.com/office/drawing/2014/main" id="{E47BABB6-6B39-4E50-B724-B989A3E24EE9}"/>
               </a:ext>
             </a:extLst>
           </p:cNvPr>
@@ -8539,7 +8539,7 @@
           <p:cNvPr id="3" name="">
             <a:extLst xmlns:a="http://schemas.openxmlformats.org/drawingml/2006/main">
               <a:ext uri="{FF2B5EF4-FFF2-40B4-BE49-F238E27FC236}">
-                <a16:creationId xmlns:a16="http://schemas.microsoft.com/office/drawing/2014/main" id="{E25F1B4D-DDC1-4C84-93C7-B6CC5D298598}"/>
+                <a16:creationId xmlns:a16="http://schemas.microsoft.com/office/drawing/2014/main" id="{303D4123-9C78-427D-A1B8-47E81A7197AA}"/>
               </a:ext>
             </a:extLst>
           </p:cNvPr>
@@ -8679,7 +8679,7 @@
           <p:cNvPr id="4" name="">
             <a:extLst xmlns:a="http://schemas.openxmlformats.org/drawingml/2006/main">
               <a:ext uri="{FF2B5EF4-FFF2-40B4-BE49-F238E27FC236}">
-                <a16:creationId xmlns:a16="http://schemas.microsoft.com/office/drawing/2014/main" id="{776A7B55-E781-48CF-83BB-4CA25FE565B8}"/>
+                <a16:creationId xmlns:a16="http://schemas.microsoft.com/office/drawing/2014/main" id="{4B31D891-7A8B-42EF-B9C6-C032744A174E}"/>
               </a:ext>
             </a:extLst>
           </p:cNvPr>
@@ -8835,7 +8835,7 @@
           <p:cNvPr id="5" name="">
             <a:extLst xmlns:a="http://schemas.openxmlformats.org/drawingml/2006/main">
               <a:ext uri="{FF2B5EF4-FFF2-40B4-BE49-F238E27FC236}">
-                <a16:creationId xmlns:a16="http://schemas.microsoft.com/office/drawing/2014/main" id="{F1B0D0F0-6767-408E-A18C-E0B711758559}"/>
+                <a16:creationId xmlns:a16="http://schemas.microsoft.com/office/drawing/2014/main" id="{4606CD15-1D8F-48F1-A787-8C57E00C09D3}"/>
               </a:ext>
             </a:extLst>
           </p:cNvPr>
@@ -8845,7 +8845,7 @@
           <p:nvPr/>
         </p:nvPicPr>
         <p:blipFill>
-          <a:blip xmlns:r="http://schemas.openxmlformats.org/officeDocument/2006/relationships" xmlns:a="http://schemas.openxmlformats.org/drawingml/2006/main" r:embed="R0389e4b821b74c08"/>
+          <a:blip xmlns:r="http://schemas.openxmlformats.org/officeDocument/2006/relationships" xmlns:a="http://schemas.openxmlformats.org/drawingml/2006/main" r:embed="R2851ecbf9a2c4ce1"/>
           <a:stretch xmlns:a="http://schemas.openxmlformats.org/drawingml/2006/main"/>
         </p:blipFill>
         <p:spPr>
@@ -8863,7 +8863,7 @@
           <p:cNvPr id="6" name="">
             <a:extLst xmlns:a="http://schemas.openxmlformats.org/drawingml/2006/main">
               <a:ext uri="{FF2B5EF4-FFF2-40B4-BE49-F238E27FC236}">
-                <a16:creationId xmlns:a16="http://schemas.microsoft.com/office/drawing/2014/main" id="{12FAFD86-CD61-4889-94C0-852D67E99ABC}"/>
+                <a16:creationId xmlns:a16="http://schemas.microsoft.com/office/drawing/2014/main" id="{221D401F-BC06-4171-AD01-5D0773E88ECA}"/>
               </a:ext>
             </a:extLst>
           </p:cNvPr>
@@ -9142,7 +9142,7 @@
     </p:spTree>
     <p:extLst>
       <p:ext uri="{BB962C8B-B14F-4D97-AF65-F5344CB8AC3E}">
-        <p14:creationId xmlns:p14="http://schemas.microsoft.com/office/powerpoint/2010/main" val="2117805753"/>
+        <p14:creationId xmlns:p14="http://schemas.microsoft.com/office/powerpoint/2010/main" val="1640837499"/>
       </p:ext>
     </p:extLst>
   </p:cSld>
@@ -9173,7 +9173,7 @@
           <p:cNvPr id="7" name="">
             <a:extLst xmlns:a="http://schemas.openxmlformats.org/drawingml/2006/main">
               <a:ext uri="{FF2B5EF4-FFF2-40B4-BE49-F238E27FC236}">
-                <a16:creationId xmlns:a16="http://schemas.microsoft.com/office/drawing/2014/main" id="{FAB41BE6-5ACD-4D19-8499-1F719A9313F7}"/>
+                <a16:creationId xmlns:a16="http://schemas.microsoft.com/office/drawing/2014/main" id="{937F2BEA-9070-458A-AC87-60553056FC8C}"/>
               </a:ext>
             </a:extLst>
           </p:cNvPr>
@@ -9329,7 +9329,7 @@
           <p:cNvPr id="2" name="">
             <a:extLst xmlns:a="http://schemas.openxmlformats.org/drawingml/2006/main">
               <a:ext uri="{FF2B5EF4-FFF2-40B4-BE49-F238E27FC236}">
-                <a16:creationId xmlns:a16="http://schemas.microsoft.com/office/drawing/2014/main" id="{CC028520-61C0-4B59-917D-DF49048A4F20}"/>
+                <a16:creationId xmlns:a16="http://schemas.microsoft.com/office/drawing/2014/main" id="{DE619CFE-26EA-4ABF-B52B-59060F6E503B}"/>
               </a:ext>
             </a:extLst>
           </p:cNvPr>
@@ -9485,7 +9485,7 @@
           <p:cNvPr id="3" name="">
             <a:extLst xmlns:a="http://schemas.openxmlformats.org/drawingml/2006/main">
               <a:ext uri="{FF2B5EF4-FFF2-40B4-BE49-F238E27FC236}">
-                <a16:creationId xmlns:a16="http://schemas.microsoft.com/office/drawing/2014/main" id="{A9B2EA25-8AF0-4E9F-BD9D-8C6F59A39C8E}"/>
+                <a16:creationId xmlns:a16="http://schemas.microsoft.com/office/drawing/2014/main" id="{70BA6F05-FFA7-46D7-8095-0DD571A89FFE}"/>
               </a:ext>
             </a:extLst>
           </p:cNvPr>
@@ -9625,7 +9625,7 @@
           <p:cNvPr id="4" name="">
             <a:extLst xmlns:a="http://schemas.openxmlformats.org/drawingml/2006/main">
               <a:ext uri="{FF2B5EF4-FFF2-40B4-BE49-F238E27FC236}">
-                <a16:creationId xmlns:a16="http://schemas.microsoft.com/office/drawing/2014/main" id="{23AA5B71-CAE6-4DB0-92E4-3394A32B8FE1}"/>
+                <a16:creationId xmlns:a16="http://schemas.microsoft.com/office/drawing/2014/main" id="{D6D7F0AA-B6E7-4200-9D9A-F144DD6179B2}"/>
               </a:ext>
             </a:extLst>
           </p:cNvPr>
@@ -9781,7 +9781,7 @@
           <p:cNvPr id="5" name="">
             <a:extLst xmlns:a="http://schemas.openxmlformats.org/drawingml/2006/main">
               <a:ext uri="{FF2B5EF4-FFF2-40B4-BE49-F238E27FC236}">
-                <a16:creationId xmlns:a16="http://schemas.microsoft.com/office/drawing/2014/main" id="{F622B527-D568-46EE-978B-0A8BC47D4871}"/>
+                <a16:creationId xmlns:a16="http://schemas.microsoft.com/office/drawing/2014/main" id="{7208EC54-88BA-46C1-BD78-4E4604307165}"/>
               </a:ext>
             </a:extLst>
           </p:cNvPr>
@@ -9791,7 +9791,7 @@
           <p:nvPr/>
         </p:nvPicPr>
         <p:blipFill>
-          <a:blip xmlns:r="http://schemas.openxmlformats.org/officeDocument/2006/relationships" xmlns:a="http://schemas.openxmlformats.org/drawingml/2006/main" r:embed="R8d139abfdb854b66"/>
+          <a:blip xmlns:r="http://schemas.openxmlformats.org/officeDocument/2006/relationships" xmlns:a="http://schemas.openxmlformats.org/drawingml/2006/main" r:embed="Rdcbfecbc5bff4b76"/>
           <a:stretch xmlns:a="http://schemas.openxmlformats.org/drawingml/2006/main"/>
         </p:blipFill>
         <p:spPr>
@@ -9809,7 +9809,7 @@
           <p:cNvPr id="6" name="">
             <a:extLst xmlns:a="http://schemas.openxmlformats.org/drawingml/2006/main">
               <a:ext uri="{FF2B5EF4-FFF2-40B4-BE49-F238E27FC236}">
-                <a16:creationId xmlns:a16="http://schemas.microsoft.com/office/drawing/2014/main" id="{8C8A1385-2F9C-4B2D-A3C6-FEC8EC8060FD}"/>
+                <a16:creationId xmlns:a16="http://schemas.microsoft.com/office/drawing/2014/main" id="{EA216D0E-FBFE-4535-B4DA-1B72B84FC2D3}"/>
               </a:ext>
             </a:extLst>
           </p:cNvPr>
@@ -10070,7 +10070,7 @@
     </p:spTree>
     <p:extLst>
       <p:ext uri="{BB962C8B-B14F-4D97-AF65-F5344CB8AC3E}">
-        <p14:creationId xmlns:p14="http://schemas.microsoft.com/office/powerpoint/2010/main" val="394731011"/>
+        <p14:creationId xmlns:p14="http://schemas.microsoft.com/office/powerpoint/2010/main" val="1143941742"/>
       </p:ext>
     </p:extLst>
   </p:cSld>
@@ -10101,7 +10101,7 @@
           <p:cNvPr id="6" name="">
             <a:extLst xmlns:a="http://schemas.openxmlformats.org/drawingml/2006/main">
               <a:ext uri="{FF2B5EF4-FFF2-40B4-BE49-F238E27FC236}">
-                <a16:creationId xmlns:a16="http://schemas.microsoft.com/office/drawing/2014/main" id="{76323E50-062C-40B4-85C1-D86AA11BDDC2}"/>
+                <a16:creationId xmlns:a16="http://schemas.microsoft.com/office/drawing/2014/main" id="{DF929458-6BA2-4CCB-9C80-02F8C5A9B905}"/>
               </a:ext>
             </a:extLst>
           </p:cNvPr>
@@ -10257,7 +10257,7 @@
           <p:cNvPr id="2" name="">
             <a:extLst xmlns:a="http://schemas.openxmlformats.org/drawingml/2006/main">
               <a:ext uri="{FF2B5EF4-FFF2-40B4-BE49-F238E27FC236}">
-                <a16:creationId xmlns:a16="http://schemas.microsoft.com/office/drawing/2014/main" id="{5F6B8176-9BAA-40EE-872A-4333BFB6ADEA}"/>
+                <a16:creationId xmlns:a16="http://schemas.microsoft.com/office/drawing/2014/main" id="{9508487F-A6D2-4E49-B2CA-7BF4FB7FD397}"/>
               </a:ext>
             </a:extLst>
           </p:cNvPr>
@@ -10413,7 +10413,7 @@
           <p:cNvPr id="3" name="">
             <a:extLst xmlns:a="http://schemas.openxmlformats.org/drawingml/2006/main">
               <a:ext uri="{FF2B5EF4-FFF2-40B4-BE49-F238E27FC236}">
-                <a16:creationId xmlns:a16="http://schemas.microsoft.com/office/drawing/2014/main" id="{B443DF7A-01E6-481A-89D2-A445882A90D1}"/>
+                <a16:creationId xmlns:a16="http://schemas.microsoft.com/office/drawing/2014/main" id="{FC8F2F39-6D39-42EA-AC88-05DAE7EFBC69}"/>
               </a:ext>
             </a:extLst>
           </p:cNvPr>
@@ -10553,7 +10553,7 @@
           <p:cNvPr id="4" name="">
             <a:extLst xmlns:a="http://schemas.openxmlformats.org/drawingml/2006/main">
               <a:ext uri="{FF2B5EF4-FFF2-40B4-BE49-F238E27FC236}">
-                <a16:creationId xmlns:a16="http://schemas.microsoft.com/office/drawing/2014/main" id="{8615FB91-AE29-44C0-A228-C7E8C914D1ED}"/>
+                <a16:creationId xmlns:a16="http://schemas.microsoft.com/office/drawing/2014/main" id="{C2617DBC-D3E7-43E4-8458-6A893DE33B1F}"/>
               </a:ext>
             </a:extLst>
           </p:cNvPr>
@@ -10709,7 +10709,7 @@
           <p:cNvPr id="5" name="">
             <a:extLst xmlns:a="http://schemas.openxmlformats.org/drawingml/2006/main">
               <a:ext uri="{FF2B5EF4-FFF2-40B4-BE49-F238E27FC236}">
-                <a16:creationId xmlns:a16="http://schemas.microsoft.com/office/drawing/2014/main" id="{261851E1-2B95-4CE2-ABED-EE80EDF8C082}"/>
+                <a16:creationId xmlns:a16="http://schemas.microsoft.com/office/drawing/2014/main" id="{E2E8EC05-33BE-4ACB-B72E-96355411558A}"/>
               </a:ext>
             </a:extLst>
           </p:cNvPr>
@@ -10970,7 +10970,7 @@
     </p:spTree>
     <p:extLst>
       <p:ext uri="{BB962C8B-B14F-4D97-AF65-F5344CB8AC3E}">
-        <p14:creationId xmlns:p14="http://schemas.microsoft.com/office/powerpoint/2010/main" val="856548276"/>
+        <p14:creationId xmlns:p14="http://schemas.microsoft.com/office/powerpoint/2010/main" val="1885901482"/>
       </p:ext>
     </p:extLst>
   </p:cSld>
@@ -11001,7 +11001,7 @@
           <p:cNvPr id="6" name="">
             <a:extLst xmlns:a="http://schemas.openxmlformats.org/drawingml/2006/main">
               <a:ext uri="{FF2B5EF4-FFF2-40B4-BE49-F238E27FC236}">
-                <a16:creationId xmlns:a16="http://schemas.microsoft.com/office/drawing/2014/main" id="{7427BF54-A668-4B14-89AC-2234F6DE18CC}"/>
+                <a16:creationId xmlns:a16="http://schemas.microsoft.com/office/drawing/2014/main" id="{47BD5FF9-A0AD-47CE-A510-FA5ADAD3A7E6}"/>
               </a:ext>
             </a:extLst>
           </p:cNvPr>
@@ -11157,7 +11157,7 @@
           <p:cNvPr id="2" name="">
             <a:extLst xmlns:a="http://schemas.openxmlformats.org/drawingml/2006/main">
               <a:ext uri="{FF2B5EF4-FFF2-40B4-BE49-F238E27FC236}">
-                <a16:creationId xmlns:a16="http://schemas.microsoft.com/office/drawing/2014/main" id="{D908F103-2360-455C-995D-F44297D4BC18}"/>
+                <a16:creationId xmlns:a16="http://schemas.microsoft.com/office/drawing/2014/main" id="{26DD0F1B-CE62-4305-A527-0861242B3DCB}"/>
               </a:ext>
             </a:extLst>
           </p:cNvPr>
@@ -11313,7 +11313,7 @@
           <p:cNvPr id="3" name="">
             <a:extLst xmlns:a="http://schemas.openxmlformats.org/drawingml/2006/main">
               <a:ext uri="{FF2B5EF4-FFF2-40B4-BE49-F238E27FC236}">
-                <a16:creationId xmlns:a16="http://schemas.microsoft.com/office/drawing/2014/main" id="{25F8FF10-7E91-485C-B90F-AE8F336305F2}"/>
+                <a16:creationId xmlns:a16="http://schemas.microsoft.com/office/drawing/2014/main" id="{DDE5E2E7-D9C8-4269-B489-E6607E99BDD3}"/>
               </a:ext>
             </a:extLst>
           </p:cNvPr>
@@ -11453,7 +11453,7 @@
           <p:cNvPr id="4" name="">
             <a:extLst xmlns:a="http://schemas.openxmlformats.org/drawingml/2006/main">
               <a:ext uri="{FF2B5EF4-FFF2-40B4-BE49-F238E27FC236}">
-                <a16:creationId xmlns:a16="http://schemas.microsoft.com/office/drawing/2014/main" id="{D3D7A319-BDDB-46AF-AD8D-C516AD7A3611}"/>
+                <a16:creationId xmlns:a16="http://schemas.microsoft.com/office/drawing/2014/main" id="{163AB0D1-8A25-4BBA-8B66-5FF8BC343BBF}"/>
               </a:ext>
             </a:extLst>
           </p:cNvPr>
@@ -11609,7 +11609,7 @@
           <p:cNvPr id="5" name="">
             <a:extLst xmlns:a="http://schemas.openxmlformats.org/drawingml/2006/main">
               <a:ext uri="{FF2B5EF4-FFF2-40B4-BE49-F238E27FC236}">
-                <a16:creationId xmlns:a16="http://schemas.microsoft.com/office/drawing/2014/main" id="{D2C4977A-82B7-45C2-9EBF-31F95B08B07B}"/>
+                <a16:creationId xmlns:a16="http://schemas.microsoft.com/office/drawing/2014/main" id="{26E5A797-1D15-41C8-A629-E0A801AB075F}"/>
               </a:ext>
             </a:extLst>
           </p:cNvPr>
@@ -11819,7 +11819,7 @@
     </p:spTree>
     <p:extLst>
       <p:ext uri="{BB962C8B-B14F-4D97-AF65-F5344CB8AC3E}">
-        <p14:creationId xmlns:p14="http://schemas.microsoft.com/office/powerpoint/2010/main" val="1251648765"/>
+        <p14:creationId xmlns:p14="http://schemas.microsoft.com/office/powerpoint/2010/main" val="1447961184"/>
       </p:ext>
     </p:extLst>
   </p:cSld>
@@ -11850,7 +11850,7 @@
           <p:cNvPr id="6" name="">
             <a:extLst xmlns:a="http://schemas.openxmlformats.org/drawingml/2006/main">
               <a:ext uri="{FF2B5EF4-FFF2-40B4-BE49-F238E27FC236}">
-                <a16:creationId xmlns:a16="http://schemas.microsoft.com/office/drawing/2014/main" id="{E3418A02-F628-4D2C-A64B-DE35462FC864}"/>
+                <a16:creationId xmlns:a16="http://schemas.microsoft.com/office/drawing/2014/main" id="{E970AD66-E2A3-47A6-ABF6-3BAAD36BF096}"/>
               </a:ext>
             </a:extLst>
           </p:cNvPr>
@@ -12006,7 +12006,7 @@
           <p:cNvPr id="2" name="">
             <a:extLst xmlns:a="http://schemas.openxmlformats.org/drawingml/2006/main">
               <a:ext uri="{FF2B5EF4-FFF2-40B4-BE49-F238E27FC236}">
-                <a16:creationId xmlns:a16="http://schemas.microsoft.com/office/drawing/2014/main" id="{5631E9B6-3CE4-4823-B939-7F5A22E190DA}"/>
+                <a16:creationId xmlns:a16="http://schemas.microsoft.com/office/drawing/2014/main" id="{26E9BC3E-A344-44A3-8EF6-CAFFA1D3631C}"/>
               </a:ext>
             </a:extLst>
           </p:cNvPr>
@@ -12162,7 +12162,7 @@
           <p:cNvPr id="3" name="">
             <a:extLst xmlns:a="http://schemas.openxmlformats.org/drawingml/2006/main">
               <a:ext uri="{FF2B5EF4-FFF2-40B4-BE49-F238E27FC236}">
-                <a16:creationId xmlns:a16="http://schemas.microsoft.com/office/drawing/2014/main" id="{25F755E3-7F1F-4813-9ED7-672650764B11}"/>
+                <a16:creationId xmlns:a16="http://schemas.microsoft.com/office/drawing/2014/main" id="{A3C2FB12-849A-40DE-BBB5-D36264175C67}"/>
               </a:ext>
             </a:extLst>
           </p:cNvPr>
@@ -12302,7 +12302,7 @@
           <p:cNvPr id="4" name="">
             <a:extLst xmlns:a="http://schemas.openxmlformats.org/drawingml/2006/main">
               <a:ext uri="{FF2B5EF4-FFF2-40B4-BE49-F238E27FC236}">
-                <a16:creationId xmlns:a16="http://schemas.microsoft.com/office/drawing/2014/main" id="{F80A025B-C943-49B1-900E-E319AD372CD3}"/>
+                <a16:creationId xmlns:a16="http://schemas.microsoft.com/office/drawing/2014/main" id="{9AB41794-B00B-46CB-99B0-FBF88DED9F45}"/>
               </a:ext>
             </a:extLst>
           </p:cNvPr>
@@ -12458,7 +12458,7 @@
           <p:cNvPr id="5" name="">
             <a:extLst xmlns:a="http://schemas.openxmlformats.org/drawingml/2006/main">
               <a:ext uri="{FF2B5EF4-FFF2-40B4-BE49-F238E27FC236}">
-                <a16:creationId xmlns:a16="http://schemas.microsoft.com/office/drawing/2014/main" id="{3A95727C-C883-42A1-A4AB-EB79EF5941DD}"/>
+                <a16:creationId xmlns:a16="http://schemas.microsoft.com/office/drawing/2014/main" id="{C5FF5574-F4B6-485D-8E5A-F07D301C6912}"/>
               </a:ext>
             </a:extLst>
           </p:cNvPr>
@@ -12696,7 +12696,7 @@
     </p:spTree>
     <p:extLst>
       <p:ext uri="{BB962C8B-B14F-4D97-AF65-F5344CB8AC3E}">
-        <p14:creationId xmlns:p14="http://schemas.microsoft.com/office/powerpoint/2010/main" val="665191684"/>
+        <p14:creationId xmlns:p14="http://schemas.microsoft.com/office/powerpoint/2010/main" val="79076675"/>
       </p:ext>
     </p:extLst>
   </p:cSld>
@@ -12727,7 +12727,7 @@
           <p:cNvPr id="6" name="">
             <a:extLst xmlns:a="http://schemas.openxmlformats.org/drawingml/2006/main">
               <a:ext uri="{FF2B5EF4-FFF2-40B4-BE49-F238E27FC236}">
-                <a16:creationId xmlns:a16="http://schemas.microsoft.com/office/drawing/2014/main" id="{AB5C7AF9-4B76-48CF-A623-CC2F8150E1D9}"/>
+                <a16:creationId xmlns:a16="http://schemas.microsoft.com/office/drawing/2014/main" id="{9621AEF5-7AA5-4EF7-A4A1-B46648AA05AD}"/>
               </a:ext>
             </a:extLst>
           </p:cNvPr>
@@ -12883,7 +12883,7 @@
           <p:cNvPr id="2" name="">
             <a:extLst xmlns:a="http://schemas.openxmlformats.org/drawingml/2006/main">
               <a:ext uri="{FF2B5EF4-FFF2-40B4-BE49-F238E27FC236}">
-                <a16:creationId xmlns:a16="http://schemas.microsoft.com/office/drawing/2014/main" id="{DB003921-080E-4D04-8F6F-16193485AC35}"/>
+                <a16:creationId xmlns:a16="http://schemas.microsoft.com/office/drawing/2014/main" id="{613B2FC1-D321-4D76-BA00-C344422D1B23}"/>
               </a:ext>
             </a:extLst>
           </p:cNvPr>
@@ -13039,7 +13039,7 @@
           <p:cNvPr id="3" name="">
             <a:extLst xmlns:a="http://schemas.openxmlformats.org/drawingml/2006/main">
               <a:ext uri="{FF2B5EF4-FFF2-40B4-BE49-F238E27FC236}">
-                <a16:creationId xmlns:a16="http://schemas.microsoft.com/office/drawing/2014/main" id="{CA38C291-C92B-426D-B083-0A8B4B57CE0A}"/>
+                <a16:creationId xmlns:a16="http://schemas.microsoft.com/office/drawing/2014/main" id="{D9005546-3D28-45B0-96DB-7AE9E5718309}"/>
               </a:ext>
             </a:extLst>
           </p:cNvPr>
@@ -13179,7 +13179,7 @@
           <p:cNvPr id="4" name="">
             <a:extLst xmlns:a="http://schemas.openxmlformats.org/drawingml/2006/main">
               <a:ext uri="{FF2B5EF4-FFF2-40B4-BE49-F238E27FC236}">
-                <a16:creationId xmlns:a16="http://schemas.microsoft.com/office/drawing/2014/main" id="{5547503E-5A67-4E77-A803-CD0B84AE914B}"/>
+                <a16:creationId xmlns:a16="http://schemas.microsoft.com/office/drawing/2014/main" id="{92245420-C80C-46D1-A8C6-494A92A6A1C7}"/>
               </a:ext>
             </a:extLst>
           </p:cNvPr>
@@ -13335,7 +13335,7 @@
           <p:cNvPr id="5" name="">
             <a:extLst xmlns:a="http://schemas.openxmlformats.org/drawingml/2006/main">
               <a:ext uri="{FF2B5EF4-FFF2-40B4-BE49-F238E27FC236}">
-                <a16:creationId xmlns:a16="http://schemas.microsoft.com/office/drawing/2014/main" id="{2408D7CD-F174-4398-852F-A8CDAF29665C}"/>
+                <a16:creationId xmlns:a16="http://schemas.microsoft.com/office/drawing/2014/main" id="{2B003EE3-793B-4D17-AC9E-21CC6A3C1EAD}"/>
               </a:ext>
             </a:extLst>
           </p:cNvPr>
@@ -13573,7 +13573,7 @@
     </p:spTree>
     <p:extLst>
       <p:ext uri="{BB962C8B-B14F-4D97-AF65-F5344CB8AC3E}">
-        <p14:creationId xmlns:p14="http://schemas.microsoft.com/office/powerpoint/2010/main" val="34873054"/>
+        <p14:creationId xmlns:p14="http://schemas.microsoft.com/office/powerpoint/2010/main" val="1935251778"/>
       </p:ext>
     </p:extLst>
   </p:cSld>
@@ -13604,7 +13604,7 @@
           <p:cNvPr id="6" name="">
             <a:extLst xmlns:a="http://schemas.openxmlformats.org/drawingml/2006/main">
               <a:ext uri="{FF2B5EF4-FFF2-40B4-BE49-F238E27FC236}">
-                <a16:creationId xmlns:a16="http://schemas.microsoft.com/office/drawing/2014/main" id="{06B7A963-6AA3-43EA-9258-CDC02974FB01}"/>
+                <a16:creationId xmlns:a16="http://schemas.microsoft.com/office/drawing/2014/main" id="{DA519839-2C87-4183-B46C-E9014DD77BE2}"/>
               </a:ext>
             </a:extLst>
           </p:cNvPr>
@@ -13760,7 +13760,7 @@
           <p:cNvPr id="2" name="">
             <a:extLst xmlns:a="http://schemas.openxmlformats.org/drawingml/2006/main">
               <a:ext uri="{FF2B5EF4-FFF2-40B4-BE49-F238E27FC236}">
-                <a16:creationId xmlns:a16="http://schemas.microsoft.com/office/drawing/2014/main" id="{2DA549AF-88BB-473C-AFB8-E9C6FABAA166}"/>
+                <a16:creationId xmlns:a16="http://schemas.microsoft.com/office/drawing/2014/main" id="{0FC95166-DB39-4B13-8073-CFE573C566AE}"/>
               </a:ext>
             </a:extLst>
           </p:cNvPr>
@@ -13916,7 +13916,7 @@
           <p:cNvPr id="3" name="">
             <a:extLst xmlns:a="http://schemas.openxmlformats.org/drawingml/2006/main">
               <a:ext uri="{FF2B5EF4-FFF2-40B4-BE49-F238E27FC236}">
-                <a16:creationId xmlns:a16="http://schemas.microsoft.com/office/drawing/2014/main" id="{323B3BA8-A29B-4BA5-809C-1F3F16238A1A}"/>
+                <a16:creationId xmlns:a16="http://schemas.microsoft.com/office/drawing/2014/main" id="{53A9CDCD-7964-4496-87AC-B3C5E0EFE0B1}"/>
               </a:ext>
             </a:extLst>
           </p:cNvPr>
@@ -14056,7 +14056,7 @@
           <p:cNvPr id="4" name="">
             <a:extLst xmlns:a="http://schemas.openxmlformats.org/drawingml/2006/main">
               <a:ext uri="{FF2B5EF4-FFF2-40B4-BE49-F238E27FC236}">
-                <a16:creationId xmlns:a16="http://schemas.microsoft.com/office/drawing/2014/main" id="{73EEC915-C77C-48ED-B92C-26BDFF53D661}"/>
+                <a16:creationId xmlns:a16="http://schemas.microsoft.com/office/drawing/2014/main" id="{E32EBCA8-0FC9-40E4-9AB0-F5E15AD6BD5A}"/>
               </a:ext>
             </a:extLst>
           </p:cNvPr>
@@ -14212,7 +14212,7 @@
           <p:cNvPr id="5" name="">
             <a:extLst xmlns:a="http://schemas.openxmlformats.org/drawingml/2006/main">
               <a:ext uri="{FF2B5EF4-FFF2-40B4-BE49-F238E27FC236}">
-                <a16:creationId xmlns:a16="http://schemas.microsoft.com/office/drawing/2014/main" id="{9E1B415B-E69E-435A-9123-B8F9E04F1587}"/>
+                <a16:creationId xmlns:a16="http://schemas.microsoft.com/office/drawing/2014/main" id="{795F87F0-EBBE-417C-8975-7E67952AC4E4}"/>
               </a:ext>
             </a:extLst>
           </p:cNvPr>
@@ -14468,7 +14468,7 @@
     </p:spTree>
     <p:extLst>
       <p:ext uri="{BB962C8B-B14F-4D97-AF65-F5344CB8AC3E}">
-        <p14:creationId xmlns:p14="http://schemas.microsoft.com/office/powerpoint/2010/main" val="1149796289"/>
+        <p14:creationId xmlns:p14="http://schemas.microsoft.com/office/powerpoint/2010/main" val="1278933623"/>
       </p:ext>
     </p:extLst>
   </p:cSld>
@@ -14499,7 +14499,7 @@
           <p:cNvPr id="6" name="">
             <a:extLst xmlns:a="http://schemas.openxmlformats.org/drawingml/2006/main">
               <a:ext uri="{FF2B5EF4-FFF2-40B4-BE49-F238E27FC236}">
-                <a16:creationId xmlns:a16="http://schemas.microsoft.com/office/drawing/2014/main" id="{6E46C00A-19C9-4938-B2D5-861E88A6C3EA}"/>
+                <a16:creationId xmlns:a16="http://schemas.microsoft.com/office/drawing/2014/main" id="{A682A071-3DC5-45E1-8F20-8A3FC682E52E}"/>
               </a:ext>
             </a:extLst>
           </p:cNvPr>
@@ -14655,7 +14655,7 @@
           <p:cNvPr id="2" name="">
             <a:extLst xmlns:a="http://schemas.openxmlformats.org/drawingml/2006/main">
               <a:ext uri="{FF2B5EF4-FFF2-40B4-BE49-F238E27FC236}">
-                <a16:creationId xmlns:a16="http://schemas.microsoft.com/office/drawing/2014/main" id="{8011829F-238F-4468-87FF-F2BDD471D5D3}"/>
+                <a16:creationId xmlns:a16="http://schemas.microsoft.com/office/drawing/2014/main" id="{3051E998-ADAF-443B-9F22-0F762D417C12}"/>
               </a:ext>
             </a:extLst>
           </p:cNvPr>
@@ -14811,7 +14811,7 @@
           <p:cNvPr id="3" name="">
             <a:extLst xmlns:a="http://schemas.openxmlformats.org/drawingml/2006/main">
               <a:ext uri="{FF2B5EF4-FFF2-40B4-BE49-F238E27FC236}">
-                <a16:creationId xmlns:a16="http://schemas.microsoft.com/office/drawing/2014/main" id="{35D09CE5-E350-4D5F-9047-82D9FC645918}"/>
+                <a16:creationId xmlns:a16="http://schemas.microsoft.com/office/drawing/2014/main" id="{3DA916E6-43DF-4F49-A07D-885729A76543}"/>
               </a:ext>
             </a:extLst>
           </p:cNvPr>
@@ -14951,7 +14951,7 @@
           <p:cNvPr id="4" name="">
             <a:extLst xmlns:a="http://schemas.openxmlformats.org/drawingml/2006/main">
               <a:ext uri="{FF2B5EF4-FFF2-40B4-BE49-F238E27FC236}">
-                <a16:creationId xmlns:a16="http://schemas.microsoft.com/office/drawing/2014/main" id="{ACE9972D-9EE3-4811-9C9A-F41B3642F541}"/>
+                <a16:creationId xmlns:a16="http://schemas.microsoft.com/office/drawing/2014/main" id="{B391F92D-DBDA-4022-9A82-A4D8F1FCDE60}"/>
               </a:ext>
             </a:extLst>
           </p:cNvPr>
@@ -15107,7 +15107,7 @@
           <p:cNvPr id="5" name="">
             <a:extLst xmlns:a="http://schemas.openxmlformats.org/drawingml/2006/main">
               <a:ext uri="{FF2B5EF4-FFF2-40B4-BE49-F238E27FC236}">
-                <a16:creationId xmlns:a16="http://schemas.microsoft.com/office/drawing/2014/main" id="{0493243D-1BED-4083-BA70-7D1E0717378D}"/>
+                <a16:creationId xmlns:a16="http://schemas.microsoft.com/office/drawing/2014/main" id="{86FE0A76-8925-49B8-8CBF-C017E494F741}"/>
               </a:ext>
             </a:extLst>
           </p:cNvPr>
@@ -15345,7 +15345,7 @@
     </p:spTree>
     <p:extLst>
       <p:ext uri="{BB962C8B-B14F-4D97-AF65-F5344CB8AC3E}">
-        <p14:creationId xmlns:p14="http://schemas.microsoft.com/office/powerpoint/2010/main" val="1194099202"/>
+        <p14:creationId xmlns:p14="http://schemas.microsoft.com/office/powerpoint/2010/main" val="1477717198"/>
       </p:ext>
     </p:extLst>
   </p:cSld>
@@ -15376,7 +15376,7 @@
           <p:cNvPr id="7" name="">
             <a:extLst xmlns:a="http://schemas.openxmlformats.org/drawingml/2006/main">
               <a:ext uri="{FF2B5EF4-FFF2-40B4-BE49-F238E27FC236}">
-                <a16:creationId xmlns:a16="http://schemas.microsoft.com/office/drawing/2014/main" id="{B3D5C326-3F8D-45A2-8497-8F890F1C8E06}"/>
+                <a16:creationId xmlns:a16="http://schemas.microsoft.com/office/drawing/2014/main" id="{7440CFB6-381C-4495-BB46-BC495E92F9C7}"/>
               </a:ext>
             </a:extLst>
           </p:cNvPr>
@@ -15532,7 +15532,7 @@
           <p:cNvPr id="2" name="">
             <a:extLst xmlns:a="http://schemas.openxmlformats.org/drawingml/2006/main">
               <a:ext uri="{FF2B5EF4-FFF2-40B4-BE49-F238E27FC236}">
-                <a16:creationId xmlns:a16="http://schemas.microsoft.com/office/drawing/2014/main" id="{828D7A0D-D593-40BC-B0C1-9CF80F32F97E}"/>
+                <a16:creationId xmlns:a16="http://schemas.microsoft.com/office/drawing/2014/main" id="{9A014973-A88A-44BF-9E26-92890602A799}"/>
               </a:ext>
             </a:extLst>
           </p:cNvPr>
@@ -15688,7 +15688,7 @@
           <p:cNvPr id="3" name="">
             <a:extLst xmlns:a="http://schemas.openxmlformats.org/drawingml/2006/main">
               <a:ext uri="{FF2B5EF4-FFF2-40B4-BE49-F238E27FC236}">
-                <a16:creationId xmlns:a16="http://schemas.microsoft.com/office/drawing/2014/main" id="{E2CEF18F-28F4-4696-B995-A5F88D48F172}"/>
+                <a16:creationId xmlns:a16="http://schemas.microsoft.com/office/drawing/2014/main" id="{57F25C8F-6867-4566-8B11-F6CBDE8CAE72}"/>
               </a:ext>
             </a:extLst>
           </p:cNvPr>
@@ -15828,7 +15828,7 @@
           <p:cNvPr id="4" name="">
             <a:extLst xmlns:a="http://schemas.openxmlformats.org/drawingml/2006/main">
               <a:ext uri="{FF2B5EF4-FFF2-40B4-BE49-F238E27FC236}">
-                <a16:creationId xmlns:a16="http://schemas.microsoft.com/office/drawing/2014/main" id="{F0C70473-759B-40ED-9CC2-2B5E3784A896}"/>
+                <a16:creationId xmlns:a16="http://schemas.microsoft.com/office/drawing/2014/main" id="{0539BFAA-A1BA-432C-87F0-8E7F8E082A33}"/>
               </a:ext>
             </a:extLst>
           </p:cNvPr>
@@ -15984,7 +15984,7 @@
           <p:cNvPr id="5" name="">
             <a:extLst xmlns:a="http://schemas.openxmlformats.org/drawingml/2006/main">
               <a:ext uri="{FF2B5EF4-FFF2-40B4-BE49-F238E27FC236}">
-                <a16:creationId xmlns:a16="http://schemas.microsoft.com/office/drawing/2014/main" id="{54A7BA4C-DFEC-4D5D-ACA7-95BAD69DB754}"/>
+                <a16:creationId xmlns:a16="http://schemas.microsoft.com/office/drawing/2014/main" id="{35656D08-3AAA-48CF-919A-D1F738D0322E}"/>
               </a:ext>
             </a:extLst>
           </p:cNvPr>
@@ -15994,7 +15994,7 @@
           <p:nvPr/>
         </p:nvPicPr>
         <p:blipFill>
-          <a:blip xmlns:r="http://schemas.openxmlformats.org/officeDocument/2006/relationships" xmlns:a="http://schemas.openxmlformats.org/drawingml/2006/main" r:embed="R84726f66787e4145"/>
+          <a:blip xmlns:r="http://schemas.openxmlformats.org/officeDocument/2006/relationships" xmlns:a="http://schemas.openxmlformats.org/drawingml/2006/main" r:embed="Rcabb0e4ee24c47bc"/>
           <a:stretch xmlns:a="http://schemas.openxmlformats.org/drawingml/2006/main"/>
         </p:blipFill>
         <p:spPr>
@@ -16012,7 +16012,7 @@
           <p:cNvPr id="6" name="">
             <a:extLst xmlns:a="http://schemas.openxmlformats.org/drawingml/2006/main">
               <a:ext uri="{FF2B5EF4-FFF2-40B4-BE49-F238E27FC236}">
-                <a16:creationId xmlns:a16="http://schemas.microsoft.com/office/drawing/2014/main" id="{EFC71EEA-34C6-406F-8282-A545154A9A93}"/>
+                <a16:creationId xmlns:a16="http://schemas.microsoft.com/office/drawing/2014/main" id="{1423B247-FF4B-45EE-87F7-193D506C3B48}"/>
               </a:ext>
             </a:extLst>
           </p:cNvPr>
@@ -16166,7 +16166,7 @@
     </p:spTree>
     <p:extLst>
       <p:ext uri="{BB962C8B-B14F-4D97-AF65-F5344CB8AC3E}">
-        <p14:creationId xmlns:p14="http://schemas.microsoft.com/office/powerpoint/2010/main" val="913267307"/>
+        <p14:creationId xmlns:p14="http://schemas.microsoft.com/office/powerpoint/2010/main" val="1665745646"/>
       </p:ext>
     </p:extLst>
   </p:cSld>
@@ -16197,7 +16197,7 @@
           <p:cNvPr id="7" name="">
             <a:extLst xmlns:a="http://schemas.openxmlformats.org/drawingml/2006/main">
               <a:ext uri="{FF2B5EF4-FFF2-40B4-BE49-F238E27FC236}">
-                <a16:creationId xmlns:a16="http://schemas.microsoft.com/office/drawing/2014/main" id="{B310B770-E9AB-48C8-8A56-0279704E9FE3}"/>
+                <a16:creationId xmlns:a16="http://schemas.microsoft.com/office/drawing/2014/main" id="{4E69140C-BB55-4EDA-92ED-53949BF758F7}"/>
               </a:ext>
             </a:extLst>
           </p:cNvPr>
@@ -16353,7 +16353,7 @@
           <p:cNvPr id="2" name="">
             <a:extLst xmlns:a="http://schemas.openxmlformats.org/drawingml/2006/main">
               <a:ext uri="{FF2B5EF4-FFF2-40B4-BE49-F238E27FC236}">
-                <a16:creationId xmlns:a16="http://schemas.microsoft.com/office/drawing/2014/main" id="{B99E9212-F077-4B2D-9616-3DF502BB1634}"/>
+                <a16:creationId xmlns:a16="http://schemas.microsoft.com/office/drawing/2014/main" id="{3BE8B98C-98AA-4A30-916A-B2CB39385F9D}"/>
               </a:ext>
             </a:extLst>
           </p:cNvPr>
@@ -16509,7 +16509,7 @@
           <p:cNvPr id="3" name="">
             <a:extLst xmlns:a="http://schemas.openxmlformats.org/drawingml/2006/main">
               <a:ext uri="{FF2B5EF4-FFF2-40B4-BE49-F238E27FC236}">
-                <a16:creationId xmlns:a16="http://schemas.microsoft.com/office/drawing/2014/main" id="{EE9F8380-6938-4E30-BEBC-B5937F3CAD7E}"/>
+                <a16:creationId xmlns:a16="http://schemas.microsoft.com/office/drawing/2014/main" id="{81A1EF2C-49E1-4318-A608-70D690A82169}"/>
               </a:ext>
             </a:extLst>
           </p:cNvPr>
@@ -16649,7 +16649,7 @@
           <p:cNvPr id="4" name="">
             <a:extLst xmlns:a="http://schemas.openxmlformats.org/drawingml/2006/main">
               <a:ext uri="{FF2B5EF4-FFF2-40B4-BE49-F238E27FC236}">
-                <a16:creationId xmlns:a16="http://schemas.microsoft.com/office/drawing/2014/main" id="{65620F2A-DADA-4AF0-9DB4-E1159ADC4F11}"/>
+                <a16:creationId xmlns:a16="http://schemas.microsoft.com/office/drawing/2014/main" id="{A5885DCC-F3D6-4A2F-9199-067FCE5F52D8}"/>
               </a:ext>
             </a:extLst>
           </p:cNvPr>
@@ -16805,7 +16805,7 @@
           <p:cNvPr id="5" name="">
             <a:extLst xmlns:a="http://schemas.openxmlformats.org/drawingml/2006/main">
               <a:ext uri="{FF2B5EF4-FFF2-40B4-BE49-F238E27FC236}">
-                <a16:creationId xmlns:a16="http://schemas.microsoft.com/office/drawing/2014/main" id="{6EA825B6-2FDA-49FC-B420-54946F19AC9D}"/>
+                <a16:creationId xmlns:a16="http://schemas.microsoft.com/office/drawing/2014/main" id="{7010217F-CFF5-4091-845F-A50F99EB5737}"/>
               </a:ext>
             </a:extLst>
           </p:cNvPr>
@@ -16815,7 +16815,7 @@
           <p:nvPr/>
         </p:nvPicPr>
         <p:blipFill>
-          <a:blip xmlns:r="http://schemas.openxmlformats.org/officeDocument/2006/relationships" xmlns:a="http://schemas.openxmlformats.org/drawingml/2006/main" r:embed="R7759df24b20e474f"/>
+          <a:blip xmlns:r="http://schemas.openxmlformats.org/officeDocument/2006/relationships" xmlns:a="http://schemas.openxmlformats.org/drawingml/2006/main" r:embed="Raa6c71087cd24716"/>
           <a:stretch xmlns:a="http://schemas.openxmlformats.org/drawingml/2006/main"/>
         </p:blipFill>
         <p:spPr>
@@ -16833,7 +16833,7 @@
           <p:cNvPr id="6" name="">
             <a:extLst xmlns:a="http://schemas.openxmlformats.org/drawingml/2006/main">
               <a:ext uri="{FF2B5EF4-FFF2-40B4-BE49-F238E27FC236}">
-                <a16:creationId xmlns:a16="http://schemas.microsoft.com/office/drawing/2014/main" id="{A03CDDEA-A8AE-4FB9-86AA-3BF883C2D956}"/>
+                <a16:creationId xmlns:a16="http://schemas.microsoft.com/office/drawing/2014/main" id="{FC10209F-54FF-45BA-BFDC-5501ECEB203E}"/>
               </a:ext>
             </a:extLst>
           </p:cNvPr>
@@ -16987,7 +16987,7 @@
     </p:spTree>
     <p:extLst>
       <p:ext uri="{BB962C8B-B14F-4D97-AF65-F5344CB8AC3E}">
-        <p14:creationId xmlns:p14="http://schemas.microsoft.com/office/powerpoint/2010/main" val="849550471"/>
+        <p14:creationId xmlns:p14="http://schemas.microsoft.com/office/powerpoint/2010/main" val="285159511"/>
       </p:ext>
     </p:extLst>
   </p:cSld>
@@ -17018,7 +17018,7 @@
           <p:cNvPr id="7" name="">
             <a:extLst xmlns:a="http://schemas.openxmlformats.org/drawingml/2006/main">
               <a:ext uri="{FF2B5EF4-FFF2-40B4-BE49-F238E27FC236}">
-                <a16:creationId xmlns:a16="http://schemas.microsoft.com/office/drawing/2014/main" id="{39F6D3F8-F1D0-4AFD-86D7-81F94493FF77}"/>
+                <a16:creationId xmlns:a16="http://schemas.microsoft.com/office/drawing/2014/main" id="{A7F0E652-7572-4E07-A698-ED165BE7CF5A}"/>
               </a:ext>
             </a:extLst>
           </p:cNvPr>
@@ -17174,7 +17174,7 @@
           <p:cNvPr id="2" name="">
             <a:extLst xmlns:a="http://schemas.openxmlformats.org/drawingml/2006/main">
               <a:ext uri="{FF2B5EF4-FFF2-40B4-BE49-F238E27FC236}">
-                <a16:creationId xmlns:a16="http://schemas.microsoft.com/office/drawing/2014/main" id="{EC258688-EC61-4486-8EB8-B15714297F31}"/>
+                <a16:creationId xmlns:a16="http://schemas.microsoft.com/office/drawing/2014/main" id="{372B8ECC-B415-4CC0-B987-FC70F772590D}"/>
               </a:ext>
             </a:extLst>
           </p:cNvPr>
@@ -17330,7 +17330,7 @@
           <p:cNvPr id="3" name="">
             <a:extLst xmlns:a="http://schemas.openxmlformats.org/drawingml/2006/main">
               <a:ext uri="{FF2B5EF4-FFF2-40B4-BE49-F238E27FC236}">
-                <a16:creationId xmlns:a16="http://schemas.microsoft.com/office/drawing/2014/main" id="{1286492C-C582-4F6F-A119-28538FD0EE26}"/>
+                <a16:creationId xmlns:a16="http://schemas.microsoft.com/office/drawing/2014/main" id="{4A128A03-56D5-4855-BE9E-B71F99670131}"/>
               </a:ext>
             </a:extLst>
           </p:cNvPr>
@@ -17470,7 +17470,7 @@
           <p:cNvPr id="4" name="">
             <a:extLst xmlns:a="http://schemas.openxmlformats.org/drawingml/2006/main">
               <a:ext uri="{FF2B5EF4-FFF2-40B4-BE49-F238E27FC236}">
-                <a16:creationId xmlns:a16="http://schemas.microsoft.com/office/drawing/2014/main" id="{9D34C7E2-A0DE-4F73-8B90-128EB2015419}"/>
+                <a16:creationId xmlns:a16="http://schemas.microsoft.com/office/drawing/2014/main" id="{27C9BD08-FFC0-428C-9B8A-BC27FB7448F0}"/>
               </a:ext>
             </a:extLst>
           </p:cNvPr>
@@ -17626,7 +17626,7 @@
           <p:cNvPr id="5" name="">
             <a:extLst xmlns:a="http://schemas.openxmlformats.org/drawingml/2006/main">
               <a:ext uri="{FF2B5EF4-FFF2-40B4-BE49-F238E27FC236}">
-                <a16:creationId xmlns:a16="http://schemas.microsoft.com/office/drawing/2014/main" id="{1E09E438-51EB-4802-9B4E-BF33E2D38A80}"/>
+                <a16:creationId xmlns:a16="http://schemas.microsoft.com/office/drawing/2014/main" id="{700B95B2-C12B-43B0-9662-066DB60F4D44}"/>
               </a:ext>
             </a:extLst>
           </p:cNvPr>
@@ -18485,7 +18485,7 @@
           <p:cNvPr id="6" name="">
             <a:extLst xmlns:a="http://schemas.openxmlformats.org/drawingml/2006/main">
               <a:ext uri="{FF2B5EF4-FFF2-40B4-BE49-F238E27FC236}">
-                <a16:creationId xmlns:a16="http://schemas.microsoft.com/office/drawing/2014/main" id="{F32D2FBB-9426-456C-B1AB-1B52F8FBD2E9}"/>
+                <a16:creationId xmlns:a16="http://schemas.microsoft.com/office/drawing/2014/main" id="{E81DEE94-8658-4D01-8F7A-40F33373329C}"/>
               </a:ext>
             </a:extLst>
           </p:cNvPr>
@@ -18639,7 +18639,7 @@
     </p:spTree>
     <p:extLst>
       <p:ext uri="{BB962C8B-B14F-4D97-AF65-F5344CB8AC3E}">
-        <p14:creationId xmlns:p14="http://schemas.microsoft.com/office/powerpoint/2010/main" val="1097702538"/>
+        <p14:creationId xmlns:p14="http://schemas.microsoft.com/office/powerpoint/2010/main" val="1548061023"/>
       </p:ext>
     </p:extLst>
   </p:cSld>

</xml_diff>

<commit_message>
Preserve RSS-selected TC candidates and disclose target footprint mismatch
</commit_message>
<xml_diff>
--- a/presentation/CSLab_Memory_Tiering_Current.pptx
+++ b/presentation/CSLab_Memory_Tiering_Current.pptx
@@ -2,27 +2,27 @@
 <file path=ppt/presentation.xml><?xml version="1.0" encoding="utf-8"?>
 <p:presentation xmlns:p="http://schemas.openxmlformats.org/presentationml/2006/main">
   <p:sldMasterIdLst>
-    <p:sldMasterId xmlns:r="http://schemas.openxmlformats.org/officeDocument/2006/relationships" id="2147483648" r:id="R4f1ad751d2b04494"/>
+    <p:sldMasterId xmlns:r="http://schemas.openxmlformats.org/officeDocument/2006/relationships" id="2147483648" r:id="R78a29d282df84a2d"/>
   </p:sldMasterIdLst>
   <p:notesMasterIdLst>
-    <p:notesMasterId xmlns:r="http://schemas.openxmlformats.org/officeDocument/2006/relationships" r:id="Rdac69977fb5748f5"/>
+    <p:notesMasterId xmlns:r="http://schemas.openxmlformats.org/officeDocument/2006/relationships" r:id="Rc9a74fb3c1d6478c"/>
   </p:notesMasterIdLst>
   <p:sldIdLst>
-    <p:sldId xmlns:r="http://schemas.openxmlformats.org/officeDocument/2006/relationships" id="256" r:id="R6db70253e1424e41"/>
-    <p:sldId xmlns:r="http://schemas.openxmlformats.org/officeDocument/2006/relationships" id="257" r:id="R5ac0d56ca19c4d93"/>
-    <p:sldId xmlns:r="http://schemas.openxmlformats.org/officeDocument/2006/relationships" id="258" r:id="R4a9ff6096b2e46c7"/>
-    <p:sldId xmlns:r="http://schemas.openxmlformats.org/officeDocument/2006/relationships" id="259" r:id="R984e69386650498e"/>
-    <p:sldId xmlns:r="http://schemas.openxmlformats.org/officeDocument/2006/relationships" id="260" r:id="Rd6f1012dbd5f4417"/>
-    <p:sldId xmlns:r="http://schemas.openxmlformats.org/officeDocument/2006/relationships" id="261" r:id="R7531b3899b004718"/>
-    <p:sldId xmlns:r="http://schemas.openxmlformats.org/officeDocument/2006/relationships" id="262" r:id="R11280f12a85c453a"/>
-    <p:sldId xmlns:r="http://schemas.openxmlformats.org/officeDocument/2006/relationships" id="263" r:id="R289510d96b814b2d"/>
-    <p:sldId xmlns:r="http://schemas.openxmlformats.org/officeDocument/2006/relationships" id="264" r:id="R7a554075a7ad4df8"/>
-    <p:sldId xmlns:r="http://schemas.openxmlformats.org/officeDocument/2006/relationships" id="265" r:id="Radf64c86c4b04d5d"/>
-    <p:sldId xmlns:r="http://schemas.openxmlformats.org/officeDocument/2006/relationships" id="266" r:id="R8ceaa216f1244f6d"/>
-    <p:sldId xmlns:r="http://schemas.openxmlformats.org/officeDocument/2006/relationships" id="267" r:id="Rb66ed1a87887450b"/>
-    <p:sldId xmlns:r="http://schemas.openxmlformats.org/officeDocument/2006/relationships" id="268" r:id="R7b2573e031564a3b"/>
-    <p:sldId xmlns:r="http://schemas.openxmlformats.org/officeDocument/2006/relationships" id="269" r:id="R908bba270eb94cd6"/>
-    <p:sldId xmlns:r="http://schemas.openxmlformats.org/officeDocument/2006/relationships" id="270" r:id="R836e6f97427a482e"/>
+    <p:sldId xmlns:r="http://schemas.openxmlformats.org/officeDocument/2006/relationships" id="256" r:id="R5db86bebbf7842b6"/>
+    <p:sldId xmlns:r="http://schemas.openxmlformats.org/officeDocument/2006/relationships" id="257" r:id="R0f2e763440c64a59"/>
+    <p:sldId xmlns:r="http://schemas.openxmlformats.org/officeDocument/2006/relationships" id="258" r:id="R712da693642b432f"/>
+    <p:sldId xmlns:r="http://schemas.openxmlformats.org/officeDocument/2006/relationships" id="259" r:id="R370516eb26ad4fc0"/>
+    <p:sldId xmlns:r="http://schemas.openxmlformats.org/officeDocument/2006/relationships" id="260" r:id="R23e0ba582f614b8a"/>
+    <p:sldId xmlns:r="http://schemas.openxmlformats.org/officeDocument/2006/relationships" id="261" r:id="R2f1ef70554214e56"/>
+    <p:sldId xmlns:r="http://schemas.openxmlformats.org/officeDocument/2006/relationships" id="262" r:id="Rdf80b18cf5984c46"/>
+    <p:sldId xmlns:r="http://schemas.openxmlformats.org/officeDocument/2006/relationships" id="263" r:id="R853a8fb8cc104cc5"/>
+    <p:sldId xmlns:r="http://schemas.openxmlformats.org/officeDocument/2006/relationships" id="264" r:id="Rdf06ab986ac14aad"/>
+    <p:sldId xmlns:r="http://schemas.openxmlformats.org/officeDocument/2006/relationships" id="265" r:id="R2bc719452bb241c2"/>
+    <p:sldId xmlns:r="http://schemas.openxmlformats.org/officeDocument/2006/relationships" id="266" r:id="Rcaeab6ceadf842d9"/>
+    <p:sldId xmlns:r="http://schemas.openxmlformats.org/officeDocument/2006/relationships" id="267" r:id="R5f9cd2e99c644df2"/>
+    <p:sldId xmlns:r="http://schemas.openxmlformats.org/officeDocument/2006/relationships" id="268" r:id="Rc80ee385e7ba4a9d"/>
+    <p:sldId xmlns:r="http://schemas.openxmlformats.org/officeDocument/2006/relationships" id="269" r:id="R13fbcfd9d9d74162"/>
+    <p:sldId xmlns:r="http://schemas.openxmlformats.org/officeDocument/2006/relationships" id="270" r:id="R86aa25bbc8aa4a48"/>
   </p:sldIdLst>
   <p:sldSz cx="12192000" cy="6858000"/>
   <p:notesSz cx="6858000" cy="9144000"/>
@@ -627,6 +627,16 @@
           <a:p xmlns:a="http://schemas.openxmlformats.org/drawingml/2006/main">
             <a:r>
               <a:t>Πηγές: docs/pin-stage2-protocol.md</a:t>
+            </a:r>
+          </a:p>
+          <a:p xmlns:a="http://schemas.openxmlformats.org/drawingml/2006/main">
+            <a:r>
+              <a:t/>
+            </a:r>
+          </a:p>
+          <a:p xmlns:a="http://schemas.openxmlformats.org/drawingml/2006/main">
+            <a:r>
+              <a:t>TC native RSS: 8.89 GB, στόχος 5.0 GB. Εντός ανοχής: false. Η επιλογή έγινε μόνο με RSS. Δεν το παρουσιάζουμε ως size-matched reproduction.</a:t>
             </a:r>
           </a:p>
         </p:txBody>
@@ -1633,7 +1643,7 @@
           <p:cNvPr id="3" name="Title">
             <a:extLst xmlns:a="http://schemas.openxmlformats.org/drawingml/2006/main">
               <a:ext uri="{FF2B5EF4-FFF2-40B4-BE49-F238E27FC236}">
-                <a16:creationId xmlns:a16="http://schemas.microsoft.com/office/drawing/2014/main" id="{3ED9AFBA-3032-4C3B-9B9A-77437D9C9F12}"/>
+                <a16:creationId xmlns:a16="http://schemas.microsoft.com/office/drawing/2014/main" id="{E6DB9BE8-5AA2-4307-8C6B-60419652A335}"/>
               </a:ext>
             </a:extLst>
           </p:cNvPr>
@@ -1862,7 +1872,7 @@
           <p:cNvPr id="2" name="Subtitle">
             <a:extLst xmlns:a="http://schemas.openxmlformats.org/drawingml/2006/main">
               <a:ext uri="{FF2B5EF4-FFF2-40B4-BE49-F238E27FC236}">
-                <a16:creationId xmlns:a16="http://schemas.microsoft.com/office/drawing/2014/main" id="{AFDE049C-2D21-4477-8F90-881596062967}"/>
+                <a16:creationId xmlns:a16="http://schemas.microsoft.com/office/drawing/2014/main" id="{F0B9A332-4DC2-4D02-AAE5-1D1062E365BF}"/>
               </a:ext>
             </a:extLst>
           </p:cNvPr>
@@ -2108,7 +2118,7 @@
           <p:cNvPr id="2" name="Section title">
             <a:extLst xmlns:a="http://schemas.openxmlformats.org/drawingml/2006/main">
               <a:ext uri="{FF2B5EF4-FFF2-40B4-BE49-F238E27FC236}">
-                <a16:creationId xmlns:a16="http://schemas.microsoft.com/office/drawing/2014/main" id="{55269F5C-14F4-48F0-9755-A7C458771E12}"/>
+                <a16:creationId xmlns:a16="http://schemas.microsoft.com/office/drawing/2014/main" id="{E8C5978A-6634-497D-A06A-18FBE95B432F}"/>
               </a:ext>
             </a:extLst>
           </p:cNvPr>
@@ -2354,7 +2364,7 @@
           <p:cNvPr id="3" name="Title">
             <a:extLst xmlns:a="http://schemas.openxmlformats.org/drawingml/2006/main">
               <a:ext uri="{FF2B5EF4-FFF2-40B4-BE49-F238E27FC236}">
-                <a16:creationId xmlns:a16="http://schemas.microsoft.com/office/drawing/2014/main" id="{8230BAC6-C2CB-4ABE-8D1F-C70727A2F078}"/>
+                <a16:creationId xmlns:a16="http://schemas.microsoft.com/office/drawing/2014/main" id="{5E2BA4CD-F286-4313-AC63-4B691B58788E}"/>
               </a:ext>
             </a:extLst>
           </p:cNvPr>
@@ -2583,7 +2593,7 @@
           <p:cNvPr id="2" name="Body">
             <a:extLst xmlns:a="http://schemas.openxmlformats.org/drawingml/2006/main">
               <a:ext uri="{FF2B5EF4-FFF2-40B4-BE49-F238E27FC236}">
-                <a16:creationId xmlns:a16="http://schemas.microsoft.com/office/drawing/2014/main" id="{7187C114-08F5-42EB-8849-5D18026251E8}"/>
+                <a16:creationId xmlns:a16="http://schemas.microsoft.com/office/drawing/2014/main" id="{E8FED702-825B-42EE-9061-69E6AA0DD5BF}"/>
               </a:ext>
             </a:extLst>
           </p:cNvPr>
@@ -2829,7 +2839,7 @@
           <p:cNvPr id="4" name="Title">
             <a:extLst xmlns:a="http://schemas.openxmlformats.org/drawingml/2006/main">
               <a:ext uri="{FF2B5EF4-FFF2-40B4-BE49-F238E27FC236}">
-                <a16:creationId xmlns:a16="http://schemas.microsoft.com/office/drawing/2014/main" id="{F33E2D3E-CB9E-4040-ACE2-ED23A1B3175D}"/>
+                <a16:creationId xmlns:a16="http://schemas.microsoft.com/office/drawing/2014/main" id="{5F15559D-8A26-43D2-9704-F0F7D9CCAB0F}"/>
               </a:ext>
             </a:extLst>
           </p:cNvPr>
@@ -3058,7 +3068,7 @@
           <p:cNvPr id="2" name="Left column">
             <a:extLst xmlns:a="http://schemas.openxmlformats.org/drawingml/2006/main">
               <a:ext uri="{FF2B5EF4-FFF2-40B4-BE49-F238E27FC236}">
-                <a16:creationId xmlns:a16="http://schemas.microsoft.com/office/drawing/2014/main" id="{D27A3C77-2013-4C0B-ADA6-EBBB037252C3}"/>
+                <a16:creationId xmlns:a16="http://schemas.microsoft.com/office/drawing/2014/main" id="{5F375E2C-CAD2-41CD-8C6A-E641CD400420}"/>
               </a:ext>
             </a:extLst>
           </p:cNvPr>
@@ -3287,7 +3297,7 @@
           <p:cNvPr id="3" name="Right column">
             <a:extLst xmlns:a="http://schemas.openxmlformats.org/drawingml/2006/main">
               <a:ext uri="{FF2B5EF4-FFF2-40B4-BE49-F238E27FC236}">
-                <a16:creationId xmlns:a16="http://schemas.microsoft.com/office/drawing/2014/main" id="{85178862-C97D-435B-BCA6-96A00FA6339C}"/>
+                <a16:creationId xmlns:a16="http://schemas.microsoft.com/office/drawing/2014/main" id="{C1FDF0D4-21D9-4665-AB4E-45E39F405160}"/>
               </a:ext>
             </a:extLst>
           </p:cNvPr>
@@ -3533,7 +3543,7 @@
           <p:cNvPr id="3" name="Title">
             <a:extLst xmlns:a="http://schemas.openxmlformats.org/drawingml/2006/main">
               <a:ext uri="{FF2B5EF4-FFF2-40B4-BE49-F238E27FC236}">
-                <a16:creationId xmlns:a16="http://schemas.microsoft.com/office/drawing/2014/main" id="{458C921F-E065-4767-B1DC-2B4ECDADF0A3}"/>
+                <a16:creationId xmlns:a16="http://schemas.microsoft.com/office/drawing/2014/main" id="{E2CEAD79-A362-40EF-AE0D-C408CBE6D4BC}"/>
               </a:ext>
             </a:extLst>
           </p:cNvPr>
@@ -3762,7 +3772,7 @@
           <p:cNvPr id="2" name="Left column">
             <a:extLst xmlns:a="http://schemas.openxmlformats.org/drawingml/2006/main">
               <a:ext uri="{FF2B5EF4-FFF2-40B4-BE49-F238E27FC236}">
-                <a16:creationId xmlns:a16="http://schemas.microsoft.com/office/drawing/2014/main" id="{4E71476E-A351-46CD-A829-52A9FE07D00C}"/>
+                <a16:creationId xmlns:a16="http://schemas.microsoft.com/office/drawing/2014/main" id="{B4DB354F-3639-4516-AE97-C8293A7DD219}"/>
               </a:ext>
             </a:extLst>
           </p:cNvPr>
@@ -4029,12 +4039,12 @@
   </p:cSld>
   <p:clrMap bg1="lt1" tx1="dk1" bg2="lt2" tx2="dk2" accent1="accent1" accent2="accent2" accent3="accent3" accent4="accent4" accent5="accent5" accent6="accent6" hlink="hlink" folHlink="folHlink"/>
   <p:sldLayoutIdLst>
-    <p:sldLayoutId xmlns:r="http://schemas.openxmlformats.org/officeDocument/2006/relationships" id="2147483649" r:id="Ra011dcee3e0544b7"/>
-    <p:sldLayoutId xmlns:r="http://schemas.openxmlformats.org/officeDocument/2006/relationships" id="2147483650" r:id="Ra780604ead9f415c"/>
-    <p:sldLayoutId xmlns:r="http://schemas.openxmlformats.org/officeDocument/2006/relationships" id="2147483651" r:id="R7563659d246e4f6e"/>
-    <p:sldLayoutId xmlns:r="http://schemas.openxmlformats.org/officeDocument/2006/relationships" id="2147483652" r:id="Rcd0c2036cb004e54"/>
-    <p:sldLayoutId xmlns:r="http://schemas.openxmlformats.org/officeDocument/2006/relationships" id="2147483653" r:id="R9f518913c849444a"/>
-    <p:sldLayoutId xmlns:r="http://schemas.openxmlformats.org/officeDocument/2006/relationships" id="2147483654" r:id="R69448717db5b4859"/>
+    <p:sldLayoutId xmlns:r="http://schemas.openxmlformats.org/officeDocument/2006/relationships" id="2147483649" r:id="Rd6a74743f95047ba"/>
+    <p:sldLayoutId xmlns:r="http://schemas.openxmlformats.org/officeDocument/2006/relationships" id="2147483650" r:id="R36b651d0f8ae4afb"/>
+    <p:sldLayoutId xmlns:r="http://schemas.openxmlformats.org/officeDocument/2006/relationships" id="2147483651" r:id="R819a71b8e1d647cb"/>
+    <p:sldLayoutId xmlns:r="http://schemas.openxmlformats.org/officeDocument/2006/relationships" id="2147483652" r:id="R4e2e38be593b4cf1"/>
+    <p:sldLayoutId xmlns:r="http://schemas.openxmlformats.org/officeDocument/2006/relationships" id="2147483653" r:id="R44f33a452a064e40"/>
+    <p:sldLayoutId xmlns:r="http://schemas.openxmlformats.org/officeDocument/2006/relationships" id="2147483654" r:id="Rb8f7227aa2994341"/>
   </p:sldLayoutIdLst>
   <p:txStyles>
     <p:titleStyle>
@@ -4585,7 +4595,7 @@
           <p:cNvPr id="7" name="">
             <a:extLst xmlns:a="http://schemas.openxmlformats.org/drawingml/2006/main">
               <a:ext uri="{FF2B5EF4-FFF2-40B4-BE49-F238E27FC236}">
-                <a16:creationId xmlns:a16="http://schemas.microsoft.com/office/drawing/2014/main" id="{43F459D3-AEEB-4F7C-B5BC-4A613BCA38B4}"/>
+                <a16:creationId xmlns:a16="http://schemas.microsoft.com/office/drawing/2014/main" id="{C3B0485D-84C5-4871-A501-4E69196162F7}"/>
               </a:ext>
             </a:extLst>
           </p:cNvPr>
@@ -4741,7 +4751,7 @@
           <p:cNvPr id="2" name="">
             <a:extLst xmlns:a="http://schemas.openxmlformats.org/drawingml/2006/main">
               <a:ext uri="{FF2B5EF4-FFF2-40B4-BE49-F238E27FC236}">
-                <a16:creationId xmlns:a16="http://schemas.microsoft.com/office/drawing/2014/main" id="{13903F9D-B1B9-49B9-AD30-C1E3A39DE5C3}"/>
+                <a16:creationId xmlns:a16="http://schemas.microsoft.com/office/drawing/2014/main" id="{F3CB5CA5-6E05-49F5-92C8-54FF7EE33CE4}"/>
               </a:ext>
             </a:extLst>
           </p:cNvPr>
@@ -4897,7 +4907,7 @@
           <p:cNvPr id="3" name="">
             <a:extLst xmlns:a="http://schemas.openxmlformats.org/drawingml/2006/main">
               <a:ext uri="{FF2B5EF4-FFF2-40B4-BE49-F238E27FC236}">
-                <a16:creationId xmlns:a16="http://schemas.microsoft.com/office/drawing/2014/main" id="{44EB9DA4-488D-42E2-B3BE-892C18C01D01}"/>
+                <a16:creationId xmlns:a16="http://schemas.microsoft.com/office/drawing/2014/main" id="{E1C53644-D8E0-42D1-ABC1-03AD0CF9ED59}"/>
               </a:ext>
             </a:extLst>
           </p:cNvPr>
@@ -5037,7 +5047,7 @@
           <p:cNvPr id="4" name="">
             <a:extLst xmlns:a="http://schemas.openxmlformats.org/drawingml/2006/main">
               <a:ext uri="{FF2B5EF4-FFF2-40B4-BE49-F238E27FC236}">
-                <a16:creationId xmlns:a16="http://schemas.microsoft.com/office/drawing/2014/main" id="{87855A04-1088-43E2-8F5E-82406DEB5377}"/>
+                <a16:creationId xmlns:a16="http://schemas.microsoft.com/office/drawing/2014/main" id="{3ADF1852-89A0-4E00-A46A-15D3C9FBB5F7}"/>
               </a:ext>
             </a:extLst>
           </p:cNvPr>
@@ -5193,7 +5203,7 @@
           <p:cNvPr id="5" name="">
             <a:extLst xmlns:a="http://schemas.openxmlformats.org/drawingml/2006/main">
               <a:ext uri="{FF2B5EF4-FFF2-40B4-BE49-F238E27FC236}">
-                <a16:creationId xmlns:a16="http://schemas.microsoft.com/office/drawing/2014/main" id="{9C4CF11A-6D79-442D-B7D6-628AE62A1488}"/>
+                <a16:creationId xmlns:a16="http://schemas.microsoft.com/office/drawing/2014/main" id="{AECC2BA1-7D68-4DF8-BD18-826B2DCB6DFF}"/>
               </a:ext>
             </a:extLst>
           </p:cNvPr>
@@ -5349,7 +5359,7 @@
           <p:cNvPr id="6" name="">
             <a:extLst xmlns:a="http://schemas.openxmlformats.org/drawingml/2006/main">
               <a:ext uri="{FF2B5EF4-FFF2-40B4-BE49-F238E27FC236}">
-                <a16:creationId xmlns:a16="http://schemas.microsoft.com/office/drawing/2014/main" id="{64518918-FECC-40BA-8D3F-47B5C64B037E}"/>
+                <a16:creationId xmlns:a16="http://schemas.microsoft.com/office/drawing/2014/main" id="{939C02D2-440B-4B90-A647-1CEBA6028923}"/>
               </a:ext>
             </a:extLst>
           </p:cNvPr>
@@ -5554,7 +5564,7 @@
     </p:spTree>
     <p:extLst>
       <p:ext uri="{BB962C8B-B14F-4D97-AF65-F5344CB8AC3E}">
-        <p14:creationId xmlns:p14="http://schemas.microsoft.com/office/powerpoint/2010/main" val="1931644613"/>
+        <p14:creationId xmlns:p14="http://schemas.microsoft.com/office/powerpoint/2010/main" val="1279497950"/>
       </p:ext>
     </p:extLst>
   </p:cSld>
@@ -5585,7 +5595,7 @@
           <p:cNvPr id="7" name="">
             <a:extLst xmlns:a="http://schemas.openxmlformats.org/drawingml/2006/main">
               <a:ext uri="{FF2B5EF4-FFF2-40B4-BE49-F238E27FC236}">
-                <a16:creationId xmlns:a16="http://schemas.microsoft.com/office/drawing/2014/main" id="{D28FC8AC-5BE9-48A3-8747-4767BFB9903B}"/>
+                <a16:creationId xmlns:a16="http://schemas.microsoft.com/office/drawing/2014/main" id="{F16EB518-FEB1-4EAA-A4C0-326DE4589DFE}"/>
               </a:ext>
             </a:extLst>
           </p:cNvPr>
@@ -5741,7 +5751,7 @@
           <p:cNvPr id="2" name="">
             <a:extLst xmlns:a="http://schemas.openxmlformats.org/drawingml/2006/main">
               <a:ext uri="{FF2B5EF4-FFF2-40B4-BE49-F238E27FC236}">
-                <a16:creationId xmlns:a16="http://schemas.microsoft.com/office/drawing/2014/main" id="{033B8758-E562-434D-9CE8-EC43AD2680A2}"/>
+                <a16:creationId xmlns:a16="http://schemas.microsoft.com/office/drawing/2014/main" id="{F165B36A-386D-43DB-B46B-FFD4F148F6A2}"/>
               </a:ext>
             </a:extLst>
           </p:cNvPr>
@@ -5897,7 +5907,7 @@
           <p:cNvPr id="3" name="">
             <a:extLst xmlns:a="http://schemas.openxmlformats.org/drawingml/2006/main">
               <a:ext uri="{FF2B5EF4-FFF2-40B4-BE49-F238E27FC236}">
-                <a16:creationId xmlns:a16="http://schemas.microsoft.com/office/drawing/2014/main" id="{2A172307-BD0C-441E-8F0D-F495835613B2}"/>
+                <a16:creationId xmlns:a16="http://schemas.microsoft.com/office/drawing/2014/main" id="{6A774D73-35D5-4C38-9C92-F4AC018808AD}"/>
               </a:ext>
             </a:extLst>
           </p:cNvPr>
@@ -6037,7 +6047,7 @@
           <p:cNvPr id="4" name="">
             <a:extLst xmlns:a="http://schemas.openxmlformats.org/drawingml/2006/main">
               <a:ext uri="{FF2B5EF4-FFF2-40B4-BE49-F238E27FC236}">
-                <a16:creationId xmlns:a16="http://schemas.microsoft.com/office/drawing/2014/main" id="{78896F23-3D1F-45E0-9890-ED45EAD4EEE2}"/>
+                <a16:creationId xmlns:a16="http://schemas.microsoft.com/office/drawing/2014/main" id="{5EC51214-50C1-45BC-AD1F-121BFB1EFB80}"/>
               </a:ext>
             </a:extLst>
           </p:cNvPr>
@@ -6193,7 +6203,7 @@
           <p:cNvPr id="5" name="">
             <a:extLst xmlns:a="http://schemas.openxmlformats.org/drawingml/2006/main">
               <a:ext uri="{FF2B5EF4-FFF2-40B4-BE49-F238E27FC236}">
-                <a16:creationId xmlns:a16="http://schemas.microsoft.com/office/drawing/2014/main" id="{C049AEC3-CD6A-496B-BAC7-BC62382DE23B}"/>
+                <a16:creationId xmlns:a16="http://schemas.microsoft.com/office/drawing/2014/main" id="{B5A60028-33C9-4B37-A331-865C32D3073D}"/>
               </a:ext>
             </a:extLst>
           </p:cNvPr>
@@ -6372,7 +6382,7 @@
           <p:cNvPr id="6" name="">
             <a:extLst xmlns:a="http://schemas.openxmlformats.org/drawingml/2006/main">
               <a:ext uri="{FF2B5EF4-FFF2-40B4-BE49-F238E27FC236}">
-                <a16:creationId xmlns:a16="http://schemas.microsoft.com/office/drawing/2014/main" id="{1BEE0AE4-C48F-4EA9-B789-736E40227853}"/>
+                <a16:creationId xmlns:a16="http://schemas.microsoft.com/office/drawing/2014/main" id="{0BC4D704-B0C9-499A-A889-49DF5699BDC1}"/>
               </a:ext>
             </a:extLst>
           </p:cNvPr>
@@ -6554,7 +6564,7 @@
     </p:spTree>
     <p:extLst>
       <p:ext uri="{BB962C8B-B14F-4D97-AF65-F5344CB8AC3E}">
-        <p14:creationId xmlns:p14="http://schemas.microsoft.com/office/powerpoint/2010/main" val="1539211053"/>
+        <p14:creationId xmlns:p14="http://schemas.microsoft.com/office/powerpoint/2010/main" val="570148348"/>
       </p:ext>
     </p:extLst>
   </p:cSld>
@@ -6585,7 +6595,7 @@
           <p:cNvPr id="7" name="">
             <a:extLst xmlns:a="http://schemas.openxmlformats.org/drawingml/2006/main">
               <a:ext uri="{FF2B5EF4-FFF2-40B4-BE49-F238E27FC236}">
-                <a16:creationId xmlns:a16="http://schemas.microsoft.com/office/drawing/2014/main" id="{FAA318BE-D117-4A08-98C9-236924CC5B58}"/>
+                <a16:creationId xmlns:a16="http://schemas.microsoft.com/office/drawing/2014/main" id="{E0FA1632-7120-41A5-8879-D2CE0C576615}"/>
               </a:ext>
             </a:extLst>
           </p:cNvPr>
@@ -6741,7 +6751,7 @@
           <p:cNvPr id="2" name="">
             <a:extLst xmlns:a="http://schemas.openxmlformats.org/drawingml/2006/main">
               <a:ext uri="{FF2B5EF4-FFF2-40B4-BE49-F238E27FC236}">
-                <a16:creationId xmlns:a16="http://schemas.microsoft.com/office/drawing/2014/main" id="{308FB4AD-73A3-4117-81BD-ADD32C30F0A9}"/>
+                <a16:creationId xmlns:a16="http://schemas.microsoft.com/office/drawing/2014/main" id="{E6282FFD-D2EF-44F8-9C52-86B5F456F9A2}"/>
               </a:ext>
             </a:extLst>
           </p:cNvPr>
@@ -6897,7 +6907,7 @@
           <p:cNvPr id="3" name="">
             <a:extLst xmlns:a="http://schemas.openxmlformats.org/drawingml/2006/main">
               <a:ext uri="{FF2B5EF4-FFF2-40B4-BE49-F238E27FC236}">
-                <a16:creationId xmlns:a16="http://schemas.microsoft.com/office/drawing/2014/main" id="{CA4A3FC9-C822-4DF9-894D-944A4E1545E5}"/>
+                <a16:creationId xmlns:a16="http://schemas.microsoft.com/office/drawing/2014/main" id="{A4877E8F-F960-4D21-8D9B-FC1CDA6B5413}"/>
               </a:ext>
             </a:extLst>
           </p:cNvPr>
@@ -7037,7 +7047,7 @@
           <p:cNvPr id="4" name="">
             <a:extLst xmlns:a="http://schemas.openxmlformats.org/drawingml/2006/main">
               <a:ext uri="{FF2B5EF4-FFF2-40B4-BE49-F238E27FC236}">
-                <a16:creationId xmlns:a16="http://schemas.microsoft.com/office/drawing/2014/main" id="{17A45C2C-A56B-4DAD-BDC1-20EC34C16F61}"/>
+                <a16:creationId xmlns:a16="http://schemas.microsoft.com/office/drawing/2014/main" id="{7F11D295-536F-4184-B2BA-A0C421E4EB58}"/>
               </a:ext>
             </a:extLst>
           </p:cNvPr>
@@ -7193,7 +7203,7 @@
           <p:cNvPr id="5" name="">
             <a:extLst xmlns:a="http://schemas.openxmlformats.org/drawingml/2006/main">
               <a:ext uri="{FF2B5EF4-FFF2-40B4-BE49-F238E27FC236}">
-                <a16:creationId xmlns:a16="http://schemas.microsoft.com/office/drawing/2014/main" id="{9C9A08B0-1FBB-465C-B748-9A7EBFAC4C48}"/>
+                <a16:creationId xmlns:a16="http://schemas.microsoft.com/office/drawing/2014/main" id="{492AB599-9158-4819-9EE0-398A1CD17182}"/>
               </a:ext>
             </a:extLst>
           </p:cNvPr>
@@ -7203,7 +7213,7 @@
           <p:nvPr/>
         </p:nvPicPr>
         <p:blipFill>
-          <a:blip xmlns:r="http://schemas.openxmlformats.org/officeDocument/2006/relationships" xmlns:a="http://schemas.openxmlformats.org/drawingml/2006/main" r:embed="R3de2c380ccf2439b"/>
+          <a:blip xmlns:r="http://schemas.openxmlformats.org/officeDocument/2006/relationships" xmlns:a="http://schemas.openxmlformats.org/drawingml/2006/main" r:embed="R089b999c15044162"/>
           <a:stretch xmlns:a="http://schemas.openxmlformats.org/drawingml/2006/main"/>
         </p:blipFill>
         <p:spPr>
@@ -7221,7 +7231,7 @@
           <p:cNvPr id="6" name="">
             <a:extLst xmlns:a="http://schemas.openxmlformats.org/drawingml/2006/main">
               <a:ext uri="{FF2B5EF4-FFF2-40B4-BE49-F238E27FC236}">
-                <a16:creationId xmlns:a16="http://schemas.microsoft.com/office/drawing/2014/main" id="{7722310F-213A-4845-BDA7-994CEFDD2458}"/>
+                <a16:creationId xmlns:a16="http://schemas.microsoft.com/office/drawing/2014/main" id="{342784F0-93CE-4D17-9C8D-A11E2D3CA5C3}"/>
               </a:ext>
             </a:extLst>
           </p:cNvPr>
@@ -7367,7 +7377,7 @@
                 <a:ea typeface="Noto Sans"/>
                 <a:cs typeface="Noto Sans"/>
               </a:rPr>
-              <a:t>Reference-selected, όχι ανεξάρτητη replication. Έλεγχοι: 12 / 21. Όλες οι δοκιμές διατηρούνται.</a:t>
+              <a:t>Reference-selected, όχι ανεξάρτητη replication. Έλεγχοι: 13 / 21. Όλες οι δοκιμές διατηρούνται.</a:t>
             </a:r>
           </a:p>
         </p:txBody>
@@ -7375,7 +7385,7 @@
     </p:spTree>
     <p:extLst>
       <p:ext uri="{BB962C8B-B14F-4D97-AF65-F5344CB8AC3E}">
-        <p14:creationId xmlns:p14="http://schemas.microsoft.com/office/powerpoint/2010/main" val="1304764051"/>
+        <p14:creationId xmlns:p14="http://schemas.microsoft.com/office/powerpoint/2010/main" val="1624483331"/>
       </p:ext>
     </p:extLst>
   </p:cSld>
@@ -7406,7 +7416,7 @@
           <p:cNvPr id="7" name="">
             <a:extLst xmlns:a="http://schemas.openxmlformats.org/drawingml/2006/main">
               <a:ext uri="{FF2B5EF4-FFF2-40B4-BE49-F238E27FC236}">
-                <a16:creationId xmlns:a16="http://schemas.microsoft.com/office/drawing/2014/main" id="{2BAD2977-C84B-4067-84DC-11451592B214}"/>
+                <a16:creationId xmlns:a16="http://schemas.microsoft.com/office/drawing/2014/main" id="{E3AB70AD-D6DF-453F-9510-7F132F921500}"/>
               </a:ext>
             </a:extLst>
           </p:cNvPr>
@@ -7562,7 +7572,7 @@
           <p:cNvPr id="2" name="">
             <a:extLst xmlns:a="http://schemas.openxmlformats.org/drawingml/2006/main">
               <a:ext uri="{FF2B5EF4-FFF2-40B4-BE49-F238E27FC236}">
-                <a16:creationId xmlns:a16="http://schemas.microsoft.com/office/drawing/2014/main" id="{03402246-C3AE-42AA-AE87-F6C8AFB28F06}"/>
+                <a16:creationId xmlns:a16="http://schemas.microsoft.com/office/drawing/2014/main" id="{56A33C94-0960-4469-A111-F823FFBC3EF2}"/>
               </a:ext>
             </a:extLst>
           </p:cNvPr>
@@ -7718,7 +7728,7 @@
           <p:cNvPr id="3" name="">
             <a:extLst xmlns:a="http://schemas.openxmlformats.org/drawingml/2006/main">
               <a:ext uri="{FF2B5EF4-FFF2-40B4-BE49-F238E27FC236}">
-                <a16:creationId xmlns:a16="http://schemas.microsoft.com/office/drawing/2014/main" id="{4BE06859-0479-4F52-A308-48E99CDEEEE3}"/>
+                <a16:creationId xmlns:a16="http://schemas.microsoft.com/office/drawing/2014/main" id="{E97A17B2-6038-4840-8944-3161BC3145BD}"/>
               </a:ext>
             </a:extLst>
           </p:cNvPr>
@@ -7858,7 +7868,7 @@
           <p:cNvPr id="4" name="">
             <a:extLst xmlns:a="http://schemas.openxmlformats.org/drawingml/2006/main">
               <a:ext uri="{FF2B5EF4-FFF2-40B4-BE49-F238E27FC236}">
-                <a16:creationId xmlns:a16="http://schemas.microsoft.com/office/drawing/2014/main" id="{512FA0D5-1529-468F-BA72-846D52F20F90}"/>
+                <a16:creationId xmlns:a16="http://schemas.microsoft.com/office/drawing/2014/main" id="{C4BD654B-B136-465E-9006-9FB36BE28F40}"/>
               </a:ext>
             </a:extLst>
           </p:cNvPr>
@@ -8014,7 +8024,7 @@
           <p:cNvPr id="5" name="">
             <a:extLst xmlns:a="http://schemas.openxmlformats.org/drawingml/2006/main">
               <a:ext uri="{FF2B5EF4-FFF2-40B4-BE49-F238E27FC236}">
-                <a16:creationId xmlns:a16="http://schemas.microsoft.com/office/drawing/2014/main" id="{88284DF1-9636-4CF8-BEC3-92329F7AE49E}"/>
+                <a16:creationId xmlns:a16="http://schemas.microsoft.com/office/drawing/2014/main" id="{067E495C-E6F5-4167-8D56-46FA839AB150}"/>
               </a:ext>
             </a:extLst>
           </p:cNvPr>
@@ -8024,7 +8034,7 @@
           <p:nvPr/>
         </p:nvPicPr>
         <p:blipFill>
-          <a:blip xmlns:r="http://schemas.openxmlformats.org/officeDocument/2006/relationships" xmlns:a="http://schemas.openxmlformats.org/drawingml/2006/main" r:embed="R3486443dc846437a"/>
+          <a:blip xmlns:r="http://schemas.openxmlformats.org/officeDocument/2006/relationships" xmlns:a="http://schemas.openxmlformats.org/drawingml/2006/main" r:embed="R033986fe216141ea"/>
           <a:stretch xmlns:a="http://schemas.openxmlformats.org/drawingml/2006/main"/>
         </p:blipFill>
         <p:spPr>
@@ -8042,7 +8052,7 @@
           <p:cNvPr id="6" name="">
             <a:extLst xmlns:a="http://schemas.openxmlformats.org/drawingml/2006/main">
               <a:ext uri="{FF2B5EF4-FFF2-40B4-BE49-F238E27FC236}">
-                <a16:creationId xmlns:a16="http://schemas.microsoft.com/office/drawing/2014/main" id="{9EFF4861-9FE3-4DAF-9B3C-65B739DB3C8C}"/>
+                <a16:creationId xmlns:a16="http://schemas.microsoft.com/office/drawing/2014/main" id="{E6C2179E-FA7B-4CA8-9295-88FAC0667E97}"/>
               </a:ext>
             </a:extLst>
           </p:cNvPr>
@@ -8196,7 +8206,7 @@
     </p:spTree>
     <p:extLst>
       <p:ext uri="{BB962C8B-B14F-4D97-AF65-F5344CB8AC3E}">
-        <p14:creationId xmlns:p14="http://schemas.microsoft.com/office/powerpoint/2010/main" val="308193032"/>
+        <p14:creationId xmlns:p14="http://schemas.microsoft.com/office/powerpoint/2010/main" val="990912755"/>
       </p:ext>
     </p:extLst>
   </p:cSld>
@@ -8227,7 +8237,7 @@
           <p:cNvPr id="7" name="">
             <a:extLst xmlns:a="http://schemas.openxmlformats.org/drawingml/2006/main">
               <a:ext uri="{FF2B5EF4-FFF2-40B4-BE49-F238E27FC236}">
-                <a16:creationId xmlns:a16="http://schemas.microsoft.com/office/drawing/2014/main" id="{D9F0B41C-FFCD-4453-8D53-5E3A974CAC0E}"/>
+                <a16:creationId xmlns:a16="http://schemas.microsoft.com/office/drawing/2014/main" id="{FAEF602F-16D2-4E46-B89E-3149E6D2D87A}"/>
               </a:ext>
             </a:extLst>
           </p:cNvPr>
@@ -8383,7 +8393,7 @@
           <p:cNvPr id="2" name="">
             <a:extLst xmlns:a="http://schemas.openxmlformats.org/drawingml/2006/main">
               <a:ext uri="{FF2B5EF4-FFF2-40B4-BE49-F238E27FC236}">
-                <a16:creationId xmlns:a16="http://schemas.microsoft.com/office/drawing/2014/main" id="{E47BABB6-6B39-4E50-B724-B989A3E24EE9}"/>
+                <a16:creationId xmlns:a16="http://schemas.microsoft.com/office/drawing/2014/main" id="{4F885E96-8CB3-4206-A0BD-ED8ED23FAF80}"/>
               </a:ext>
             </a:extLst>
           </p:cNvPr>
@@ -8539,7 +8549,7 @@
           <p:cNvPr id="3" name="">
             <a:extLst xmlns:a="http://schemas.openxmlformats.org/drawingml/2006/main">
               <a:ext uri="{FF2B5EF4-FFF2-40B4-BE49-F238E27FC236}">
-                <a16:creationId xmlns:a16="http://schemas.microsoft.com/office/drawing/2014/main" id="{303D4123-9C78-427D-A1B8-47E81A7197AA}"/>
+                <a16:creationId xmlns:a16="http://schemas.microsoft.com/office/drawing/2014/main" id="{6DF29870-F99B-488A-A1AA-3071C8ECACA9}"/>
               </a:ext>
             </a:extLst>
           </p:cNvPr>
@@ -8679,7 +8689,7 @@
           <p:cNvPr id="4" name="">
             <a:extLst xmlns:a="http://schemas.openxmlformats.org/drawingml/2006/main">
               <a:ext uri="{FF2B5EF4-FFF2-40B4-BE49-F238E27FC236}">
-                <a16:creationId xmlns:a16="http://schemas.microsoft.com/office/drawing/2014/main" id="{4B31D891-7A8B-42EF-B9C6-C032744A174E}"/>
+                <a16:creationId xmlns:a16="http://schemas.microsoft.com/office/drawing/2014/main" id="{62F0E6CF-C45D-4516-9B1C-CACB71A4B59F}"/>
               </a:ext>
             </a:extLst>
           </p:cNvPr>
@@ -8835,7 +8845,7 @@
           <p:cNvPr id="5" name="">
             <a:extLst xmlns:a="http://schemas.openxmlformats.org/drawingml/2006/main">
               <a:ext uri="{FF2B5EF4-FFF2-40B4-BE49-F238E27FC236}">
-                <a16:creationId xmlns:a16="http://schemas.microsoft.com/office/drawing/2014/main" id="{4606CD15-1D8F-48F1-A787-8C57E00C09D3}"/>
+                <a16:creationId xmlns:a16="http://schemas.microsoft.com/office/drawing/2014/main" id="{50A89CF7-B301-4230-9273-2F5B0EDB7514}"/>
               </a:ext>
             </a:extLst>
           </p:cNvPr>
@@ -8845,7 +8855,7 @@
           <p:nvPr/>
         </p:nvPicPr>
         <p:blipFill>
-          <a:blip xmlns:r="http://schemas.openxmlformats.org/officeDocument/2006/relationships" xmlns:a="http://schemas.openxmlformats.org/drawingml/2006/main" r:embed="R2851ecbf9a2c4ce1"/>
+          <a:blip xmlns:r="http://schemas.openxmlformats.org/officeDocument/2006/relationships" xmlns:a="http://schemas.openxmlformats.org/drawingml/2006/main" r:embed="Re00bc645573d4c49"/>
           <a:stretch xmlns:a="http://schemas.openxmlformats.org/drawingml/2006/main"/>
         </p:blipFill>
         <p:spPr>
@@ -8863,7 +8873,7 @@
           <p:cNvPr id="6" name="">
             <a:extLst xmlns:a="http://schemas.openxmlformats.org/drawingml/2006/main">
               <a:ext uri="{FF2B5EF4-FFF2-40B4-BE49-F238E27FC236}">
-                <a16:creationId xmlns:a16="http://schemas.microsoft.com/office/drawing/2014/main" id="{221D401F-BC06-4171-AD01-5D0773E88ECA}"/>
+                <a16:creationId xmlns:a16="http://schemas.microsoft.com/office/drawing/2014/main" id="{BF0167D1-FCD6-4921-8DA5-E28C640384AF}"/>
               </a:ext>
             </a:extLst>
           </p:cNvPr>
@@ -9142,7 +9152,7 @@
     </p:spTree>
     <p:extLst>
       <p:ext uri="{BB962C8B-B14F-4D97-AF65-F5344CB8AC3E}">
-        <p14:creationId xmlns:p14="http://schemas.microsoft.com/office/powerpoint/2010/main" val="1640837499"/>
+        <p14:creationId xmlns:p14="http://schemas.microsoft.com/office/powerpoint/2010/main" val="982078146"/>
       </p:ext>
     </p:extLst>
   </p:cSld>
@@ -9173,7 +9183,7 @@
           <p:cNvPr id="7" name="">
             <a:extLst xmlns:a="http://schemas.openxmlformats.org/drawingml/2006/main">
               <a:ext uri="{FF2B5EF4-FFF2-40B4-BE49-F238E27FC236}">
-                <a16:creationId xmlns:a16="http://schemas.microsoft.com/office/drawing/2014/main" id="{937F2BEA-9070-458A-AC87-60553056FC8C}"/>
+                <a16:creationId xmlns:a16="http://schemas.microsoft.com/office/drawing/2014/main" id="{19A3B0BC-D7A9-4272-B14D-94E96A37323F}"/>
               </a:ext>
             </a:extLst>
           </p:cNvPr>
@@ -9329,7 +9339,7 @@
           <p:cNvPr id="2" name="">
             <a:extLst xmlns:a="http://schemas.openxmlformats.org/drawingml/2006/main">
               <a:ext uri="{FF2B5EF4-FFF2-40B4-BE49-F238E27FC236}">
-                <a16:creationId xmlns:a16="http://schemas.microsoft.com/office/drawing/2014/main" id="{DE619CFE-26EA-4ABF-B52B-59060F6E503B}"/>
+                <a16:creationId xmlns:a16="http://schemas.microsoft.com/office/drawing/2014/main" id="{D76DBB2B-39F3-49FE-9587-82D3F2FE2029}"/>
               </a:ext>
             </a:extLst>
           </p:cNvPr>
@@ -9485,7 +9495,7 @@
           <p:cNvPr id="3" name="">
             <a:extLst xmlns:a="http://schemas.openxmlformats.org/drawingml/2006/main">
               <a:ext uri="{FF2B5EF4-FFF2-40B4-BE49-F238E27FC236}">
-                <a16:creationId xmlns:a16="http://schemas.microsoft.com/office/drawing/2014/main" id="{70BA6F05-FFA7-46D7-8095-0DD571A89FFE}"/>
+                <a16:creationId xmlns:a16="http://schemas.microsoft.com/office/drawing/2014/main" id="{5CF629CE-D705-4DE6-B650-BDA775D73297}"/>
               </a:ext>
             </a:extLst>
           </p:cNvPr>
@@ -9625,7 +9635,7 @@
           <p:cNvPr id="4" name="">
             <a:extLst xmlns:a="http://schemas.openxmlformats.org/drawingml/2006/main">
               <a:ext uri="{FF2B5EF4-FFF2-40B4-BE49-F238E27FC236}">
-                <a16:creationId xmlns:a16="http://schemas.microsoft.com/office/drawing/2014/main" id="{D6D7F0AA-B6E7-4200-9D9A-F144DD6179B2}"/>
+                <a16:creationId xmlns:a16="http://schemas.microsoft.com/office/drawing/2014/main" id="{EB298D40-6C07-4AFE-A48C-A6D9E4BD4AC9}"/>
               </a:ext>
             </a:extLst>
           </p:cNvPr>
@@ -9781,7 +9791,7 @@
           <p:cNvPr id="5" name="">
             <a:extLst xmlns:a="http://schemas.openxmlformats.org/drawingml/2006/main">
               <a:ext uri="{FF2B5EF4-FFF2-40B4-BE49-F238E27FC236}">
-                <a16:creationId xmlns:a16="http://schemas.microsoft.com/office/drawing/2014/main" id="{7208EC54-88BA-46C1-BD78-4E4604307165}"/>
+                <a16:creationId xmlns:a16="http://schemas.microsoft.com/office/drawing/2014/main" id="{1D274002-DCE4-4FE7-9834-7D4C3EC13358}"/>
               </a:ext>
             </a:extLst>
           </p:cNvPr>
@@ -9791,7 +9801,7 @@
           <p:nvPr/>
         </p:nvPicPr>
         <p:blipFill>
-          <a:blip xmlns:r="http://schemas.openxmlformats.org/officeDocument/2006/relationships" xmlns:a="http://schemas.openxmlformats.org/drawingml/2006/main" r:embed="Rdcbfecbc5bff4b76"/>
+          <a:blip xmlns:r="http://schemas.openxmlformats.org/officeDocument/2006/relationships" xmlns:a="http://schemas.openxmlformats.org/drawingml/2006/main" r:embed="Rea10309da9bf4d2a"/>
           <a:stretch xmlns:a="http://schemas.openxmlformats.org/drawingml/2006/main"/>
         </p:blipFill>
         <p:spPr>
@@ -9809,7 +9819,7 @@
           <p:cNvPr id="6" name="">
             <a:extLst xmlns:a="http://schemas.openxmlformats.org/drawingml/2006/main">
               <a:ext uri="{FF2B5EF4-FFF2-40B4-BE49-F238E27FC236}">
-                <a16:creationId xmlns:a16="http://schemas.microsoft.com/office/drawing/2014/main" id="{EA216D0E-FBFE-4535-B4DA-1B72B84FC2D3}"/>
+                <a16:creationId xmlns:a16="http://schemas.microsoft.com/office/drawing/2014/main" id="{ECC56909-A3AC-4028-9336-2AB7B96A4801}"/>
               </a:ext>
             </a:extLst>
           </p:cNvPr>
@@ -10070,7 +10080,7 @@
     </p:spTree>
     <p:extLst>
       <p:ext uri="{BB962C8B-B14F-4D97-AF65-F5344CB8AC3E}">
-        <p14:creationId xmlns:p14="http://schemas.microsoft.com/office/powerpoint/2010/main" val="1143941742"/>
+        <p14:creationId xmlns:p14="http://schemas.microsoft.com/office/powerpoint/2010/main" val="1726169038"/>
       </p:ext>
     </p:extLst>
   </p:cSld>
@@ -10101,7 +10111,7 @@
           <p:cNvPr id="6" name="">
             <a:extLst xmlns:a="http://schemas.openxmlformats.org/drawingml/2006/main">
               <a:ext uri="{FF2B5EF4-FFF2-40B4-BE49-F238E27FC236}">
-                <a16:creationId xmlns:a16="http://schemas.microsoft.com/office/drawing/2014/main" id="{DF929458-6BA2-4CCB-9C80-02F8C5A9B905}"/>
+                <a16:creationId xmlns:a16="http://schemas.microsoft.com/office/drawing/2014/main" id="{1A82F510-5FD2-42C7-B156-7291E1388137}"/>
               </a:ext>
             </a:extLst>
           </p:cNvPr>
@@ -10257,7 +10267,7 @@
           <p:cNvPr id="2" name="">
             <a:extLst xmlns:a="http://schemas.openxmlformats.org/drawingml/2006/main">
               <a:ext uri="{FF2B5EF4-FFF2-40B4-BE49-F238E27FC236}">
-                <a16:creationId xmlns:a16="http://schemas.microsoft.com/office/drawing/2014/main" id="{9508487F-A6D2-4E49-B2CA-7BF4FB7FD397}"/>
+                <a16:creationId xmlns:a16="http://schemas.microsoft.com/office/drawing/2014/main" id="{C5744D1F-B289-4117-80B4-5DB50904771D}"/>
               </a:ext>
             </a:extLst>
           </p:cNvPr>
@@ -10413,7 +10423,7 @@
           <p:cNvPr id="3" name="">
             <a:extLst xmlns:a="http://schemas.openxmlformats.org/drawingml/2006/main">
               <a:ext uri="{FF2B5EF4-FFF2-40B4-BE49-F238E27FC236}">
-                <a16:creationId xmlns:a16="http://schemas.microsoft.com/office/drawing/2014/main" id="{FC8F2F39-6D39-42EA-AC88-05DAE7EFBC69}"/>
+                <a16:creationId xmlns:a16="http://schemas.microsoft.com/office/drawing/2014/main" id="{784EFD6E-4491-4F17-8B28-8C1427378EAA}"/>
               </a:ext>
             </a:extLst>
           </p:cNvPr>
@@ -10553,7 +10563,7 @@
           <p:cNvPr id="4" name="">
             <a:extLst xmlns:a="http://schemas.openxmlformats.org/drawingml/2006/main">
               <a:ext uri="{FF2B5EF4-FFF2-40B4-BE49-F238E27FC236}">
-                <a16:creationId xmlns:a16="http://schemas.microsoft.com/office/drawing/2014/main" id="{C2617DBC-D3E7-43E4-8458-6A893DE33B1F}"/>
+                <a16:creationId xmlns:a16="http://schemas.microsoft.com/office/drawing/2014/main" id="{0F17699E-AF2F-4F21-AB69-B5C6C9C9268A}"/>
               </a:ext>
             </a:extLst>
           </p:cNvPr>
@@ -10709,7 +10719,7 @@
           <p:cNvPr id="5" name="">
             <a:extLst xmlns:a="http://schemas.openxmlformats.org/drawingml/2006/main">
               <a:ext uri="{FF2B5EF4-FFF2-40B4-BE49-F238E27FC236}">
-                <a16:creationId xmlns:a16="http://schemas.microsoft.com/office/drawing/2014/main" id="{E2E8EC05-33BE-4ACB-B72E-96355411558A}"/>
+                <a16:creationId xmlns:a16="http://schemas.microsoft.com/office/drawing/2014/main" id="{478B80FC-1C4B-46A0-A9B8-4ECCC45C632E}"/>
               </a:ext>
             </a:extLst>
           </p:cNvPr>
@@ -10970,7 +10980,7 @@
     </p:spTree>
     <p:extLst>
       <p:ext uri="{BB962C8B-B14F-4D97-AF65-F5344CB8AC3E}">
-        <p14:creationId xmlns:p14="http://schemas.microsoft.com/office/powerpoint/2010/main" val="1885901482"/>
+        <p14:creationId xmlns:p14="http://schemas.microsoft.com/office/powerpoint/2010/main" val="1548277759"/>
       </p:ext>
     </p:extLst>
   </p:cSld>
@@ -11001,7 +11011,7 @@
           <p:cNvPr id="6" name="">
             <a:extLst xmlns:a="http://schemas.openxmlformats.org/drawingml/2006/main">
               <a:ext uri="{FF2B5EF4-FFF2-40B4-BE49-F238E27FC236}">
-                <a16:creationId xmlns:a16="http://schemas.microsoft.com/office/drawing/2014/main" id="{47BD5FF9-A0AD-47CE-A510-FA5ADAD3A7E6}"/>
+                <a16:creationId xmlns:a16="http://schemas.microsoft.com/office/drawing/2014/main" id="{CB3BAC4F-F124-4655-BFB1-F686A0189C1B}"/>
               </a:ext>
             </a:extLst>
           </p:cNvPr>
@@ -11157,7 +11167,7 @@
           <p:cNvPr id="2" name="">
             <a:extLst xmlns:a="http://schemas.openxmlformats.org/drawingml/2006/main">
               <a:ext uri="{FF2B5EF4-FFF2-40B4-BE49-F238E27FC236}">
-                <a16:creationId xmlns:a16="http://schemas.microsoft.com/office/drawing/2014/main" id="{26DD0F1B-CE62-4305-A527-0861242B3DCB}"/>
+                <a16:creationId xmlns:a16="http://schemas.microsoft.com/office/drawing/2014/main" id="{57ACF392-947D-43DF-B84B-3D8EAC1BC37F}"/>
               </a:ext>
             </a:extLst>
           </p:cNvPr>
@@ -11313,7 +11323,7 @@
           <p:cNvPr id="3" name="">
             <a:extLst xmlns:a="http://schemas.openxmlformats.org/drawingml/2006/main">
               <a:ext uri="{FF2B5EF4-FFF2-40B4-BE49-F238E27FC236}">
-                <a16:creationId xmlns:a16="http://schemas.microsoft.com/office/drawing/2014/main" id="{DDE5E2E7-D9C8-4269-B489-E6607E99BDD3}"/>
+                <a16:creationId xmlns:a16="http://schemas.microsoft.com/office/drawing/2014/main" id="{37261028-146F-4A35-9D67-F610AEB69C18}"/>
               </a:ext>
             </a:extLst>
           </p:cNvPr>
@@ -11453,7 +11463,7 @@
           <p:cNvPr id="4" name="">
             <a:extLst xmlns:a="http://schemas.openxmlformats.org/drawingml/2006/main">
               <a:ext uri="{FF2B5EF4-FFF2-40B4-BE49-F238E27FC236}">
-                <a16:creationId xmlns:a16="http://schemas.microsoft.com/office/drawing/2014/main" id="{163AB0D1-8A25-4BBA-8B66-5FF8BC343BBF}"/>
+                <a16:creationId xmlns:a16="http://schemas.microsoft.com/office/drawing/2014/main" id="{3E57D693-4528-4702-AB21-64229FE136A5}"/>
               </a:ext>
             </a:extLst>
           </p:cNvPr>
@@ -11609,7 +11619,7 @@
           <p:cNvPr id="5" name="">
             <a:extLst xmlns:a="http://schemas.openxmlformats.org/drawingml/2006/main">
               <a:ext uri="{FF2B5EF4-FFF2-40B4-BE49-F238E27FC236}">
-                <a16:creationId xmlns:a16="http://schemas.microsoft.com/office/drawing/2014/main" id="{26E5A797-1D15-41C8-A629-E0A801AB075F}"/>
+                <a16:creationId xmlns:a16="http://schemas.microsoft.com/office/drawing/2014/main" id="{4F39CF0B-D38A-4658-B090-F3F425248275}"/>
               </a:ext>
             </a:extLst>
           </p:cNvPr>
@@ -11819,7 +11829,7 @@
     </p:spTree>
     <p:extLst>
       <p:ext uri="{BB962C8B-B14F-4D97-AF65-F5344CB8AC3E}">
-        <p14:creationId xmlns:p14="http://schemas.microsoft.com/office/powerpoint/2010/main" val="1447961184"/>
+        <p14:creationId xmlns:p14="http://schemas.microsoft.com/office/powerpoint/2010/main" val="390822318"/>
       </p:ext>
     </p:extLst>
   </p:cSld>
@@ -11850,7 +11860,7 @@
           <p:cNvPr id="6" name="">
             <a:extLst xmlns:a="http://schemas.openxmlformats.org/drawingml/2006/main">
               <a:ext uri="{FF2B5EF4-FFF2-40B4-BE49-F238E27FC236}">
-                <a16:creationId xmlns:a16="http://schemas.microsoft.com/office/drawing/2014/main" id="{E970AD66-E2A3-47A6-ABF6-3BAAD36BF096}"/>
+                <a16:creationId xmlns:a16="http://schemas.microsoft.com/office/drawing/2014/main" id="{D6BBC345-8C25-419C-A40C-3F65A6A43233}"/>
               </a:ext>
             </a:extLst>
           </p:cNvPr>
@@ -12006,7 +12016,7 @@
           <p:cNvPr id="2" name="">
             <a:extLst xmlns:a="http://schemas.openxmlformats.org/drawingml/2006/main">
               <a:ext uri="{FF2B5EF4-FFF2-40B4-BE49-F238E27FC236}">
-                <a16:creationId xmlns:a16="http://schemas.microsoft.com/office/drawing/2014/main" id="{26E9BC3E-A344-44A3-8EF6-CAFFA1D3631C}"/>
+                <a16:creationId xmlns:a16="http://schemas.microsoft.com/office/drawing/2014/main" id="{BD7E18AA-46F7-48B5-A1A5-8956ABD6086D}"/>
               </a:ext>
             </a:extLst>
           </p:cNvPr>
@@ -12162,7 +12172,7 @@
           <p:cNvPr id="3" name="">
             <a:extLst xmlns:a="http://schemas.openxmlformats.org/drawingml/2006/main">
               <a:ext uri="{FF2B5EF4-FFF2-40B4-BE49-F238E27FC236}">
-                <a16:creationId xmlns:a16="http://schemas.microsoft.com/office/drawing/2014/main" id="{A3C2FB12-849A-40DE-BBB5-D36264175C67}"/>
+                <a16:creationId xmlns:a16="http://schemas.microsoft.com/office/drawing/2014/main" id="{D485C0FE-5CEE-4A60-B5D3-20E718F62B62}"/>
               </a:ext>
             </a:extLst>
           </p:cNvPr>
@@ -12302,7 +12312,7 @@
           <p:cNvPr id="4" name="">
             <a:extLst xmlns:a="http://schemas.openxmlformats.org/drawingml/2006/main">
               <a:ext uri="{FF2B5EF4-FFF2-40B4-BE49-F238E27FC236}">
-                <a16:creationId xmlns:a16="http://schemas.microsoft.com/office/drawing/2014/main" id="{9AB41794-B00B-46CB-99B0-FBF88DED9F45}"/>
+                <a16:creationId xmlns:a16="http://schemas.microsoft.com/office/drawing/2014/main" id="{3F167341-DA20-4547-8165-B5B97ADD5F50}"/>
               </a:ext>
             </a:extLst>
           </p:cNvPr>
@@ -12458,7 +12468,7 @@
           <p:cNvPr id="5" name="">
             <a:extLst xmlns:a="http://schemas.openxmlformats.org/drawingml/2006/main">
               <a:ext uri="{FF2B5EF4-FFF2-40B4-BE49-F238E27FC236}">
-                <a16:creationId xmlns:a16="http://schemas.microsoft.com/office/drawing/2014/main" id="{C5FF5574-F4B6-485D-8E5A-F07D301C6912}"/>
+                <a16:creationId xmlns:a16="http://schemas.microsoft.com/office/drawing/2014/main" id="{0DDDF6D7-262C-4B66-9DEE-C19ECC56156D}"/>
               </a:ext>
             </a:extLst>
           </p:cNvPr>
@@ -12696,7 +12706,7 @@
     </p:spTree>
     <p:extLst>
       <p:ext uri="{BB962C8B-B14F-4D97-AF65-F5344CB8AC3E}">
-        <p14:creationId xmlns:p14="http://schemas.microsoft.com/office/powerpoint/2010/main" val="79076675"/>
+        <p14:creationId xmlns:p14="http://schemas.microsoft.com/office/powerpoint/2010/main" val="1726800506"/>
       </p:ext>
     </p:extLst>
   </p:cSld>
@@ -12727,7 +12737,7 @@
           <p:cNvPr id="6" name="">
             <a:extLst xmlns:a="http://schemas.openxmlformats.org/drawingml/2006/main">
               <a:ext uri="{FF2B5EF4-FFF2-40B4-BE49-F238E27FC236}">
-                <a16:creationId xmlns:a16="http://schemas.microsoft.com/office/drawing/2014/main" id="{9621AEF5-7AA5-4EF7-A4A1-B46648AA05AD}"/>
+                <a16:creationId xmlns:a16="http://schemas.microsoft.com/office/drawing/2014/main" id="{0512198A-05AF-40CA-BE95-E615FF7624DB}"/>
               </a:ext>
             </a:extLst>
           </p:cNvPr>
@@ -12883,7 +12893,7 @@
           <p:cNvPr id="2" name="">
             <a:extLst xmlns:a="http://schemas.openxmlformats.org/drawingml/2006/main">
               <a:ext uri="{FF2B5EF4-FFF2-40B4-BE49-F238E27FC236}">
-                <a16:creationId xmlns:a16="http://schemas.microsoft.com/office/drawing/2014/main" id="{613B2FC1-D321-4D76-BA00-C344422D1B23}"/>
+                <a16:creationId xmlns:a16="http://schemas.microsoft.com/office/drawing/2014/main" id="{3B525C72-D91F-400A-90D5-2DB6468F6AA3}"/>
               </a:ext>
             </a:extLst>
           </p:cNvPr>
@@ -13039,7 +13049,7 @@
           <p:cNvPr id="3" name="">
             <a:extLst xmlns:a="http://schemas.openxmlformats.org/drawingml/2006/main">
               <a:ext uri="{FF2B5EF4-FFF2-40B4-BE49-F238E27FC236}">
-                <a16:creationId xmlns:a16="http://schemas.microsoft.com/office/drawing/2014/main" id="{D9005546-3D28-45B0-96DB-7AE9E5718309}"/>
+                <a16:creationId xmlns:a16="http://schemas.microsoft.com/office/drawing/2014/main" id="{76D0299A-0141-48EC-B6AA-888210B303A4}"/>
               </a:ext>
             </a:extLst>
           </p:cNvPr>
@@ -13179,7 +13189,7 @@
           <p:cNvPr id="4" name="">
             <a:extLst xmlns:a="http://schemas.openxmlformats.org/drawingml/2006/main">
               <a:ext uri="{FF2B5EF4-FFF2-40B4-BE49-F238E27FC236}">
-                <a16:creationId xmlns:a16="http://schemas.microsoft.com/office/drawing/2014/main" id="{92245420-C80C-46D1-A8C6-494A92A6A1C7}"/>
+                <a16:creationId xmlns:a16="http://schemas.microsoft.com/office/drawing/2014/main" id="{9A7A1683-4E40-41EF-A93F-5CE359459C47}"/>
               </a:ext>
             </a:extLst>
           </p:cNvPr>
@@ -13335,7 +13345,7 @@
           <p:cNvPr id="5" name="">
             <a:extLst xmlns:a="http://schemas.openxmlformats.org/drawingml/2006/main">
               <a:ext uri="{FF2B5EF4-FFF2-40B4-BE49-F238E27FC236}">
-                <a16:creationId xmlns:a16="http://schemas.microsoft.com/office/drawing/2014/main" id="{2B003EE3-793B-4D17-AC9E-21CC6A3C1EAD}"/>
+                <a16:creationId xmlns:a16="http://schemas.microsoft.com/office/drawing/2014/main" id="{4FE4DBCF-D6C4-49B8-9C02-A1D2646301B2}"/>
               </a:ext>
             </a:extLst>
           </p:cNvPr>
@@ -13573,7 +13583,7 @@
     </p:spTree>
     <p:extLst>
       <p:ext uri="{BB962C8B-B14F-4D97-AF65-F5344CB8AC3E}">
-        <p14:creationId xmlns:p14="http://schemas.microsoft.com/office/powerpoint/2010/main" val="1935251778"/>
+        <p14:creationId xmlns:p14="http://schemas.microsoft.com/office/powerpoint/2010/main" val="1263368821"/>
       </p:ext>
     </p:extLst>
   </p:cSld>
@@ -13604,7 +13614,7 @@
           <p:cNvPr id="6" name="">
             <a:extLst xmlns:a="http://schemas.openxmlformats.org/drawingml/2006/main">
               <a:ext uri="{FF2B5EF4-FFF2-40B4-BE49-F238E27FC236}">
-                <a16:creationId xmlns:a16="http://schemas.microsoft.com/office/drawing/2014/main" id="{DA519839-2C87-4183-B46C-E9014DD77BE2}"/>
+                <a16:creationId xmlns:a16="http://schemas.microsoft.com/office/drawing/2014/main" id="{E43AEB59-C0CE-437A-A86F-F40CFC126C50}"/>
               </a:ext>
             </a:extLst>
           </p:cNvPr>
@@ -13760,7 +13770,7 @@
           <p:cNvPr id="2" name="">
             <a:extLst xmlns:a="http://schemas.openxmlformats.org/drawingml/2006/main">
               <a:ext uri="{FF2B5EF4-FFF2-40B4-BE49-F238E27FC236}">
-                <a16:creationId xmlns:a16="http://schemas.microsoft.com/office/drawing/2014/main" id="{0FC95166-DB39-4B13-8073-CFE573C566AE}"/>
+                <a16:creationId xmlns:a16="http://schemas.microsoft.com/office/drawing/2014/main" id="{1A803150-E8F8-4E77-B1DF-27E2F8DA706C}"/>
               </a:ext>
             </a:extLst>
           </p:cNvPr>
@@ -13916,7 +13926,7 @@
           <p:cNvPr id="3" name="">
             <a:extLst xmlns:a="http://schemas.openxmlformats.org/drawingml/2006/main">
               <a:ext uri="{FF2B5EF4-FFF2-40B4-BE49-F238E27FC236}">
-                <a16:creationId xmlns:a16="http://schemas.microsoft.com/office/drawing/2014/main" id="{53A9CDCD-7964-4496-87AC-B3C5E0EFE0B1}"/>
+                <a16:creationId xmlns:a16="http://schemas.microsoft.com/office/drawing/2014/main" id="{83D229F2-61D0-4929-AB08-EBD62A22DBEE}"/>
               </a:ext>
             </a:extLst>
           </p:cNvPr>
@@ -14056,7 +14066,7 @@
           <p:cNvPr id="4" name="">
             <a:extLst xmlns:a="http://schemas.openxmlformats.org/drawingml/2006/main">
               <a:ext uri="{FF2B5EF4-FFF2-40B4-BE49-F238E27FC236}">
-                <a16:creationId xmlns:a16="http://schemas.microsoft.com/office/drawing/2014/main" id="{E32EBCA8-0FC9-40E4-9AB0-F5E15AD6BD5A}"/>
+                <a16:creationId xmlns:a16="http://schemas.microsoft.com/office/drawing/2014/main" id="{E69BAD39-E399-4E15-A712-56B2234A0369}"/>
               </a:ext>
             </a:extLst>
           </p:cNvPr>
@@ -14212,7 +14222,7 @@
           <p:cNvPr id="5" name="">
             <a:extLst xmlns:a="http://schemas.openxmlformats.org/drawingml/2006/main">
               <a:ext uri="{FF2B5EF4-FFF2-40B4-BE49-F238E27FC236}">
-                <a16:creationId xmlns:a16="http://schemas.microsoft.com/office/drawing/2014/main" id="{795F87F0-EBBE-417C-8975-7E67952AC4E4}"/>
+                <a16:creationId xmlns:a16="http://schemas.microsoft.com/office/drawing/2014/main" id="{0F117DEB-F112-4C3E-A208-160966764583}"/>
               </a:ext>
             </a:extLst>
           </p:cNvPr>
@@ -14468,7 +14478,7 @@
     </p:spTree>
     <p:extLst>
       <p:ext uri="{BB962C8B-B14F-4D97-AF65-F5344CB8AC3E}">
-        <p14:creationId xmlns:p14="http://schemas.microsoft.com/office/powerpoint/2010/main" val="1278933623"/>
+        <p14:creationId xmlns:p14="http://schemas.microsoft.com/office/powerpoint/2010/main" val="492374881"/>
       </p:ext>
     </p:extLst>
   </p:cSld>
@@ -14499,7 +14509,7 @@
           <p:cNvPr id="6" name="">
             <a:extLst xmlns:a="http://schemas.openxmlformats.org/drawingml/2006/main">
               <a:ext uri="{FF2B5EF4-FFF2-40B4-BE49-F238E27FC236}">
-                <a16:creationId xmlns:a16="http://schemas.microsoft.com/office/drawing/2014/main" id="{A682A071-3DC5-45E1-8F20-8A3FC682E52E}"/>
+                <a16:creationId xmlns:a16="http://schemas.microsoft.com/office/drawing/2014/main" id="{3640D340-CCD3-4C9E-AA28-EE813F637E2A}"/>
               </a:ext>
             </a:extLst>
           </p:cNvPr>
@@ -14655,7 +14665,7 @@
           <p:cNvPr id="2" name="">
             <a:extLst xmlns:a="http://schemas.openxmlformats.org/drawingml/2006/main">
               <a:ext uri="{FF2B5EF4-FFF2-40B4-BE49-F238E27FC236}">
-                <a16:creationId xmlns:a16="http://schemas.microsoft.com/office/drawing/2014/main" id="{3051E998-ADAF-443B-9F22-0F762D417C12}"/>
+                <a16:creationId xmlns:a16="http://schemas.microsoft.com/office/drawing/2014/main" id="{305C6468-88BC-4B28-A0FA-6FF786435336}"/>
               </a:ext>
             </a:extLst>
           </p:cNvPr>
@@ -14811,7 +14821,7 @@
           <p:cNvPr id="3" name="">
             <a:extLst xmlns:a="http://schemas.openxmlformats.org/drawingml/2006/main">
               <a:ext uri="{FF2B5EF4-FFF2-40B4-BE49-F238E27FC236}">
-                <a16:creationId xmlns:a16="http://schemas.microsoft.com/office/drawing/2014/main" id="{3DA916E6-43DF-4F49-A07D-885729A76543}"/>
+                <a16:creationId xmlns:a16="http://schemas.microsoft.com/office/drawing/2014/main" id="{833E4358-9D66-4DD0-8BD0-33401630D7F8}"/>
               </a:ext>
             </a:extLst>
           </p:cNvPr>
@@ -14951,7 +14961,7 @@
           <p:cNvPr id="4" name="">
             <a:extLst xmlns:a="http://schemas.openxmlformats.org/drawingml/2006/main">
               <a:ext uri="{FF2B5EF4-FFF2-40B4-BE49-F238E27FC236}">
-                <a16:creationId xmlns:a16="http://schemas.microsoft.com/office/drawing/2014/main" id="{B391F92D-DBDA-4022-9A82-A4D8F1FCDE60}"/>
+                <a16:creationId xmlns:a16="http://schemas.microsoft.com/office/drawing/2014/main" id="{1940611A-676E-4B95-B236-BB58A8856CD9}"/>
               </a:ext>
             </a:extLst>
           </p:cNvPr>
@@ -15107,7 +15117,7 @@
           <p:cNvPr id="5" name="">
             <a:extLst xmlns:a="http://schemas.openxmlformats.org/drawingml/2006/main">
               <a:ext uri="{FF2B5EF4-FFF2-40B4-BE49-F238E27FC236}">
-                <a16:creationId xmlns:a16="http://schemas.microsoft.com/office/drawing/2014/main" id="{86FE0A76-8925-49B8-8CBF-C017E494F741}"/>
+                <a16:creationId xmlns:a16="http://schemas.microsoft.com/office/drawing/2014/main" id="{3D93CF48-389B-41C9-A6E6-BA727905B8DC}"/>
               </a:ext>
             </a:extLst>
           </p:cNvPr>
@@ -15345,7 +15355,7 @@
     </p:spTree>
     <p:extLst>
       <p:ext uri="{BB962C8B-B14F-4D97-AF65-F5344CB8AC3E}">
-        <p14:creationId xmlns:p14="http://schemas.microsoft.com/office/powerpoint/2010/main" val="1477717198"/>
+        <p14:creationId xmlns:p14="http://schemas.microsoft.com/office/powerpoint/2010/main" val="618971621"/>
       </p:ext>
     </p:extLst>
   </p:cSld>
@@ -15376,7 +15386,7 @@
           <p:cNvPr id="7" name="">
             <a:extLst xmlns:a="http://schemas.openxmlformats.org/drawingml/2006/main">
               <a:ext uri="{FF2B5EF4-FFF2-40B4-BE49-F238E27FC236}">
-                <a16:creationId xmlns:a16="http://schemas.microsoft.com/office/drawing/2014/main" id="{7440CFB6-381C-4495-BB46-BC495E92F9C7}"/>
+                <a16:creationId xmlns:a16="http://schemas.microsoft.com/office/drawing/2014/main" id="{3F7C1CF9-8844-46A0-BE3E-2C3185352578}"/>
               </a:ext>
             </a:extLst>
           </p:cNvPr>
@@ -15532,7 +15542,7 @@
           <p:cNvPr id="2" name="">
             <a:extLst xmlns:a="http://schemas.openxmlformats.org/drawingml/2006/main">
               <a:ext uri="{FF2B5EF4-FFF2-40B4-BE49-F238E27FC236}">
-                <a16:creationId xmlns:a16="http://schemas.microsoft.com/office/drawing/2014/main" id="{9A014973-A88A-44BF-9E26-92890602A799}"/>
+                <a16:creationId xmlns:a16="http://schemas.microsoft.com/office/drawing/2014/main" id="{8F87F7FE-5429-4432-9108-695F1BB4498F}"/>
               </a:ext>
             </a:extLst>
           </p:cNvPr>
@@ -15688,7 +15698,7 @@
           <p:cNvPr id="3" name="">
             <a:extLst xmlns:a="http://schemas.openxmlformats.org/drawingml/2006/main">
               <a:ext uri="{FF2B5EF4-FFF2-40B4-BE49-F238E27FC236}">
-                <a16:creationId xmlns:a16="http://schemas.microsoft.com/office/drawing/2014/main" id="{57F25C8F-6867-4566-8B11-F6CBDE8CAE72}"/>
+                <a16:creationId xmlns:a16="http://schemas.microsoft.com/office/drawing/2014/main" id="{D3CEAFF1-A3A8-4621-84A0-068238215CDF}"/>
               </a:ext>
             </a:extLst>
           </p:cNvPr>
@@ -15828,7 +15838,7 @@
           <p:cNvPr id="4" name="">
             <a:extLst xmlns:a="http://schemas.openxmlformats.org/drawingml/2006/main">
               <a:ext uri="{FF2B5EF4-FFF2-40B4-BE49-F238E27FC236}">
-                <a16:creationId xmlns:a16="http://schemas.microsoft.com/office/drawing/2014/main" id="{0539BFAA-A1BA-432C-87F0-8E7F8E082A33}"/>
+                <a16:creationId xmlns:a16="http://schemas.microsoft.com/office/drawing/2014/main" id="{EF6C74E9-A98D-4437-8D19-159651F71C33}"/>
               </a:ext>
             </a:extLst>
           </p:cNvPr>
@@ -15984,7 +15994,7 @@
           <p:cNvPr id="5" name="">
             <a:extLst xmlns:a="http://schemas.openxmlformats.org/drawingml/2006/main">
               <a:ext uri="{FF2B5EF4-FFF2-40B4-BE49-F238E27FC236}">
-                <a16:creationId xmlns:a16="http://schemas.microsoft.com/office/drawing/2014/main" id="{35656D08-3AAA-48CF-919A-D1F738D0322E}"/>
+                <a16:creationId xmlns:a16="http://schemas.microsoft.com/office/drawing/2014/main" id="{4F06F549-82C9-47E0-8164-EB2E86E09206}"/>
               </a:ext>
             </a:extLst>
           </p:cNvPr>
@@ -15994,7 +16004,7 @@
           <p:nvPr/>
         </p:nvPicPr>
         <p:blipFill>
-          <a:blip xmlns:r="http://schemas.openxmlformats.org/officeDocument/2006/relationships" xmlns:a="http://schemas.openxmlformats.org/drawingml/2006/main" r:embed="Rcabb0e4ee24c47bc"/>
+          <a:blip xmlns:r="http://schemas.openxmlformats.org/officeDocument/2006/relationships" xmlns:a="http://schemas.openxmlformats.org/drawingml/2006/main" r:embed="R19daf8246b8446b1"/>
           <a:stretch xmlns:a="http://schemas.openxmlformats.org/drawingml/2006/main"/>
         </p:blipFill>
         <p:spPr>
@@ -16012,7 +16022,7 @@
           <p:cNvPr id="6" name="">
             <a:extLst xmlns:a="http://schemas.openxmlformats.org/drawingml/2006/main">
               <a:ext uri="{FF2B5EF4-FFF2-40B4-BE49-F238E27FC236}">
-                <a16:creationId xmlns:a16="http://schemas.microsoft.com/office/drawing/2014/main" id="{1423B247-FF4B-45EE-87F7-193D506C3B48}"/>
+                <a16:creationId xmlns:a16="http://schemas.microsoft.com/office/drawing/2014/main" id="{5793850A-F43D-4E05-8927-1E3762CEE349}"/>
               </a:ext>
             </a:extLst>
           </p:cNvPr>
@@ -16166,7 +16176,7 @@
     </p:spTree>
     <p:extLst>
       <p:ext uri="{BB962C8B-B14F-4D97-AF65-F5344CB8AC3E}">
-        <p14:creationId xmlns:p14="http://schemas.microsoft.com/office/powerpoint/2010/main" val="1665745646"/>
+        <p14:creationId xmlns:p14="http://schemas.microsoft.com/office/powerpoint/2010/main" val="1592091853"/>
       </p:ext>
     </p:extLst>
   </p:cSld>
@@ -16197,7 +16207,7 @@
           <p:cNvPr id="7" name="">
             <a:extLst xmlns:a="http://schemas.openxmlformats.org/drawingml/2006/main">
               <a:ext uri="{FF2B5EF4-FFF2-40B4-BE49-F238E27FC236}">
-                <a16:creationId xmlns:a16="http://schemas.microsoft.com/office/drawing/2014/main" id="{4E69140C-BB55-4EDA-92ED-53949BF758F7}"/>
+                <a16:creationId xmlns:a16="http://schemas.microsoft.com/office/drawing/2014/main" id="{F9F56164-34B3-4DA6-A128-8FA43E59D507}"/>
               </a:ext>
             </a:extLst>
           </p:cNvPr>
@@ -16353,7 +16363,7 @@
           <p:cNvPr id="2" name="">
             <a:extLst xmlns:a="http://schemas.openxmlformats.org/drawingml/2006/main">
               <a:ext uri="{FF2B5EF4-FFF2-40B4-BE49-F238E27FC236}">
-                <a16:creationId xmlns:a16="http://schemas.microsoft.com/office/drawing/2014/main" id="{3BE8B98C-98AA-4A30-916A-B2CB39385F9D}"/>
+                <a16:creationId xmlns:a16="http://schemas.microsoft.com/office/drawing/2014/main" id="{4CA07AEF-676B-4B04-9823-58EFA8D8D1B1}"/>
               </a:ext>
             </a:extLst>
           </p:cNvPr>
@@ -16509,7 +16519,7 @@
           <p:cNvPr id="3" name="">
             <a:extLst xmlns:a="http://schemas.openxmlformats.org/drawingml/2006/main">
               <a:ext uri="{FF2B5EF4-FFF2-40B4-BE49-F238E27FC236}">
-                <a16:creationId xmlns:a16="http://schemas.microsoft.com/office/drawing/2014/main" id="{81A1EF2C-49E1-4318-A608-70D690A82169}"/>
+                <a16:creationId xmlns:a16="http://schemas.microsoft.com/office/drawing/2014/main" id="{E351E0CA-A959-40A6-9EA3-1DE8DCA7D5FA}"/>
               </a:ext>
             </a:extLst>
           </p:cNvPr>
@@ -16649,7 +16659,7 @@
           <p:cNvPr id="4" name="">
             <a:extLst xmlns:a="http://schemas.openxmlformats.org/drawingml/2006/main">
               <a:ext uri="{FF2B5EF4-FFF2-40B4-BE49-F238E27FC236}">
-                <a16:creationId xmlns:a16="http://schemas.microsoft.com/office/drawing/2014/main" id="{A5885DCC-F3D6-4A2F-9199-067FCE5F52D8}"/>
+                <a16:creationId xmlns:a16="http://schemas.microsoft.com/office/drawing/2014/main" id="{5292B07A-2AE3-47BD-A534-A59B2ABE6F17}"/>
               </a:ext>
             </a:extLst>
           </p:cNvPr>
@@ -16805,7 +16815,7 @@
           <p:cNvPr id="5" name="">
             <a:extLst xmlns:a="http://schemas.openxmlformats.org/drawingml/2006/main">
               <a:ext uri="{FF2B5EF4-FFF2-40B4-BE49-F238E27FC236}">
-                <a16:creationId xmlns:a16="http://schemas.microsoft.com/office/drawing/2014/main" id="{7010217F-CFF5-4091-845F-A50F99EB5737}"/>
+                <a16:creationId xmlns:a16="http://schemas.microsoft.com/office/drawing/2014/main" id="{A033017C-898C-4C7B-A44E-8C846C372D36}"/>
               </a:ext>
             </a:extLst>
           </p:cNvPr>
@@ -16815,7 +16825,7 @@
           <p:nvPr/>
         </p:nvPicPr>
         <p:blipFill>
-          <a:blip xmlns:r="http://schemas.openxmlformats.org/officeDocument/2006/relationships" xmlns:a="http://schemas.openxmlformats.org/drawingml/2006/main" r:embed="Raa6c71087cd24716"/>
+          <a:blip xmlns:r="http://schemas.openxmlformats.org/officeDocument/2006/relationships" xmlns:a="http://schemas.openxmlformats.org/drawingml/2006/main" r:embed="Ree598182099149b8"/>
           <a:stretch xmlns:a="http://schemas.openxmlformats.org/drawingml/2006/main"/>
         </p:blipFill>
         <p:spPr>
@@ -16833,7 +16843,7 @@
           <p:cNvPr id="6" name="">
             <a:extLst xmlns:a="http://schemas.openxmlformats.org/drawingml/2006/main">
               <a:ext uri="{FF2B5EF4-FFF2-40B4-BE49-F238E27FC236}">
-                <a16:creationId xmlns:a16="http://schemas.microsoft.com/office/drawing/2014/main" id="{FC10209F-54FF-45BA-BFDC-5501ECEB203E}"/>
+                <a16:creationId xmlns:a16="http://schemas.microsoft.com/office/drawing/2014/main" id="{17EFFAB7-7F55-47DE-A3F3-7206D7AB54D8}"/>
               </a:ext>
             </a:extLst>
           </p:cNvPr>
@@ -16987,7 +16997,7 @@
     </p:spTree>
     <p:extLst>
       <p:ext uri="{BB962C8B-B14F-4D97-AF65-F5344CB8AC3E}">
-        <p14:creationId xmlns:p14="http://schemas.microsoft.com/office/powerpoint/2010/main" val="285159511"/>
+        <p14:creationId xmlns:p14="http://schemas.microsoft.com/office/powerpoint/2010/main" val="482112205"/>
       </p:ext>
     </p:extLst>
   </p:cSld>
@@ -17018,7 +17028,7 @@
           <p:cNvPr id="7" name="">
             <a:extLst xmlns:a="http://schemas.openxmlformats.org/drawingml/2006/main">
               <a:ext uri="{FF2B5EF4-FFF2-40B4-BE49-F238E27FC236}">
-                <a16:creationId xmlns:a16="http://schemas.microsoft.com/office/drawing/2014/main" id="{A7F0E652-7572-4E07-A698-ED165BE7CF5A}"/>
+                <a16:creationId xmlns:a16="http://schemas.microsoft.com/office/drawing/2014/main" id="{629645B0-AC21-4D8A-84BE-1CA847392D7B}"/>
               </a:ext>
             </a:extLst>
           </p:cNvPr>
@@ -17174,7 +17184,7 @@
           <p:cNvPr id="2" name="">
             <a:extLst xmlns:a="http://schemas.openxmlformats.org/drawingml/2006/main">
               <a:ext uri="{FF2B5EF4-FFF2-40B4-BE49-F238E27FC236}">
-                <a16:creationId xmlns:a16="http://schemas.microsoft.com/office/drawing/2014/main" id="{372B8ECC-B415-4CC0-B987-FC70F772590D}"/>
+                <a16:creationId xmlns:a16="http://schemas.microsoft.com/office/drawing/2014/main" id="{930AE3C4-FAA3-482B-86E2-F5A9CDC35991}"/>
               </a:ext>
             </a:extLst>
           </p:cNvPr>
@@ -17330,7 +17340,7 @@
           <p:cNvPr id="3" name="">
             <a:extLst xmlns:a="http://schemas.openxmlformats.org/drawingml/2006/main">
               <a:ext uri="{FF2B5EF4-FFF2-40B4-BE49-F238E27FC236}">
-                <a16:creationId xmlns:a16="http://schemas.microsoft.com/office/drawing/2014/main" id="{4A128A03-56D5-4855-BE9E-B71F99670131}"/>
+                <a16:creationId xmlns:a16="http://schemas.microsoft.com/office/drawing/2014/main" id="{315ED9AD-DF88-4DA7-AA12-1A71B43F6D2F}"/>
               </a:ext>
             </a:extLst>
           </p:cNvPr>
@@ -17470,7 +17480,7 @@
           <p:cNvPr id="4" name="">
             <a:extLst xmlns:a="http://schemas.openxmlformats.org/drawingml/2006/main">
               <a:ext uri="{FF2B5EF4-FFF2-40B4-BE49-F238E27FC236}">
-                <a16:creationId xmlns:a16="http://schemas.microsoft.com/office/drawing/2014/main" id="{27C9BD08-FFC0-428C-9B8A-BC27FB7448F0}"/>
+                <a16:creationId xmlns:a16="http://schemas.microsoft.com/office/drawing/2014/main" id="{1A7CD9B5-8F14-441A-BB90-F2AF33709EB4}"/>
               </a:ext>
             </a:extLst>
           </p:cNvPr>
@@ -17626,7 +17636,7 @@
           <p:cNvPr id="5" name="">
             <a:extLst xmlns:a="http://schemas.openxmlformats.org/drawingml/2006/main">
               <a:ext uri="{FF2B5EF4-FFF2-40B4-BE49-F238E27FC236}">
-                <a16:creationId xmlns:a16="http://schemas.microsoft.com/office/drawing/2014/main" id="{700B95B2-C12B-43B0-9662-066DB60F4D44}"/>
+                <a16:creationId xmlns:a16="http://schemas.microsoft.com/office/drawing/2014/main" id="{5D571468-74CE-4C1A-ABEB-038F67680ACC}"/>
               </a:ext>
             </a:extLst>
           </p:cNvPr>
@@ -18485,7 +18495,7 @@
           <p:cNvPr id="6" name="">
             <a:extLst xmlns:a="http://schemas.openxmlformats.org/drawingml/2006/main">
               <a:ext uri="{FF2B5EF4-FFF2-40B4-BE49-F238E27FC236}">
-                <a16:creationId xmlns:a16="http://schemas.microsoft.com/office/drawing/2014/main" id="{E81DEE94-8658-4D01-8F7A-40F33373329C}"/>
+                <a16:creationId xmlns:a16="http://schemas.microsoft.com/office/drawing/2014/main" id="{3B4361DA-CEE8-4E4C-A2AD-12B018E0D1FB}"/>
               </a:ext>
             </a:extLst>
           </p:cNvPr>
@@ -18639,7 +18649,7 @@
     </p:spTree>
     <p:extLst>
       <p:ext uri="{BB962C8B-B14F-4D97-AF65-F5344CB8AC3E}">
-        <p14:creationId xmlns:p14="http://schemas.microsoft.com/office/powerpoint/2010/main" val="1548061023"/>
+        <p14:creationId xmlns:p14="http://schemas.microsoft.com/office/powerpoint/2010/main" val="1130384129"/>
       </p:ext>
     </p:extLst>
   </p:cSld>

</xml_diff>

<commit_message>
Validate larger-input TC control and preserve worsened CDF agreement
</commit_message>
<xml_diff>
--- a/presentation/CSLab_Memory_Tiering_Current.pptx
+++ b/presentation/CSLab_Memory_Tiering_Current.pptx
@@ -2,27 +2,27 @@
 <file path=ppt/presentation.xml><?xml version="1.0" encoding="utf-8"?>
 <p:presentation xmlns:p="http://schemas.openxmlformats.org/presentationml/2006/main">
   <p:sldMasterIdLst>
-    <p:sldMasterId xmlns:r="http://schemas.openxmlformats.org/officeDocument/2006/relationships" id="2147483648" r:id="R78a29d282df84a2d"/>
+    <p:sldMasterId xmlns:r="http://schemas.openxmlformats.org/officeDocument/2006/relationships" id="2147483648" r:id="Rd44f624bf6fd4d67"/>
   </p:sldMasterIdLst>
   <p:notesMasterIdLst>
-    <p:notesMasterId xmlns:r="http://schemas.openxmlformats.org/officeDocument/2006/relationships" r:id="Rc9a74fb3c1d6478c"/>
+    <p:notesMasterId xmlns:r="http://schemas.openxmlformats.org/officeDocument/2006/relationships" r:id="R9486e60e64564194"/>
   </p:notesMasterIdLst>
   <p:sldIdLst>
-    <p:sldId xmlns:r="http://schemas.openxmlformats.org/officeDocument/2006/relationships" id="256" r:id="R5db86bebbf7842b6"/>
-    <p:sldId xmlns:r="http://schemas.openxmlformats.org/officeDocument/2006/relationships" id="257" r:id="R0f2e763440c64a59"/>
-    <p:sldId xmlns:r="http://schemas.openxmlformats.org/officeDocument/2006/relationships" id="258" r:id="R712da693642b432f"/>
-    <p:sldId xmlns:r="http://schemas.openxmlformats.org/officeDocument/2006/relationships" id="259" r:id="R370516eb26ad4fc0"/>
-    <p:sldId xmlns:r="http://schemas.openxmlformats.org/officeDocument/2006/relationships" id="260" r:id="R23e0ba582f614b8a"/>
-    <p:sldId xmlns:r="http://schemas.openxmlformats.org/officeDocument/2006/relationships" id="261" r:id="R2f1ef70554214e56"/>
-    <p:sldId xmlns:r="http://schemas.openxmlformats.org/officeDocument/2006/relationships" id="262" r:id="Rdf80b18cf5984c46"/>
-    <p:sldId xmlns:r="http://schemas.openxmlformats.org/officeDocument/2006/relationships" id="263" r:id="R853a8fb8cc104cc5"/>
-    <p:sldId xmlns:r="http://schemas.openxmlformats.org/officeDocument/2006/relationships" id="264" r:id="Rdf06ab986ac14aad"/>
-    <p:sldId xmlns:r="http://schemas.openxmlformats.org/officeDocument/2006/relationships" id="265" r:id="R2bc719452bb241c2"/>
-    <p:sldId xmlns:r="http://schemas.openxmlformats.org/officeDocument/2006/relationships" id="266" r:id="Rcaeab6ceadf842d9"/>
-    <p:sldId xmlns:r="http://schemas.openxmlformats.org/officeDocument/2006/relationships" id="267" r:id="R5f9cd2e99c644df2"/>
-    <p:sldId xmlns:r="http://schemas.openxmlformats.org/officeDocument/2006/relationships" id="268" r:id="Rc80ee385e7ba4a9d"/>
-    <p:sldId xmlns:r="http://schemas.openxmlformats.org/officeDocument/2006/relationships" id="269" r:id="R13fbcfd9d9d74162"/>
-    <p:sldId xmlns:r="http://schemas.openxmlformats.org/officeDocument/2006/relationships" id="270" r:id="R86aa25bbc8aa4a48"/>
+    <p:sldId xmlns:r="http://schemas.openxmlformats.org/officeDocument/2006/relationships" id="256" r:id="R4ae9f2cc56b342ab"/>
+    <p:sldId xmlns:r="http://schemas.openxmlformats.org/officeDocument/2006/relationships" id="257" r:id="Re0de712f80e34921"/>
+    <p:sldId xmlns:r="http://schemas.openxmlformats.org/officeDocument/2006/relationships" id="258" r:id="R84b4243d64174da3"/>
+    <p:sldId xmlns:r="http://schemas.openxmlformats.org/officeDocument/2006/relationships" id="259" r:id="Rc25ff0bdffba4b69"/>
+    <p:sldId xmlns:r="http://schemas.openxmlformats.org/officeDocument/2006/relationships" id="260" r:id="R742f94f5e63d47aa"/>
+    <p:sldId xmlns:r="http://schemas.openxmlformats.org/officeDocument/2006/relationships" id="261" r:id="Rd7a10badcc6f4d52"/>
+    <p:sldId xmlns:r="http://schemas.openxmlformats.org/officeDocument/2006/relationships" id="262" r:id="Rcc99dae05045432e"/>
+    <p:sldId xmlns:r="http://schemas.openxmlformats.org/officeDocument/2006/relationships" id="263" r:id="R6037f7ec827b40df"/>
+    <p:sldId xmlns:r="http://schemas.openxmlformats.org/officeDocument/2006/relationships" id="264" r:id="R9492df12b4e241ba"/>
+    <p:sldId xmlns:r="http://schemas.openxmlformats.org/officeDocument/2006/relationships" id="265" r:id="R8dad5b478791420f"/>
+    <p:sldId xmlns:r="http://schemas.openxmlformats.org/officeDocument/2006/relationships" id="266" r:id="R3025e00a35e54070"/>
+    <p:sldId xmlns:r="http://schemas.openxmlformats.org/officeDocument/2006/relationships" id="267" r:id="R5b84e2fc4f1e449c"/>
+    <p:sldId xmlns:r="http://schemas.openxmlformats.org/officeDocument/2006/relationships" id="268" r:id="R1efee1fda49644c6"/>
+    <p:sldId xmlns:r="http://schemas.openxmlformats.org/officeDocument/2006/relationships" id="269" r:id="Rc933bd6fddfa4df4"/>
+    <p:sldId xmlns:r="http://schemas.openxmlformats.org/officeDocument/2006/relationships" id="270" r:id="R1a63a88c652041ab"/>
   </p:sldIdLst>
   <p:sldSz cx="12192000" cy="6858000"/>
   <p:notesSz cx="6858000" cy="9144000"/>
@@ -636,7 +636,7 @@
           </a:p>
           <a:p xmlns:a="http://schemas.openxmlformats.org/drawingml/2006/main">
             <a:r>
-              <a:t>TC native RSS: 8.89 GB, στόχος 5.0 GB. Εντός ανοχής: false. Η επιλογή έγινε μόνο με RSS. Δεν το παρουσιάζουμε ως size-matched reproduction.</a:t>
+              <a:t>TC native RSS: 8.89 GB, στόχος 5.0 GB. Εντός ανοχής: false. Η επιλογή έγινε μόνο με RSS. Δεν το παρουσιάζουμε ως size-matched reproduction. Το ολοκληρωμένο one-thread control έχει pooled miss σφάλμα 53.87 μ.μ., χειρότερο από τις 34,87 μ.μ. του μικρότερου input. Το twenty-thread control παραμένει ξεχωριστό.</a:t>
             </a:r>
           </a:p>
         </p:txBody>
@@ -1643,7 +1643,7 @@
           <p:cNvPr id="3" name="Title">
             <a:extLst xmlns:a="http://schemas.openxmlformats.org/drawingml/2006/main">
               <a:ext uri="{FF2B5EF4-FFF2-40B4-BE49-F238E27FC236}">
-                <a16:creationId xmlns:a16="http://schemas.microsoft.com/office/drawing/2014/main" id="{E6DB9BE8-5AA2-4307-8C6B-60419652A335}"/>
+                <a16:creationId xmlns:a16="http://schemas.microsoft.com/office/drawing/2014/main" id="{4B75C78F-2364-4C05-B7CF-6E7561EF9343}"/>
               </a:ext>
             </a:extLst>
           </p:cNvPr>
@@ -1872,7 +1872,7 @@
           <p:cNvPr id="2" name="Subtitle">
             <a:extLst xmlns:a="http://schemas.openxmlformats.org/drawingml/2006/main">
               <a:ext uri="{FF2B5EF4-FFF2-40B4-BE49-F238E27FC236}">
-                <a16:creationId xmlns:a16="http://schemas.microsoft.com/office/drawing/2014/main" id="{F0B9A332-4DC2-4D02-AAE5-1D1062E365BF}"/>
+                <a16:creationId xmlns:a16="http://schemas.microsoft.com/office/drawing/2014/main" id="{39FCE63E-7D5A-4A67-A349-685678361647}"/>
               </a:ext>
             </a:extLst>
           </p:cNvPr>
@@ -2118,7 +2118,7 @@
           <p:cNvPr id="2" name="Section title">
             <a:extLst xmlns:a="http://schemas.openxmlformats.org/drawingml/2006/main">
               <a:ext uri="{FF2B5EF4-FFF2-40B4-BE49-F238E27FC236}">
-                <a16:creationId xmlns:a16="http://schemas.microsoft.com/office/drawing/2014/main" id="{E8C5978A-6634-497D-A06A-18FBE95B432F}"/>
+                <a16:creationId xmlns:a16="http://schemas.microsoft.com/office/drawing/2014/main" id="{5C47DB5B-2567-4EC4-B00C-AB4596C52654}"/>
               </a:ext>
             </a:extLst>
           </p:cNvPr>
@@ -2364,7 +2364,7 @@
           <p:cNvPr id="3" name="Title">
             <a:extLst xmlns:a="http://schemas.openxmlformats.org/drawingml/2006/main">
               <a:ext uri="{FF2B5EF4-FFF2-40B4-BE49-F238E27FC236}">
-                <a16:creationId xmlns:a16="http://schemas.microsoft.com/office/drawing/2014/main" id="{5E2BA4CD-F286-4313-AC63-4B691B58788E}"/>
+                <a16:creationId xmlns:a16="http://schemas.microsoft.com/office/drawing/2014/main" id="{E0AECF8D-8290-4557-9171-FB40F788AC19}"/>
               </a:ext>
             </a:extLst>
           </p:cNvPr>
@@ -2593,7 +2593,7 @@
           <p:cNvPr id="2" name="Body">
             <a:extLst xmlns:a="http://schemas.openxmlformats.org/drawingml/2006/main">
               <a:ext uri="{FF2B5EF4-FFF2-40B4-BE49-F238E27FC236}">
-                <a16:creationId xmlns:a16="http://schemas.microsoft.com/office/drawing/2014/main" id="{E8FED702-825B-42EE-9061-69E6AA0DD5BF}"/>
+                <a16:creationId xmlns:a16="http://schemas.microsoft.com/office/drawing/2014/main" id="{4D8173A0-47EC-452B-9E53-687247FEEFFC}"/>
               </a:ext>
             </a:extLst>
           </p:cNvPr>
@@ -2839,7 +2839,7 @@
           <p:cNvPr id="4" name="Title">
             <a:extLst xmlns:a="http://schemas.openxmlformats.org/drawingml/2006/main">
               <a:ext uri="{FF2B5EF4-FFF2-40B4-BE49-F238E27FC236}">
-                <a16:creationId xmlns:a16="http://schemas.microsoft.com/office/drawing/2014/main" id="{5F15559D-8A26-43D2-9704-F0F7D9CCAB0F}"/>
+                <a16:creationId xmlns:a16="http://schemas.microsoft.com/office/drawing/2014/main" id="{FC549BD4-291F-411B-98E3-417BA60273D9}"/>
               </a:ext>
             </a:extLst>
           </p:cNvPr>
@@ -3068,7 +3068,7 @@
           <p:cNvPr id="2" name="Left column">
             <a:extLst xmlns:a="http://schemas.openxmlformats.org/drawingml/2006/main">
               <a:ext uri="{FF2B5EF4-FFF2-40B4-BE49-F238E27FC236}">
-                <a16:creationId xmlns:a16="http://schemas.microsoft.com/office/drawing/2014/main" id="{5F375E2C-CAD2-41CD-8C6A-E641CD400420}"/>
+                <a16:creationId xmlns:a16="http://schemas.microsoft.com/office/drawing/2014/main" id="{EAC2D3A3-3114-4D95-8596-6419640D1DE0}"/>
               </a:ext>
             </a:extLst>
           </p:cNvPr>
@@ -3297,7 +3297,7 @@
           <p:cNvPr id="3" name="Right column">
             <a:extLst xmlns:a="http://schemas.openxmlformats.org/drawingml/2006/main">
               <a:ext uri="{FF2B5EF4-FFF2-40B4-BE49-F238E27FC236}">
-                <a16:creationId xmlns:a16="http://schemas.microsoft.com/office/drawing/2014/main" id="{C1FDF0D4-21D9-4665-AB4E-45E39F405160}"/>
+                <a16:creationId xmlns:a16="http://schemas.microsoft.com/office/drawing/2014/main" id="{C5EE0F4B-F6F9-4EEC-BF9A-47B58153EC4F}"/>
               </a:ext>
             </a:extLst>
           </p:cNvPr>
@@ -3543,7 +3543,7 @@
           <p:cNvPr id="3" name="Title">
             <a:extLst xmlns:a="http://schemas.openxmlformats.org/drawingml/2006/main">
               <a:ext uri="{FF2B5EF4-FFF2-40B4-BE49-F238E27FC236}">
-                <a16:creationId xmlns:a16="http://schemas.microsoft.com/office/drawing/2014/main" id="{E2CEAD79-A362-40EF-AE0D-C408CBE6D4BC}"/>
+                <a16:creationId xmlns:a16="http://schemas.microsoft.com/office/drawing/2014/main" id="{97C1CA1E-0318-49F1-A4C6-AF36BF771DAA}"/>
               </a:ext>
             </a:extLst>
           </p:cNvPr>
@@ -3772,7 +3772,7 @@
           <p:cNvPr id="2" name="Left column">
             <a:extLst xmlns:a="http://schemas.openxmlformats.org/drawingml/2006/main">
               <a:ext uri="{FF2B5EF4-FFF2-40B4-BE49-F238E27FC236}">
-                <a16:creationId xmlns:a16="http://schemas.microsoft.com/office/drawing/2014/main" id="{B4DB354F-3639-4516-AE97-C8293A7DD219}"/>
+                <a16:creationId xmlns:a16="http://schemas.microsoft.com/office/drawing/2014/main" id="{5AA06CB2-CAAB-4909-8512-67F755B0D75B}"/>
               </a:ext>
             </a:extLst>
           </p:cNvPr>
@@ -4039,12 +4039,12 @@
   </p:cSld>
   <p:clrMap bg1="lt1" tx1="dk1" bg2="lt2" tx2="dk2" accent1="accent1" accent2="accent2" accent3="accent3" accent4="accent4" accent5="accent5" accent6="accent6" hlink="hlink" folHlink="folHlink"/>
   <p:sldLayoutIdLst>
-    <p:sldLayoutId xmlns:r="http://schemas.openxmlformats.org/officeDocument/2006/relationships" id="2147483649" r:id="Rd6a74743f95047ba"/>
-    <p:sldLayoutId xmlns:r="http://schemas.openxmlformats.org/officeDocument/2006/relationships" id="2147483650" r:id="R36b651d0f8ae4afb"/>
-    <p:sldLayoutId xmlns:r="http://schemas.openxmlformats.org/officeDocument/2006/relationships" id="2147483651" r:id="R819a71b8e1d647cb"/>
-    <p:sldLayoutId xmlns:r="http://schemas.openxmlformats.org/officeDocument/2006/relationships" id="2147483652" r:id="R4e2e38be593b4cf1"/>
-    <p:sldLayoutId xmlns:r="http://schemas.openxmlformats.org/officeDocument/2006/relationships" id="2147483653" r:id="R44f33a452a064e40"/>
-    <p:sldLayoutId xmlns:r="http://schemas.openxmlformats.org/officeDocument/2006/relationships" id="2147483654" r:id="Rb8f7227aa2994341"/>
+    <p:sldLayoutId xmlns:r="http://schemas.openxmlformats.org/officeDocument/2006/relationships" id="2147483649" r:id="R4a20085b1ff54878"/>
+    <p:sldLayoutId xmlns:r="http://schemas.openxmlformats.org/officeDocument/2006/relationships" id="2147483650" r:id="R46da71e81c4c49e8"/>
+    <p:sldLayoutId xmlns:r="http://schemas.openxmlformats.org/officeDocument/2006/relationships" id="2147483651" r:id="Rdc3bbda750d04182"/>
+    <p:sldLayoutId xmlns:r="http://schemas.openxmlformats.org/officeDocument/2006/relationships" id="2147483652" r:id="R912f8d074fcc4ac7"/>
+    <p:sldLayoutId xmlns:r="http://schemas.openxmlformats.org/officeDocument/2006/relationships" id="2147483653" r:id="Rf8acb74a4ec045a8"/>
+    <p:sldLayoutId xmlns:r="http://schemas.openxmlformats.org/officeDocument/2006/relationships" id="2147483654" r:id="Rd01516338eea44c7"/>
   </p:sldLayoutIdLst>
   <p:txStyles>
     <p:titleStyle>
@@ -4595,7 +4595,7 @@
           <p:cNvPr id="7" name="">
             <a:extLst xmlns:a="http://schemas.openxmlformats.org/drawingml/2006/main">
               <a:ext uri="{FF2B5EF4-FFF2-40B4-BE49-F238E27FC236}">
-                <a16:creationId xmlns:a16="http://schemas.microsoft.com/office/drawing/2014/main" id="{C3B0485D-84C5-4871-A501-4E69196162F7}"/>
+                <a16:creationId xmlns:a16="http://schemas.microsoft.com/office/drawing/2014/main" id="{70677EA4-E938-4E49-8033-C339B88D62E2}"/>
               </a:ext>
             </a:extLst>
           </p:cNvPr>
@@ -4751,7 +4751,7 @@
           <p:cNvPr id="2" name="">
             <a:extLst xmlns:a="http://schemas.openxmlformats.org/drawingml/2006/main">
               <a:ext uri="{FF2B5EF4-FFF2-40B4-BE49-F238E27FC236}">
-                <a16:creationId xmlns:a16="http://schemas.microsoft.com/office/drawing/2014/main" id="{F3CB5CA5-6E05-49F5-92C8-54FF7EE33CE4}"/>
+                <a16:creationId xmlns:a16="http://schemas.microsoft.com/office/drawing/2014/main" id="{B3AF4170-BC2E-40AD-A72F-D61E7319B02E}"/>
               </a:ext>
             </a:extLst>
           </p:cNvPr>
@@ -4907,7 +4907,7 @@
           <p:cNvPr id="3" name="">
             <a:extLst xmlns:a="http://schemas.openxmlformats.org/drawingml/2006/main">
               <a:ext uri="{FF2B5EF4-FFF2-40B4-BE49-F238E27FC236}">
-                <a16:creationId xmlns:a16="http://schemas.microsoft.com/office/drawing/2014/main" id="{E1C53644-D8E0-42D1-ABC1-03AD0CF9ED59}"/>
+                <a16:creationId xmlns:a16="http://schemas.microsoft.com/office/drawing/2014/main" id="{3B61C246-88F0-4399-ACB5-8BA789DEA22F}"/>
               </a:ext>
             </a:extLst>
           </p:cNvPr>
@@ -5047,7 +5047,7 @@
           <p:cNvPr id="4" name="">
             <a:extLst xmlns:a="http://schemas.openxmlformats.org/drawingml/2006/main">
               <a:ext uri="{FF2B5EF4-FFF2-40B4-BE49-F238E27FC236}">
-                <a16:creationId xmlns:a16="http://schemas.microsoft.com/office/drawing/2014/main" id="{3ADF1852-89A0-4E00-A46A-15D3C9FBB5F7}"/>
+                <a16:creationId xmlns:a16="http://schemas.microsoft.com/office/drawing/2014/main" id="{4C344311-0EFF-4D09-BEC2-CD05FE1FBD82}"/>
               </a:ext>
             </a:extLst>
           </p:cNvPr>
@@ -5203,7 +5203,7 @@
           <p:cNvPr id="5" name="">
             <a:extLst xmlns:a="http://schemas.openxmlformats.org/drawingml/2006/main">
               <a:ext uri="{FF2B5EF4-FFF2-40B4-BE49-F238E27FC236}">
-                <a16:creationId xmlns:a16="http://schemas.microsoft.com/office/drawing/2014/main" id="{AECC2BA1-7D68-4DF8-BD18-826B2DCB6DFF}"/>
+                <a16:creationId xmlns:a16="http://schemas.microsoft.com/office/drawing/2014/main" id="{B349C4E9-C6EB-4DEC-A14E-A3E611AB7C39}"/>
               </a:ext>
             </a:extLst>
           </p:cNvPr>
@@ -5359,7 +5359,7 @@
           <p:cNvPr id="6" name="">
             <a:extLst xmlns:a="http://schemas.openxmlformats.org/drawingml/2006/main">
               <a:ext uri="{FF2B5EF4-FFF2-40B4-BE49-F238E27FC236}">
-                <a16:creationId xmlns:a16="http://schemas.microsoft.com/office/drawing/2014/main" id="{939C02D2-440B-4B90-A647-1CEBA6028923}"/>
+                <a16:creationId xmlns:a16="http://schemas.microsoft.com/office/drawing/2014/main" id="{875F1C69-2819-4982-AF9A-3F2F3845084C}"/>
               </a:ext>
             </a:extLst>
           </p:cNvPr>
@@ -5564,7 +5564,7 @@
     </p:spTree>
     <p:extLst>
       <p:ext uri="{BB962C8B-B14F-4D97-AF65-F5344CB8AC3E}">
-        <p14:creationId xmlns:p14="http://schemas.microsoft.com/office/powerpoint/2010/main" val="1279497950"/>
+        <p14:creationId xmlns:p14="http://schemas.microsoft.com/office/powerpoint/2010/main" val="1612334649"/>
       </p:ext>
     </p:extLst>
   </p:cSld>
@@ -5595,7 +5595,7 @@
           <p:cNvPr id="7" name="">
             <a:extLst xmlns:a="http://schemas.openxmlformats.org/drawingml/2006/main">
               <a:ext uri="{FF2B5EF4-FFF2-40B4-BE49-F238E27FC236}">
-                <a16:creationId xmlns:a16="http://schemas.microsoft.com/office/drawing/2014/main" id="{F16EB518-FEB1-4EAA-A4C0-326DE4589DFE}"/>
+                <a16:creationId xmlns:a16="http://schemas.microsoft.com/office/drawing/2014/main" id="{DF04DF5A-2726-4592-9D6B-8B621D4C7DC0}"/>
               </a:ext>
             </a:extLst>
           </p:cNvPr>
@@ -5751,7 +5751,7 @@
           <p:cNvPr id="2" name="">
             <a:extLst xmlns:a="http://schemas.openxmlformats.org/drawingml/2006/main">
               <a:ext uri="{FF2B5EF4-FFF2-40B4-BE49-F238E27FC236}">
-                <a16:creationId xmlns:a16="http://schemas.microsoft.com/office/drawing/2014/main" id="{F165B36A-386D-43DB-B46B-FFD4F148F6A2}"/>
+                <a16:creationId xmlns:a16="http://schemas.microsoft.com/office/drawing/2014/main" id="{7D7A64CD-6FB2-4247-8156-83CF85C5AB32}"/>
               </a:ext>
             </a:extLst>
           </p:cNvPr>
@@ -5907,7 +5907,7 @@
           <p:cNvPr id="3" name="">
             <a:extLst xmlns:a="http://schemas.openxmlformats.org/drawingml/2006/main">
               <a:ext uri="{FF2B5EF4-FFF2-40B4-BE49-F238E27FC236}">
-                <a16:creationId xmlns:a16="http://schemas.microsoft.com/office/drawing/2014/main" id="{6A774D73-35D5-4C38-9C92-F4AC018808AD}"/>
+                <a16:creationId xmlns:a16="http://schemas.microsoft.com/office/drawing/2014/main" id="{7A1F0309-CD98-4306-8F89-9464306D1D15}"/>
               </a:ext>
             </a:extLst>
           </p:cNvPr>
@@ -6047,7 +6047,7 @@
           <p:cNvPr id="4" name="">
             <a:extLst xmlns:a="http://schemas.openxmlformats.org/drawingml/2006/main">
               <a:ext uri="{FF2B5EF4-FFF2-40B4-BE49-F238E27FC236}">
-                <a16:creationId xmlns:a16="http://schemas.microsoft.com/office/drawing/2014/main" id="{5EC51214-50C1-45BC-AD1F-121BFB1EFB80}"/>
+                <a16:creationId xmlns:a16="http://schemas.microsoft.com/office/drawing/2014/main" id="{40667B13-0F4E-47C0-9D61-48B3BD399C12}"/>
               </a:ext>
             </a:extLst>
           </p:cNvPr>
@@ -6203,7 +6203,7 @@
           <p:cNvPr id="5" name="">
             <a:extLst xmlns:a="http://schemas.openxmlformats.org/drawingml/2006/main">
               <a:ext uri="{FF2B5EF4-FFF2-40B4-BE49-F238E27FC236}">
-                <a16:creationId xmlns:a16="http://schemas.microsoft.com/office/drawing/2014/main" id="{B5A60028-33C9-4B37-A331-865C32D3073D}"/>
+                <a16:creationId xmlns:a16="http://schemas.microsoft.com/office/drawing/2014/main" id="{1C504896-50A8-414F-BC6C-1F942395F81A}"/>
               </a:ext>
             </a:extLst>
           </p:cNvPr>
@@ -6382,7 +6382,7 @@
           <p:cNvPr id="6" name="">
             <a:extLst xmlns:a="http://schemas.openxmlformats.org/drawingml/2006/main">
               <a:ext uri="{FF2B5EF4-FFF2-40B4-BE49-F238E27FC236}">
-                <a16:creationId xmlns:a16="http://schemas.microsoft.com/office/drawing/2014/main" id="{0BC4D704-B0C9-499A-A889-49DF5699BDC1}"/>
+                <a16:creationId xmlns:a16="http://schemas.microsoft.com/office/drawing/2014/main" id="{5B6A9EDB-521B-4778-ACC7-E13B8EF2F3DC}"/>
               </a:ext>
             </a:extLst>
           </p:cNvPr>
@@ -6564,7 +6564,7 @@
     </p:spTree>
     <p:extLst>
       <p:ext uri="{BB962C8B-B14F-4D97-AF65-F5344CB8AC3E}">
-        <p14:creationId xmlns:p14="http://schemas.microsoft.com/office/powerpoint/2010/main" val="570148348"/>
+        <p14:creationId xmlns:p14="http://schemas.microsoft.com/office/powerpoint/2010/main" val="70988619"/>
       </p:ext>
     </p:extLst>
   </p:cSld>
@@ -6595,7 +6595,7 @@
           <p:cNvPr id="7" name="">
             <a:extLst xmlns:a="http://schemas.openxmlformats.org/drawingml/2006/main">
               <a:ext uri="{FF2B5EF4-FFF2-40B4-BE49-F238E27FC236}">
-                <a16:creationId xmlns:a16="http://schemas.microsoft.com/office/drawing/2014/main" id="{E0FA1632-7120-41A5-8879-D2CE0C576615}"/>
+                <a16:creationId xmlns:a16="http://schemas.microsoft.com/office/drawing/2014/main" id="{28AD6490-6BC0-4B9B-9C3A-FF104FFE1509}"/>
               </a:ext>
             </a:extLst>
           </p:cNvPr>
@@ -6751,7 +6751,7 @@
           <p:cNvPr id="2" name="">
             <a:extLst xmlns:a="http://schemas.openxmlformats.org/drawingml/2006/main">
               <a:ext uri="{FF2B5EF4-FFF2-40B4-BE49-F238E27FC236}">
-                <a16:creationId xmlns:a16="http://schemas.microsoft.com/office/drawing/2014/main" id="{E6282FFD-D2EF-44F8-9C52-86B5F456F9A2}"/>
+                <a16:creationId xmlns:a16="http://schemas.microsoft.com/office/drawing/2014/main" id="{0DA00A07-146E-4E2E-83CE-C7EE00E40DFE}"/>
               </a:ext>
             </a:extLst>
           </p:cNvPr>
@@ -6907,7 +6907,7 @@
           <p:cNvPr id="3" name="">
             <a:extLst xmlns:a="http://schemas.openxmlformats.org/drawingml/2006/main">
               <a:ext uri="{FF2B5EF4-FFF2-40B4-BE49-F238E27FC236}">
-                <a16:creationId xmlns:a16="http://schemas.microsoft.com/office/drawing/2014/main" id="{A4877E8F-F960-4D21-8D9B-FC1CDA6B5413}"/>
+                <a16:creationId xmlns:a16="http://schemas.microsoft.com/office/drawing/2014/main" id="{9EE8CADC-D664-47D4-90E6-556097480459}"/>
               </a:ext>
             </a:extLst>
           </p:cNvPr>
@@ -7047,7 +7047,7 @@
           <p:cNvPr id="4" name="">
             <a:extLst xmlns:a="http://schemas.openxmlformats.org/drawingml/2006/main">
               <a:ext uri="{FF2B5EF4-FFF2-40B4-BE49-F238E27FC236}">
-                <a16:creationId xmlns:a16="http://schemas.microsoft.com/office/drawing/2014/main" id="{7F11D295-536F-4184-B2BA-A0C421E4EB58}"/>
+                <a16:creationId xmlns:a16="http://schemas.microsoft.com/office/drawing/2014/main" id="{ED325962-B41A-4701-BB7D-4B9991DA0B37}"/>
               </a:ext>
             </a:extLst>
           </p:cNvPr>
@@ -7203,7 +7203,7 @@
           <p:cNvPr id="5" name="">
             <a:extLst xmlns:a="http://schemas.openxmlformats.org/drawingml/2006/main">
               <a:ext uri="{FF2B5EF4-FFF2-40B4-BE49-F238E27FC236}">
-                <a16:creationId xmlns:a16="http://schemas.microsoft.com/office/drawing/2014/main" id="{492AB599-9158-4819-9EE0-398A1CD17182}"/>
+                <a16:creationId xmlns:a16="http://schemas.microsoft.com/office/drawing/2014/main" id="{26D07703-23F1-4CA7-AC58-1D36EDE133B5}"/>
               </a:ext>
             </a:extLst>
           </p:cNvPr>
@@ -7213,7 +7213,7 @@
           <p:nvPr/>
         </p:nvPicPr>
         <p:blipFill>
-          <a:blip xmlns:r="http://schemas.openxmlformats.org/officeDocument/2006/relationships" xmlns:a="http://schemas.openxmlformats.org/drawingml/2006/main" r:embed="R089b999c15044162"/>
+          <a:blip xmlns:r="http://schemas.openxmlformats.org/officeDocument/2006/relationships" xmlns:a="http://schemas.openxmlformats.org/drawingml/2006/main" r:embed="Rfc8b32e8c6bf4ada"/>
           <a:stretch xmlns:a="http://schemas.openxmlformats.org/drawingml/2006/main"/>
         </p:blipFill>
         <p:spPr>
@@ -7231,7 +7231,7 @@
           <p:cNvPr id="6" name="">
             <a:extLst xmlns:a="http://schemas.openxmlformats.org/drawingml/2006/main">
               <a:ext uri="{FF2B5EF4-FFF2-40B4-BE49-F238E27FC236}">
-                <a16:creationId xmlns:a16="http://schemas.microsoft.com/office/drawing/2014/main" id="{342784F0-93CE-4D17-9C8D-A11E2D3CA5C3}"/>
+                <a16:creationId xmlns:a16="http://schemas.microsoft.com/office/drawing/2014/main" id="{B0212CE2-F2AE-40B2-A41F-97F75943D675}"/>
               </a:ext>
             </a:extLst>
           </p:cNvPr>
@@ -7377,7 +7377,7 @@
                 <a:ea typeface="Noto Sans"/>
                 <a:cs typeface="Noto Sans"/>
               </a:rPr>
-              <a:t>Reference-selected, όχι ανεξάρτητη replication. Έλεγχοι: 13 / 21. Όλες οι δοκιμές διατηρούνται.</a:t>
+              <a:t>Reference-selected, όχι ανεξάρτητη replication. Έλεγχοι: 14 / 21. Όλες οι δοκιμές διατηρούνται.</a:t>
             </a:r>
           </a:p>
         </p:txBody>
@@ -7385,7 +7385,7 @@
     </p:spTree>
     <p:extLst>
       <p:ext uri="{BB962C8B-B14F-4D97-AF65-F5344CB8AC3E}">
-        <p14:creationId xmlns:p14="http://schemas.microsoft.com/office/powerpoint/2010/main" val="1624483331"/>
+        <p14:creationId xmlns:p14="http://schemas.microsoft.com/office/powerpoint/2010/main" val="1961797703"/>
       </p:ext>
     </p:extLst>
   </p:cSld>
@@ -7416,7 +7416,7 @@
           <p:cNvPr id="7" name="">
             <a:extLst xmlns:a="http://schemas.openxmlformats.org/drawingml/2006/main">
               <a:ext uri="{FF2B5EF4-FFF2-40B4-BE49-F238E27FC236}">
-                <a16:creationId xmlns:a16="http://schemas.microsoft.com/office/drawing/2014/main" id="{E3AB70AD-D6DF-453F-9510-7F132F921500}"/>
+                <a16:creationId xmlns:a16="http://schemas.microsoft.com/office/drawing/2014/main" id="{B6E12BCF-0B93-4F25-8834-0FA8213A9020}"/>
               </a:ext>
             </a:extLst>
           </p:cNvPr>
@@ -7572,7 +7572,7 @@
           <p:cNvPr id="2" name="">
             <a:extLst xmlns:a="http://schemas.openxmlformats.org/drawingml/2006/main">
               <a:ext uri="{FF2B5EF4-FFF2-40B4-BE49-F238E27FC236}">
-                <a16:creationId xmlns:a16="http://schemas.microsoft.com/office/drawing/2014/main" id="{56A33C94-0960-4469-A111-F823FFBC3EF2}"/>
+                <a16:creationId xmlns:a16="http://schemas.microsoft.com/office/drawing/2014/main" id="{7BD2A8EB-CE27-49AA-83B8-C49740C0F3B1}"/>
               </a:ext>
             </a:extLst>
           </p:cNvPr>
@@ -7728,7 +7728,7 @@
           <p:cNvPr id="3" name="">
             <a:extLst xmlns:a="http://schemas.openxmlformats.org/drawingml/2006/main">
               <a:ext uri="{FF2B5EF4-FFF2-40B4-BE49-F238E27FC236}">
-                <a16:creationId xmlns:a16="http://schemas.microsoft.com/office/drawing/2014/main" id="{E97A17B2-6038-4840-8944-3161BC3145BD}"/>
+                <a16:creationId xmlns:a16="http://schemas.microsoft.com/office/drawing/2014/main" id="{0C6E5DFA-F61F-408C-9C97-183EF906091F}"/>
               </a:ext>
             </a:extLst>
           </p:cNvPr>
@@ -7868,7 +7868,7 @@
           <p:cNvPr id="4" name="">
             <a:extLst xmlns:a="http://schemas.openxmlformats.org/drawingml/2006/main">
               <a:ext uri="{FF2B5EF4-FFF2-40B4-BE49-F238E27FC236}">
-                <a16:creationId xmlns:a16="http://schemas.microsoft.com/office/drawing/2014/main" id="{C4BD654B-B136-465E-9006-9FB36BE28F40}"/>
+                <a16:creationId xmlns:a16="http://schemas.microsoft.com/office/drawing/2014/main" id="{E26782FD-1295-48A9-A766-12FFF3931D9B}"/>
               </a:ext>
             </a:extLst>
           </p:cNvPr>
@@ -8024,7 +8024,7 @@
           <p:cNvPr id="5" name="">
             <a:extLst xmlns:a="http://schemas.openxmlformats.org/drawingml/2006/main">
               <a:ext uri="{FF2B5EF4-FFF2-40B4-BE49-F238E27FC236}">
-                <a16:creationId xmlns:a16="http://schemas.microsoft.com/office/drawing/2014/main" id="{067E495C-E6F5-4167-8D56-46FA839AB150}"/>
+                <a16:creationId xmlns:a16="http://schemas.microsoft.com/office/drawing/2014/main" id="{CF27D612-F1E5-4179-86FF-D625320A76D3}"/>
               </a:ext>
             </a:extLst>
           </p:cNvPr>
@@ -8034,7 +8034,7 @@
           <p:nvPr/>
         </p:nvPicPr>
         <p:blipFill>
-          <a:blip xmlns:r="http://schemas.openxmlformats.org/officeDocument/2006/relationships" xmlns:a="http://schemas.openxmlformats.org/drawingml/2006/main" r:embed="R033986fe216141ea"/>
+          <a:blip xmlns:r="http://schemas.openxmlformats.org/officeDocument/2006/relationships" xmlns:a="http://schemas.openxmlformats.org/drawingml/2006/main" r:embed="Rf8142c0e7a114303"/>
           <a:stretch xmlns:a="http://schemas.openxmlformats.org/drawingml/2006/main"/>
         </p:blipFill>
         <p:spPr>
@@ -8052,7 +8052,7 @@
           <p:cNvPr id="6" name="">
             <a:extLst xmlns:a="http://schemas.openxmlformats.org/drawingml/2006/main">
               <a:ext uri="{FF2B5EF4-FFF2-40B4-BE49-F238E27FC236}">
-                <a16:creationId xmlns:a16="http://schemas.microsoft.com/office/drawing/2014/main" id="{E6C2179E-FA7B-4CA8-9295-88FAC0667E97}"/>
+                <a16:creationId xmlns:a16="http://schemas.microsoft.com/office/drawing/2014/main" id="{7A44E8EB-143F-4B8F-AC76-6FCBDD4F11A1}"/>
               </a:ext>
             </a:extLst>
           </p:cNvPr>
@@ -8206,7 +8206,7 @@
     </p:spTree>
     <p:extLst>
       <p:ext uri="{BB962C8B-B14F-4D97-AF65-F5344CB8AC3E}">
-        <p14:creationId xmlns:p14="http://schemas.microsoft.com/office/powerpoint/2010/main" val="990912755"/>
+        <p14:creationId xmlns:p14="http://schemas.microsoft.com/office/powerpoint/2010/main" val="1882745088"/>
       </p:ext>
     </p:extLst>
   </p:cSld>
@@ -8237,7 +8237,7 @@
           <p:cNvPr id="7" name="">
             <a:extLst xmlns:a="http://schemas.openxmlformats.org/drawingml/2006/main">
               <a:ext uri="{FF2B5EF4-FFF2-40B4-BE49-F238E27FC236}">
-                <a16:creationId xmlns:a16="http://schemas.microsoft.com/office/drawing/2014/main" id="{FAEF602F-16D2-4E46-B89E-3149E6D2D87A}"/>
+                <a16:creationId xmlns:a16="http://schemas.microsoft.com/office/drawing/2014/main" id="{F30DE204-E93E-40FE-91D7-E2F57DCF4D7B}"/>
               </a:ext>
             </a:extLst>
           </p:cNvPr>
@@ -8393,7 +8393,7 @@
           <p:cNvPr id="2" name="">
             <a:extLst xmlns:a="http://schemas.openxmlformats.org/drawingml/2006/main">
               <a:ext uri="{FF2B5EF4-FFF2-40B4-BE49-F238E27FC236}">
-                <a16:creationId xmlns:a16="http://schemas.microsoft.com/office/drawing/2014/main" id="{4F885E96-8CB3-4206-A0BD-ED8ED23FAF80}"/>
+                <a16:creationId xmlns:a16="http://schemas.microsoft.com/office/drawing/2014/main" id="{2068B022-B011-434A-B942-C53AA1EB604B}"/>
               </a:ext>
             </a:extLst>
           </p:cNvPr>
@@ -8549,7 +8549,7 @@
           <p:cNvPr id="3" name="">
             <a:extLst xmlns:a="http://schemas.openxmlformats.org/drawingml/2006/main">
               <a:ext uri="{FF2B5EF4-FFF2-40B4-BE49-F238E27FC236}">
-                <a16:creationId xmlns:a16="http://schemas.microsoft.com/office/drawing/2014/main" id="{6DF29870-F99B-488A-A1AA-3071C8ECACA9}"/>
+                <a16:creationId xmlns:a16="http://schemas.microsoft.com/office/drawing/2014/main" id="{88DFBC50-8957-4D53-A64D-267ADAF5735C}"/>
               </a:ext>
             </a:extLst>
           </p:cNvPr>
@@ -8689,7 +8689,7 @@
           <p:cNvPr id="4" name="">
             <a:extLst xmlns:a="http://schemas.openxmlformats.org/drawingml/2006/main">
               <a:ext uri="{FF2B5EF4-FFF2-40B4-BE49-F238E27FC236}">
-                <a16:creationId xmlns:a16="http://schemas.microsoft.com/office/drawing/2014/main" id="{62F0E6CF-C45D-4516-9B1C-CACB71A4B59F}"/>
+                <a16:creationId xmlns:a16="http://schemas.microsoft.com/office/drawing/2014/main" id="{549C6DBD-F0A3-430B-AB13-8C128B25D29A}"/>
               </a:ext>
             </a:extLst>
           </p:cNvPr>
@@ -8845,7 +8845,7 @@
           <p:cNvPr id="5" name="">
             <a:extLst xmlns:a="http://schemas.openxmlformats.org/drawingml/2006/main">
               <a:ext uri="{FF2B5EF4-FFF2-40B4-BE49-F238E27FC236}">
-                <a16:creationId xmlns:a16="http://schemas.microsoft.com/office/drawing/2014/main" id="{50A89CF7-B301-4230-9273-2F5B0EDB7514}"/>
+                <a16:creationId xmlns:a16="http://schemas.microsoft.com/office/drawing/2014/main" id="{724E418C-CD9F-4B9F-8050-B1F7D3DF5B3E}"/>
               </a:ext>
             </a:extLst>
           </p:cNvPr>
@@ -8855,7 +8855,7 @@
           <p:nvPr/>
         </p:nvPicPr>
         <p:blipFill>
-          <a:blip xmlns:r="http://schemas.openxmlformats.org/officeDocument/2006/relationships" xmlns:a="http://schemas.openxmlformats.org/drawingml/2006/main" r:embed="Re00bc645573d4c49"/>
+          <a:blip xmlns:r="http://schemas.openxmlformats.org/officeDocument/2006/relationships" xmlns:a="http://schemas.openxmlformats.org/drawingml/2006/main" r:embed="R08efbbbc7c5a4410"/>
           <a:stretch xmlns:a="http://schemas.openxmlformats.org/drawingml/2006/main"/>
         </p:blipFill>
         <p:spPr>
@@ -8873,7 +8873,7 @@
           <p:cNvPr id="6" name="">
             <a:extLst xmlns:a="http://schemas.openxmlformats.org/drawingml/2006/main">
               <a:ext uri="{FF2B5EF4-FFF2-40B4-BE49-F238E27FC236}">
-                <a16:creationId xmlns:a16="http://schemas.microsoft.com/office/drawing/2014/main" id="{BF0167D1-FCD6-4921-8DA5-E28C640384AF}"/>
+                <a16:creationId xmlns:a16="http://schemas.microsoft.com/office/drawing/2014/main" id="{9307B52B-B456-486D-BFFD-472904FFDF0D}"/>
               </a:ext>
             </a:extLst>
           </p:cNvPr>
@@ -9152,7 +9152,7 @@
     </p:spTree>
     <p:extLst>
       <p:ext uri="{BB962C8B-B14F-4D97-AF65-F5344CB8AC3E}">
-        <p14:creationId xmlns:p14="http://schemas.microsoft.com/office/powerpoint/2010/main" val="982078146"/>
+        <p14:creationId xmlns:p14="http://schemas.microsoft.com/office/powerpoint/2010/main" val="320725551"/>
       </p:ext>
     </p:extLst>
   </p:cSld>
@@ -9183,7 +9183,7 @@
           <p:cNvPr id="7" name="">
             <a:extLst xmlns:a="http://schemas.openxmlformats.org/drawingml/2006/main">
               <a:ext uri="{FF2B5EF4-FFF2-40B4-BE49-F238E27FC236}">
-                <a16:creationId xmlns:a16="http://schemas.microsoft.com/office/drawing/2014/main" id="{19A3B0BC-D7A9-4272-B14D-94E96A37323F}"/>
+                <a16:creationId xmlns:a16="http://schemas.microsoft.com/office/drawing/2014/main" id="{7AAF2739-77C6-47CE-9D60-832BC6FC630E}"/>
               </a:ext>
             </a:extLst>
           </p:cNvPr>
@@ -9339,7 +9339,7 @@
           <p:cNvPr id="2" name="">
             <a:extLst xmlns:a="http://schemas.openxmlformats.org/drawingml/2006/main">
               <a:ext uri="{FF2B5EF4-FFF2-40B4-BE49-F238E27FC236}">
-                <a16:creationId xmlns:a16="http://schemas.microsoft.com/office/drawing/2014/main" id="{D76DBB2B-39F3-49FE-9587-82D3F2FE2029}"/>
+                <a16:creationId xmlns:a16="http://schemas.microsoft.com/office/drawing/2014/main" id="{ED7289E5-6A59-4248-8453-EB715864389D}"/>
               </a:ext>
             </a:extLst>
           </p:cNvPr>
@@ -9495,7 +9495,7 @@
           <p:cNvPr id="3" name="">
             <a:extLst xmlns:a="http://schemas.openxmlformats.org/drawingml/2006/main">
               <a:ext uri="{FF2B5EF4-FFF2-40B4-BE49-F238E27FC236}">
-                <a16:creationId xmlns:a16="http://schemas.microsoft.com/office/drawing/2014/main" id="{5CF629CE-D705-4DE6-B650-BDA775D73297}"/>
+                <a16:creationId xmlns:a16="http://schemas.microsoft.com/office/drawing/2014/main" id="{65670840-375A-4941-B5AC-08184ECD9AE0}"/>
               </a:ext>
             </a:extLst>
           </p:cNvPr>
@@ -9635,7 +9635,7 @@
           <p:cNvPr id="4" name="">
             <a:extLst xmlns:a="http://schemas.openxmlformats.org/drawingml/2006/main">
               <a:ext uri="{FF2B5EF4-FFF2-40B4-BE49-F238E27FC236}">
-                <a16:creationId xmlns:a16="http://schemas.microsoft.com/office/drawing/2014/main" id="{EB298D40-6C07-4AFE-A48C-A6D9E4BD4AC9}"/>
+                <a16:creationId xmlns:a16="http://schemas.microsoft.com/office/drawing/2014/main" id="{AE94C7DC-EA37-4148-A7B3-28B44649F0E2}"/>
               </a:ext>
             </a:extLst>
           </p:cNvPr>
@@ -9791,7 +9791,7 @@
           <p:cNvPr id="5" name="">
             <a:extLst xmlns:a="http://schemas.openxmlformats.org/drawingml/2006/main">
               <a:ext uri="{FF2B5EF4-FFF2-40B4-BE49-F238E27FC236}">
-                <a16:creationId xmlns:a16="http://schemas.microsoft.com/office/drawing/2014/main" id="{1D274002-DCE4-4FE7-9834-7D4C3EC13358}"/>
+                <a16:creationId xmlns:a16="http://schemas.microsoft.com/office/drawing/2014/main" id="{DDC64F89-14EA-4AA4-B433-1792B8F1F723}"/>
               </a:ext>
             </a:extLst>
           </p:cNvPr>
@@ -9801,7 +9801,7 @@
           <p:nvPr/>
         </p:nvPicPr>
         <p:blipFill>
-          <a:blip xmlns:r="http://schemas.openxmlformats.org/officeDocument/2006/relationships" xmlns:a="http://schemas.openxmlformats.org/drawingml/2006/main" r:embed="Rea10309da9bf4d2a"/>
+          <a:blip xmlns:r="http://schemas.openxmlformats.org/officeDocument/2006/relationships" xmlns:a="http://schemas.openxmlformats.org/drawingml/2006/main" r:embed="R370eea93c0584c22"/>
           <a:stretch xmlns:a="http://schemas.openxmlformats.org/drawingml/2006/main"/>
         </p:blipFill>
         <p:spPr>
@@ -9819,7 +9819,7 @@
           <p:cNvPr id="6" name="">
             <a:extLst xmlns:a="http://schemas.openxmlformats.org/drawingml/2006/main">
               <a:ext uri="{FF2B5EF4-FFF2-40B4-BE49-F238E27FC236}">
-                <a16:creationId xmlns:a16="http://schemas.microsoft.com/office/drawing/2014/main" id="{ECC56909-A3AC-4028-9336-2AB7B96A4801}"/>
+                <a16:creationId xmlns:a16="http://schemas.microsoft.com/office/drawing/2014/main" id="{012BA3B3-5465-48B4-892D-47EBA4155C3C}"/>
               </a:ext>
             </a:extLst>
           </p:cNvPr>
@@ -10080,7 +10080,7 @@
     </p:spTree>
     <p:extLst>
       <p:ext uri="{BB962C8B-B14F-4D97-AF65-F5344CB8AC3E}">
-        <p14:creationId xmlns:p14="http://schemas.microsoft.com/office/powerpoint/2010/main" val="1726169038"/>
+        <p14:creationId xmlns:p14="http://schemas.microsoft.com/office/powerpoint/2010/main" val="624042891"/>
       </p:ext>
     </p:extLst>
   </p:cSld>
@@ -10111,7 +10111,7 @@
           <p:cNvPr id="6" name="">
             <a:extLst xmlns:a="http://schemas.openxmlformats.org/drawingml/2006/main">
               <a:ext uri="{FF2B5EF4-FFF2-40B4-BE49-F238E27FC236}">
-                <a16:creationId xmlns:a16="http://schemas.microsoft.com/office/drawing/2014/main" id="{1A82F510-5FD2-42C7-B156-7291E1388137}"/>
+                <a16:creationId xmlns:a16="http://schemas.microsoft.com/office/drawing/2014/main" id="{B8AE1FC3-A5AD-4E0E-862A-C5B6AAA700D7}"/>
               </a:ext>
             </a:extLst>
           </p:cNvPr>
@@ -10267,7 +10267,7 @@
           <p:cNvPr id="2" name="">
             <a:extLst xmlns:a="http://schemas.openxmlformats.org/drawingml/2006/main">
               <a:ext uri="{FF2B5EF4-FFF2-40B4-BE49-F238E27FC236}">
-                <a16:creationId xmlns:a16="http://schemas.microsoft.com/office/drawing/2014/main" id="{C5744D1F-B289-4117-80B4-5DB50904771D}"/>
+                <a16:creationId xmlns:a16="http://schemas.microsoft.com/office/drawing/2014/main" id="{26E951FA-FBBC-4CDE-A3B0-5B0A6CD09F78}"/>
               </a:ext>
             </a:extLst>
           </p:cNvPr>
@@ -10423,7 +10423,7 @@
           <p:cNvPr id="3" name="">
             <a:extLst xmlns:a="http://schemas.openxmlformats.org/drawingml/2006/main">
               <a:ext uri="{FF2B5EF4-FFF2-40B4-BE49-F238E27FC236}">
-                <a16:creationId xmlns:a16="http://schemas.microsoft.com/office/drawing/2014/main" id="{784EFD6E-4491-4F17-8B28-8C1427378EAA}"/>
+                <a16:creationId xmlns:a16="http://schemas.microsoft.com/office/drawing/2014/main" id="{63C4691B-2B85-459C-8EB0-0EFA5095D919}"/>
               </a:ext>
             </a:extLst>
           </p:cNvPr>
@@ -10563,7 +10563,7 @@
           <p:cNvPr id="4" name="">
             <a:extLst xmlns:a="http://schemas.openxmlformats.org/drawingml/2006/main">
               <a:ext uri="{FF2B5EF4-FFF2-40B4-BE49-F238E27FC236}">
-                <a16:creationId xmlns:a16="http://schemas.microsoft.com/office/drawing/2014/main" id="{0F17699E-AF2F-4F21-AB69-B5C6C9C9268A}"/>
+                <a16:creationId xmlns:a16="http://schemas.microsoft.com/office/drawing/2014/main" id="{DB870E87-F820-4181-BC8B-9050DB002841}"/>
               </a:ext>
             </a:extLst>
           </p:cNvPr>
@@ -10719,7 +10719,7 @@
           <p:cNvPr id="5" name="">
             <a:extLst xmlns:a="http://schemas.openxmlformats.org/drawingml/2006/main">
               <a:ext uri="{FF2B5EF4-FFF2-40B4-BE49-F238E27FC236}">
-                <a16:creationId xmlns:a16="http://schemas.microsoft.com/office/drawing/2014/main" id="{478B80FC-1C4B-46A0-A9B8-4ECCC45C632E}"/>
+                <a16:creationId xmlns:a16="http://schemas.microsoft.com/office/drawing/2014/main" id="{F47BFE60-A0FD-4889-86DE-BCE94BC0DE73}"/>
               </a:ext>
             </a:extLst>
           </p:cNvPr>
@@ -10980,7 +10980,7 @@
     </p:spTree>
     <p:extLst>
       <p:ext uri="{BB962C8B-B14F-4D97-AF65-F5344CB8AC3E}">
-        <p14:creationId xmlns:p14="http://schemas.microsoft.com/office/powerpoint/2010/main" val="1548277759"/>
+        <p14:creationId xmlns:p14="http://schemas.microsoft.com/office/powerpoint/2010/main" val="1637517742"/>
       </p:ext>
     </p:extLst>
   </p:cSld>
@@ -11011,7 +11011,7 @@
           <p:cNvPr id="6" name="">
             <a:extLst xmlns:a="http://schemas.openxmlformats.org/drawingml/2006/main">
               <a:ext uri="{FF2B5EF4-FFF2-40B4-BE49-F238E27FC236}">
-                <a16:creationId xmlns:a16="http://schemas.microsoft.com/office/drawing/2014/main" id="{CB3BAC4F-F124-4655-BFB1-F686A0189C1B}"/>
+                <a16:creationId xmlns:a16="http://schemas.microsoft.com/office/drawing/2014/main" id="{9DBDDC7C-898F-4461-A39B-0B40E45759C5}"/>
               </a:ext>
             </a:extLst>
           </p:cNvPr>
@@ -11167,7 +11167,7 @@
           <p:cNvPr id="2" name="">
             <a:extLst xmlns:a="http://schemas.openxmlformats.org/drawingml/2006/main">
               <a:ext uri="{FF2B5EF4-FFF2-40B4-BE49-F238E27FC236}">
-                <a16:creationId xmlns:a16="http://schemas.microsoft.com/office/drawing/2014/main" id="{57ACF392-947D-43DF-B84B-3D8EAC1BC37F}"/>
+                <a16:creationId xmlns:a16="http://schemas.microsoft.com/office/drawing/2014/main" id="{0FA87106-A696-4C01-8403-B40181AD1A41}"/>
               </a:ext>
             </a:extLst>
           </p:cNvPr>
@@ -11323,7 +11323,7 @@
           <p:cNvPr id="3" name="">
             <a:extLst xmlns:a="http://schemas.openxmlformats.org/drawingml/2006/main">
               <a:ext uri="{FF2B5EF4-FFF2-40B4-BE49-F238E27FC236}">
-                <a16:creationId xmlns:a16="http://schemas.microsoft.com/office/drawing/2014/main" id="{37261028-146F-4A35-9D67-F610AEB69C18}"/>
+                <a16:creationId xmlns:a16="http://schemas.microsoft.com/office/drawing/2014/main" id="{6AE208C6-FB2B-48EF-A1AF-3F4541B3DB37}"/>
               </a:ext>
             </a:extLst>
           </p:cNvPr>
@@ -11463,7 +11463,7 @@
           <p:cNvPr id="4" name="">
             <a:extLst xmlns:a="http://schemas.openxmlformats.org/drawingml/2006/main">
               <a:ext uri="{FF2B5EF4-FFF2-40B4-BE49-F238E27FC236}">
-                <a16:creationId xmlns:a16="http://schemas.microsoft.com/office/drawing/2014/main" id="{3E57D693-4528-4702-AB21-64229FE136A5}"/>
+                <a16:creationId xmlns:a16="http://schemas.microsoft.com/office/drawing/2014/main" id="{4D86513A-0821-4955-8C2A-39BB27F0E496}"/>
               </a:ext>
             </a:extLst>
           </p:cNvPr>
@@ -11619,7 +11619,7 @@
           <p:cNvPr id="5" name="">
             <a:extLst xmlns:a="http://schemas.openxmlformats.org/drawingml/2006/main">
               <a:ext uri="{FF2B5EF4-FFF2-40B4-BE49-F238E27FC236}">
-                <a16:creationId xmlns:a16="http://schemas.microsoft.com/office/drawing/2014/main" id="{4F39CF0B-D38A-4658-B090-F3F425248275}"/>
+                <a16:creationId xmlns:a16="http://schemas.microsoft.com/office/drawing/2014/main" id="{4FC2B0C6-7E0F-41EF-AE14-F4EF85680AB6}"/>
               </a:ext>
             </a:extLst>
           </p:cNvPr>
@@ -11829,7 +11829,7 @@
     </p:spTree>
     <p:extLst>
       <p:ext uri="{BB962C8B-B14F-4D97-AF65-F5344CB8AC3E}">
-        <p14:creationId xmlns:p14="http://schemas.microsoft.com/office/powerpoint/2010/main" val="390822318"/>
+        <p14:creationId xmlns:p14="http://schemas.microsoft.com/office/powerpoint/2010/main" val="83424288"/>
       </p:ext>
     </p:extLst>
   </p:cSld>
@@ -11860,7 +11860,7 @@
           <p:cNvPr id="6" name="">
             <a:extLst xmlns:a="http://schemas.openxmlformats.org/drawingml/2006/main">
               <a:ext uri="{FF2B5EF4-FFF2-40B4-BE49-F238E27FC236}">
-                <a16:creationId xmlns:a16="http://schemas.microsoft.com/office/drawing/2014/main" id="{D6BBC345-8C25-419C-A40C-3F65A6A43233}"/>
+                <a16:creationId xmlns:a16="http://schemas.microsoft.com/office/drawing/2014/main" id="{07972FFA-D39A-4285-931D-1D4FB3D576D5}"/>
               </a:ext>
             </a:extLst>
           </p:cNvPr>
@@ -12016,7 +12016,7 @@
           <p:cNvPr id="2" name="">
             <a:extLst xmlns:a="http://schemas.openxmlformats.org/drawingml/2006/main">
               <a:ext uri="{FF2B5EF4-FFF2-40B4-BE49-F238E27FC236}">
-                <a16:creationId xmlns:a16="http://schemas.microsoft.com/office/drawing/2014/main" id="{BD7E18AA-46F7-48B5-A1A5-8956ABD6086D}"/>
+                <a16:creationId xmlns:a16="http://schemas.microsoft.com/office/drawing/2014/main" id="{038C14DC-0B61-41A8-97BA-A689669DC6A2}"/>
               </a:ext>
             </a:extLst>
           </p:cNvPr>
@@ -12172,7 +12172,7 @@
           <p:cNvPr id="3" name="">
             <a:extLst xmlns:a="http://schemas.openxmlformats.org/drawingml/2006/main">
               <a:ext uri="{FF2B5EF4-FFF2-40B4-BE49-F238E27FC236}">
-                <a16:creationId xmlns:a16="http://schemas.microsoft.com/office/drawing/2014/main" id="{D485C0FE-5CEE-4A60-B5D3-20E718F62B62}"/>
+                <a16:creationId xmlns:a16="http://schemas.microsoft.com/office/drawing/2014/main" id="{77CBC439-CE6C-4D57-8A80-66BDCC422342}"/>
               </a:ext>
             </a:extLst>
           </p:cNvPr>
@@ -12312,7 +12312,7 @@
           <p:cNvPr id="4" name="">
             <a:extLst xmlns:a="http://schemas.openxmlformats.org/drawingml/2006/main">
               <a:ext uri="{FF2B5EF4-FFF2-40B4-BE49-F238E27FC236}">
-                <a16:creationId xmlns:a16="http://schemas.microsoft.com/office/drawing/2014/main" id="{3F167341-DA20-4547-8165-B5B97ADD5F50}"/>
+                <a16:creationId xmlns:a16="http://schemas.microsoft.com/office/drawing/2014/main" id="{2BE151D7-342B-411B-BA60-C81C8F9C91BA}"/>
               </a:ext>
             </a:extLst>
           </p:cNvPr>
@@ -12468,7 +12468,7 @@
           <p:cNvPr id="5" name="">
             <a:extLst xmlns:a="http://schemas.openxmlformats.org/drawingml/2006/main">
               <a:ext uri="{FF2B5EF4-FFF2-40B4-BE49-F238E27FC236}">
-                <a16:creationId xmlns:a16="http://schemas.microsoft.com/office/drawing/2014/main" id="{0DDDF6D7-262C-4B66-9DEE-C19ECC56156D}"/>
+                <a16:creationId xmlns:a16="http://schemas.microsoft.com/office/drawing/2014/main" id="{BED8C84C-5B86-4626-9846-5B1D6C9C8662}"/>
               </a:ext>
             </a:extLst>
           </p:cNvPr>
@@ -12706,7 +12706,7 @@
     </p:spTree>
     <p:extLst>
       <p:ext uri="{BB962C8B-B14F-4D97-AF65-F5344CB8AC3E}">
-        <p14:creationId xmlns:p14="http://schemas.microsoft.com/office/powerpoint/2010/main" val="1726800506"/>
+        <p14:creationId xmlns:p14="http://schemas.microsoft.com/office/powerpoint/2010/main" val="955930551"/>
       </p:ext>
     </p:extLst>
   </p:cSld>
@@ -12737,7 +12737,7 @@
           <p:cNvPr id="6" name="">
             <a:extLst xmlns:a="http://schemas.openxmlformats.org/drawingml/2006/main">
               <a:ext uri="{FF2B5EF4-FFF2-40B4-BE49-F238E27FC236}">
-                <a16:creationId xmlns:a16="http://schemas.microsoft.com/office/drawing/2014/main" id="{0512198A-05AF-40CA-BE95-E615FF7624DB}"/>
+                <a16:creationId xmlns:a16="http://schemas.microsoft.com/office/drawing/2014/main" id="{F95BFD16-9AF0-4622-A88C-056708809048}"/>
               </a:ext>
             </a:extLst>
           </p:cNvPr>
@@ -12893,7 +12893,7 @@
           <p:cNvPr id="2" name="">
             <a:extLst xmlns:a="http://schemas.openxmlformats.org/drawingml/2006/main">
               <a:ext uri="{FF2B5EF4-FFF2-40B4-BE49-F238E27FC236}">
-                <a16:creationId xmlns:a16="http://schemas.microsoft.com/office/drawing/2014/main" id="{3B525C72-D91F-400A-90D5-2DB6468F6AA3}"/>
+                <a16:creationId xmlns:a16="http://schemas.microsoft.com/office/drawing/2014/main" id="{1AB440E9-F4EE-41AF-9492-03E15F6CA3D3}"/>
               </a:ext>
             </a:extLst>
           </p:cNvPr>
@@ -13049,7 +13049,7 @@
           <p:cNvPr id="3" name="">
             <a:extLst xmlns:a="http://schemas.openxmlformats.org/drawingml/2006/main">
               <a:ext uri="{FF2B5EF4-FFF2-40B4-BE49-F238E27FC236}">
-                <a16:creationId xmlns:a16="http://schemas.microsoft.com/office/drawing/2014/main" id="{76D0299A-0141-48EC-B6AA-888210B303A4}"/>
+                <a16:creationId xmlns:a16="http://schemas.microsoft.com/office/drawing/2014/main" id="{CB235F3E-ED2C-40DC-BB71-C6788E395039}"/>
               </a:ext>
             </a:extLst>
           </p:cNvPr>
@@ -13189,7 +13189,7 @@
           <p:cNvPr id="4" name="">
             <a:extLst xmlns:a="http://schemas.openxmlformats.org/drawingml/2006/main">
               <a:ext uri="{FF2B5EF4-FFF2-40B4-BE49-F238E27FC236}">
-                <a16:creationId xmlns:a16="http://schemas.microsoft.com/office/drawing/2014/main" id="{9A7A1683-4E40-41EF-A93F-5CE359459C47}"/>
+                <a16:creationId xmlns:a16="http://schemas.microsoft.com/office/drawing/2014/main" id="{6F0B4F40-3EAA-4625-B743-F2A00C6CAAAA}"/>
               </a:ext>
             </a:extLst>
           </p:cNvPr>
@@ -13345,7 +13345,7 @@
           <p:cNvPr id="5" name="">
             <a:extLst xmlns:a="http://schemas.openxmlformats.org/drawingml/2006/main">
               <a:ext uri="{FF2B5EF4-FFF2-40B4-BE49-F238E27FC236}">
-                <a16:creationId xmlns:a16="http://schemas.microsoft.com/office/drawing/2014/main" id="{4FE4DBCF-D6C4-49B8-9C02-A1D2646301B2}"/>
+                <a16:creationId xmlns:a16="http://schemas.microsoft.com/office/drawing/2014/main" id="{A6EEA96B-3C78-4038-A7C9-929B844C1C55}"/>
               </a:ext>
             </a:extLst>
           </p:cNvPr>
@@ -13583,7 +13583,7 @@
     </p:spTree>
     <p:extLst>
       <p:ext uri="{BB962C8B-B14F-4D97-AF65-F5344CB8AC3E}">
-        <p14:creationId xmlns:p14="http://schemas.microsoft.com/office/powerpoint/2010/main" val="1263368821"/>
+        <p14:creationId xmlns:p14="http://schemas.microsoft.com/office/powerpoint/2010/main" val="949266184"/>
       </p:ext>
     </p:extLst>
   </p:cSld>
@@ -13614,7 +13614,7 @@
           <p:cNvPr id="6" name="">
             <a:extLst xmlns:a="http://schemas.openxmlformats.org/drawingml/2006/main">
               <a:ext uri="{FF2B5EF4-FFF2-40B4-BE49-F238E27FC236}">
-                <a16:creationId xmlns:a16="http://schemas.microsoft.com/office/drawing/2014/main" id="{E43AEB59-C0CE-437A-A86F-F40CFC126C50}"/>
+                <a16:creationId xmlns:a16="http://schemas.microsoft.com/office/drawing/2014/main" id="{AE4FC974-82D6-495A-B64D-610369BED6E2}"/>
               </a:ext>
             </a:extLst>
           </p:cNvPr>
@@ -13770,7 +13770,7 @@
           <p:cNvPr id="2" name="">
             <a:extLst xmlns:a="http://schemas.openxmlformats.org/drawingml/2006/main">
               <a:ext uri="{FF2B5EF4-FFF2-40B4-BE49-F238E27FC236}">
-                <a16:creationId xmlns:a16="http://schemas.microsoft.com/office/drawing/2014/main" id="{1A803150-E8F8-4E77-B1DF-27E2F8DA706C}"/>
+                <a16:creationId xmlns:a16="http://schemas.microsoft.com/office/drawing/2014/main" id="{B9509F12-EC5B-4373-8B26-C6532D4E211F}"/>
               </a:ext>
             </a:extLst>
           </p:cNvPr>
@@ -13926,7 +13926,7 @@
           <p:cNvPr id="3" name="">
             <a:extLst xmlns:a="http://schemas.openxmlformats.org/drawingml/2006/main">
               <a:ext uri="{FF2B5EF4-FFF2-40B4-BE49-F238E27FC236}">
-                <a16:creationId xmlns:a16="http://schemas.microsoft.com/office/drawing/2014/main" id="{83D229F2-61D0-4929-AB08-EBD62A22DBEE}"/>
+                <a16:creationId xmlns:a16="http://schemas.microsoft.com/office/drawing/2014/main" id="{2B7E3E5D-F6C1-4C9D-A152-B064DEFCE9D0}"/>
               </a:ext>
             </a:extLst>
           </p:cNvPr>
@@ -14066,7 +14066,7 @@
           <p:cNvPr id="4" name="">
             <a:extLst xmlns:a="http://schemas.openxmlformats.org/drawingml/2006/main">
               <a:ext uri="{FF2B5EF4-FFF2-40B4-BE49-F238E27FC236}">
-                <a16:creationId xmlns:a16="http://schemas.microsoft.com/office/drawing/2014/main" id="{E69BAD39-E399-4E15-A712-56B2234A0369}"/>
+                <a16:creationId xmlns:a16="http://schemas.microsoft.com/office/drawing/2014/main" id="{BA11E0A6-4A8E-4D91-AE99-500605F20F52}"/>
               </a:ext>
             </a:extLst>
           </p:cNvPr>
@@ -14222,7 +14222,7 @@
           <p:cNvPr id="5" name="">
             <a:extLst xmlns:a="http://schemas.openxmlformats.org/drawingml/2006/main">
               <a:ext uri="{FF2B5EF4-FFF2-40B4-BE49-F238E27FC236}">
-                <a16:creationId xmlns:a16="http://schemas.microsoft.com/office/drawing/2014/main" id="{0F117DEB-F112-4C3E-A208-160966764583}"/>
+                <a16:creationId xmlns:a16="http://schemas.microsoft.com/office/drawing/2014/main" id="{55555A11-C41F-46EA-8F2E-5C881823DD6D}"/>
               </a:ext>
             </a:extLst>
           </p:cNvPr>
@@ -14478,7 +14478,7 @@
     </p:spTree>
     <p:extLst>
       <p:ext uri="{BB962C8B-B14F-4D97-AF65-F5344CB8AC3E}">
-        <p14:creationId xmlns:p14="http://schemas.microsoft.com/office/powerpoint/2010/main" val="492374881"/>
+        <p14:creationId xmlns:p14="http://schemas.microsoft.com/office/powerpoint/2010/main" val="452823860"/>
       </p:ext>
     </p:extLst>
   </p:cSld>
@@ -14509,7 +14509,7 @@
           <p:cNvPr id="6" name="">
             <a:extLst xmlns:a="http://schemas.openxmlformats.org/drawingml/2006/main">
               <a:ext uri="{FF2B5EF4-FFF2-40B4-BE49-F238E27FC236}">
-                <a16:creationId xmlns:a16="http://schemas.microsoft.com/office/drawing/2014/main" id="{3640D340-CCD3-4C9E-AA28-EE813F637E2A}"/>
+                <a16:creationId xmlns:a16="http://schemas.microsoft.com/office/drawing/2014/main" id="{A9C7D305-9CF7-4DF3-8C37-13CC40C2BA15}"/>
               </a:ext>
             </a:extLst>
           </p:cNvPr>
@@ -14665,7 +14665,7 @@
           <p:cNvPr id="2" name="">
             <a:extLst xmlns:a="http://schemas.openxmlformats.org/drawingml/2006/main">
               <a:ext uri="{FF2B5EF4-FFF2-40B4-BE49-F238E27FC236}">
-                <a16:creationId xmlns:a16="http://schemas.microsoft.com/office/drawing/2014/main" id="{305C6468-88BC-4B28-A0FA-6FF786435336}"/>
+                <a16:creationId xmlns:a16="http://schemas.microsoft.com/office/drawing/2014/main" id="{907DD65D-C4A1-4458-B95E-5A52CABBF41A}"/>
               </a:ext>
             </a:extLst>
           </p:cNvPr>
@@ -14821,7 +14821,7 @@
           <p:cNvPr id="3" name="">
             <a:extLst xmlns:a="http://schemas.openxmlformats.org/drawingml/2006/main">
               <a:ext uri="{FF2B5EF4-FFF2-40B4-BE49-F238E27FC236}">
-                <a16:creationId xmlns:a16="http://schemas.microsoft.com/office/drawing/2014/main" id="{833E4358-9D66-4DD0-8BD0-33401630D7F8}"/>
+                <a16:creationId xmlns:a16="http://schemas.microsoft.com/office/drawing/2014/main" id="{C485E152-4355-4DF8-8C9E-0A8F45E9E262}"/>
               </a:ext>
             </a:extLst>
           </p:cNvPr>
@@ -14961,7 +14961,7 @@
           <p:cNvPr id="4" name="">
             <a:extLst xmlns:a="http://schemas.openxmlformats.org/drawingml/2006/main">
               <a:ext uri="{FF2B5EF4-FFF2-40B4-BE49-F238E27FC236}">
-                <a16:creationId xmlns:a16="http://schemas.microsoft.com/office/drawing/2014/main" id="{1940611A-676E-4B95-B236-BB58A8856CD9}"/>
+                <a16:creationId xmlns:a16="http://schemas.microsoft.com/office/drawing/2014/main" id="{B4FE8BF1-2B4A-44B4-A266-7C8B7490186D}"/>
               </a:ext>
             </a:extLst>
           </p:cNvPr>
@@ -15117,7 +15117,7 @@
           <p:cNvPr id="5" name="">
             <a:extLst xmlns:a="http://schemas.openxmlformats.org/drawingml/2006/main">
               <a:ext uri="{FF2B5EF4-FFF2-40B4-BE49-F238E27FC236}">
-                <a16:creationId xmlns:a16="http://schemas.microsoft.com/office/drawing/2014/main" id="{3D93CF48-389B-41C9-A6E6-BA727905B8DC}"/>
+                <a16:creationId xmlns:a16="http://schemas.microsoft.com/office/drawing/2014/main" id="{7B997A76-D03B-4953-B8DF-B089959AF91C}"/>
               </a:ext>
             </a:extLst>
           </p:cNvPr>
@@ -15355,7 +15355,7 @@
     </p:spTree>
     <p:extLst>
       <p:ext uri="{BB962C8B-B14F-4D97-AF65-F5344CB8AC3E}">
-        <p14:creationId xmlns:p14="http://schemas.microsoft.com/office/powerpoint/2010/main" val="618971621"/>
+        <p14:creationId xmlns:p14="http://schemas.microsoft.com/office/powerpoint/2010/main" val="1123929792"/>
       </p:ext>
     </p:extLst>
   </p:cSld>
@@ -15386,7 +15386,7 @@
           <p:cNvPr id="7" name="">
             <a:extLst xmlns:a="http://schemas.openxmlformats.org/drawingml/2006/main">
               <a:ext uri="{FF2B5EF4-FFF2-40B4-BE49-F238E27FC236}">
-                <a16:creationId xmlns:a16="http://schemas.microsoft.com/office/drawing/2014/main" id="{3F7C1CF9-8844-46A0-BE3E-2C3185352578}"/>
+                <a16:creationId xmlns:a16="http://schemas.microsoft.com/office/drawing/2014/main" id="{B079DE79-8CE6-458F-B796-27E4F547B911}"/>
               </a:ext>
             </a:extLst>
           </p:cNvPr>
@@ -15542,7 +15542,7 @@
           <p:cNvPr id="2" name="">
             <a:extLst xmlns:a="http://schemas.openxmlformats.org/drawingml/2006/main">
               <a:ext uri="{FF2B5EF4-FFF2-40B4-BE49-F238E27FC236}">
-                <a16:creationId xmlns:a16="http://schemas.microsoft.com/office/drawing/2014/main" id="{8F87F7FE-5429-4432-9108-695F1BB4498F}"/>
+                <a16:creationId xmlns:a16="http://schemas.microsoft.com/office/drawing/2014/main" id="{5F0495A9-AC2D-439E-9986-452CF597BA66}"/>
               </a:ext>
             </a:extLst>
           </p:cNvPr>
@@ -15698,7 +15698,7 @@
           <p:cNvPr id="3" name="">
             <a:extLst xmlns:a="http://schemas.openxmlformats.org/drawingml/2006/main">
               <a:ext uri="{FF2B5EF4-FFF2-40B4-BE49-F238E27FC236}">
-                <a16:creationId xmlns:a16="http://schemas.microsoft.com/office/drawing/2014/main" id="{D3CEAFF1-A3A8-4621-84A0-068238215CDF}"/>
+                <a16:creationId xmlns:a16="http://schemas.microsoft.com/office/drawing/2014/main" id="{401E92E9-96D0-4F6A-937E-6E5F973B6D1E}"/>
               </a:ext>
             </a:extLst>
           </p:cNvPr>
@@ -15838,7 +15838,7 @@
           <p:cNvPr id="4" name="">
             <a:extLst xmlns:a="http://schemas.openxmlformats.org/drawingml/2006/main">
               <a:ext uri="{FF2B5EF4-FFF2-40B4-BE49-F238E27FC236}">
-                <a16:creationId xmlns:a16="http://schemas.microsoft.com/office/drawing/2014/main" id="{EF6C74E9-A98D-4437-8D19-159651F71C33}"/>
+                <a16:creationId xmlns:a16="http://schemas.microsoft.com/office/drawing/2014/main" id="{9D6F15AF-A118-4531-A624-C7F5817B3D2E}"/>
               </a:ext>
             </a:extLst>
           </p:cNvPr>
@@ -15994,7 +15994,7 @@
           <p:cNvPr id="5" name="">
             <a:extLst xmlns:a="http://schemas.openxmlformats.org/drawingml/2006/main">
               <a:ext uri="{FF2B5EF4-FFF2-40B4-BE49-F238E27FC236}">
-                <a16:creationId xmlns:a16="http://schemas.microsoft.com/office/drawing/2014/main" id="{4F06F549-82C9-47E0-8164-EB2E86E09206}"/>
+                <a16:creationId xmlns:a16="http://schemas.microsoft.com/office/drawing/2014/main" id="{413A6C2A-A031-43B9-A150-3AAFE78B4321}"/>
               </a:ext>
             </a:extLst>
           </p:cNvPr>
@@ -16004,7 +16004,7 @@
           <p:nvPr/>
         </p:nvPicPr>
         <p:blipFill>
-          <a:blip xmlns:r="http://schemas.openxmlformats.org/officeDocument/2006/relationships" xmlns:a="http://schemas.openxmlformats.org/drawingml/2006/main" r:embed="R19daf8246b8446b1"/>
+          <a:blip xmlns:r="http://schemas.openxmlformats.org/officeDocument/2006/relationships" xmlns:a="http://schemas.openxmlformats.org/drawingml/2006/main" r:embed="R0c26b668fcef4733"/>
           <a:stretch xmlns:a="http://schemas.openxmlformats.org/drawingml/2006/main"/>
         </p:blipFill>
         <p:spPr>
@@ -16022,7 +16022,7 @@
           <p:cNvPr id="6" name="">
             <a:extLst xmlns:a="http://schemas.openxmlformats.org/drawingml/2006/main">
               <a:ext uri="{FF2B5EF4-FFF2-40B4-BE49-F238E27FC236}">
-                <a16:creationId xmlns:a16="http://schemas.microsoft.com/office/drawing/2014/main" id="{5793850A-F43D-4E05-8927-1E3762CEE349}"/>
+                <a16:creationId xmlns:a16="http://schemas.microsoft.com/office/drawing/2014/main" id="{57E06541-C763-4FD9-9AB6-D91001D972B5}"/>
               </a:ext>
             </a:extLst>
           </p:cNvPr>
@@ -16176,7 +16176,7 @@
     </p:spTree>
     <p:extLst>
       <p:ext uri="{BB962C8B-B14F-4D97-AF65-F5344CB8AC3E}">
-        <p14:creationId xmlns:p14="http://schemas.microsoft.com/office/powerpoint/2010/main" val="1592091853"/>
+        <p14:creationId xmlns:p14="http://schemas.microsoft.com/office/powerpoint/2010/main" val="1878057327"/>
       </p:ext>
     </p:extLst>
   </p:cSld>
@@ -16207,7 +16207,7 @@
           <p:cNvPr id="7" name="">
             <a:extLst xmlns:a="http://schemas.openxmlformats.org/drawingml/2006/main">
               <a:ext uri="{FF2B5EF4-FFF2-40B4-BE49-F238E27FC236}">
-                <a16:creationId xmlns:a16="http://schemas.microsoft.com/office/drawing/2014/main" id="{F9F56164-34B3-4DA6-A128-8FA43E59D507}"/>
+                <a16:creationId xmlns:a16="http://schemas.microsoft.com/office/drawing/2014/main" id="{DACF018E-AD20-4723-A838-54F13DFA1B29}"/>
               </a:ext>
             </a:extLst>
           </p:cNvPr>
@@ -16363,7 +16363,7 @@
           <p:cNvPr id="2" name="">
             <a:extLst xmlns:a="http://schemas.openxmlformats.org/drawingml/2006/main">
               <a:ext uri="{FF2B5EF4-FFF2-40B4-BE49-F238E27FC236}">
-                <a16:creationId xmlns:a16="http://schemas.microsoft.com/office/drawing/2014/main" id="{4CA07AEF-676B-4B04-9823-58EFA8D8D1B1}"/>
+                <a16:creationId xmlns:a16="http://schemas.microsoft.com/office/drawing/2014/main" id="{17495D6F-E18D-481C-BA47-85CB4A74C477}"/>
               </a:ext>
             </a:extLst>
           </p:cNvPr>
@@ -16519,7 +16519,7 @@
           <p:cNvPr id="3" name="">
             <a:extLst xmlns:a="http://schemas.openxmlformats.org/drawingml/2006/main">
               <a:ext uri="{FF2B5EF4-FFF2-40B4-BE49-F238E27FC236}">
-                <a16:creationId xmlns:a16="http://schemas.microsoft.com/office/drawing/2014/main" id="{E351E0CA-A959-40A6-9EA3-1DE8DCA7D5FA}"/>
+                <a16:creationId xmlns:a16="http://schemas.microsoft.com/office/drawing/2014/main" id="{DFCBFC99-F38A-46DA-A04D-045F759887A8}"/>
               </a:ext>
             </a:extLst>
           </p:cNvPr>
@@ -16659,7 +16659,7 @@
           <p:cNvPr id="4" name="">
             <a:extLst xmlns:a="http://schemas.openxmlformats.org/drawingml/2006/main">
               <a:ext uri="{FF2B5EF4-FFF2-40B4-BE49-F238E27FC236}">
-                <a16:creationId xmlns:a16="http://schemas.microsoft.com/office/drawing/2014/main" id="{5292B07A-2AE3-47BD-A534-A59B2ABE6F17}"/>
+                <a16:creationId xmlns:a16="http://schemas.microsoft.com/office/drawing/2014/main" id="{EDFDE67D-B797-4332-8B7B-3748D0C2449F}"/>
               </a:ext>
             </a:extLst>
           </p:cNvPr>
@@ -16815,7 +16815,7 @@
           <p:cNvPr id="5" name="">
             <a:extLst xmlns:a="http://schemas.openxmlformats.org/drawingml/2006/main">
               <a:ext uri="{FF2B5EF4-FFF2-40B4-BE49-F238E27FC236}">
-                <a16:creationId xmlns:a16="http://schemas.microsoft.com/office/drawing/2014/main" id="{A033017C-898C-4C7B-A44E-8C846C372D36}"/>
+                <a16:creationId xmlns:a16="http://schemas.microsoft.com/office/drawing/2014/main" id="{A0F1A831-3FC5-4E5D-8EF5-249620B76BB0}"/>
               </a:ext>
             </a:extLst>
           </p:cNvPr>
@@ -16825,7 +16825,7 @@
           <p:nvPr/>
         </p:nvPicPr>
         <p:blipFill>
-          <a:blip xmlns:r="http://schemas.openxmlformats.org/officeDocument/2006/relationships" xmlns:a="http://schemas.openxmlformats.org/drawingml/2006/main" r:embed="Ree598182099149b8"/>
+          <a:blip xmlns:r="http://schemas.openxmlformats.org/officeDocument/2006/relationships" xmlns:a="http://schemas.openxmlformats.org/drawingml/2006/main" r:embed="Ra974122f605f43db"/>
           <a:stretch xmlns:a="http://schemas.openxmlformats.org/drawingml/2006/main"/>
         </p:blipFill>
         <p:spPr>
@@ -16843,7 +16843,7 @@
           <p:cNvPr id="6" name="">
             <a:extLst xmlns:a="http://schemas.openxmlformats.org/drawingml/2006/main">
               <a:ext uri="{FF2B5EF4-FFF2-40B4-BE49-F238E27FC236}">
-                <a16:creationId xmlns:a16="http://schemas.microsoft.com/office/drawing/2014/main" id="{17EFFAB7-7F55-47DE-A3F3-7206D7AB54D8}"/>
+                <a16:creationId xmlns:a16="http://schemas.microsoft.com/office/drawing/2014/main" id="{0BCA33C1-5A19-4552-BDA3-78BD1CEA100B}"/>
               </a:ext>
             </a:extLst>
           </p:cNvPr>
@@ -16997,7 +16997,7 @@
     </p:spTree>
     <p:extLst>
       <p:ext uri="{BB962C8B-B14F-4D97-AF65-F5344CB8AC3E}">
-        <p14:creationId xmlns:p14="http://schemas.microsoft.com/office/powerpoint/2010/main" val="482112205"/>
+        <p14:creationId xmlns:p14="http://schemas.microsoft.com/office/powerpoint/2010/main" val="1964921519"/>
       </p:ext>
     </p:extLst>
   </p:cSld>
@@ -17028,7 +17028,7 @@
           <p:cNvPr id="7" name="">
             <a:extLst xmlns:a="http://schemas.openxmlformats.org/drawingml/2006/main">
               <a:ext uri="{FF2B5EF4-FFF2-40B4-BE49-F238E27FC236}">
-                <a16:creationId xmlns:a16="http://schemas.microsoft.com/office/drawing/2014/main" id="{629645B0-AC21-4D8A-84BE-1CA847392D7B}"/>
+                <a16:creationId xmlns:a16="http://schemas.microsoft.com/office/drawing/2014/main" id="{BAAD7F63-3B09-4916-8573-25E5BBA3597F}"/>
               </a:ext>
             </a:extLst>
           </p:cNvPr>
@@ -17184,7 +17184,7 @@
           <p:cNvPr id="2" name="">
             <a:extLst xmlns:a="http://schemas.openxmlformats.org/drawingml/2006/main">
               <a:ext uri="{FF2B5EF4-FFF2-40B4-BE49-F238E27FC236}">
-                <a16:creationId xmlns:a16="http://schemas.microsoft.com/office/drawing/2014/main" id="{930AE3C4-FAA3-482B-86E2-F5A9CDC35991}"/>
+                <a16:creationId xmlns:a16="http://schemas.microsoft.com/office/drawing/2014/main" id="{CD7F7B42-F13B-45B7-BE3D-BB62501B0575}"/>
               </a:ext>
             </a:extLst>
           </p:cNvPr>
@@ -17340,7 +17340,7 @@
           <p:cNvPr id="3" name="">
             <a:extLst xmlns:a="http://schemas.openxmlformats.org/drawingml/2006/main">
               <a:ext uri="{FF2B5EF4-FFF2-40B4-BE49-F238E27FC236}">
-                <a16:creationId xmlns:a16="http://schemas.microsoft.com/office/drawing/2014/main" id="{315ED9AD-DF88-4DA7-AA12-1A71B43F6D2F}"/>
+                <a16:creationId xmlns:a16="http://schemas.microsoft.com/office/drawing/2014/main" id="{220B274A-4B93-4DB1-8C6F-4FCC41E7493C}"/>
               </a:ext>
             </a:extLst>
           </p:cNvPr>
@@ -17480,7 +17480,7 @@
           <p:cNvPr id="4" name="">
             <a:extLst xmlns:a="http://schemas.openxmlformats.org/drawingml/2006/main">
               <a:ext uri="{FF2B5EF4-FFF2-40B4-BE49-F238E27FC236}">
-                <a16:creationId xmlns:a16="http://schemas.microsoft.com/office/drawing/2014/main" id="{1A7CD9B5-8F14-441A-BB90-F2AF33709EB4}"/>
+                <a16:creationId xmlns:a16="http://schemas.microsoft.com/office/drawing/2014/main" id="{9CD3FCF7-82F0-4F5B-AECB-F4A6EA07D9FB}"/>
               </a:ext>
             </a:extLst>
           </p:cNvPr>
@@ -17636,7 +17636,7 @@
           <p:cNvPr id="5" name="">
             <a:extLst xmlns:a="http://schemas.openxmlformats.org/drawingml/2006/main">
               <a:ext uri="{FF2B5EF4-FFF2-40B4-BE49-F238E27FC236}">
-                <a16:creationId xmlns:a16="http://schemas.microsoft.com/office/drawing/2014/main" id="{5D571468-74CE-4C1A-ABEB-038F67680ACC}"/>
+                <a16:creationId xmlns:a16="http://schemas.microsoft.com/office/drawing/2014/main" id="{D80779EC-EF5D-49EC-B209-F9A8BB580696}"/>
               </a:ext>
             </a:extLst>
           </p:cNvPr>
@@ -18495,7 +18495,7 @@
           <p:cNvPr id="6" name="">
             <a:extLst xmlns:a="http://schemas.openxmlformats.org/drawingml/2006/main">
               <a:ext uri="{FF2B5EF4-FFF2-40B4-BE49-F238E27FC236}">
-                <a16:creationId xmlns:a16="http://schemas.microsoft.com/office/drawing/2014/main" id="{3B4361DA-CEE8-4E4C-A2AD-12B018E0D1FB}"/>
+                <a16:creationId xmlns:a16="http://schemas.microsoft.com/office/drawing/2014/main" id="{ADB27FF3-2F63-4AD2-8F98-FF63A5121EEA}"/>
               </a:ext>
             </a:extLst>
           </p:cNvPr>
@@ -18649,7 +18649,7 @@
     </p:spTree>
     <p:extLst>
       <p:ext uri="{BB962C8B-B14F-4D97-AF65-F5344CB8AC3E}">
-        <p14:creationId xmlns:p14="http://schemas.microsoft.com/office/powerpoint/2010/main" val="1130384129"/>
+        <p14:creationId xmlns:p14="http://schemas.microsoft.com/office/powerpoint/2010/main" val="1419238044"/>
       </p:ext>
     </p:extLst>
   </p:cSld>

</xml_diff>

<commit_message>
Validate simulator TC and complete six-workload comparison
</commit_message>
<xml_diff>
--- a/presentation/CSLab_Memory_Tiering_Current.pptx
+++ b/presentation/CSLab_Memory_Tiering_Current.pptx
@@ -2,27 +2,27 @@
 <file path=ppt/presentation.xml><?xml version="1.0" encoding="utf-8"?>
 <p:presentation xmlns:p="http://schemas.openxmlformats.org/presentationml/2006/main">
   <p:sldMasterIdLst>
-    <p:sldMasterId xmlns:r="http://schemas.openxmlformats.org/officeDocument/2006/relationships" id="2147483648" r:id="Rd44f624bf6fd4d67"/>
+    <p:sldMasterId xmlns:r="http://schemas.openxmlformats.org/officeDocument/2006/relationships" id="2147483648" r:id="R6c231bb76c904d20"/>
   </p:sldMasterIdLst>
   <p:notesMasterIdLst>
-    <p:notesMasterId xmlns:r="http://schemas.openxmlformats.org/officeDocument/2006/relationships" r:id="R9486e60e64564194"/>
+    <p:notesMasterId xmlns:r="http://schemas.openxmlformats.org/officeDocument/2006/relationships" r:id="Rbe647938e4a3452d"/>
   </p:notesMasterIdLst>
   <p:sldIdLst>
-    <p:sldId xmlns:r="http://schemas.openxmlformats.org/officeDocument/2006/relationships" id="256" r:id="R4ae9f2cc56b342ab"/>
-    <p:sldId xmlns:r="http://schemas.openxmlformats.org/officeDocument/2006/relationships" id="257" r:id="Re0de712f80e34921"/>
-    <p:sldId xmlns:r="http://schemas.openxmlformats.org/officeDocument/2006/relationships" id="258" r:id="R84b4243d64174da3"/>
-    <p:sldId xmlns:r="http://schemas.openxmlformats.org/officeDocument/2006/relationships" id="259" r:id="Rc25ff0bdffba4b69"/>
-    <p:sldId xmlns:r="http://schemas.openxmlformats.org/officeDocument/2006/relationships" id="260" r:id="R742f94f5e63d47aa"/>
-    <p:sldId xmlns:r="http://schemas.openxmlformats.org/officeDocument/2006/relationships" id="261" r:id="Rd7a10badcc6f4d52"/>
-    <p:sldId xmlns:r="http://schemas.openxmlformats.org/officeDocument/2006/relationships" id="262" r:id="Rcc99dae05045432e"/>
-    <p:sldId xmlns:r="http://schemas.openxmlformats.org/officeDocument/2006/relationships" id="263" r:id="R6037f7ec827b40df"/>
-    <p:sldId xmlns:r="http://schemas.openxmlformats.org/officeDocument/2006/relationships" id="264" r:id="R9492df12b4e241ba"/>
-    <p:sldId xmlns:r="http://schemas.openxmlformats.org/officeDocument/2006/relationships" id="265" r:id="R8dad5b478791420f"/>
-    <p:sldId xmlns:r="http://schemas.openxmlformats.org/officeDocument/2006/relationships" id="266" r:id="R3025e00a35e54070"/>
-    <p:sldId xmlns:r="http://schemas.openxmlformats.org/officeDocument/2006/relationships" id="267" r:id="R5b84e2fc4f1e449c"/>
-    <p:sldId xmlns:r="http://schemas.openxmlformats.org/officeDocument/2006/relationships" id="268" r:id="R1efee1fda49644c6"/>
-    <p:sldId xmlns:r="http://schemas.openxmlformats.org/officeDocument/2006/relationships" id="269" r:id="Rc933bd6fddfa4df4"/>
-    <p:sldId xmlns:r="http://schemas.openxmlformats.org/officeDocument/2006/relationships" id="270" r:id="R1a63a88c652041ab"/>
+    <p:sldId xmlns:r="http://schemas.openxmlformats.org/officeDocument/2006/relationships" id="256" r:id="Rd61b053ae3e04559"/>
+    <p:sldId xmlns:r="http://schemas.openxmlformats.org/officeDocument/2006/relationships" id="257" r:id="R7246baa217cc4a1f"/>
+    <p:sldId xmlns:r="http://schemas.openxmlformats.org/officeDocument/2006/relationships" id="258" r:id="R55967340ceb34e6a"/>
+    <p:sldId xmlns:r="http://schemas.openxmlformats.org/officeDocument/2006/relationships" id="259" r:id="Rb980d665a65e42d3"/>
+    <p:sldId xmlns:r="http://schemas.openxmlformats.org/officeDocument/2006/relationships" id="260" r:id="R5fd77406aa5c4b52"/>
+    <p:sldId xmlns:r="http://schemas.openxmlformats.org/officeDocument/2006/relationships" id="261" r:id="R9797b83bfb4446c3"/>
+    <p:sldId xmlns:r="http://schemas.openxmlformats.org/officeDocument/2006/relationships" id="262" r:id="R5750ff7c674048ea"/>
+    <p:sldId xmlns:r="http://schemas.openxmlformats.org/officeDocument/2006/relationships" id="263" r:id="Ra239b68bf5e44324"/>
+    <p:sldId xmlns:r="http://schemas.openxmlformats.org/officeDocument/2006/relationships" id="264" r:id="Rdf30253767814914"/>
+    <p:sldId xmlns:r="http://schemas.openxmlformats.org/officeDocument/2006/relationships" id="265" r:id="Rc9a0bedbd99a4fd1"/>
+    <p:sldId xmlns:r="http://schemas.openxmlformats.org/officeDocument/2006/relationships" id="266" r:id="R862d475cecb947c2"/>
+    <p:sldId xmlns:r="http://schemas.openxmlformats.org/officeDocument/2006/relationships" id="267" r:id="Rcdcc1e02001e4079"/>
+    <p:sldId xmlns:r="http://schemas.openxmlformats.org/officeDocument/2006/relationships" id="268" r:id="R5f235c7067184996"/>
+    <p:sldId xmlns:r="http://schemas.openxmlformats.org/officeDocument/2006/relationships" id="269" r:id="R519482bfa35145c1"/>
+    <p:sldId xmlns:r="http://schemas.openxmlformats.org/officeDocument/2006/relationships" id="270" r:id="R9743d70556cc4a3d"/>
   </p:sldIdLst>
   <p:sldSz cx="12192000" cy="6858000"/>
   <p:notesSz cx="6858000" cy="9144000"/>
@@ -706,7 +706,7 @@
           <a:lstStyle xmlns:a="http://schemas.openxmlformats.org/drawingml/2006/main"/>
           <a:p xmlns:a="http://schemas.openxmlformats.org/drawingml/2006/main">
             <a:r>
-              <a:t>70 δευτερόλεπτα. Η probe μετρά physical accepted requests στο CXL bridge. Τα bridge/controller clocks είναι ανεξάρτητα και δεν αθροίζονται. Το overview συγκρίνει διαφορετικά setups και όχι identical traces. Οι μη ολοκληρωμένες εκτελέσεις είναι pending, όχι μηδενικές μπάρες.</a:t>
+              <a:t>70 δευτερόλεπτα. Η probe μετρά physical accepted requests στο CXL bridge. Τα bridge/controller clocks είναι ανεξάρτητα και δεν αθροίζονται. Το overview συγκρίνει διαφορετικά setups και όχι identical traces. Και τα έξι graph workloads ολοκληρώθηκαν και ελέγχθηκαν. TC: 621.867.320 requests σε 63 παράθυρα, 31,07 ώρες, μέγιστη απόκλιση 37,78 ποσοστιαίες μονάδες. Το PR έχει μικρή αριθμητική απόκλιση, αλλά δεν τεκμηριώνεται πλήρης αναπαραγωγή. Liblinear και BC window controls παραμένουν στην ουρά.</a:t>
             </a:r>
           </a:p>
           <a:p xmlns:a="http://schemas.openxmlformats.org/drawingml/2006/main">
@@ -1643,7 +1643,7 @@
           <p:cNvPr id="3" name="Title">
             <a:extLst xmlns:a="http://schemas.openxmlformats.org/drawingml/2006/main">
               <a:ext uri="{FF2B5EF4-FFF2-40B4-BE49-F238E27FC236}">
-                <a16:creationId xmlns:a16="http://schemas.microsoft.com/office/drawing/2014/main" id="{4B75C78F-2364-4C05-B7CF-6E7561EF9343}"/>
+                <a16:creationId xmlns:a16="http://schemas.microsoft.com/office/drawing/2014/main" id="{C2DD47EC-A2DA-4873-9028-294DFDB27B2C}"/>
               </a:ext>
             </a:extLst>
           </p:cNvPr>
@@ -1872,7 +1872,7 @@
           <p:cNvPr id="2" name="Subtitle">
             <a:extLst xmlns:a="http://schemas.openxmlformats.org/drawingml/2006/main">
               <a:ext uri="{FF2B5EF4-FFF2-40B4-BE49-F238E27FC236}">
-                <a16:creationId xmlns:a16="http://schemas.microsoft.com/office/drawing/2014/main" id="{39FCE63E-7D5A-4A67-A349-685678361647}"/>
+                <a16:creationId xmlns:a16="http://schemas.microsoft.com/office/drawing/2014/main" id="{9AF52281-CBAB-43A7-BF4F-F3561E8B5BEF}"/>
               </a:ext>
             </a:extLst>
           </p:cNvPr>
@@ -2118,7 +2118,7 @@
           <p:cNvPr id="2" name="Section title">
             <a:extLst xmlns:a="http://schemas.openxmlformats.org/drawingml/2006/main">
               <a:ext uri="{FF2B5EF4-FFF2-40B4-BE49-F238E27FC236}">
-                <a16:creationId xmlns:a16="http://schemas.microsoft.com/office/drawing/2014/main" id="{5C47DB5B-2567-4EC4-B00C-AB4596C52654}"/>
+                <a16:creationId xmlns:a16="http://schemas.microsoft.com/office/drawing/2014/main" id="{9CDB4AB8-03E8-4C79-8A2B-5E58F3A9D188}"/>
               </a:ext>
             </a:extLst>
           </p:cNvPr>
@@ -2364,7 +2364,7 @@
           <p:cNvPr id="3" name="Title">
             <a:extLst xmlns:a="http://schemas.openxmlformats.org/drawingml/2006/main">
               <a:ext uri="{FF2B5EF4-FFF2-40B4-BE49-F238E27FC236}">
-                <a16:creationId xmlns:a16="http://schemas.microsoft.com/office/drawing/2014/main" id="{E0AECF8D-8290-4557-9171-FB40F788AC19}"/>
+                <a16:creationId xmlns:a16="http://schemas.microsoft.com/office/drawing/2014/main" id="{895DCB73-7C6F-42DD-B3E1-5AAF5587135D}"/>
               </a:ext>
             </a:extLst>
           </p:cNvPr>
@@ -2593,7 +2593,7 @@
           <p:cNvPr id="2" name="Body">
             <a:extLst xmlns:a="http://schemas.openxmlformats.org/drawingml/2006/main">
               <a:ext uri="{FF2B5EF4-FFF2-40B4-BE49-F238E27FC236}">
-                <a16:creationId xmlns:a16="http://schemas.microsoft.com/office/drawing/2014/main" id="{4D8173A0-47EC-452B-9E53-687247FEEFFC}"/>
+                <a16:creationId xmlns:a16="http://schemas.microsoft.com/office/drawing/2014/main" id="{A18BBC31-74DC-4F21-AFDD-9F3FDC3B179F}"/>
               </a:ext>
             </a:extLst>
           </p:cNvPr>
@@ -2839,7 +2839,7 @@
           <p:cNvPr id="4" name="Title">
             <a:extLst xmlns:a="http://schemas.openxmlformats.org/drawingml/2006/main">
               <a:ext uri="{FF2B5EF4-FFF2-40B4-BE49-F238E27FC236}">
-                <a16:creationId xmlns:a16="http://schemas.microsoft.com/office/drawing/2014/main" id="{FC549BD4-291F-411B-98E3-417BA60273D9}"/>
+                <a16:creationId xmlns:a16="http://schemas.microsoft.com/office/drawing/2014/main" id="{A61D2277-5F9E-4BAC-9950-946AC8E652C8}"/>
               </a:ext>
             </a:extLst>
           </p:cNvPr>
@@ -3068,7 +3068,7 @@
           <p:cNvPr id="2" name="Left column">
             <a:extLst xmlns:a="http://schemas.openxmlformats.org/drawingml/2006/main">
               <a:ext uri="{FF2B5EF4-FFF2-40B4-BE49-F238E27FC236}">
-                <a16:creationId xmlns:a16="http://schemas.microsoft.com/office/drawing/2014/main" id="{EAC2D3A3-3114-4D95-8596-6419640D1DE0}"/>
+                <a16:creationId xmlns:a16="http://schemas.microsoft.com/office/drawing/2014/main" id="{B26D82AB-FB8F-4049-A0F1-B86FD0325939}"/>
               </a:ext>
             </a:extLst>
           </p:cNvPr>
@@ -3297,7 +3297,7 @@
           <p:cNvPr id="3" name="Right column">
             <a:extLst xmlns:a="http://schemas.openxmlformats.org/drawingml/2006/main">
               <a:ext uri="{FF2B5EF4-FFF2-40B4-BE49-F238E27FC236}">
-                <a16:creationId xmlns:a16="http://schemas.microsoft.com/office/drawing/2014/main" id="{C5EE0F4B-F6F9-4EEC-BF9A-47B58153EC4F}"/>
+                <a16:creationId xmlns:a16="http://schemas.microsoft.com/office/drawing/2014/main" id="{AFA261C9-1095-438F-BE17-6E7BDF35B89C}"/>
               </a:ext>
             </a:extLst>
           </p:cNvPr>
@@ -3543,7 +3543,7 @@
           <p:cNvPr id="3" name="Title">
             <a:extLst xmlns:a="http://schemas.openxmlformats.org/drawingml/2006/main">
               <a:ext uri="{FF2B5EF4-FFF2-40B4-BE49-F238E27FC236}">
-                <a16:creationId xmlns:a16="http://schemas.microsoft.com/office/drawing/2014/main" id="{97C1CA1E-0318-49F1-A4C6-AF36BF771DAA}"/>
+                <a16:creationId xmlns:a16="http://schemas.microsoft.com/office/drawing/2014/main" id="{1BC148D5-44DE-4233-AD05-FB8E44691771}"/>
               </a:ext>
             </a:extLst>
           </p:cNvPr>
@@ -3772,7 +3772,7 @@
           <p:cNvPr id="2" name="Left column">
             <a:extLst xmlns:a="http://schemas.openxmlformats.org/drawingml/2006/main">
               <a:ext uri="{FF2B5EF4-FFF2-40B4-BE49-F238E27FC236}">
-                <a16:creationId xmlns:a16="http://schemas.microsoft.com/office/drawing/2014/main" id="{5AA06CB2-CAAB-4909-8512-67F755B0D75B}"/>
+                <a16:creationId xmlns:a16="http://schemas.microsoft.com/office/drawing/2014/main" id="{C296FB22-A420-46F6-8B98-A2730C208BFC}"/>
               </a:ext>
             </a:extLst>
           </p:cNvPr>
@@ -4039,12 +4039,12 @@
   </p:cSld>
   <p:clrMap bg1="lt1" tx1="dk1" bg2="lt2" tx2="dk2" accent1="accent1" accent2="accent2" accent3="accent3" accent4="accent4" accent5="accent5" accent6="accent6" hlink="hlink" folHlink="folHlink"/>
   <p:sldLayoutIdLst>
-    <p:sldLayoutId xmlns:r="http://schemas.openxmlformats.org/officeDocument/2006/relationships" id="2147483649" r:id="R4a20085b1ff54878"/>
-    <p:sldLayoutId xmlns:r="http://schemas.openxmlformats.org/officeDocument/2006/relationships" id="2147483650" r:id="R46da71e81c4c49e8"/>
-    <p:sldLayoutId xmlns:r="http://schemas.openxmlformats.org/officeDocument/2006/relationships" id="2147483651" r:id="Rdc3bbda750d04182"/>
-    <p:sldLayoutId xmlns:r="http://schemas.openxmlformats.org/officeDocument/2006/relationships" id="2147483652" r:id="R912f8d074fcc4ac7"/>
-    <p:sldLayoutId xmlns:r="http://schemas.openxmlformats.org/officeDocument/2006/relationships" id="2147483653" r:id="Rf8acb74a4ec045a8"/>
-    <p:sldLayoutId xmlns:r="http://schemas.openxmlformats.org/officeDocument/2006/relationships" id="2147483654" r:id="Rd01516338eea44c7"/>
+    <p:sldLayoutId xmlns:r="http://schemas.openxmlformats.org/officeDocument/2006/relationships" id="2147483649" r:id="Ra5972c6fc63b45f0"/>
+    <p:sldLayoutId xmlns:r="http://schemas.openxmlformats.org/officeDocument/2006/relationships" id="2147483650" r:id="R3f09ecb28a114c6c"/>
+    <p:sldLayoutId xmlns:r="http://schemas.openxmlformats.org/officeDocument/2006/relationships" id="2147483651" r:id="R1533c30cf5664779"/>
+    <p:sldLayoutId xmlns:r="http://schemas.openxmlformats.org/officeDocument/2006/relationships" id="2147483652" r:id="R90c13e040bca4515"/>
+    <p:sldLayoutId xmlns:r="http://schemas.openxmlformats.org/officeDocument/2006/relationships" id="2147483653" r:id="Re3148ff59d384ae6"/>
+    <p:sldLayoutId xmlns:r="http://schemas.openxmlformats.org/officeDocument/2006/relationships" id="2147483654" r:id="R0900cbf7222a455e"/>
   </p:sldLayoutIdLst>
   <p:txStyles>
     <p:titleStyle>
@@ -4595,7 +4595,7 @@
           <p:cNvPr id="7" name="">
             <a:extLst xmlns:a="http://schemas.openxmlformats.org/drawingml/2006/main">
               <a:ext uri="{FF2B5EF4-FFF2-40B4-BE49-F238E27FC236}">
-                <a16:creationId xmlns:a16="http://schemas.microsoft.com/office/drawing/2014/main" id="{70677EA4-E938-4E49-8033-C339B88D62E2}"/>
+                <a16:creationId xmlns:a16="http://schemas.microsoft.com/office/drawing/2014/main" id="{61BACEE4-2544-4073-9C68-584B68AB15AB}"/>
               </a:ext>
             </a:extLst>
           </p:cNvPr>
@@ -4751,7 +4751,7 @@
           <p:cNvPr id="2" name="">
             <a:extLst xmlns:a="http://schemas.openxmlformats.org/drawingml/2006/main">
               <a:ext uri="{FF2B5EF4-FFF2-40B4-BE49-F238E27FC236}">
-                <a16:creationId xmlns:a16="http://schemas.microsoft.com/office/drawing/2014/main" id="{B3AF4170-BC2E-40AD-A72F-D61E7319B02E}"/>
+                <a16:creationId xmlns:a16="http://schemas.microsoft.com/office/drawing/2014/main" id="{E82C635B-A6DC-49E5-AEE6-48C9E60D3E6F}"/>
               </a:ext>
             </a:extLst>
           </p:cNvPr>
@@ -4907,7 +4907,7 @@
           <p:cNvPr id="3" name="">
             <a:extLst xmlns:a="http://schemas.openxmlformats.org/drawingml/2006/main">
               <a:ext uri="{FF2B5EF4-FFF2-40B4-BE49-F238E27FC236}">
-                <a16:creationId xmlns:a16="http://schemas.microsoft.com/office/drawing/2014/main" id="{3B61C246-88F0-4399-ACB5-8BA789DEA22F}"/>
+                <a16:creationId xmlns:a16="http://schemas.microsoft.com/office/drawing/2014/main" id="{41C986EB-4E09-4F0B-BE77-2E5AED24305C}"/>
               </a:ext>
             </a:extLst>
           </p:cNvPr>
@@ -5047,7 +5047,7 @@
           <p:cNvPr id="4" name="">
             <a:extLst xmlns:a="http://schemas.openxmlformats.org/drawingml/2006/main">
               <a:ext uri="{FF2B5EF4-FFF2-40B4-BE49-F238E27FC236}">
-                <a16:creationId xmlns:a16="http://schemas.microsoft.com/office/drawing/2014/main" id="{4C344311-0EFF-4D09-BEC2-CD05FE1FBD82}"/>
+                <a16:creationId xmlns:a16="http://schemas.microsoft.com/office/drawing/2014/main" id="{8E0D6EA8-608B-4E33-ABCD-0B928A6F82C4}"/>
               </a:ext>
             </a:extLst>
           </p:cNvPr>
@@ -5203,7 +5203,7 @@
           <p:cNvPr id="5" name="">
             <a:extLst xmlns:a="http://schemas.openxmlformats.org/drawingml/2006/main">
               <a:ext uri="{FF2B5EF4-FFF2-40B4-BE49-F238E27FC236}">
-                <a16:creationId xmlns:a16="http://schemas.microsoft.com/office/drawing/2014/main" id="{B349C4E9-C6EB-4DEC-A14E-A3E611AB7C39}"/>
+                <a16:creationId xmlns:a16="http://schemas.microsoft.com/office/drawing/2014/main" id="{4C6E5D6A-622B-4159-80B0-B9CDC866BFCA}"/>
               </a:ext>
             </a:extLst>
           </p:cNvPr>
@@ -5359,7 +5359,7 @@
           <p:cNvPr id="6" name="">
             <a:extLst xmlns:a="http://schemas.openxmlformats.org/drawingml/2006/main">
               <a:ext uri="{FF2B5EF4-FFF2-40B4-BE49-F238E27FC236}">
-                <a16:creationId xmlns:a16="http://schemas.microsoft.com/office/drawing/2014/main" id="{875F1C69-2819-4982-AF9A-3F2F3845084C}"/>
+                <a16:creationId xmlns:a16="http://schemas.microsoft.com/office/drawing/2014/main" id="{0743DF9E-2F3B-47B6-A754-A3C3EFFE8B68}"/>
               </a:ext>
             </a:extLst>
           </p:cNvPr>
@@ -5564,7 +5564,7 @@
     </p:spTree>
     <p:extLst>
       <p:ext uri="{BB962C8B-B14F-4D97-AF65-F5344CB8AC3E}">
-        <p14:creationId xmlns:p14="http://schemas.microsoft.com/office/powerpoint/2010/main" val="1612334649"/>
+        <p14:creationId xmlns:p14="http://schemas.microsoft.com/office/powerpoint/2010/main" val="300157998"/>
       </p:ext>
     </p:extLst>
   </p:cSld>
@@ -5595,7 +5595,7 @@
           <p:cNvPr id="7" name="">
             <a:extLst xmlns:a="http://schemas.openxmlformats.org/drawingml/2006/main">
               <a:ext uri="{FF2B5EF4-FFF2-40B4-BE49-F238E27FC236}">
-                <a16:creationId xmlns:a16="http://schemas.microsoft.com/office/drawing/2014/main" id="{DF04DF5A-2726-4592-9D6B-8B621D4C7DC0}"/>
+                <a16:creationId xmlns:a16="http://schemas.microsoft.com/office/drawing/2014/main" id="{D3DC4369-F020-4237-971E-6F5B54C0A575}"/>
               </a:ext>
             </a:extLst>
           </p:cNvPr>
@@ -5751,7 +5751,7 @@
           <p:cNvPr id="2" name="">
             <a:extLst xmlns:a="http://schemas.openxmlformats.org/drawingml/2006/main">
               <a:ext uri="{FF2B5EF4-FFF2-40B4-BE49-F238E27FC236}">
-                <a16:creationId xmlns:a16="http://schemas.microsoft.com/office/drawing/2014/main" id="{7D7A64CD-6FB2-4247-8156-83CF85C5AB32}"/>
+                <a16:creationId xmlns:a16="http://schemas.microsoft.com/office/drawing/2014/main" id="{0CE2DF83-2810-44B0-9C17-D930E7478057}"/>
               </a:ext>
             </a:extLst>
           </p:cNvPr>
@@ -5907,7 +5907,7 @@
           <p:cNvPr id="3" name="">
             <a:extLst xmlns:a="http://schemas.openxmlformats.org/drawingml/2006/main">
               <a:ext uri="{FF2B5EF4-FFF2-40B4-BE49-F238E27FC236}">
-                <a16:creationId xmlns:a16="http://schemas.microsoft.com/office/drawing/2014/main" id="{7A1F0309-CD98-4306-8F89-9464306D1D15}"/>
+                <a16:creationId xmlns:a16="http://schemas.microsoft.com/office/drawing/2014/main" id="{44261E5F-183E-4178-A97D-1685161D0442}"/>
               </a:ext>
             </a:extLst>
           </p:cNvPr>
@@ -6047,7 +6047,7 @@
           <p:cNvPr id="4" name="">
             <a:extLst xmlns:a="http://schemas.openxmlformats.org/drawingml/2006/main">
               <a:ext uri="{FF2B5EF4-FFF2-40B4-BE49-F238E27FC236}">
-                <a16:creationId xmlns:a16="http://schemas.microsoft.com/office/drawing/2014/main" id="{40667B13-0F4E-47C0-9D61-48B3BD399C12}"/>
+                <a16:creationId xmlns:a16="http://schemas.microsoft.com/office/drawing/2014/main" id="{D6CC6B00-148D-45F7-AB1D-3DE38C32B4CB}"/>
               </a:ext>
             </a:extLst>
           </p:cNvPr>
@@ -6203,7 +6203,7 @@
           <p:cNvPr id="5" name="">
             <a:extLst xmlns:a="http://schemas.openxmlformats.org/drawingml/2006/main">
               <a:ext uri="{FF2B5EF4-FFF2-40B4-BE49-F238E27FC236}">
-                <a16:creationId xmlns:a16="http://schemas.microsoft.com/office/drawing/2014/main" id="{1C504896-50A8-414F-BC6C-1F942395F81A}"/>
+                <a16:creationId xmlns:a16="http://schemas.microsoft.com/office/drawing/2014/main" id="{D8C2B6C8-974F-4D61-ADB8-987F6204F35D}"/>
               </a:ext>
             </a:extLst>
           </p:cNvPr>
@@ -6382,7 +6382,7 @@
           <p:cNvPr id="6" name="">
             <a:extLst xmlns:a="http://schemas.openxmlformats.org/drawingml/2006/main">
               <a:ext uri="{FF2B5EF4-FFF2-40B4-BE49-F238E27FC236}">
-                <a16:creationId xmlns:a16="http://schemas.microsoft.com/office/drawing/2014/main" id="{5B6A9EDB-521B-4778-ACC7-E13B8EF2F3DC}"/>
+                <a16:creationId xmlns:a16="http://schemas.microsoft.com/office/drawing/2014/main" id="{DB70690E-A2C8-47D0-86D4-58905A970CBF}"/>
               </a:ext>
             </a:extLst>
           </p:cNvPr>
@@ -6564,7 +6564,7 @@
     </p:spTree>
     <p:extLst>
       <p:ext uri="{BB962C8B-B14F-4D97-AF65-F5344CB8AC3E}">
-        <p14:creationId xmlns:p14="http://schemas.microsoft.com/office/powerpoint/2010/main" val="70988619"/>
+        <p14:creationId xmlns:p14="http://schemas.microsoft.com/office/powerpoint/2010/main" val="1209903509"/>
       </p:ext>
     </p:extLst>
   </p:cSld>
@@ -6595,7 +6595,7 @@
           <p:cNvPr id="7" name="">
             <a:extLst xmlns:a="http://schemas.openxmlformats.org/drawingml/2006/main">
               <a:ext uri="{FF2B5EF4-FFF2-40B4-BE49-F238E27FC236}">
-                <a16:creationId xmlns:a16="http://schemas.microsoft.com/office/drawing/2014/main" id="{28AD6490-6BC0-4B9B-9C3A-FF104FFE1509}"/>
+                <a16:creationId xmlns:a16="http://schemas.microsoft.com/office/drawing/2014/main" id="{500584E0-3BBB-4297-81BD-427DAC81E612}"/>
               </a:ext>
             </a:extLst>
           </p:cNvPr>
@@ -6751,7 +6751,7 @@
           <p:cNvPr id="2" name="">
             <a:extLst xmlns:a="http://schemas.openxmlformats.org/drawingml/2006/main">
               <a:ext uri="{FF2B5EF4-FFF2-40B4-BE49-F238E27FC236}">
-                <a16:creationId xmlns:a16="http://schemas.microsoft.com/office/drawing/2014/main" id="{0DA00A07-146E-4E2E-83CE-C7EE00E40DFE}"/>
+                <a16:creationId xmlns:a16="http://schemas.microsoft.com/office/drawing/2014/main" id="{771906DC-8AD1-49B0-9FBE-6617B356F025}"/>
               </a:ext>
             </a:extLst>
           </p:cNvPr>
@@ -6907,7 +6907,7 @@
           <p:cNvPr id="3" name="">
             <a:extLst xmlns:a="http://schemas.openxmlformats.org/drawingml/2006/main">
               <a:ext uri="{FF2B5EF4-FFF2-40B4-BE49-F238E27FC236}">
-                <a16:creationId xmlns:a16="http://schemas.microsoft.com/office/drawing/2014/main" id="{9EE8CADC-D664-47D4-90E6-556097480459}"/>
+                <a16:creationId xmlns:a16="http://schemas.microsoft.com/office/drawing/2014/main" id="{6190B0D5-D7A0-44CC-B6AF-A785CBD9416C}"/>
               </a:ext>
             </a:extLst>
           </p:cNvPr>
@@ -7047,7 +7047,7 @@
           <p:cNvPr id="4" name="">
             <a:extLst xmlns:a="http://schemas.openxmlformats.org/drawingml/2006/main">
               <a:ext uri="{FF2B5EF4-FFF2-40B4-BE49-F238E27FC236}">
-                <a16:creationId xmlns:a16="http://schemas.microsoft.com/office/drawing/2014/main" id="{ED325962-B41A-4701-BB7D-4B9991DA0B37}"/>
+                <a16:creationId xmlns:a16="http://schemas.microsoft.com/office/drawing/2014/main" id="{AFBD3A9F-86A7-4862-95D1-E3AE399C6B1E}"/>
               </a:ext>
             </a:extLst>
           </p:cNvPr>
@@ -7203,7 +7203,7 @@
           <p:cNvPr id="5" name="">
             <a:extLst xmlns:a="http://schemas.openxmlformats.org/drawingml/2006/main">
               <a:ext uri="{FF2B5EF4-FFF2-40B4-BE49-F238E27FC236}">
-                <a16:creationId xmlns:a16="http://schemas.microsoft.com/office/drawing/2014/main" id="{26D07703-23F1-4CA7-AC58-1D36EDE133B5}"/>
+                <a16:creationId xmlns:a16="http://schemas.microsoft.com/office/drawing/2014/main" id="{537CBFA8-9A18-4C11-A7CF-D5645C72F0EF}"/>
               </a:ext>
             </a:extLst>
           </p:cNvPr>
@@ -7213,7 +7213,7 @@
           <p:nvPr/>
         </p:nvPicPr>
         <p:blipFill>
-          <a:blip xmlns:r="http://schemas.openxmlformats.org/officeDocument/2006/relationships" xmlns:a="http://schemas.openxmlformats.org/drawingml/2006/main" r:embed="Rfc8b32e8c6bf4ada"/>
+          <a:blip xmlns:r="http://schemas.openxmlformats.org/officeDocument/2006/relationships" xmlns:a="http://schemas.openxmlformats.org/drawingml/2006/main" r:embed="Rf8aefffdb95d40eb"/>
           <a:stretch xmlns:a="http://schemas.openxmlformats.org/drawingml/2006/main"/>
         </p:blipFill>
         <p:spPr>
@@ -7231,7 +7231,7 @@
           <p:cNvPr id="6" name="">
             <a:extLst xmlns:a="http://schemas.openxmlformats.org/drawingml/2006/main">
               <a:ext uri="{FF2B5EF4-FFF2-40B4-BE49-F238E27FC236}">
-                <a16:creationId xmlns:a16="http://schemas.microsoft.com/office/drawing/2014/main" id="{B0212CE2-F2AE-40B2-A41F-97F75943D675}"/>
+                <a16:creationId xmlns:a16="http://schemas.microsoft.com/office/drawing/2014/main" id="{53585E80-21A9-4FED-A0CD-E5AF3E95D8CF}"/>
               </a:ext>
             </a:extLst>
           </p:cNvPr>
@@ -7385,7 +7385,7 @@
     </p:spTree>
     <p:extLst>
       <p:ext uri="{BB962C8B-B14F-4D97-AF65-F5344CB8AC3E}">
-        <p14:creationId xmlns:p14="http://schemas.microsoft.com/office/powerpoint/2010/main" val="1961797703"/>
+        <p14:creationId xmlns:p14="http://schemas.microsoft.com/office/powerpoint/2010/main" val="382208671"/>
       </p:ext>
     </p:extLst>
   </p:cSld>
@@ -7416,7 +7416,7 @@
           <p:cNvPr id="7" name="">
             <a:extLst xmlns:a="http://schemas.openxmlformats.org/drawingml/2006/main">
               <a:ext uri="{FF2B5EF4-FFF2-40B4-BE49-F238E27FC236}">
-                <a16:creationId xmlns:a16="http://schemas.microsoft.com/office/drawing/2014/main" id="{B6E12BCF-0B93-4F25-8834-0FA8213A9020}"/>
+                <a16:creationId xmlns:a16="http://schemas.microsoft.com/office/drawing/2014/main" id="{D4F4086A-7E08-4CE5-97F6-245DBE83D6B7}"/>
               </a:ext>
             </a:extLst>
           </p:cNvPr>
@@ -7572,7 +7572,7 @@
           <p:cNvPr id="2" name="">
             <a:extLst xmlns:a="http://schemas.openxmlformats.org/drawingml/2006/main">
               <a:ext uri="{FF2B5EF4-FFF2-40B4-BE49-F238E27FC236}">
-                <a16:creationId xmlns:a16="http://schemas.microsoft.com/office/drawing/2014/main" id="{7BD2A8EB-CE27-49AA-83B8-C49740C0F3B1}"/>
+                <a16:creationId xmlns:a16="http://schemas.microsoft.com/office/drawing/2014/main" id="{28B40EA6-075A-44F3-8CE5-729395E67CF9}"/>
               </a:ext>
             </a:extLst>
           </p:cNvPr>
@@ -7728,7 +7728,7 @@
           <p:cNvPr id="3" name="">
             <a:extLst xmlns:a="http://schemas.openxmlformats.org/drawingml/2006/main">
               <a:ext uri="{FF2B5EF4-FFF2-40B4-BE49-F238E27FC236}">
-                <a16:creationId xmlns:a16="http://schemas.microsoft.com/office/drawing/2014/main" id="{0C6E5DFA-F61F-408C-9C97-183EF906091F}"/>
+                <a16:creationId xmlns:a16="http://schemas.microsoft.com/office/drawing/2014/main" id="{8C86061C-830A-44B3-8394-A0F87B870046}"/>
               </a:ext>
             </a:extLst>
           </p:cNvPr>
@@ -7868,7 +7868,7 @@
           <p:cNvPr id="4" name="">
             <a:extLst xmlns:a="http://schemas.openxmlformats.org/drawingml/2006/main">
               <a:ext uri="{FF2B5EF4-FFF2-40B4-BE49-F238E27FC236}">
-                <a16:creationId xmlns:a16="http://schemas.microsoft.com/office/drawing/2014/main" id="{E26782FD-1295-48A9-A766-12FFF3931D9B}"/>
+                <a16:creationId xmlns:a16="http://schemas.microsoft.com/office/drawing/2014/main" id="{9FF3E2AA-98D1-400A-8057-6FB158CC0DFE}"/>
               </a:ext>
             </a:extLst>
           </p:cNvPr>
@@ -8024,7 +8024,7 @@
           <p:cNvPr id="5" name="">
             <a:extLst xmlns:a="http://schemas.openxmlformats.org/drawingml/2006/main">
               <a:ext uri="{FF2B5EF4-FFF2-40B4-BE49-F238E27FC236}">
-                <a16:creationId xmlns:a16="http://schemas.microsoft.com/office/drawing/2014/main" id="{CF27D612-F1E5-4179-86FF-D625320A76D3}"/>
+                <a16:creationId xmlns:a16="http://schemas.microsoft.com/office/drawing/2014/main" id="{83C93366-24AE-45DD-B124-1E9C9EDA3E14}"/>
               </a:ext>
             </a:extLst>
           </p:cNvPr>
@@ -8034,7 +8034,7 @@
           <p:nvPr/>
         </p:nvPicPr>
         <p:blipFill>
-          <a:blip xmlns:r="http://schemas.openxmlformats.org/officeDocument/2006/relationships" xmlns:a="http://schemas.openxmlformats.org/drawingml/2006/main" r:embed="Rf8142c0e7a114303"/>
+          <a:blip xmlns:r="http://schemas.openxmlformats.org/officeDocument/2006/relationships" xmlns:a="http://schemas.openxmlformats.org/drawingml/2006/main" r:embed="R4e952415c6204173"/>
           <a:stretch xmlns:a="http://schemas.openxmlformats.org/drawingml/2006/main"/>
         </p:blipFill>
         <p:spPr>
@@ -8052,7 +8052,7 @@
           <p:cNvPr id="6" name="">
             <a:extLst xmlns:a="http://schemas.openxmlformats.org/drawingml/2006/main">
               <a:ext uri="{FF2B5EF4-FFF2-40B4-BE49-F238E27FC236}">
-                <a16:creationId xmlns:a16="http://schemas.microsoft.com/office/drawing/2014/main" id="{7A44E8EB-143F-4B8F-AC76-6FCBDD4F11A1}"/>
+                <a16:creationId xmlns:a16="http://schemas.microsoft.com/office/drawing/2014/main" id="{FE63AC8D-8CF4-47E1-A53B-707EDB829B8F}"/>
               </a:ext>
             </a:extLst>
           </p:cNvPr>
@@ -8198,7 +8198,7 @@
                 <a:ea typeface="Noto Sans"/>
                 <a:cs typeface="Noto Sans"/>
               </a:rPr>
-              <a:t>PR: complete · TC: running · Snapshot resume: bounded validation passed, reboot untested.</a:t>
+              <a:t>PR: complete · TC: complete · Snapshot resume: bounded validation passed, reboot untested.</a:t>
             </a:r>
           </a:p>
         </p:txBody>
@@ -8206,7 +8206,7 @@
     </p:spTree>
     <p:extLst>
       <p:ext uri="{BB962C8B-B14F-4D97-AF65-F5344CB8AC3E}">
-        <p14:creationId xmlns:p14="http://schemas.microsoft.com/office/powerpoint/2010/main" val="1882745088"/>
+        <p14:creationId xmlns:p14="http://schemas.microsoft.com/office/powerpoint/2010/main" val="1922461015"/>
       </p:ext>
     </p:extLst>
   </p:cSld>
@@ -8237,7 +8237,7 @@
           <p:cNvPr id="7" name="">
             <a:extLst xmlns:a="http://schemas.openxmlformats.org/drawingml/2006/main">
               <a:ext uri="{FF2B5EF4-FFF2-40B4-BE49-F238E27FC236}">
-                <a16:creationId xmlns:a16="http://schemas.microsoft.com/office/drawing/2014/main" id="{F30DE204-E93E-40FE-91D7-E2F57DCF4D7B}"/>
+                <a16:creationId xmlns:a16="http://schemas.microsoft.com/office/drawing/2014/main" id="{7D263BA5-5BD3-4860-888F-4E3A574E4095}"/>
               </a:ext>
             </a:extLst>
           </p:cNvPr>
@@ -8393,7 +8393,7 @@
           <p:cNvPr id="2" name="">
             <a:extLst xmlns:a="http://schemas.openxmlformats.org/drawingml/2006/main">
               <a:ext uri="{FF2B5EF4-FFF2-40B4-BE49-F238E27FC236}">
-                <a16:creationId xmlns:a16="http://schemas.microsoft.com/office/drawing/2014/main" id="{2068B022-B011-434A-B942-C53AA1EB604B}"/>
+                <a16:creationId xmlns:a16="http://schemas.microsoft.com/office/drawing/2014/main" id="{0A7FB993-9A57-484C-B1B7-FB2FE0BC0A63}"/>
               </a:ext>
             </a:extLst>
           </p:cNvPr>
@@ -8549,7 +8549,7 @@
           <p:cNvPr id="3" name="">
             <a:extLst xmlns:a="http://schemas.openxmlformats.org/drawingml/2006/main">
               <a:ext uri="{FF2B5EF4-FFF2-40B4-BE49-F238E27FC236}">
-                <a16:creationId xmlns:a16="http://schemas.microsoft.com/office/drawing/2014/main" id="{88DFBC50-8957-4D53-A64D-267ADAF5735C}"/>
+                <a16:creationId xmlns:a16="http://schemas.microsoft.com/office/drawing/2014/main" id="{C906158B-1FE2-4F73-8D99-BEFAC4A0D00C}"/>
               </a:ext>
             </a:extLst>
           </p:cNvPr>
@@ -8689,7 +8689,7 @@
           <p:cNvPr id="4" name="">
             <a:extLst xmlns:a="http://schemas.openxmlformats.org/drawingml/2006/main">
               <a:ext uri="{FF2B5EF4-FFF2-40B4-BE49-F238E27FC236}">
-                <a16:creationId xmlns:a16="http://schemas.microsoft.com/office/drawing/2014/main" id="{549C6DBD-F0A3-430B-AB13-8C128B25D29A}"/>
+                <a16:creationId xmlns:a16="http://schemas.microsoft.com/office/drawing/2014/main" id="{7D1E5CFA-D6B2-452E-A37C-C91D5D8EC439}"/>
               </a:ext>
             </a:extLst>
           </p:cNvPr>
@@ -8845,7 +8845,7 @@
           <p:cNvPr id="5" name="">
             <a:extLst xmlns:a="http://schemas.openxmlformats.org/drawingml/2006/main">
               <a:ext uri="{FF2B5EF4-FFF2-40B4-BE49-F238E27FC236}">
-                <a16:creationId xmlns:a16="http://schemas.microsoft.com/office/drawing/2014/main" id="{724E418C-CD9F-4B9F-8050-B1F7D3DF5B3E}"/>
+                <a16:creationId xmlns:a16="http://schemas.microsoft.com/office/drawing/2014/main" id="{57AC3C5B-C541-485C-9513-7FBF831547C0}"/>
               </a:ext>
             </a:extLst>
           </p:cNvPr>
@@ -8855,7 +8855,7 @@
           <p:nvPr/>
         </p:nvPicPr>
         <p:blipFill>
-          <a:blip xmlns:r="http://schemas.openxmlformats.org/officeDocument/2006/relationships" xmlns:a="http://schemas.openxmlformats.org/drawingml/2006/main" r:embed="R08efbbbc7c5a4410"/>
+          <a:blip xmlns:r="http://schemas.openxmlformats.org/officeDocument/2006/relationships" xmlns:a="http://schemas.openxmlformats.org/drawingml/2006/main" r:embed="R749b8ce075d040d0"/>
           <a:stretch xmlns:a="http://schemas.openxmlformats.org/drawingml/2006/main"/>
         </p:blipFill>
         <p:spPr>
@@ -8873,7 +8873,7 @@
           <p:cNvPr id="6" name="">
             <a:extLst xmlns:a="http://schemas.openxmlformats.org/drawingml/2006/main">
               <a:ext uri="{FF2B5EF4-FFF2-40B4-BE49-F238E27FC236}">
-                <a16:creationId xmlns:a16="http://schemas.microsoft.com/office/drawing/2014/main" id="{9307B52B-B456-486D-BFFD-472904FFDF0D}"/>
+                <a16:creationId xmlns:a16="http://schemas.microsoft.com/office/drawing/2014/main" id="{6AAB5DE5-6A67-41BE-BED0-BB78852BD09A}"/>
               </a:ext>
             </a:extLst>
           </p:cNvPr>
@@ -9152,7 +9152,7 @@
     </p:spTree>
     <p:extLst>
       <p:ext uri="{BB962C8B-B14F-4D97-AF65-F5344CB8AC3E}">
-        <p14:creationId xmlns:p14="http://schemas.microsoft.com/office/powerpoint/2010/main" val="320725551"/>
+        <p14:creationId xmlns:p14="http://schemas.microsoft.com/office/powerpoint/2010/main" val="1352078952"/>
       </p:ext>
     </p:extLst>
   </p:cSld>
@@ -9183,7 +9183,7 @@
           <p:cNvPr id="7" name="">
             <a:extLst xmlns:a="http://schemas.openxmlformats.org/drawingml/2006/main">
               <a:ext uri="{FF2B5EF4-FFF2-40B4-BE49-F238E27FC236}">
-                <a16:creationId xmlns:a16="http://schemas.microsoft.com/office/drawing/2014/main" id="{7AAF2739-77C6-47CE-9D60-832BC6FC630E}"/>
+                <a16:creationId xmlns:a16="http://schemas.microsoft.com/office/drawing/2014/main" id="{DA23C989-EAE9-4DE1-8595-913B58210F4C}"/>
               </a:ext>
             </a:extLst>
           </p:cNvPr>
@@ -9339,7 +9339,7 @@
           <p:cNvPr id="2" name="">
             <a:extLst xmlns:a="http://schemas.openxmlformats.org/drawingml/2006/main">
               <a:ext uri="{FF2B5EF4-FFF2-40B4-BE49-F238E27FC236}">
-                <a16:creationId xmlns:a16="http://schemas.microsoft.com/office/drawing/2014/main" id="{ED7289E5-6A59-4248-8453-EB715864389D}"/>
+                <a16:creationId xmlns:a16="http://schemas.microsoft.com/office/drawing/2014/main" id="{41DB8C9D-175C-4039-8E84-ABC704D6EDC8}"/>
               </a:ext>
             </a:extLst>
           </p:cNvPr>
@@ -9495,7 +9495,7 @@
           <p:cNvPr id="3" name="">
             <a:extLst xmlns:a="http://schemas.openxmlformats.org/drawingml/2006/main">
               <a:ext uri="{FF2B5EF4-FFF2-40B4-BE49-F238E27FC236}">
-                <a16:creationId xmlns:a16="http://schemas.microsoft.com/office/drawing/2014/main" id="{65670840-375A-4941-B5AC-08184ECD9AE0}"/>
+                <a16:creationId xmlns:a16="http://schemas.microsoft.com/office/drawing/2014/main" id="{9E91F6C8-0685-4D55-B2E4-0653755D26A8}"/>
               </a:ext>
             </a:extLst>
           </p:cNvPr>
@@ -9635,7 +9635,7 @@
           <p:cNvPr id="4" name="">
             <a:extLst xmlns:a="http://schemas.openxmlformats.org/drawingml/2006/main">
               <a:ext uri="{FF2B5EF4-FFF2-40B4-BE49-F238E27FC236}">
-                <a16:creationId xmlns:a16="http://schemas.microsoft.com/office/drawing/2014/main" id="{AE94C7DC-EA37-4148-A7B3-28B44649F0E2}"/>
+                <a16:creationId xmlns:a16="http://schemas.microsoft.com/office/drawing/2014/main" id="{7D699F55-5A3A-4A78-92BF-715C739DB17F}"/>
               </a:ext>
             </a:extLst>
           </p:cNvPr>
@@ -9791,7 +9791,7 @@
           <p:cNvPr id="5" name="">
             <a:extLst xmlns:a="http://schemas.openxmlformats.org/drawingml/2006/main">
               <a:ext uri="{FF2B5EF4-FFF2-40B4-BE49-F238E27FC236}">
-                <a16:creationId xmlns:a16="http://schemas.microsoft.com/office/drawing/2014/main" id="{DDC64F89-14EA-4AA4-B433-1792B8F1F723}"/>
+                <a16:creationId xmlns:a16="http://schemas.microsoft.com/office/drawing/2014/main" id="{6602E806-34D9-4896-889B-E562B74C2FB9}"/>
               </a:ext>
             </a:extLst>
           </p:cNvPr>
@@ -9801,7 +9801,7 @@
           <p:nvPr/>
         </p:nvPicPr>
         <p:blipFill>
-          <a:blip xmlns:r="http://schemas.openxmlformats.org/officeDocument/2006/relationships" xmlns:a="http://schemas.openxmlformats.org/drawingml/2006/main" r:embed="R370eea93c0584c22"/>
+          <a:blip xmlns:r="http://schemas.openxmlformats.org/officeDocument/2006/relationships" xmlns:a="http://schemas.openxmlformats.org/drawingml/2006/main" r:embed="R3db7976803994b54"/>
           <a:stretch xmlns:a="http://schemas.openxmlformats.org/drawingml/2006/main"/>
         </p:blipFill>
         <p:spPr>
@@ -9819,7 +9819,7 @@
           <p:cNvPr id="6" name="">
             <a:extLst xmlns:a="http://schemas.openxmlformats.org/drawingml/2006/main">
               <a:ext uri="{FF2B5EF4-FFF2-40B4-BE49-F238E27FC236}">
-                <a16:creationId xmlns:a16="http://schemas.microsoft.com/office/drawing/2014/main" id="{012BA3B3-5465-48B4-892D-47EBA4155C3C}"/>
+                <a16:creationId xmlns:a16="http://schemas.microsoft.com/office/drawing/2014/main" id="{447F6D3E-174F-4AC4-8731-95592F425341}"/>
               </a:ext>
             </a:extLst>
           </p:cNvPr>
@@ -10080,7 +10080,7 @@
     </p:spTree>
     <p:extLst>
       <p:ext uri="{BB962C8B-B14F-4D97-AF65-F5344CB8AC3E}">
-        <p14:creationId xmlns:p14="http://schemas.microsoft.com/office/powerpoint/2010/main" val="624042891"/>
+        <p14:creationId xmlns:p14="http://schemas.microsoft.com/office/powerpoint/2010/main" val="924459817"/>
       </p:ext>
     </p:extLst>
   </p:cSld>
@@ -10111,7 +10111,7 @@
           <p:cNvPr id="6" name="">
             <a:extLst xmlns:a="http://schemas.openxmlformats.org/drawingml/2006/main">
               <a:ext uri="{FF2B5EF4-FFF2-40B4-BE49-F238E27FC236}">
-                <a16:creationId xmlns:a16="http://schemas.microsoft.com/office/drawing/2014/main" id="{B8AE1FC3-A5AD-4E0E-862A-C5B6AAA700D7}"/>
+                <a16:creationId xmlns:a16="http://schemas.microsoft.com/office/drawing/2014/main" id="{275DFF1E-618D-43D4-A25A-1752E1BB9784}"/>
               </a:ext>
             </a:extLst>
           </p:cNvPr>
@@ -10267,7 +10267,7 @@
           <p:cNvPr id="2" name="">
             <a:extLst xmlns:a="http://schemas.openxmlformats.org/drawingml/2006/main">
               <a:ext uri="{FF2B5EF4-FFF2-40B4-BE49-F238E27FC236}">
-                <a16:creationId xmlns:a16="http://schemas.microsoft.com/office/drawing/2014/main" id="{26E951FA-FBBC-4CDE-A3B0-5B0A6CD09F78}"/>
+                <a16:creationId xmlns:a16="http://schemas.microsoft.com/office/drawing/2014/main" id="{87DEA45F-C4D4-439C-9DFB-A30CBACC26C6}"/>
               </a:ext>
             </a:extLst>
           </p:cNvPr>
@@ -10423,7 +10423,7 @@
           <p:cNvPr id="3" name="">
             <a:extLst xmlns:a="http://schemas.openxmlformats.org/drawingml/2006/main">
               <a:ext uri="{FF2B5EF4-FFF2-40B4-BE49-F238E27FC236}">
-                <a16:creationId xmlns:a16="http://schemas.microsoft.com/office/drawing/2014/main" id="{63C4691B-2B85-459C-8EB0-0EFA5095D919}"/>
+                <a16:creationId xmlns:a16="http://schemas.microsoft.com/office/drawing/2014/main" id="{D5C0A064-B5D0-4041-BD16-FA33F6EFE09B}"/>
               </a:ext>
             </a:extLst>
           </p:cNvPr>
@@ -10563,7 +10563,7 @@
           <p:cNvPr id="4" name="">
             <a:extLst xmlns:a="http://schemas.openxmlformats.org/drawingml/2006/main">
               <a:ext uri="{FF2B5EF4-FFF2-40B4-BE49-F238E27FC236}">
-                <a16:creationId xmlns:a16="http://schemas.microsoft.com/office/drawing/2014/main" id="{DB870E87-F820-4181-BC8B-9050DB002841}"/>
+                <a16:creationId xmlns:a16="http://schemas.microsoft.com/office/drawing/2014/main" id="{5FB5A0D9-F1BD-4AF9-8DB8-58AA3810DB37}"/>
               </a:ext>
             </a:extLst>
           </p:cNvPr>
@@ -10719,7 +10719,7 @@
           <p:cNvPr id="5" name="">
             <a:extLst xmlns:a="http://schemas.openxmlformats.org/drawingml/2006/main">
               <a:ext uri="{FF2B5EF4-FFF2-40B4-BE49-F238E27FC236}">
-                <a16:creationId xmlns:a16="http://schemas.microsoft.com/office/drawing/2014/main" id="{F47BFE60-A0FD-4889-86DE-BCE94BC0DE73}"/>
+                <a16:creationId xmlns:a16="http://schemas.microsoft.com/office/drawing/2014/main" id="{7BC9ADC2-871A-40D9-8670-55DB29803D71}"/>
               </a:ext>
             </a:extLst>
           </p:cNvPr>
@@ -10980,7 +10980,7 @@
     </p:spTree>
     <p:extLst>
       <p:ext uri="{BB962C8B-B14F-4D97-AF65-F5344CB8AC3E}">
-        <p14:creationId xmlns:p14="http://schemas.microsoft.com/office/powerpoint/2010/main" val="1637517742"/>
+        <p14:creationId xmlns:p14="http://schemas.microsoft.com/office/powerpoint/2010/main" val="1144818246"/>
       </p:ext>
     </p:extLst>
   </p:cSld>
@@ -11011,7 +11011,7 @@
           <p:cNvPr id="6" name="">
             <a:extLst xmlns:a="http://schemas.openxmlformats.org/drawingml/2006/main">
               <a:ext uri="{FF2B5EF4-FFF2-40B4-BE49-F238E27FC236}">
-                <a16:creationId xmlns:a16="http://schemas.microsoft.com/office/drawing/2014/main" id="{9DBDDC7C-898F-4461-A39B-0B40E45759C5}"/>
+                <a16:creationId xmlns:a16="http://schemas.microsoft.com/office/drawing/2014/main" id="{0B306BCC-DC04-4C7F-9A2E-EE750EB44D15}"/>
               </a:ext>
             </a:extLst>
           </p:cNvPr>
@@ -11167,7 +11167,7 @@
           <p:cNvPr id="2" name="">
             <a:extLst xmlns:a="http://schemas.openxmlformats.org/drawingml/2006/main">
               <a:ext uri="{FF2B5EF4-FFF2-40B4-BE49-F238E27FC236}">
-                <a16:creationId xmlns:a16="http://schemas.microsoft.com/office/drawing/2014/main" id="{0FA87106-A696-4C01-8403-B40181AD1A41}"/>
+                <a16:creationId xmlns:a16="http://schemas.microsoft.com/office/drawing/2014/main" id="{531118CB-7AA4-4F57-B91C-62CDCA58AD3F}"/>
               </a:ext>
             </a:extLst>
           </p:cNvPr>
@@ -11323,7 +11323,7 @@
           <p:cNvPr id="3" name="">
             <a:extLst xmlns:a="http://schemas.openxmlformats.org/drawingml/2006/main">
               <a:ext uri="{FF2B5EF4-FFF2-40B4-BE49-F238E27FC236}">
-                <a16:creationId xmlns:a16="http://schemas.microsoft.com/office/drawing/2014/main" id="{6AE208C6-FB2B-48EF-A1AF-3F4541B3DB37}"/>
+                <a16:creationId xmlns:a16="http://schemas.microsoft.com/office/drawing/2014/main" id="{A72C4C76-CC37-441A-A8AC-6576CE402155}"/>
               </a:ext>
             </a:extLst>
           </p:cNvPr>
@@ -11463,7 +11463,7 @@
           <p:cNvPr id="4" name="">
             <a:extLst xmlns:a="http://schemas.openxmlformats.org/drawingml/2006/main">
               <a:ext uri="{FF2B5EF4-FFF2-40B4-BE49-F238E27FC236}">
-                <a16:creationId xmlns:a16="http://schemas.microsoft.com/office/drawing/2014/main" id="{4D86513A-0821-4955-8C2A-39BB27F0E496}"/>
+                <a16:creationId xmlns:a16="http://schemas.microsoft.com/office/drawing/2014/main" id="{F550C15B-DAB2-4334-872C-303503A52ECE}"/>
               </a:ext>
             </a:extLst>
           </p:cNvPr>
@@ -11619,7 +11619,7 @@
           <p:cNvPr id="5" name="">
             <a:extLst xmlns:a="http://schemas.openxmlformats.org/drawingml/2006/main">
               <a:ext uri="{FF2B5EF4-FFF2-40B4-BE49-F238E27FC236}">
-                <a16:creationId xmlns:a16="http://schemas.microsoft.com/office/drawing/2014/main" id="{4FC2B0C6-7E0F-41EF-AE14-F4EF85680AB6}"/>
+                <a16:creationId xmlns:a16="http://schemas.microsoft.com/office/drawing/2014/main" id="{097B5F59-A52A-49B0-A586-AE3870E68A9A}"/>
               </a:ext>
             </a:extLst>
           </p:cNvPr>
@@ -11829,7 +11829,7 @@
     </p:spTree>
     <p:extLst>
       <p:ext uri="{BB962C8B-B14F-4D97-AF65-F5344CB8AC3E}">
-        <p14:creationId xmlns:p14="http://schemas.microsoft.com/office/powerpoint/2010/main" val="83424288"/>
+        <p14:creationId xmlns:p14="http://schemas.microsoft.com/office/powerpoint/2010/main" val="1755705603"/>
       </p:ext>
     </p:extLst>
   </p:cSld>
@@ -11860,7 +11860,7 @@
           <p:cNvPr id="6" name="">
             <a:extLst xmlns:a="http://schemas.openxmlformats.org/drawingml/2006/main">
               <a:ext uri="{FF2B5EF4-FFF2-40B4-BE49-F238E27FC236}">
-                <a16:creationId xmlns:a16="http://schemas.microsoft.com/office/drawing/2014/main" id="{07972FFA-D39A-4285-931D-1D4FB3D576D5}"/>
+                <a16:creationId xmlns:a16="http://schemas.microsoft.com/office/drawing/2014/main" id="{A9C210DA-36BA-4A68-BDFA-3296CFCF96EE}"/>
               </a:ext>
             </a:extLst>
           </p:cNvPr>
@@ -12016,7 +12016,7 @@
           <p:cNvPr id="2" name="">
             <a:extLst xmlns:a="http://schemas.openxmlformats.org/drawingml/2006/main">
               <a:ext uri="{FF2B5EF4-FFF2-40B4-BE49-F238E27FC236}">
-                <a16:creationId xmlns:a16="http://schemas.microsoft.com/office/drawing/2014/main" id="{038C14DC-0B61-41A8-97BA-A689669DC6A2}"/>
+                <a16:creationId xmlns:a16="http://schemas.microsoft.com/office/drawing/2014/main" id="{67424EFC-7F4B-4384-90AD-3A95532C7C4A}"/>
               </a:ext>
             </a:extLst>
           </p:cNvPr>
@@ -12172,7 +12172,7 @@
           <p:cNvPr id="3" name="">
             <a:extLst xmlns:a="http://schemas.openxmlformats.org/drawingml/2006/main">
               <a:ext uri="{FF2B5EF4-FFF2-40B4-BE49-F238E27FC236}">
-                <a16:creationId xmlns:a16="http://schemas.microsoft.com/office/drawing/2014/main" id="{77CBC439-CE6C-4D57-8A80-66BDCC422342}"/>
+                <a16:creationId xmlns:a16="http://schemas.microsoft.com/office/drawing/2014/main" id="{438F718D-64EF-4FFB-BDA8-E68A35137C71}"/>
               </a:ext>
             </a:extLst>
           </p:cNvPr>
@@ -12312,7 +12312,7 @@
           <p:cNvPr id="4" name="">
             <a:extLst xmlns:a="http://schemas.openxmlformats.org/drawingml/2006/main">
               <a:ext uri="{FF2B5EF4-FFF2-40B4-BE49-F238E27FC236}">
-                <a16:creationId xmlns:a16="http://schemas.microsoft.com/office/drawing/2014/main" id="{2BE151D7-342B-411B-BA60-C81C8F9C91BA}"/>
+                <a16:creationId xmlns:a16="http://schemas.microsoft.com/office/drawing/2014/main" id="{DA6EF674-9365-44EF-B12B-2F6F09D6F73C}"/>
               </a:ext>
             </a:extLst>
           </p:cNvPr>
@@ -12468,7 +12468,7 @@
           <p:cNvPr id="5" name="">
             <a:extLst xmlns:a="http://schemas.openxmlformats.org/drawingml/2006/main">
               <a:ext uri="{FF2B5EF4-FFF2-40B4-BE49-F238E27FC236}">
-                <a16:creationId xmlns:a16="http://schemas.microsoft.com/office/drawing/2014/main" id="{BED8C84C-5B86-4626-9846-5B1D6C9C8662}"/>
+                <a16:creationId xmlns:a16="http://schemas.microsoft.com/office/drawing/2014/main" id="{A8292E12-B22D-40E7-B92B-5886A5BD2B75}"/>
               </a:ext>
             </a:extLst>
           </p:cNvPr>
@@ -12706,7 +12706,7 @@
     </p:spTree>
     <p:extLst>
       <p:ext uri="{BB962C8B-B14F-4D97-AF65-F5344CB8AC3E}">
-        <p14:creationId xmlns:p14="http://schemas.microsoft.com/office/powerpoint/2010/main" val="955930551"/>
+        <p14:creationId xmlns:p14="http://schemas.microsoft.com/office/powerpoint/2010/main" val="322110164"/>
       </p:ext>
     </p:extLst>
   </p:cSld>
@@ -12737,7 +12737,7 @@
           <p:cNvPr id="6" name="">
             <a:extLst xmlns:a="http://schemas.openxmlformats.org/drawingml/2006/main">
               <a:ext uri="{FF2B5EF4-FFF2-40B4-BE49-F238E27FC236}">
-                <a16:creationId xmlns:a16="http://schemas.microsoft.com/office/drawing/2014/main" id="{F95BFD16-9AF0-4622-A88C-056708809048}"/>
+                <a16:creationId xmlns:a16="http://schemas.microsoft.com/office/drawing/2014/main" id="{2F1000BD-CCA3-436E-82EB-6EC795664A48}"/>
               </a:ext>
             </a:extLst>
           </p:cNvPr>
@@ -12893,7 +12893,7 @@
           <p:cNvPr id="2" name="">
             <a:extLst xmlns:a="http://schemas.openxmlformats.org/drawingml/2006/main">
               <a:ext uri="{FF2B5EF4-FFF2-40B4-BE49-F238E27FC236}">
-                <a16:creationId xmlns:a16="http://schemas.microsoft.com/office/drawing/2014/main" id="{1AB440E9-F4EE-41AF-9492-03E15F6CA3D3}"/>
+                <a16:creationId xmlns:a16="http://schemas.microsoft.com/office/drawing/2014/main" id="{8E22A707-EDE7-4DF7-B303-1B5F8DFB9078}"/>
               </a:ext>
             </a:extLst>
           </p:cNvPr>
@@ -13049,7 +13049,7 @@
           <p:cNvPr id="3" name="">
             <a:extLst xmlns:a="http://schemas.openxmlformats.org/drawingml/2006/main">
               <a:ext uri="{FF2B5EF4-FFF2-40B4-BE49-F238E27FC236}">
-                <a16:creationId xmlns:a16="http://schemas.microsoft.com/office/drawing/2014/main" id="{CB235F3E-ED2C-40DC-BB71-C6788E395039}"/>
+                <a16:creationId xmlns:a16="http://schemas.microsoft.com/office/drawing/2014/main" id="{A4609C26-A67E-43A9-ACC6-FAF4BAE53E3A}"/>
               </a:ext>
             </a:extLst>
           </p:cNvPr>
@@ -13189,7 +13189,7 @@
           <p:cNvPr id="4" name="">
             <a:extLst xmlns:a="http://schemas.openxmlformats.org/drawingml/2006/main">
               <a:ext uri="{FF2B5EF4-FFF2-40B4-BE49-F238E27FC236}">
-                <a16:creationId xmlns:a16="http://schemas.microsoft.com/office/drawing/2014/main" id="{6F0B4F40-3EAA-4625-B743-F2A00C6CAAAA}"/>
+                <a16:creationId xmlns:a16="http://schemas.microsoft.com/office/drawing/2014/main" id="{D24C7999-9302-49A4-81AC-EA17FB6B846E}"/>
               </a:ext>
             </a:extLst>
           </p:cNvPr>
@@ -13345,7 +13345,7 @@
           <p:cNvPr id="5" name="">
             <a:extLst xmlns:a="http://schemas.openxmlformats.org/drawingml/2006/main">
               <a:ext uri="{FF2B5EF4-FFF2-40B4-BE49-F238E27FC236}">
-                <a16:creationId xmlns:a16="http://schemas.microsoft.com/office/drawing/2014/main" id="{A6EEA96B-3C78-4038-A7C9-929B844C1C55}"/>
+                <a16:creationId xmlns:a16="http://schemas.microsoft.com/office/drawing/2014/main" id="{7F3384A3-CF4D-4B46-B69E-F3B6F5A5D263}"/>
               </a:ext>
             </a:extLst>
           </p:cNvPr>
@@ -13583,7 +13583,7 @@
     </p:spTree>
     <p:extLst>
       <p:ext uri="{BB962C8B-B14F-4D97-AF65-F5344CB8AC3E}">
-        <p14:creationId xmlns:p14="http://schemas.microsoft.com/office/powerpoint/2010/main" val="949266184"/>
+        <p14:creationId xmlns:p14="http://schemas.microsoft.com/office/powerpoint/2010/main" val="1204813943"/>
       </p:ext>
     </p:extLst>
   </p:cSld>
@@ -13614,7 +13614,7 @@
           <p:cNvPr id="6" name="">
             <a:extLst xmlns:a="http://schemas.openxmlformats.org/drawingml/2006/main">
               <a:ext uri="{FF2B5EF4-FFF2-40B4-BE49-F238E27FC236}">
-                <a16:creationId xmlns:a16="http://schemas.microsoft.com/office/drawing/2014/main" id="{AE4FC974-82D6-495A-B64D-610369BED6E2}"/>
+                <a16:creationId xmlns:a16="http://schemas.microsoft.com/office/drawing/2014/main" id="{ECB49942-186E-4F09-A9E4-4BFE985D3CEE}"/>
               </a:ext>
             </a:extLst>
           </p:cNvPr>
@@ -13770,7 +13770,7 @@
           <p:cNvPr id="2" name="">
             <a:extLst xmlns:a="http://schemas.openxmlformats.org/drawingml/2006/main">
               <a:ext uri="{FF2B5EF4-FFF2-40B4-BE49-F238E27FC236}">
-                <a16:creationId xmlns:a16="http://schemas.microsoft.com/office/drawing/2014/main" id="{B9509F12-EC5B-4373-8B26-C6532D4E211F}"/>
+                <a16:creationId xmlns:a16="http://schemas.microsoft.com/office/drawing/2014/main" id="{BF447101-D1F3-4B4E-A6A0-57169DFCD539}"/>
               </a:ext>
             </a:extLst>
           </p:cNvPr>
@@ -13926,7 +13926,7 @@
           <p:cNvPr id="3" name="">
             <a:extLst xmlns:a="http://schemas.openxmlformats.org/drawingml/2006/main">
               <a:ext uri="{FF2B5EF4-FFF2-40B4-BE49-F238E27FC236}">
-                <a16:creationId xmlns:a16="http://schemas.microsoft.com/office/drawing/2014/main" id="{2B7E3E5D-F6C1-4C9D-A152-B064DEFCE9D0}"/>
+                <a16:creationId xmlns:a16="http://schemas.microsoft.com/office/drawing/2014/main" id="{F383A4CD-420B-40EF-9466-6722023F378D}"/>
               </a:ext>
             </a:extLst>
           </p:cNvPr>
@@ -14066,7 +14066,7 @@
           <p:cNvPr id="4" name="">
             <a:extLst xmlns:a="http://schemas.openxmlformats.org/drawingml/2006/main">
               <a:ext uri="{FF2B5EF4-FFF2-40B4-BE49-F238E27FC236}">
-                <a16:creationId xmlns:a16="http://schemas.microsoft.com/office/drawing/2014/main" id="{BA11E0A6-4A8E-4D91-AE99-500605F20F52}"/>
+                <a16:creationId xmlns:a16="http://schemas.microsoft.com/office/drawing/2014/main" id="{72A3E0FE-5DFB-41B8-BA72-454AAED21649}"/>
               </a:ext>
             </a:extLst>
           </p:cNvPr>
@@ -14222,7 +14222,7 @@
           <p:cNvPr id="5" name="">
             <a:extLst xmlns:a="http://schemas.openxmlformats.org/drawingml/2006/main">
               <a:ext uri="{FF2B5EF4-FFF2-40B4-BE49-F238E27FC236}">
-                <a16:creationId xmlns:a16="http://schemas.microsoft.com/office/drawing/2014/main" id="{55555A11-C41F-46EA-8F2E-5C881823DD6D}"/>
+                <a16:creationId xmlns:a16="http://schemas.microsoft.com/office/drawing/2014/main" id="{8621D7EF-9181-4E68-A6C6-66ABD6B27782}"/>
               </a:ext>
             </a:extLst>
           </p:cNvPr>
@@ -14478,7 +14478,7 @@
     </p:spTree>
     <p:extLst>
       <p:ext uri="{BB962C8B-B14F-4D97-AF65-F5344CB8AC3E}">
-        <p14:creationId xmlns:p14="http://schemas.microsoft.com/office/powerpoint/2010/main" val="452823860"/>
+        <p14:creationId xmlns:p14="http://schemas.microsoft.com/office/powerpoint/2010/main" val="630134498"/>
       </p:ext>
     </p:extLst>
   </p:cSld>
@@ -14509,7 +14509,7 @@
           <p:cNvPr id="6" name="">
             <a:extLst xmlns:a="http://schemas.openxmlformats.org/drawingml/2006/main">
               <a:ext uri="{FF2B5EF4-FFF2-40B4-BE49-F238E27FC236}">
-                <a16:creationId xmlns:a16="http://schemas.microsoft.com/office/drawing/2014/main" id="{A9C7D305-9CF7-4DF3-8C37-13CC40C2BA15}"/>
+                <a16:creationId xmlns:a16="http://schemas.microsoft.com/office/drawing/2014/main" id="{EF165613-4996-416F-88DC-E72CB70A1FA4}"/>
               </a:ext>
             </a:extLst>
           </p:cNvPr>
@@ -14665,7 +14665,7 @@
           <p:cNvPr id="2" name="">
             <a:extLst xmlns:a="http://schemas.openxmlformats.org/drawingml/2006/main">
               <a:ext uri="{FF2B5EF4-FFF2-40B4-BE49-F238E27FC236}">
-                <a16:creationId xmlns:a16="http://schemas.microsoft.com/office/drawing/2014/main" id="{907DD65D-C4A1-4458-B95E-5A52CABBF41A}"/>
+                <a16:creationId xmlns:a16="http://schemas.microsoft.com/office/drawing/2014/main" id="{6D670971-A818-4519-97C0-28F14FAEC4C9}"/>
               </a:ext>
             </a:extLst>
           </p:cNvPr>
@@ -14821,7 +14821,7 @@
           <p:cNvPr id="3" name="">
             <a:extLst xmlns:a="http://schemas.openxmlformats.org/drawingml/2006/main">
               <a:ext uri="{FF2B5EF4-FFF2-40B4-BE49-F238E27FC236}">
-                <a16:creationId xmlns:a16="http://schemas.microsoft.com/office/drawing/2014/main" id="{C485E152-4355-4DF8-8C9E-0A8F45E9E262}"/>
+                <a16:creationId xmlns:a16="http://schemas.microsoft.com/office/drawing/2014/main" id="{97D9FD9F-3AA4-42AA-8E2B-EDE95426C2B4}"/>
               </a:ext>
             </a:extLst>
           </p:cNvPr>
@@ -14961,7 +14961,7 @@
           <p:cNvPr id="4" name="">
             <a:extLst xmlns:a="http://schemas.openxmlformats.org/drawingml/2006/main">
               <a:ext uri="{FF2B5EF4-FFF2-40B4-BE49-F238E27FC236}">
-                <a16:creationId xmlns:a16="http://schemas.microsoft.com/office/drawing/2014/main" id="{B4FE8BF1-2B4A-44B4-A266-7C8B7490186D}"/>
+                <a16:creationId xmlns:a16="http://schemas.microsoft.com/office/drawing/2014/main" id="{0FB25197-8D84-48B3-AE35-3558AE938837}"/>
               </a:ext>
             </a:extLst>
           </p:cNvPr>
@@ -15117,7 +15117,7 @@
           <p:cNvPr id="5" name="">
             <a:extLst xmlns:a="http://schemas.openxmlformats.org/drawingml/2006/main">
               <a:ext uri="{FF2B5EF4-FFF2-40B4-BE49-F238E27FC236}">
-                <a16:creationId xmlns:a16="http://schemas.microsoft.com/office/drawing/2014/main" id="{7B997A76-D03B-4953-B8DF-B089959AF91C}"/>
+                <a16:creationId xmlns:a16="http://schemas.microsoft.com/office/drawing/2014/main" id="{A416D14D-4175-4535-B3DD-D81ED828C3BC}"/>
               </a:ext>
             </a:extLst>
           </p:cNvPr>
@@ -15355,7 +15355,7 @@
     </p:spTree>
     <p:extLst>
       <p:ext uri="{BB962C8B-B14F-4D97-AF65-F5344CB8AC3E}">
-        <p14:creationId xmlns:p14="http://schemas.microsoft.com/office/powerpoint/2010/main" val="1123929792"/>
+        <p14:creationId xmlns:p14="http://schemas.microsoft.com/office/powerpoint/2010/main" val="1651792383"/>
       </p:ext>
     </p:extLst>
   </p:cSld>
@@ -15386,7 +15386,7 @@
           <p:cNvPr id="7" name="">
             <a:extLst xmlns:a="http://schemas.openxmlformats.org/drawingml/2006/main">
               <a:ext uri="{FF2B5EF4-FFF2-40B4-BE49-F238E27FC236}">
-                <a16:creationId xmlns:a16="http://schemas.microsoft.com/office/drawing/2014/main" id="{B079DE79-8CE6-458F-B796-27E4F547B911}"/>
+                <a16:creationId xmlns:a16="http://schemas.microsoft.com/office/drawing/2014/main" id="{EF83EDC6-11AB-4065-8FA6-F4358C3258E1}"/>
               </a:ext>
             </a:extLst>
           </p:cNvPr>
@@ -15542,7 +15542,7 @@
           <p:cNvPr id="2" name="">
             <a:extLst xmlns:a="http://schemas.openxmlformats.org/drawingml/2006/main">
               <a:ext uri="{FF2B5EF4-FFF2-40B4-BE49-F238E27FC236}">
-                <a16:creationId xmlns:a16="http://schemas.microsoft.com/office/drawing/2014/main" id="{5F0495A9-AC2D-439E-9986-452CF597BA66}"/>
+                <a16:creationId xmlns:a16="http://schemas.microsoft.com/office/drawing/2014/main" id="{7039BE89-8418-4499-B8B6-75D629F5E2DF}"/>
               </a:ext>
             </a:extLst>
           </p:cNvPr>
@@ -15698,7 +15698,7 @@
           <p:cNvPr id="3" name="">
             <a:extLst xmlns:a="http://schemas.openxmlformats.org/drawingml/2006/main">
               <a:ext uri="{FF2B5EF4-FFF2-40B4-BE49-F238E27FC236}">
-                <a16:creationId xmlns:a16="http://schemas.microsoft.com/office/drawing/2014/main" id="{401E92E9-96D0-4F6A-937E-6E5F973B6D1E}"/>
+                <a16:creationId xmlns:a16="http://schemas.microsoft.com/office/drawing/2014/main" id="{E49FCDA2-3B10-49A5-A734-BE4B875F9B13}"/>
               </a:ext>
             </a:extLst>
           </p:cNvPr>
@@ -15838,7 +15838,7 @@
           <p:cNvPr id="4" name="">
             <a:extLst xmlns:a="http://schemas.openxmlformats.org/drawingml/2006/main">
               <a:ext uri="{FF2B5EF4-FFF2-40B4-BE49-F238E27FC236}">
-                <a16:creationId xmlns:a16="http://schemas.microsoft.com/office/drawing/2014/main" id="{9D6F15AF-A118-4531-A624-C7F5817B3D2E}"/>
+                <a16:creationId xmlns:a16="http://schemas.microsoft.com/office/drawing/2014/main" id="{30CA0A09-4BD0-40D6-8269-02080F0C44BF}"/>
               </a:ext>
             </a:extLst>
           </p:cNvPr>
@@ -15994,7 +15994,7 @@
           <p:cNvPr id="5" name="">
             <a:extLst xmlns:a="http://schemas.openxmlformats.org/drawingml/2006/main">
               <a:ext uri="{FF2B5EF4-FFF2-40B4-BE49-F238E27FC236}">
-                <a16:creationId xmlns:a16="http://schemas.microsoft.com/office/drawing/2014/main" id="{413A6C2A-A031-43B9-A150-3AAFE78B4321}"/>
+                <a16:creationId xmlns:a16="http://schemas.microsoft.com/office/drawing/2014/main" id="{443CD78F-8DC7-41E4-8CD4-6B6529FCD315}"/>
               </a:ext>
             </a:extLst>
           </p:cNvPr>
@@ -16004,7 +16004,7 @@
           <p:nvPr/>
         </p:nvPicPr>
         <p:blipFill>
-          <a:blip xmlns:r="http://schemas.openxmlformats.org/officeDocument/2006/relationships" xmlns:a="http://schemas.openxmlformats.org/drawingml/2006/main" r:embed="R0c26b668fcef4733"/>
+          <a:blip xmlns:r="http://schemas.openxmlformats.org/officeDocument/2006/relationships" xmlns:a="http://schemas.openxmlformats.org/drawingml/2006/main" r:embed="R7c72d53381d54294"/>
           <a:stretch xmlns:a="http://schemas.openxmlformats.org/drawingml/2006/main"/>
         </p:blipFill>
         <p:spPr>
@@ -16022,7 +16022,7 @@
           <p:cNvPr id="6" name="">
             <a:extLst xmlns:a="http://schemas.openxmlformats.org/drawingml/2006/main">
               <a:ext uri="{FF2B5EF4-FFF2-40B4-BE49-F238E27FC236}">
-                <a16:creationId xmlns:a16="http://schemas.microsoft.com/office/drawing/2014/main" id="{57E06541-C763-4FD9-9AB6-D91001D972B5}"/>
+                <a16:creationId xmlns:a16="http://schemas.microsoft.com/office/drawing/2014/main" id="{E1797B5F-0EF4-4E5E-A141-20ABE689CFC5}"/>
               </a:ext>
             </a:extLst>
           </p:cNvPr>
@@ -16176,7 +16176,7 @@
     </p:spTree>
     <p:extLst>
       <p:ext uri="{BB962C8B-B14F-4D97-AF65-F5344CB8AC3E}">
-        <p14:creationId xmlns:p14="http://schemas.microsoft.com/office/powerpoint/2010/main" val="1878057327"/>
+        <p14:creationId xmlns:p14="http://schemas.microsoft.com/office/powerpoint/2010/main" val="1505740347"/>
       </p:ext>
     </p:extLst>
   </p:cSld>
@@ -16207,7 +16207,7 @@
           <p:cNvPr id="7" name="">
             <a:extLst xmlns:a="http://schemas.openxmlformats.org/drawingml/2006/main">
               <a:ext uri="{FF2B5EF4-FFF2-40B4-BE49-F238E27FC236}">
-                <a16:creationId xmlns:a16="http://schemas.microsoft.com/office/drawing/2014/main" id="{DACF018E-AD20-4723-A838-54F13DFA1B29}"/>
+                <a16:creationId xmlns:a16="http://schemas.microsoft.com/office/drawing/2014/main" id="{48E6A57A-5849-4CA1-B024-EBB922DD4514}"/>
               </a:ext>
             </a:extLst>
           </p:cNvPr>
@@ -16363,7 +16363,7 @@
           <p:cNvPr id="2" name="">
             <a:extLst xmlns:a="http://schemas.openxmlformats.org/drawingml/2006/main">
               <a:ext uri="{FF2B5EF4-FFF2-40B4-BE49-F238E27FC236}">
-                <a16:creationId xmlns:a16="http://schemas.microsoft.com/office/drawing/2014/main" id="{17495D6F-E18D-481C-BA47-85CB4A74C477}"/>
+                <a16:creationId xmlns:a16="http://schemas.microsoft.com/office/drawing/2014/main" id="{CA1AF54B-6C2E-411B-8898-E37EA35BF0C3}"/>
               </a:ext>
             </a:extLst>
           </p:cNvPr>
@@ -16519,7 +16519,7 @@
           <p:cNvPr id="3" name="">
             <a:extLst xmlns:a="http://schemas.openxmlformats.org/drawingml/2006/main">
               <a:ext uri="{FF2B5EF4-FFF2-40B4-BE49-F238E27FC236}">
-                <a16:creationId xmlns:a16="http://schemas.microsoft.com/office/drawing/2014/main" id="{DFCBFC99-F38A-46DA-A04D-045F759887A8}"/>
+                <a16:creationId xmlns:a16="http://schemas.microsoft.com/office/drawing/2014/main" id="{F17BD64B-6914-44CF-91C3-46BB81D4F324}"/>
               </a:ext>
             </a:extLst>
           </p:cNvPr>
@@ -16659,7 +16659,7 @@
           <p:cNvPr id="4" name="">
             <a:extLst xmlns:a="http://schemas.openxmlformats.org/drawingml/2006/main">
               <a:ext uri="{FF2B5EF4-FFF2-40B4-BE49-F238E27FC236}">
-                <a16:creationId xmlns:a16="http://schemas.microsoft.com/office/drawing/2014/main" id="{EDFDE67D-B797-4332-8B7B-3748D0C2449F}"/>
+                <a16:creationId xmlns:a16="http://schemas.microsoft.com/office/drawing/2014/main" id="{69E5F429-7892-4A34-853F-73C8991362D9}"/>
               </a:ext>
             </a:extLst>
           </p:cNvPr>
@@ -16815,7 +16815,7 @@
           <p:cNvPr id="5" name="">
             <a:extLst xmlns:a="http://schemas.openxmlformats.org/drawingml/2006/main">
               <a:ext uri="{FF2B5EF4-FFF2-40B4-BE49-F238E27FC236}">
-                <a16:creationId xmlns:a16="http://schemas.microsoft.com/office/drawing/2014/main" id="{A0F1A831-3FC5-4E5D-8EF5-249620B76BB0}"/>
+                <a16:creationId xmlns:a16="http://schemas.microsoft.com/office/drawing/2014/main" id="{8F436765-6088-41A4-AECA-2362456E5D2B}"/>
               </a:ext>
             </a:extLst>
           </p:cNvPr>
@@ -16825,7 +16825,7 @@
           <p:nvPr/>
         </p:nvPicPr>
         <p:blipFill>
-          <a:blip xmlns:r="http://schemas.openxmlformats.org/officeDocument/2006/relationships" xmlns:a="http://schemas.openxmlformats.org/drawingml/2006/main" r:embed="Ra974122f605f43db"/>
+          <a:blip xmlns:r="http://schemas.openxmlformats.org/officeDocument/2006/relationships" xmlns:a="http://schemas.openxmlformats.org/drawingml/2006/main" r:embed="Rae9e118ad6184e1c"/>
           <a:stretch xmlns:a="http://schemas.openxmlformats.org/drawingml/2006/main"/>
         </p:blipFill>
         <p:spPr>
@@ -16843,7 +16843,7 @@
           <p:cNvPr id="6" name="">
             <a:extLst xmlns:a="http://schemas.openxmlformats.org/drawingml/2006/main">
               <a:ext uri="{FF2B5EF4-FFF2-40B4-BE49-F238E27FC236}">
-                <a16:creationId xmlns:a16="http://schemas.microsoft.com/office/drawing/2014/main" id="{0BCA33C1-5A19-4552-BDA3-78BD1CEA100B}"/>
+                <a16:creationId xmlns:a16="http://schemas.microsoft.com/office/drawing/2014/main" id="{9E826E42-0C6B-4F20-AEF2-1EF85AF4997A}"/>
               </a:ext>
             </a:extLst>
           </p:cNvPr>
@@ -16997,7 +16997,7 @@
     </p:spTree>
     <p:extLst>
       <p:ext uri="{BB962C8B-B14F-4D97-AF65-F5344CB8AC3E}">
-        <p14:creationId xmlns:p14="http://schemas.microsoft.com/office/powerpoint/2010/main" val="1964921519"/>
+        <p14:creationId xmlns:p14="http://schemas.microsoft.com/office/powerpoint/2010/main" val="306421330"/>
       </p:ext>
     </p:extLst>
   </p:cSld>
@@ -17028,7 +17028,7 @@
           <p:cNvPr id="7" name="">
             <a:extLst xmlns:a="http://schemas.openxmlformats.org/drawingml/2006/main">
               <a:ext uri="{FF2B5EF4-FFF2-40B4-BE49-F238E27FC236}">
-                <a16:creationId xmlns:a16="http://schemas.microsoft.com/office/drawing/2014/main" id="{BAAD7F63-3B09-4916-8573-25E5BBA3597F}"/>
+                <a16:creationId xmlns:a16="http://schemas.microsoft.com/office/drawing/2014/main" id="{0BDE0249-8117-49C9-8CC2-6A822053661E}"/>
               </a:ext>
             </a:extLst>
           </p:cNvPr>
@@ -17184,7 +17184,7 @@
           <p:cNvPr id="2" name="">
             <a:extLst xmlns:a="http://schemas.openxmlformats.org/drawingml/2006/main">
               <a:ext uri="{FF2B5EF4-FFF2-40B4-BE49-F238E27FC236}">
-                <a16:creationId xmlns:a16="http://schemas.microsoft.com/office/drawing/2014/main" id="{CD7F7B42-F13B-45B7-BE3D-BB62501B0575}"/>
+                <a16:creationId xmlns:a16="http://schemas.microsoft.com/office/drawing/2014/main" id="{8F0EB0C8-A330-44FD-86F6-DFBEA5BD3C21}"/>
               </a:ext>
             </a:extLst>
           </p:cNvPr>
@@ -17340,7 +17340,7 @@
           <p:cNvPr id="3" name="">
             <a:extLst xmlns:a="http://schemas.openxmlformats.org/drawingml/2006/main">
               <a:ext uri="{FF2B5EF4-FFF2-40B4-BE49-F238E27FC236}">
-                <a16:creationId xmlns:a16="http://schemas.microsoft.com/office/drawing/2014/main" id="{220B274A-4B93-4DB1-8C6F-4FCC41E7493C}"/>
+                <a16:creationId xmlns:a16="http://schemas.microsoft.com/office/drawing/2014/main" id="{E57785F9-A3CF-48F6-BE3B-989228F647B1}"/>
               </a:ext>
             </a:extLst>
           </p:cNvPr>
@@ -17480,7 +17480,7 @@
           <p:cNvPr id="4" name="">
             <a:extLst xmlns:a="http://schemas.openxmlformats.org/drawingml/2006/main">
               <a:ext uri="{FF2B5EF4-FFF2-40B4-BE49-F238E27FC236}">
-                <a16:creationId xmlns:a16="http://schemas.microsoft.com/office/drawing/2014/main" id="{9CD3FCF7-82F0-4F5B-AECB-F4A6EA07D9FB}"/>
+                <a16:creationId xmlns:a16="http://schemas.microsoft.com/office/drawing/2014/main" id="{299924E7-5F2F-4151-BA1D-6A07C4592D69}"/>
               </a:ext>
             </a:extLst>
           </p:cNvPr>
@@ -17636,7 +17636,7 @@
           <p:cNvPr id="5" name="">
             <a:extLst xmlns:a="http://schemas.openxmlformats.org/drawingml/2006/main">
               <a:ext uri="{FF2B5EF4-FFF2-40B4-BE49-F238E27FC236}">
-                <a16:creationId xmlns:a16="http://schemas.microsoft.com/office/drawing/2014/main" id="{D80779EC-EF5D-49EC-B209-F9A8BB580696}"/>
+                <a16:creationId xmlns:a16="http://schemas.microsoft.com/office/drawing/2014/main" id="{C67CF9EA-C345-4A50-87AA-FB50B8EFD71D}"/>
               </a:ext>
             </a:extLst>
           </p:cNvPr>
@@ -18495,7 +18495,7 @@
           <p:cNvPr id="6" name="">
             <a:extLst xmlns:a="http://schemas.openxmlformats.org/drawingml/2006/main">
               <a:ext uri="{FF2B5EF4-FFF2-40B4-BE49-F238E27FC236}">
-                <a16:creationId xmlns:a16="http://schemas.microsoft.com/office/drawing/2014/main" id="{ADB27FF3-2F63-4AD2-8F98-FF63A5121EEA}"/>
+                <a16:creationId xmlns:a16="http://schemas.microsoft.com/office/drawing/2014/main" id="{B0FFCAB3-EE6F-474D-9317-E4A3BE0B8B1C}"/>
               </a:ext>
             </a:extLst>
           </p:cNvPr>
@@ -18649,7 +18649,7 @@
     </p:spTree>
     <p:extLst>
       <p:ext uri="{BB962C8B-B14F-4D97-AF65-F5344CB8AC3E}">
-        <p14:creationId xmlns:p14="http://schemas.microsoft.com/office/powerpoint/2010/main" val="1419238044"/>
+        <p14:creationId xmlns:p14="http://schemas.microsoft.com/office/powerpoint/2010/main" val="286801333"/>
       </p:ext>
     </p:extLst>
   </p:cSld>

</xml_diff>